<commit_message>
Leva a questão aberta da pesquisa ao slide 27 e ajusta o roteiro
Co-Authored-By: Claude Opus 5.5 <noreply@anthropic.com>
Claude-Session: https://claude.ai/code/session_01HxStpW4pQoDfJdTDYr6zEC
</commit_message>
<xml_diff>
--- a/apresentacao_qualificacao/Qualificacao_PNED_Pipa.pptx
+++ b/apresentacao_qualificacao/Qualificacao_PNED_Pipa.pptx
@@ -25506,131 +25506,6 @@
           </a:blipFill>
         </p:spPr>
       </p:sp>
-      <p:grpSp>
-        <p:nvGrpSpPr>
-          <p:cNvPr name="Group 6" id="6"/>
-          <p:cNvGrpSpPr/>
-          <p:nvPr/>
-        </p:nvGrpSpPr>
-        <p:grpSpPr>
-          <a:xfrm rot="0">
-            <a:off x="8640331" y="5257409"/>
-            <a:ext cx="8618969" cy="4000891"/>
-            <a:chOff x="0" y="0"/>
-            <a:chExt cx="2270016" cy="1053733"/>
-          </a:xfrm>
-        </p:grpSpPr>
-        <p:sp>
-          <p:nvSpPr>
-            <p:cNvPr name="Freeform 7" id="7"/>
-            <p:cNvSpPr/>
-            <p:nvPr/>
-          </p:nvSpPr>
-          <p:spPr>
-            <a:xfrm flipH="false" flipV="false" rot="0">
-              <a:off x="0" y="0"/>
-              <a:ext cx="2270016" cy="1053733"/>
-            </a:xfrm>
-            <a:custGeom>
-              <a:avLst/>
-              <a:gdLst/>
-              <a:ahLst/>
-              <a:cxnLst/>
-              <a:rect r="r" b="b" t="t" l="l"/>
-              <a:pathLst>
-                <a:path h="1053733" w="2270016">
-                  <a:moveTo>
-                    <a:pt x="37726" y="0"/>
-                  </a:moveTo>
-                  <a:lnTo>
-                    <a:pt x="2232290" y="0"/>
-                  </a:lnTo>
-                  <a:cubicBezTo>
-                    <a:pt x="2242296" y="0"/>
-                    <a:pt x="2251892" y="3975"/>
-                    <a:pt x="2258967" y="11050"/>
-                  </a:cubicBezTo>
-                  <a:cubicBezTo>
-                    <a:pt x="2266042" y="18125"/>
-                    <a:pt x="2270016" y="27721"/>
-                    <a:pt x="2270016" y="37726"/>
-                  </a:cubicBezTo>
-                  <a:lnTo>
-                    <a:pt x="2270016" y="1016006"/>
-                  </a:lnTo>
-                  <a:cubicBezTo>
-                    <a:pt x="2270016" y="1026012"/>
-                    <a:pt x="2266042" y="1035608"/>
-                    <a:pt x="2258967" y="1042683"/>
-                  </a:cubicBezTo>
-                  <a:cubicBezTo>
-                    <a:pt x="2251892" y="1049758"/>
-                    <a:pt x="2242296" y="1053733"/>
-                    <a:pt x="2232290" y="1053733"/>
-                  </a:cubicBezTo>
-                  <a:lnTo>
-                    <a:pt x="37726" y="1053733"/>
-                  </a:lnTo>
-                  <a:cubicBezTo>
-                    <a:pt x="27721" y="1053733"/>
-                    <a:pt x="18125" y="1049758"/>
-                    <a:pt x="11050" y="1042683"/>
-                  </a:cubicBezTo>
-                  <a:cubicBezTo>
-                    <a:pt x="3975" y="1035608"/>
-                    <a:pt x="0" y="1026012"/>
-                    <a:pt x="0" y="1016006"/>
-                  </a:cubicBezTo>
-                  <a:lnTo>
-                    <a:pt x="0" y="37726"/>
-                  </a:lnTo>
-                  <a:cubicBezTo>
-                    <a:pt x="0" y="27721"/>
-                    <a:pt x="3975" y="18125"/>
-                    <a:pt x="11050" y="11050"/>
-                  </a:cubicBezTo>
-                  <a:cubicBezTo>
-                    <a:pt x="18125" y="3975"/>
-                    <a:pt x="27721" y="0"/>
-                    <a:pt x="37726" y="0"/>
-                  </a:cubicBezTo>
-                  <a:close/>
-                </a:path>
-              </a:pathLst>
-            </a:custGeom>
-            <a:solidFill>
-              <a:srgbClr val="FFCE32"/>
-            </a:solidFill>
-          </p:spPr>
-        </p:sp>
-        <p:sp>
-          <p:nvSpPr>
-            <p:cNvPr name="TextBox 8" id="8"/>
-            <p:cNvSpPr txBox="true"/>
-            <p:nvPr/>
-          </p:nvSpPr>
-          <p:spPr>
-            <a:xfrm>
-              <a:off x="0" y="-57150"/>
-              <a:ext cx="2270016" cy="1110883"/>
-            </a:xfrm>
-            <a:prstGeom prst="rect">
-              <a:avLst/>
-            </a:prstGeom>
-          </p:spPr>
-          <p:txBody>
-            <a:bodyPr anchor="ctr" rtlCol="false" tIns="50800" lIns="50800" bIns="50800" rIns="50800"/>
-            <a:lstStyle/>
-            <a:p>
-              <a:pPr algn="ctr">
-                <a:lnSpc>
-                  <a:spcPts val="3499"/>
-                </a:lnSpc>
-              </a:pPr>
-            </a:p>
-          </p:txBody>
-        </p:sp>
-      </p:grpSp>
       <p:sp>
         <p:nvSpPr>
           <p:cNvPr name="Freeform 9" id="9"/>
@@ -25847,8 +25722,8 @@
         </p:nvSpPr>
         <p:spPr>
           <a:xfrm>
-            <a:off x="8280000" y="3240000"/>
-            <a:ext cx="9216000" cy="1224000"/>
+            <a:off x="8496000" y="3024000"/>
+            <a:ext cx="9000000" cy="1080000"/>
           </a:xfrm>
           <a:prstGeom prst="rect">
             <a:avLst/>
@@ -25861,7 +25736,7 @@
           </a:bodyPr>
           <a:lstStyle/>
           <a:p>
-            <a:pPr algn="ctr">
+            <a:pPr algn="l">
               <a:lnSpc>
                 <a:spcPct val="88000"/>
               </a:lnSpc>
@@ -25883,7 +25758,7 @@
                 <a:cs typeface="Canva Sans Bold"/>
                 <a:sym typeface="Canva Sans Bold"/>
               </a:rPr>
-              <a:t>PRÓXIMOS PASSOS</a:t>
+              <a:t>A QUESTÃO ABERTA</a:t>
             </a:r>
             <a:endParaRPr lang="pt-BR" sz="4400" dirty="0"/>
           </a:p>
@@ -25897,8 +25772,8 @@
         </p:nvSpPr>
         <p:spPr>
           <a:xfrm>
-            <a:off x="9288000" y="5472000"/>
-            <a:ext cx="7416000" cy="3600000"/>
+            <a:off x="8568000" y="4176000"/>
+            <a:ext cx="9216000" cy="1080000"/>
           </a:xfrm>
           <a:prstGeom prst="rect">
             <a:avLst/>
@@ -25906,44 +25781,71 @@
           <a:noFill/>
         </p:spPr>
         <p:txBody>
-          <a:bodyPr wrap="square" lIns="0" tIns="0" rIns="0" bIns="0" anchor="ctr" rtlCol="0">
+          <a:bodyPr wrap="square" lIns="0" tIns="0" rIns="0" bIns="0" anchor="t" rtlCol="0">
             <a:noAutofit/>
           </a:bodyPr>
           <a:lstStyle/>
           <a:p>
-            <a:pPr algn="l" marL="270000" indent="-270000">
-              <a:lnSpc>
-                <a:spcPct val="100000"/>
-              </a:lnSpc>
-              <a:spcBef>
-                <a:spcPts val="0"/>
-              </a:spcBef>
-              <a:spcAft>
-                <a:spcPts val="725"/>
-              </a:spcAft>
-              <a:buClr>
-                <a:srgbClr val="111111"/>
-              </a:buClr>
-              <a:buSzPct val="100000"/>
-              <a:buFont typeface="Arial"/>
-              <a:buChar char="•"/>
-            </a:pPr>
-            <a:r>
-              <a:rPr lang="pt-BR" sz="2320" dirty="0">
-                <a:solidFill>
-                  <a:srgbClr val="111111"/>
+            <a:pPr algn="l">
+              <a:lnSpc>
+                <a:spcPct val="105000"/>
+              </a:lnSpc>
+              <a:spcBef>
+                <a:spcPts val="0"/>
+              </a:spcBef>
+              <a:spcAft>
+                <a:spcPts val="0"/>
+              </a:spcAft>
+              <a:buNone/>
+            </a:pPr>
+            <a:r>
+              <a:rPr lang="pt-BR" sz="2030" dirty="0">
+                <a:solidFill>
+                  <a:srgbClr val="FFFFFF"/>
                 </a:solidFill>
                 <a:latin typeface="Canva Sans"/>
                 <a:ea typeface="Canva Sans"/>
                 <a:cs typeface="Canva Sans"/>
                 <a:sym typeface="Canva Sans"/>
               </a:rPr>
-              <a:t>Submeter a emenda ao Comitê de Ética em Pesquisa</a:t>
-            </a:r>
-            <a:endParaRPr lang="pt-BR" sz="2320" dirty="0"/>
-          </a:p>
-          <a:p>
-            <a:pPr algn="l" marL="270000" indent="-270000">
+              <a:t>A política fez da educação digital um direito e deixou os meios na dependência de cada ente federado. A pergunta de fundo, que só as narrativas podem responder:</a:t>
+            </a:r>
+            <a:endParaRPr lang="pt-BR" sz="2030" dirty="0"/>
+          </a:p>
+        </p:txBody>
+      </p:sp>
+      <p:sp>
+        <p:nvSpPr>
+          <p:cNvPr id="203" name="Cartão 203"/>
+          <p:cNvSpPr/>
+          <p:nvPr/>
+        </p:nvSpPr>
+        <p:spPr>
+          <a:xfrm>
+            <a:off x="8568000" y="5292000"/>
+            <a:ext cx="9216000" cy="2376000"/>
+          </a:xfrm>
+          <a:prstGeom prst="roundRect">
+            <a:avLst>
+              <a:gd name="adj" fmla="val 5000"/>
+            </a:avLst>
+          </a:prstGeom>
+          <a:solidFill>
+            <a:srgbClr val="FFCE32"/>
+          </a:solidFill>
+          <a:ln w="38100">
+            <a:solidFill>
+              <a:srgbClr val="111111"/>
+            </a:solidFill>
+          </a:ln>
+        </p:spPr>
+        <p:txBody>
+          <a:bodyPr wrap="square" lIns="216000" tIns="216000" rIns="216000" bIns="216000" anchor="ctr" rtlCol="0">
+            <a:noAutofit/>
+          </a:bodyPr>
+          <a:lstStyle/>
+          <a:p>
+            <a:pPr algn="l">
               <a:lnSpc>
                 <a:spcPct val="100000"/>
               </a:lnSpc>
@@ -25951,17 +25853,125 @@
                 <a:spcPts val="0"/>
               </a:spcBef>
               <a:spcAft>
-                <a:spcPts val="725"/>
-              </a:spcAft>
-              <a:buClr>
-                <a:srgbClr val="111111"/>
-              </a:buClr>
-              <a:buSzPct val="100000"/>
-              <a:buFont typeface="Arial"/>
-              <a:buChar char="•"/>
-            </a:pPr>
-            <a:r>
-              <a:rPr lang="pt-BR" sz="2320" dirty="0">
+                <a:spcPts val="869"/>
+              </a:spcAft>
+              <a:buNone/>
+            </a:pPr>
+            <a:r>
+              <a:rPr lang="pt-BR" sz="2248" b="1" dirty="0">
+                <a:solidFill>
+                  <a:srgbClr val="111111"/>
+                </a:solidFill>
+                <a:latin typeface="Canva Sans Bold"/>
+                <a:ea typeface="Canva Sans Bold"/>
+                <a:cs typeface="Canva Sans Bold"/>
+                <a:sym typeface="Canva Sans Bold"/>
+              </a:rPr>
+              <a:t>Quando a política não faz chegar o equipamento nem a formação, quem paga, no silêncio do cotidiano escolar, o preço dessa ausência?</a:t>
+            </a:r>
+            <a:endParaRPr lang="pt-BR" sz="2248" dirty="0"/>
+          </a:p>
+          <a:p>
+            <a:pPr algn="l">
+              <a:lnSpc>
+                <a:spcPct val="100000"/>
+              </a:lnSpc>
+              <a:spcBef>
+                <a:spcPts val="0"/>
+              </a:spcBef>
+              <a:spcAft>
+                <a:spcPts val="0"/>
+              </a:spcAft>
+              <a:buNone/>
+            </a:pPr>
+            <a:r>
+              <a:rPr lang="pt-BR" sz="2248" b="1" dirty="0">
+                <a:solidFill>
+                  <a:srgbClr val="111111"/>
+                </a:solidFill>
+                <a:latin typeface="Canva Sans Bold"/>
+                <a:ea typeface="Canva Sans Bold"/>
+                <a:cs typeface="Canva Sans Bold"/>
+                <a:sym typeface="Canva Sans Bold"/>
+              </a:rPr>
+              <a:t>E o que isso significa para os direitos que a lei prometeu às crianças?</a:t>
+            </a:r>
+            <a:endParaRPr lang="pt-BR" sz="2248" dirty="0"/>
+          </a:p>
+        </p:txBody>
+      </p:sp>
+      <p:sp>
+        <p:nvSpPr>
+          <p:cNvPr id="204" name="Cartão 204"/>
+          <p:cNvSpPr/>
+          <p:nvPr/>
+        </p:nvSpPr>
+        <p:spPr>
+          <a:xfrm>
+            <a:off x="8568000" y="7884000"/>
+            <a:ext cx="9216000" cy="2160000"/>
+          </a:xfrm>
+          <a:prstGeom prst="roundRect">
+            <a:avLst>
+              <a:gd name="adj" fmla="val 5000"/>
+            </a:avLst>
+          </a:prstGeom>
+          <a:solidFill>
+            <a:srgbClr val="EFE3D4"/>
+          </a:solidFill>
+          <a:ln w="38100">
+            <a:solidFill>
+              <a:srgbClr val="111111"/>
+            </a:solidFill>
+          </a:ln>
+        </p:spPr>
+        <p:txBody>
+          <a:bodyPr wrap="square" lIns="180000" tIns="180000" rIns="180000" bIns="180000" anchor="ctr" rtlCol="0">
+            <a:noAutofit/>
+          </a:bodyPr>
+          <a:lstStyle/>
+          <a:p>
+            <a:pPr algn="l">
+              <a:lnSpc>
+                <a:spcPct val="100000"/>
+              </a:lnSpc>
+              <a:spcBef>
+                <a:spcPts val="0"/>
+              </a:spcBef>
+              <a:spcAft>
+                <a:spcPts val="434"/>
+              </a:spcAft>
+              <a:buNone/>
+            </a:pPr>
+            <a:r>
+              <a:rPr lang="pt-BR" sz="2175" b="1" dirty="0">
+                <a:solidFill>
+                  <a:srgbClr val="111111"/>
+                </a:solidFill>
+                <a:latin typeface="Canva Sans Bold"/>
+                <a:ea typeface="Canva Sans Bold"/>
+                <a:cs typeface="Canva Sans Bold"/>
+                <a:sym typeface="Canva Sans Bold"/>
+              </a:rPr>
+              <a:t>Próximos passos</a:t>
+            </a:r>
+            <a:endParaRPr lang="pt-BR" sz="2175" dirty="0"/>
+          </a:p>
+          <a:p>
+            <a:pPr algn="l">
+              <a:lnSpc>
+                <a:spcPct val="100000"/>
+              </a:lnSpc>
+              <a:spcBef>
+                <a:spcPts val="0"/>
+              </a:spcBef>
+              <a:spcAft>
+                <a:spcPts val="0"/>
+              </a:spcAft>
+              <a:buNone/>
+            </a:pPr>
+            <a:r>
+              <a:rPr lang="pt-BR" sz="1885" dirty="0">
                 <a:solidFill>
                   <a:srgbClr val="111111"/>
                 </a:solidFill>
@@ -25970,105 +25980,9 @@
                 <a:cs typeface="Canva Sans"/>
                 <a:sym typeface="Canva Sans"/>
               </a:rPr>
-              <a:t>Realizar o campo em dez semanas, após a aprovação</a:t>
-            </a:r>
-            <a:endParaRPr lang="pt-BR" sz="2320" dirty="0"/>
-          </a:p>
-          <a:p>
-            <a:pPr algn="l" marL="270000" indent="-270000">
-              <a:lnSpc>
-                <a:spcPct val="100000"/>
-              </a:lnSpc>
-              <a:spcBef>
-                <a:spcPts val="0"/>
-              </a:spcBef>
-              <a:spcAft>
-                <a:spcPts val="725"/>
-              </a:spcAft>
-              <a:buClr>
-                <a:srgbClr val="111111"/>
-              </a:buClr>
-              <a:buSzPct val="100000"/>
-              <a:buFont typeface="Arial"/>
-              <a:buChar char="•"/>
-            </a:pPr>
-            <a:r>
-              <a:rPr lang="pt-BR" sz="2320" dirty="0">
-                <a:solidFill>
-                  <a:srgbClr val="111111"/>
-                </a:solidFill>
-                <a:latin typeface="Canva Sans"/>
-                <a:ea typeface="Canva Sans"/>
-                <a:cs typeface="Canva Sans"/>
-                <a:sym typeface="Canva Sans"/>
-              </a:rPr>
-              <a:t>Completar a análise documental: cadernos do laboratório, aquisição de 2022 e dados fiscais do município</a:t>
-            </a:r>
-            <a:endParaRPr lang="pt-BR" sz="2320" dirty="0"/>
-          </a:p>
-          <a:p>
-            <a:pPr algn="l" marL="270000" indent="-270000">
-              <a:lnSpc>
-                <a:spcPct val="100000"/>
-              </a:lnSpc>
-              <a:spcBef>
-                <a:spcPts val="0"/>
-              </a:spcBef>
-              <a:spcAft>
-                <a:spcPts val="725"/>
-              </a:spcAft>
-              <a:buClr>
-                <a:srgbClr val="111111"/>
-              </a:buClr>
-              <a:buSzPct val="100000"/>
-              <a:buFont typeface="Arial"/>
-              <a:buChar char="•"/>
-            </a:pPr>
-            <a:r>
-              <a:rPr lang="pt-BR" sz="2320" dirty="0">
-                <a:solidFill>
-                  <a:srgbClr val="111111"/>
-                </a:solidFill>
-                <a:latin typeface="Canva Sans"/>
-                <a:ea typeface="Canva Sans"/>
-                <a:cs typeface="Canva Sans"/>
-                <a:sym typeface="Canva Sans"/>
-              </a:rPr>
-              <a:t>Escrever o capítulo 7, com as narrativas dos profissionais</a:t>
-            </a:r>
-            <a:endParaRPr lang="pt-BR" sz="2320" dirty="0"/>
-          </a:p>
-          <a:p>
-            <a:pPr algn="l" marL="270000" indent="-270000">
-              <a:lnSpc>
-                <a:spcPct val="100000"/>
-              </a:lnSpc>
-              <a:spcBef>
-                <a:spcPts val="0"/>
-              </a:spcBef>
-              <a:spcAft>
-                <a:spcPts val="725"/>
-              </a:spcAft>
-              <a:buClr>
-                <a:srgbClr val="111111"/>
-              </a:buClr>
-              <a:buSzPct val="100000"/>
-              <a:buFont typeface="Arial"/>
-              <a:buChar char="•"/>
-            </a:pPr>
-            <a:r>
-              <a:rPr lang="pt-BR" sz="2320" dirty="0">
-                <a:solidFill>
-                  <a:srgbClr val="111111"/>
-                </a:solidFill>
-                <a:latin typeface="Canva Sans"/>
-                <a:ea typeface="Canva Sans"/>
-                <a:cs typeface="Canva Sans"/>
-                <a:sym typeface="Canva Sans"/>
-              </a:rPr>
-              <a:t>Incorporar as contribuições da banca</a:t>
-            </a:r>
-            <a:endParaRPr lang="pt-BR" sz="2320" dirty="0"/>
+              <a:t>Emenda ao CEP · campo em dez semanas após a aprovação · análise documental (cadernos do laboratório, aquisição de 2022, dados fiscais do município) · capítulo 7, com as narrativas dos profissionais · contribuições da banca</a:t>
+            </a:r>
+            <a:endParaRPr lang="pt-BR" sz="1885" dirty="0"/>
           </a:p>
         </p:txBody>
       </p:sp>

</xml_diff>

<commit_message>
Registra que os documentos já foram solicitados à direção e à Secretaria
Co-Authored-By: Claude Opus 5.5 <noreply@anthropic.com>
Claude-Session: https://claude.ai/code/session_01HxStpW4pQoDfJdTDYr6zEC
</commit_message>
<xml_diff>
--- a/apresentacao_qualificacao/Qualificacao_PNED_Pipa.pptx
+++ b/apresentacao_qualificacao/Qualificacao_PNED_Pipa.pptx
@@ -17071,7 +17071,7 @@
                 <a:cs typeface="Canva Sans"/>
                 <a:sym typeface="Canva Sans"/>
               </a:rPr>
-              <a:t>Lei, Res. CNE/CEB nº 2/2025, PPP, planos, atas e registros da SME</a:t>
+              <a:t>PPP, planos, atas e registros, já solicitados à direção e à Secretaria</a:t>
             </a:r>
             <a:endParaRPr lang="pt-BR" sz="1812" dirty="0"/>
           </a:p>
@@ -25980,7 +25980,7 @@
                 <a:cs typeface="Canva Sans"/>
                 <a:sym typeface="Canva Sans"/>
               </a:rPr>
-              <a:t>Emenda ao CEP · campo em dez semanas após a aprovação · análise documental (cadernos do laboratório, aquisição de 2022, dados fiscais do município) · capítulo 7, com as narrativas dos profissionais · contribuições da banca</a:t>
+              <a:t>Emenda ao CEP · campo em dez semanas após a aprovação · análise documental: os documentos da escola já foram solicitados à direção, e os municipais, ao técnico da Secretaria de Educação · capítulo 7, com as narrativas dos profissionais · contribuições da banca</a:t>
             </a:r>
             <a:endParaRPr lang="pt-BR" sz="1885" dirty="0"/>
           </a:p>

</xml_diff>

<commit_message>
Acrescenta rótulos aos objetivos específicos
Co-Authored-By: Claude Opus 5.5 <noreply@anthropic.com>
Claude-Session: https://claude.ai/code/session_01HxStpW4pQoDfJdTDYr6zEC
</commit_message>
<xml_diff>
--- a/apresentacao_qualificacao/Qualificacao_PNED_Pipa.pptx
+++ b/apresentacao_qualificacao/Qualificacao_PNED_Pipa.pptx
@@ -6210,20 +6210,47 @@
           </a:bodyPr>
           <a:lstStyle/>
           <a:p>
+            <a:pPr algn="ctr">
+              <a:lnSpc>
+                <a:spcPct val="100000"/>
+              </a:lnSpc>
+              <a:spcBef>
+                <a:spcPts val="0"/>
+              </a:spcBef>
+              <a:spcAft>
+                <a:spcPts val="434"/>
+              </a:spcAft>
+              <a:buNone/>
+            </a:pPr>
+            <a:r>
+              <a:rPr lang="pt-BR" sz="2175" b="1" dirty="0">
+                <a:solidFill>
+                  <a:srgbClr val="111111"/>
+                </a:solidFill>
+                <a:latin typeface="Canva Sans Bold"/>
+                <a:ea typeface="Canva Sans Bold"/>
+                <a:cs typeface="Canva Sans Bold"/>
+                <a:sym typeface="Canva Sans Bold"/>
+              </a:rPr>
+              <a:t>INTERPRETAÇÃO</a:t>
+            </a:r>
+            <a:endParaRPr lang="pt-BR" sz="2175" dirty="0"/>
+          </a:p>
+          <a:p>
             <a:pPr algn="l">
               <a:lnSpc>
-                <a:spcPct val="100000"/>
-              </a:lnSpc>
-              <a:spcBef>
-                <a:spcPts val="0"/>
-              </a:spcBef>
-              <a:spcAft>
-                <a:spcPts val="0"/>
-              </a:spcAft>
-              <a:buNone/>
-            </a:pPr>
-            <a:r>
-              <a:rPr lang="pt-BR" sz="1958" dirty="0">
+                <a:spcPct val="98000"/>
+              </a:lnSpc>
+              <a:spcBef>
+                <a:spcPts val="0"/>
+              </a:spcBef>
+              <a:spcAft>
+                <a:spcPts val="0"/>
+              </a:spcAft>
+              <a:buNone/>
+            </a:pPr>
+            <a:r>
+              <a:rPr lang="pt-BR" sz="1812" dirty="0">
                 <a:solidFill>
                   <a:srgbClr val="111111"/>
                 </a:solidFill>
@@ -6235,7 +6262,7 @@
               <a:t>a) </a:t>
             </a:r>
             <a:r>
-              <a:rPr lang="pt-BR" sz="1958" b="1" dirty="0">
+              <a:rPr lang="pt-BR" sz="1812" b="1" dirty="0">
                 <a:solidFill>
                   <a:srgbClr val="111111"/>
                 </a:solidFill>
@@ -6247,7 +6274,7 @@
               <a:t>Compreender</a:t>
             </a:r>
             <a:r>
-              <a:rPr lang="pt-BR" sz="1958" dirty="0">
+              <a:rPr lang="pt-BR" sz="1812" dirty="0">
                 <a:solidFill>
                   <a:srgbClr val="111111"/>
                 </a:solidFill>
@@ -6258,7 +6285,7 @@
               </a:rPr>
               <a:t> como os diferentes profissionais da educação interpretam os textos da PNED e os discursos sobre educação digital, considerando suas experiências, crenças, valores e formas de organização do trabalho;</a:t>
             </a:r>
-            <a:endParaRPr lang="pt-BR" sz="1958" dirty="0"/>
+            <a:endParaRPr lang="pt-BR" sz="1812" dirty="0"/>
           </a:p>
         </p:txBody>
       </p:sp>
@@ -6344,20 +6371,47 @@
           </a:bodyPr>
           <a:lstStyle/>
           <a:p>
+            <a:pPr algn="ctr">
+              <a:lnSpc>
+                <a:spcPct val="100000"/>
+              </a:lnSpc>
+              <a:spcBef>
+                <a:spcPts val="0"/>
+              </a:spcBef>
+              <a:spcAft>
+                <a:spcPts val="434"/>
+              </a:spcAft>
+              <a:buNone/>
+            </a:pPr>
+            <a:r>
+              <a:rPr lang="pt-BR" sz="2175" b="1" dirty="0">
+                <a:solidFill>
+                  <a:srgbClr val="111111"/>
+                </a:solidFill>
+                <a:latin typeface="Canva Sans Bold"/>
+                <a:ea typeface="Canva Sans Bold"/>
+                <a:cs typeface="Canva Sans Bold"/>
+                <a:sym typeface="Canva Sans Bold"/>
+              </a:rPr>
+              <a:t>CONDIÇÕES E TERRITÓRIO</a:t>
+            </a:r>
+            <a:endParaRPr lang="pt-BR" sz="2175" dirty="0"/>
+          </a:p>
+          <a:p>
             <a:pPr algn="l">
               <a:lnSpc>
-                <a:spcPct val="100000"/>
-              </a:lnSpc>
-              <a:spcBef>
-                <a:spcPts val="0"/>
-              </a:spcBef>
-              <a:spcAft>
-                <a:spcPts val="0"/>
-              </a:spcAft>
-              <a:buNone/>
-            </a:pPr>
-            <a:r>
-              <a:rPr lang="pt-BR" sz="1958" dirty="0">
+                <a:spcPct val="98000"/>
+              </a:lnSpc>
+              <a:spcBef>
+                <a:spcPts val="0"/>
+              </a:spcBef>
+              <a:spcAft>
+                <a:spcPts val="0"/>
+              </a:spcAft>
+              <a:buNone/>
+            </a:pPr>
+            <a:r>
+              <a:rPr lang="pt-BR" sz="1812" dirty="0">
                 <a:solidFill>
                   <a:srgbClr val="111111"/>
                 </a:solidFill>
@@ -6369,7 +6423,7 @@
               <a:t>b) </a:t>
             </a:r>
             <a:r>
-              <a:rPr lang="pt-BR" sz="1958" b="1" dirty="0">
+              <a:rPr lang="pt-BR" sz="1812" b="1" dirty="0">
                 <a:solidFill>
                   <a:srgbClr val="111111"/>
                 </a:solidFill>
@@ -6381,7 +6435,7 @@
               <a:t>Analisar</a:t>
             </a:r>
             <a:r>
-              <a:rPr lang="pt-BR" sz="1958" dirty="0">
+              <a:rPr lang="pt-BR" sz="1812" dirty="0">
                 <a:solidFill>
                   <a:srgbClr val="111111"/>
                 </a:solidFill>
@@ -6392,7 +6446,7 @@
               </a:rPr>
               <a:t> como as condições materiais e institucionais da escola, articuladas às especificidades socioespaciais do território, atravessam os processos de tradução e recontextualização da PNED em ações, escolhas e práticas cotidianas;</a:t>
             </a:r>
-            <a:endParaRPr lang="pt-BR" sz="1958" dirty="0"/>
+            <a:endParaRPr lang="pt-BR" sz="1812" dirty="0"/>
           </a:p>
         </p:txBody>
       </p:sp>
@@ -6478,20 +6532,47 @@
           </a:bodyPr>
           <a:lstStyle/>
           <a:p>
+            <a:pPr algn="ctr">
+              <a:lnSpc>
+                <a:spcPct val="100000"/>
+              </a:lnSpc>
+              <a:spcBef>
+                <a:spcPts val="0"/>
+              </a:spcBef>
+              <a:spcAft>
+                <a:spcPts val="434"/>
+              </a:spcAft>
+              <a:buNone/>
+            </a:pPr>
+            <a:r>
+              <a:rPr lang="pt-BR" sz="2175" b="1" dirty="0">
+                <a:solidFill>
+                  <a:srgbClr val="111111"/>
+                </a:solidFill>
+                <a:latin typeface="Canva Sans Bold"/>
+                <a:ea typeface="Canva Sans Bold"/>
+                <a:cs typeface="Canva Sans Bold"/>
+                <a:sym typeface="Canva Sans Bold"/>
+              </a:rPr>
+              <a:t>FORMAS DE ATUAÇÃO</a:t>
+            </a:r>
+            <a:endParaRPr lang="pt-BR" sz="2175" dirty="0"/>
+          </a:p>
+          <a:p>
             <a:pPr algn="l">
               <a:lnSpc>
-                <a:spcPct val="100000"/>
-              </a:lnSpc>
-              <a:spcBef>
-                <a:spcPts val="0"/>
-              </a:spcBef>
-              <a:spcAft>
-                <a:spcPts val="0"/>
-              </a:spcAft>
-              <a:buNone/>
-            </a:pPr>
-            <a:r>
-              <a:rPr lang="pt-BR" sz="1958" dirty="0">
+                <a:spcPct val="98000"/>
+              </a:lnSpc>
+              <a:spcBef>
+                <a:spcPts val="0"/>
+              </a:spcBef>
+              <a:spcAft>
+                <a:spcPts val="0"/>
+              </a:spcAft>
+              <a:buNone/>
+            </a:pPr>
+            <a:r>
+              <a:rPr lang="pt-BR" sz="1812" dirty="0">
                 <a:solidFill>
                   <a:srgbClr val="111111"/>
                 </a:solidFill>
@@ -6503,7 +6584,7 @@
               <a:t>c) </a:t>
             </a:r>
             <a:r>
-              <a:rPr lang="pt-BR" sz="1958" b="1" dirty="0">
+              <a:rPr lang="pt-BR" sz="1812" b="1" dirty="0">
                 <a:solidFill>
                   <a:srgbClr val="111111"/>
                 </a:solidFill>
@@ -6515,7 +6596,7 @@
               <a:t>Identificar</a:t>
             </a:r>
             <a:r>
-              <a:rPr lang="pt-BR" sz="1958" dirty="0">
+              <a:rPr lang="pt-BR" sz="1812" dirty="0">
                 <a:solidFill>
                   <a:srgbClr val="111111"/>
                 </a:solidFill>
@@ -6526,7 +6607,7 @@
               </a:rPr>
               <a:t> as diferentes formas de atuação produzidas diante da política, com atenção às situações em que emergem adesão, acomodação, adaptação, omissão seletiva, negociação, ressignificação ou resistência;</a:t>
             </a:r>
-            <a:endParaRPr lang="pt-BR" sz="1958" dirty="0"/>
+            <a:endParaRPr lang="pt-BR" sz="1812" dirty="0"/>
           </a:p>
         </p:txBody>
       </p:sp>
@@ -6612,20 +6693,47 @@
           </a:bodyPr>
           <a:lstStyle/>
           <a:p>
+            <a:pPr algn="ctr">
+              <a:lnSpc>
+                <a:spcPct val="100000"/>
+              </a:lnSpc>
+              <a:spcBef>
+                <a:spcPts val="0"/>
+              </a:spcBef>
+              <a:spcAft>
+                <a:spcPts val="434"/>
+              </a:spcAft>
+              <a:buNone/>
+            </a:pPr>
+            <a:r>
+              <a:rPr lang="pt-BR" sz="2175" b="1" dirty="0">
+                <a:solidFill>
+                  <a:srgbClr val="111111"/>
+                </a:solidFill>
+                <a:latin typeface="Canva Sans Bold"/>
+                <a:ea typeface="Canva Sans Bold"/>
+                <a:cs typeface="Canva Sans Bold"/>
+                <a:sym typeface="Canva Sans Bold"/>
+              </a:rPr>
+              <a:t>CRIANÇAS</a:t>
+            </a:r>
+            <a:endParaRPr lang="pt-BR" sz="2175" dirty="0"/>
+          </a:p>
+          <a:p>
             <a:pPr algn="l">
               <a:lnSpc>
-                <a:spcPct val="100000"/>
-              </a:lnSpc>
-              <a:spcBef>
-                <a:spcPts val="0"/>
-              </a:spcBef>
-              <a:spcAft>
-                <a:spcPts val="0"/>
-              </a:spcAft>
-              <a:buNone/>
-            </a:pPr>
-            <a:r>
-              <a:rPr lang="pt-BR" sz="1958" dirty="0">
+                <a:spcPct val="98000"/>
+              </a:lnSpc>
+              <a:spcBef>
+                <a:spcPts val="0"/>
+              </a:spcBef>
+              <a:spcAft>
+                <a:spcPts val="0"/>
+              </a:spcAft>
+              <a:buNone/>
+            </a:pPr>
+            <a:r>
+              <a:rPr lang="pt-BR" sz="1812" dirty="0">
                 <a:solidFill>
                   <a:srgbClr val="111111"/>
                 </a:solidFill>
@@ -6637,7 +6745,7 @@
               <a:t>d) </a:t>
             </a:r>
             <a:r>
-              <a:rPr lang="pt-BR" sz="1958" b="1" dirty="0">
+              <a:rPr lang="pt-BR" sz="1812" b="1" dirty="0">
                 <a:solidFill>
                   <a:srgbClr val="111111"/>
                 </a:solidFill>
@@ -6649,7 +6757,7 @@
               <a:t>Discutir</a:t>
             </a:r>
             <a:r>
-              <a:rPr lang="pt-BR" sz="1958" dirty="0">
+              <a:rPr lang="pt-BR" sz="1812" dirty="0">
                 <a:solidFill>
                   <a:srgbClr val="111111"/>
                 </a:solidFill>
@@ -6660,7 +6768,7 @@
               </a:rPr>
               <a:t> as implicações das diferentes formas de encenação da PNED para a educação digital das crianças, considerando as possibilidades de provisão, proteção e participação no ambiente digital.</a:t>
             </a:r>
-            <a:endParaRPr lang="pt-BR" sz="1958" dirty="0"/>
+            <a:endParaRPr lang="pt-BR" sz="1812" dirty="0"/>
           </a:p>
         </p:txBody>
       </p:sp>

</xml_diff>

<commit_message>
Recoloca Pipa como foco da apresentação e do roteiro de fala
O caso é a escola de Pipa; o território municipal e a SME passam a ser
o percurso em funil até ela. Ajusta objeto, objetivo (a), relevâncias,
ineditismo, decisões da RSL, desenho e a lâmina de Tibau do Sul.

Co-Authored-By: Claude Opus 5.5 <noreply@anthropic.com>
Claude-Session: https://claude.ai/code/session_01HxStpW4pQoDfJdTDYr6zEC
</commit_message>
<xml_diff>
--- a/apresentacao_qualificacao/Qualificacao_PNED_Pipa.pptx
+++ b/apresentacao_qualificacao/Qualificacao_PNED_Pipa.pptx
@@ -5230,7 +5230,7 @@
                 <a:cs typeface="Canva Sans"/>
                 <a:sym typeface="Canva Sans"/>
               </a:rPr>
-              <a:t>A Política Nacional de Educação Digital (</a:t>
+              <a:t>A encenação da Política Nacional de Educação Digital (</a:t>
             </a:r>
             <a:r>
               <a:rPr lang="pt-BR" sz="2102" b="1" dirty="0">
@@ -5254,7 +5254,7 @@
                 <a:cs typeface="Canva Sans"/>
                 <a:sym typeface="Canva Sans"/>
               </a:rPr>
-              <a:t>), no eixo </a:t>
+              <a:t>), eixo </a:t>
             </a:r>
             <a:r>
               <a:rPr lang="pt-BR" sz="2102" b="1" dirty="0">
@@ -5278,7 +5278,7 @@
                 <a:cs typeface="Canva Sans"/>
                 <a:sym typeface="Canva Sans"/>
               </a:rPr>
-              <a:t>, acompanhada em funil: da </a:t>
+              <a:t>, na </a:t>
             </a:r>
             <a:r>
               <a:rPr lang="pt-BR" sz="2102" b="1" dirty="0">
@@ -5290,7 +5290,7 @@
                 <a:cs typeface="Canva Sans Bold"/>
                 <a:sym typeface="Canva Sans Bold"/>
               </a:rPr>
-              <a:t>Secretaria Municipal de Educação de Tibau do Sul/RN</a:t>
+              <a:t>Escola Municipal Domitila Castelo da Silva, em Pipa</a:t>
             </a:r>
             <a:r>
               <a:rPr lang="pt-BR" sz="2102" dirty="0">
@@ -5302,7 +5302,34 @@
                 <a:cs typeface="Canva Sans"/>
                 <a:sym typeface="Canva Sans"/>
               </a:rPr>
-              <a:t>, que a traduz para uma rede de localidades muito diferentes, até a </a:t>
+              <a:t>, pelos profissionais dos anos iniciais (1º ao 5º ano): docentes, coordenação, direção e apoio pedagógico.</a:t>
+            </a:r>
+            <a:endParaRPr lang="pt-BR" sz="2102" dirty="0"/>
+          </a:p>
+          <a:p>
+            <a:pPr algn="l">
+              <a:lnSpc>
+                <a:spcPct val="100000"/>
+              </a:lnSpc>
+              <a:spcBef>
+                <a:spcPts val="0"/>
+              </a:spcBef>
+              <a:spcAft>
+                <a:spcPts val="869"/>
+              </a:spcAft>
+              <a:buNone/>
+            </a:pPr>
+            <a:r>
+              <a:rPr lang="pt-BR" sz="2102" dirty="0">
+                <a:solidFill>
+                  <a:srgbClr val="111111"/>
+                </a:solidFill>
+                <a:latin typeface="Canva Sans"/>
+                <a:ea typeface="Canva Sans"/>
+                <a:cs typeface="Canva Sans"/>
+                <a:sym typeface="Canva Sans"/>
+              </a:rPr>
+              <a:t>Para chegar a Pipa, a pesquisa percorre o </a:t>
             </a:r>
             <a:r>
               <a:rPr lang="pt-BR" sz="2102" b="1" dirty="0">
@@ -5314,7 +5341,7 @@
                 <a:cs typeface="Canva Sans Bold"/>
                 <a:sym typeface="Canva Sans Bold"/>
               </a:rPr>
-              <a:t>Escola Municipal Domitila Castelo da Silva</a:t>
+              <a:t>território municipal de Tibau do Sul</a:t>
             </a:r>
             <a:r>
               <a:rPr lang="pt-BR" sz="2102" dirty="0">
@@ -5326,23 +5353,20 @@
                 <a:cs typeface="Canva Sans"/>
                 <a:sym typeface="Canva Sans"/>
               </a:rPr>
-              <a:t>, em Pipa.</a:t>
-            </a:r>
-            <a:endParaRPr lang="pt-BR" sz="2102" dirty="0"/>
-          </a:p>
-          <a:p>
-            <a:pPr algn="l">
-              <a:lnSpc>
-                <a:spcPct val="100000"/>
-              </a:lnSpc>
-              <a:spcBef>
-                <a:spcPts val="0"/>
-              </a:spcBef>
-              <a:spcAft>
-                <a:spcPts val="869"/>
-              </a:spcAft>
-              <a:buNone/>
-            </a:pPr>
+              <a:t> e os documentos da </a:t>
+            </a:r>
+            <a:r>
+              <a:rPr lang="pt-BR" sz="2102" b="1" dirty="0">
+                <a:solidFill>
+                  <a:srgbClr val="111111"/>
+                </a:solidFill>
+                <a:latin typeface="Canva Sans Bold"/>
+                <a:ea typeface="Canva Sans Bold"/>
+                <a:cs typeface="Canva Sans Bold"/>
+                <a:sym typeface="Canva Sans Bold"/>
+              </a:rPr>
+              <a:t>Secretaria Municipal de Educação</a:t>
+            </a:r>
             <a:r>
               <a:rPr lang="pt-BR" sz="2102" dirty="0">
                 <a:solidFill>
@@ -5353,7 +5377,7 @@
                 <a:cs typeface="Canva Sans"/>
                 <a:sym typeface="Canva Sans"/>
               </a:rPr>
-              <a:t>Na escola, os profissionais da educação dos anos iniciais (1º ao 5º ano) a interpretam, traduzem e recontextualizam: professoras e professores, coordenação, direção e apoio pedagógico.</a:t>
+              <a:t>, perguntando se consideram a realidade diversa de cada localidade.</a:t>
             </a:r>
             <a:endParaRPr lang="pt-BR" sz="2102" dirty="0"/>
           </a:p>
@@ -6255,7 +6279,7 @@
                 <a:cs typeface="Canva Sans Bold"/>
                 <a:sym typeface="Canva Sans Bold"/>
               </a:rPr>
-              <a:t>REDE MUNICIPAL</a:t>
+              <a:t>DO MUNICÍPIO A PIPA</a:t>
             </a:r>
             <a:endParaRPr lang="pt-BR" sz="2175" dirty="0"/>
           </a:p>
@@ -6306,7 +6330,7 @@
                 <a:cs typeface="Canva Sans"/>
                 <a:sym typeface="Canva Sans"/>
               </a:rPr>
-              <a:t> a recontextualização da PNED pela Secretaria Municipal de Educação em planos, currículos, formações e orientações para a rede, considerando as especificidades das localidades do município, entre elas as áreas rurais e a comunidade quilombola de Sibaúma;</a:t>
+              <a:t> a recontextualização da PNED pela Secretaria Municipal de Educação em planos, currículos, formações e orientações para a rede, considerando as especificidades das localidades do município, entre elas as áreas rurais e a comunidade quilombola de Sibaúma, até chegar a Pipa;</a:t>
             </a:r>
             <a:endParaRPr lang="pt-BR" sz="1812" dirty="0"/>
           </a:p>
@@ -7548,7 +7572,7 @@
                 <a:cs typeface="Canva Sans"/>
                 <a:sym typeface="Canva Sans"/>
               </a:rPr>
-              <a:t> mostra se e como a tradução municipal da PNED considera as diferenças entre as localidades, com devolutiva à escola e à Secretaria Municipal de Educação</a:t>
+              <a:t> mostra se a tradução municipal da PNED considera as diferenças entre as localidades e o que chega a Pipa, com devolutiva à escola e à Secretaria Municipal de Educação</a:t>
             </a:r>
             <a:endParaRPr lang="pt-BR" sz="2030" dirty="0"/>
           </a:p>
@@ -8011,7 +8035,7 @@
                 <a:cs typeface="Canva Sans"/>
                 <a:sym typeface="Canva Sans"/>
               </a:rPr>
-              <a:t>Acompanha a chegada da PNED da Secretaria à escola. Nenhum dos nove estudos da RSL examina essa política nem uma rede municipal de pequeno porte.</a:t>
+              <a:t>Acompanha a chegada da PNED a uma escola de Pipa, lida a partir da rede. Nenhum dos nove estudos da RSL examina essa política nem uma rede municipal de pequeno porte.</a:t>
             </a:r>
             <a:endParaRPr lang="pt-BR" sz="2030" dirty="0"/>
           </a:p>
@@ -8148,7 +8172,7 @@
                 <a:cs typeface="Canva Sans"/>
                 <a:sym typeface="Canva Sans"/>
               </a:rPr>
-              <a:t>O território municipal, de Tibau do Sul a Pipa, entra como parte do contexto, lido com Santos (território usado) e Massey (encontro de trajetórias).</a:t>
+              <a:t>Pipa no centro, lida dentro do território municipal diverso, com Santos (território usado) e Massey (encontro de trajetórias).</a:t>
             </a:r>
             <a:endParaRPr lang="pt-BR" sz="2030" dirty="0"/>
           </a:p>
@@ -10603,7 +10627,7 @@
                 <a:cs typeface="Canva Sans Bold"/>
                 <a:sym typeface="Canva Sans Bold"/>
               </a:rPr>
-              <a:t>toma o eixo Educação Digital Escolar como objeto, da Secretaria de Tibau do Sul à escola</a:t>
+              <a:t>toma o eixo Educação Digital Escolar como objeto, numa escola de Pipa, lida a partir da rede municipal</a:t>
             </a:r>
             <a:endParaRPr lang="pt-BR" sz="1885" dirty="0"/>
           </a:p>
@@ -15739,7 +15763,7 @@
                 <a:cs typeface="Canva Sans"/>
                 <a:sym typeface="Canva Sans"/>
               </a:rPr>
-              <a:t>Caso único com unidades incorporadas: a SME e a escola (YIN, 2001)</a:t>
+              <a:t>Caso único: a escola de Pipa (YIN, 2001)</a:t>
             </a:r>
             <a:endParaRPr lang="pt-BR" sz="2030" dirty="0"/>
           </a:p>
@@ -15771,7 +15795,7 @@
                 <a:cs typeface="Canva Sans"/>
                 <a:sym typeface="Canva Sans"/>
               </a:rPr>
-              <a:t>Funil: da rede e do território municipal à escola</a:t>
+              <a:t>Percurso em funil: território municipal, documentos da SME, Pipa e a escola</a:t>
             </a:r>
             <a:endParaRPr lang="pt-BR" sz="2030" dirty="0"/>
           </a:p>
@@ -22954,7 +22978,7 @@
                 <a:cs typeface="Canva Sans"/>
                 <a:sym typeface="Canva Sans"/>
               </a:rPr>
-              <a:t> a tradução municipal da PNED considera essas diferenças?</a:t>
+              <a:t> a tradução municipal da PNED considera essas diferenças? O que chega a Pipa?</a:t>
             </a:r>
             <a:endParaRPr lang="pt-BR" sz="2392" dirty="0"/>
           </a:p>

</xml_diff>

<commit_message>
Refaz o slide 21: educação digital na lei, o que é inegociável e com que meios
Co-Authored-By: Claude Opus 5.5 <noreply@anthropic.com>
Claude-Session: https://claude.ai/code/session_01HxStpW4pQoDfJdTDYr6zEC
</commit_message>
<xml_diff>
--- a/apresentacao_qualificacao/Qualificacao_PNED_Pipa.pptx
+++ b/apresentacao_qualificacao/Qualificacao_PNED_Pipa.pptx
@@ -21306,7 +21306,7 @@
         </p:nvSpPr>
         <p:spPr>
           <a:xfrm>
-            <a:off x="1908000" y="1512000"/>
+            <a:off x="1908000" y="1296000"/>
             <a:ext cx="9000000" cy="2880000"/>
           </a:xfrm>
           <a:prstGeom prst="rect">
@@ -21383,8 +21383,8 @@
         </p:nvSpPr>
         <p:spPr>
           <a:xfrm>
-            <a:off x="2664000" y="5544000"/>
-            <a:ext cx="5760000" cy="4608000"/>
+            <a:off x="2664000" y="5364000"/>
+            <a:ext cx="6048000" cy="4824000"/>
           </a:xfrm>
           <a:prstGeom prst="rect">
             <a:avLst/>
@@ -21410,7 +21410,7 @@
               <a:buNone/>
             </a:pPr>
             <a:r>
-              <a:rPr lang="pt-BR" sz="2755" b="1" dirty="0">
+              <a:rPr lang="pt-BR" sz="2392" b="1" dirty="0">
                 <a:solidFill>
                   <a:srgbClr val="111111"/>
                 </a:solidFill>
@@ -21419,9 +21419,63 @@
                 <a:cs typeface="Canva Sans Bold"/>
                 <a:sym typeface="Canva Sans Bold"/>
               </a:rPr>
-              <a:t>O que a lei exige</a:t>
-            </a:r>
-            <a:endParaRPr lang="pt-BR" sz="2755" dirty="0"/>
+              <a:t>Educação digital, para a lei</a:t>
+            </a:r>
+            <a:endParaRPr lang="pt-BR" sz="2392" dirty="0"/>
+          </a:p>
+          <a:p>
+            <a:pPr algn="l">
+              <a:lnSpc>
+                <a:spcPct val="100000"/>
+              </a:lnSpc>
+              <a:spcBef>
+                <a:spcPts val="0"/>
+              </a:spcBef>
+              <a:spcAft>
+                <a:spcPts val="869"/>
+              </a:spcAft>
+              <a:buNone/>
+            </a:pPr>
+            <a:r>
+              <a:rPr lang="pt-BR" sz="1885" dirty="0">
+                <a:solidFill>
+                  <a:srgbClr val="111111"/>
+                </a:solidFill>
+                <a:latin typeface="Canva Sans"/>
+                <a:ea typeface="Canva Sans"/>
+                <a:cs typeface="Canva Sans"/>
+                <a:sym typeface="Canva Sans"/>
+              </a:rPr>
+              <a:t>Letramento digital e informacional e aprendizagem de computação, programação, robótica e outras competências digitais, em todos os níveis e modalidades (art. 3º)</a:t>
+            </a:r>
+            <a:endParaRPr lang="pt-BR" sz="1885" dirty="0"/>
+          </a:p>
+          <a:p>
+            <a:pPr algn="l">
+              <a:lnSpc>
+                <a:spcPct val="100000"/>
+              </a:lnSpc>
+              <a:spcBef>
+                <a:spcPts val="0"/>
+              </a:spcBef>
+              <a:spcAft>
+                <a:spcPts val="725"/>
+              </a:spcAft>
+              <a:buNone/>
+            </a:pPr>
+            <a:r>
+              <a:rPr lang="pt-BR" sz="2392" b="1" dirty="0">
+                <a:solidFill>
+                  <a:srgbClr val="111111"/>
+                </a:solidFill>
+                <a:latin typeface="Canva Sans Bold"/>
+                <a:ea typeface="Canva Sans Bold"/>
+                <a:cs typeface="Canva Sans Bold"/>
+                <a:sym typeface="Canva Sans Bold"/>
+              </a:rPr>
+              <a:t>O que é inegociável</a:t>
+            </a:r>
+            <a:endParaRPr lang="pt-BR" sz="2392" dirty="0"/>
           </a:p>
           <a:p>
             <a:pPr algn="l" marL="270000" indent="-270000">
@@ -21442,7 +21496,7 @@
               <a:buChar char="•"/>
             </a:pPr>
             <a:r>
-              <a:rPr lang="pt-BR" sz="2102" dirty="0">
+              <a:rPr lang="pt-BR" sz="1885" dirty="0">
                 <a:solidFill>
                   <a:srgbClr val="111111"/>
                 </a:solidFill>
@@ -21451,9 +21505,9 @@
                 <a:cs typeface="Canva Sans"/>
                 <a:sym typeface="Canva Sans"/>
               </a:rPr>
-              <a:t>Componente curricular obrigatório no ensino fundamental, após a derrubada do veto</a:t>
-            </a:r>
-            <a:endParaRPr lang="pt-BR" sz="2102" dirty="0"/>
+              <a:t>Componente curricular obrigatório no ensino fundamental, após a derrubada do veto (dez. 2023)</a:t>
+            </a:r>
+            <a:endParaRPr lang="pt-BR" sz="1885" dirty="0"/>
           </a:p>
           <a:p>
             <a:pPr algn="l" marL="270000" indent="-270000">
@@ -21474,7 +21528,7 @@
               <a:buChar char="•"/>
             </a:pPr>
             <a:r>
-              <a:rPr lang="pt-BR" sz="2102" dirty="0">
+              <a:rPr lang="pt-BR" sz="1885" dirty="0">
                 <a:solidFill>
                   <a:srgbClr val="111111"/>
                 </a:solidFill>
@@ -21483,9 +21537,9 @@
                 <a:cs typeface="Canva Sans"/>
                 <a:sym typeface="Canva Sans"/>
               </a:rPr>
-              <a:t>Implementação curricular a partir de 2026 (Res. CNE/CEB nº 2/2025, art. 36)</a:t>
-            </a:r>
-            <a:endParaRPr lang="pt-BR" sz="2102" dirty="0"/>
+              <a:t>Dever do Estado, com conectividade garantida às escolas públicas (LDB, art. 4º, XII)</a:t>
+            </a:r>
+            <a:endParaRPr lang="pt-BR" sz="1885" dirty="0"/>
           </a:p>
           <a:p>
             <a:pPr algn="l" marL="270000" indent="-270000">
@@ -21506,7 +21560,7 @@
               <a:buChar char="•"/>
             </a:pPr>
             <a:r>
-              <a:rPr lang="pt-BR" sz="2102" dirty="0">
+              <a:rPr lang="pt-BR" sz="1885" dirty="0">
                 <a:solidFill>
                   <a:srgbClr val="111111"/>
                 </a:solidFill>
@@ -21515,9 +21569,9 @@
                 <a:cs typeface="Canva Sans"/>
                 <a:sym typeface="Canva Sans"/>
               </a:rPr>
-              <a:t>Formação tratada como ação de promoção</a:t>
-            </a:r>
-            <a:endParaRPr lang="pt-BR" sz="2102" dirty="0"/>
+              <a:t>Currículos implementados a partir de 2026 (Res. CNE/CEB nº 2/2025, art. 36)</a:t>
+            </a:r>
+            <a:endParaRPr lang="pt-BR" sz="1885" dirty="0"/>
           </a:p>
         </p:txBody>
       </p:sp>
@@ -21529,8 +21583,8 @@
         </p:nvSpPr>
         <p:spPr>
           <a:xfrm>
-            <a:off x="10152000" y="5544000"/>
-            <a:ext cx="5760000" cy="4608000"/>
+            <a:off x="9792000" y="5364000"/>
+            <a:ext cx="6264000" cy="4824000"/>
           </a:xfrm>
           <a:prstGeom prst="rect">
             <a:avLst/>
@@ -21556,7 +21610,7 @@
               <a:buNone/>
             </a:pPr>
             <a:r>
-              <a:rPr lang="pt-BR" sz="2755" b="1" dirty="0">
+              <a:rPr lang="pt-BR" sz="2392" b="1" dirty="0">
                 <a:solidFill>
                   <a:srgbClr val="111111"/>
                 </a:solidFill>
@@ -21567,7 +21621,7 @@
               </a:rPr>
               <a:t>Com que meios</a:t>
             </a:r>
-            <a:endParaRPr lang="pt-BR" sz="2755" dirty="0"/>
+            <a:endParaRPr lang="pt-BR" sz="2392" dirty="0"/>
           </a:p>
           <a:p>
             <a:pPr algn="l" marL="270000" indent="-270000">
@@ -21588,7 +21642,7 @@
               <a:buChar char="•"/>
             </a:pPr>
             <a:r>
-              <a:rPr lang="pt-BR" sz="2102" dirty="0">
+              <a:rPr lang="pt-BR" sz="1885" dirty="0">
                 <a:solidFill>
                   <a:srgbClr val="111111"/>
                 </a:solidFill>
@@ -21597,9 +21651,9 @@
                 <a:cs typeface="Canva Sans"/>
                 <a:sym typeface="Canva Sans"/>
               </a:rPr>
-              <a:t>Inclusão digital “dentro dos limites orçamentários” de cada ente (art. 2º)</a:t>
-            </a:r>
-            <a:endParaRPr lang="pt-BR" sz="2102" dirty="0"/>
+              <a:t>Formação de professores e gestores como ação de promoção (art. 3º, § 1º, IX e X)</a:t>
+            </a:r>
+            <a:endParaRPr lang="pt-BR" sz="1885" dirty="0"/>
           </a:p>
           <a:p>
             <a:pPr algn="l" marL="270000" indent="-270000">
@@ -21620,7 +21674,7 @@
               <a:buChar char="•"/>
             </a:pPr>
             <a:r>
-              <a:rPr lang="pt-BR" sz="2102" dirty="0">
+              <a:rPr lang="pt-BR" sz="1885" dirty="0">
                 <a:solidFill>
                   <a:srgbClr val="111111"/>
                 </a:solidFill>
@@ -21629,9 +21683,9 @@
                 <a:cs typeface="Canva Sans"/>
                 <a:sym typeface="Canva Sans"/>
               </a:rPr>
-              <a:t>Art. 11: nenhum fundo próprio nem transferência obrigatória aos municípios</a:t>
-            </a:r>
-            <a:endParaRPr lang="pt-BR" sz="2102" dirty="0"/>
+              <a:t>Inclusão digital “dentro dos limites orçamentários” de cada ente (art. 2º)</a:t>
+            </a:r>
+            <a:endParaRPr lang="pt-BR" sz="1885" dirty="0"/>
           </a:p>
           <a:p>
             <a:pPr algn="l" marL="270000" indent="-270000">
@@ -21652,7 +21706,39 @@
               <a:buChar char="•"/>
             </a:pPr>
             <a:r>
-              <a:rPr lang="pt-BR" sz="2102" b="1" dirty="0">
+              <a:rPr lang="pt-BR" sz="1885" dirty="0">
+                <a:solidFill>
+                  <a:srgbClr val="111111"/>
+                </a:solidFill>
+                <a:latin typeface="Canva Sans"/>
+                <a:ea typeface="Canva Sans"/>
+                <a:cs typeface="Canva Sans"/>
+                <a:sym typeface="Canva Sans"/>
+              </a:rPr>
+              <a:t>Nenhum fundo próprio nem transferência obrigatória aos municípios (art. 11)</a:t>
+            </a:r>
+            <a:endParaRPr lang="pt-BR" sz="1885" dirty="0"/>
+          </a:p>
+          <a:p>
+            <a:pPr algn="l" marL="270000" indent="-270000">
+              <a:lnSpc>
+                <a:spcPct val="100000"/>
+              </a:lnSpc>
+              <a:spcBef>
+                <a:spcPts val="0"/>
+              </a:spcBef>
+              <a:spcAft>
+                <a:spcPts val="725"/>
+              </a:spcAft>
+              <a:buClr>
+                <a:srgbClr val="111111"/>
+              </a:buClr>
+              <a:buSzPct val="100000"/>
+              <a:buFont typeface="Arial"/>
+              <a:buChar char="•"/>
+            </a:pPr>
+            <a:r>
+              <a:rPr lang="pt-BR" sz="1885" b="1" dirty="0">
                 <a:solidFill>
                   <a:srgbClr val="111111"/>
                 </a:solidFill>
@@ -21664,7 +21750,7 @@
               <a:t>Vazio material:</a:t>
             </a:r>
             <a:r>
-              <a:rPr lang="pt-BR" sz="2102" dirty="0">
+              <a:rPr lang="pt-BR" sz="1885" dirty="0">
                 <a:solidFill>
                   <a:srgbClr val="111111"/>
                 </a:solidFill>
@@ -21673,9 +21759,9 @@
                 <a:cs typeface="Canva Sans"/>
                 <a:sym typeface="Canva Sans"/>
               </a:rPr>
-              <a:t> proposição a verificar no campo</a:t>
-            </a:r>
-            <a:endParaRPr lang="pt-BR" sz="2102" dirty="0"/>
+              <a:t> a obrigação tem data e os meios não; proposição a verificar no campo</a:t>
+            </a:r>
+            <a:endParaRPr lang="pt-BR" sz="1885" dirty="0"/>
           </a:p>
         </p:txBody>
       </p:sp>

</xml_diff>

<commit_message>
Recoloca os slides separados de Pipa e da escola com as fotografias antigas e da escola
Co-Authored-By: Claude Opus 5.5 <noreply@anthropic.com>
Claude-Session: https://claude.ai/code/session_01HxStpW4pQoDfJdTDYr6zEC
</commit_message>
<xml_diff>
--- a/apresentacao_qualificacao/Qualificacao_PNED_Pipa.pptx
+++ b/apresentacao_qualificacao/Qualificacao_PNED_Pipa.pptx
@@ -34,6 +34,7 @@
     <p:sldId id="293" r:id="rId46"/>
     <p:sldId id="294" r:id="rId47"/>
     <p:sldId id="295" r:id="rId48"/>
+    <p:sldId id="296" r:id="rId49"/>
   </p:sldIdLst>
   <p:sldSz cx="18288000" cy="10287000"/>
   <p:notesSz cx="6858000" cy="9144000"/>
@@ -23143,14 +23144,14 @@
       </p:sp>
       <p:sp>
         <p:nvSpPr>
-          <p:cNvPr name="Freeform 10" id="10"/>
+          <p:cNvPr name="Freeform 3" id="3"/>
           <p:cNvSpPr/>
           <p:nvPr/>
         </p:nvSpPr>
         <p:spPr>
-          <a:xfrm flipH="true" flipV="false" rot="0">
-            <a:off x="-703516" y="799557"/>
-            <a:ext cx="4559335" cy="4114800"/>
+          <a:xfrm flipH="false" flipV="false" rot="-559059">
+            <a:off x="14704686" y="-67215"/>
+            <a:ext cx="4178322" cy="5381913"/>
           </a:xfrm>
           <a:custGeom>
             <a:avLst/>
@@ -23159,21 +23160,21 @@
             <a:cxnLst/>
             <a:rect r="r" b="b" t="t" l="l"/>
             <a:pathLst>
-              <a:path h="4114800" w="4559335">
+              <a:path h="5381913" w="4178322">
                 <a:moveTo>
-                  <a:pt x="4559335" y="0"/>
+                  <a:pt x="0" y="0"/>
                 </a:moveTo>
                 <a:lnTo>
+                  <a:pt x="4178322" y="0"/>
+                </a:lnTo>
+                <a:lnTo>
+                  <a:pt x="4178322" y="5381913"/>
+                </a:lnTo>
+                <a:lnTo>
+                  <a:pt x="0" y="5381913"/>
+                </a:lnTo>
+                <a:lnTo>
                   <a:pt x="0" y="0"/>
-                </a:lnTo>
-                <a:lnTo>
-                  <a:pt x="0" y="4114800"/>
-                </a:lnTo>
-                <a:lnTo>
-                  <a:pt x="4559335" y="4114800"/>
-                </a:lnTo>
-                <a:lnTo>
-                  <a:pt x="4559335" y="0"/>
                 </a:lnTo>
                 <a:close/>
               </a:path>
@@ -23195,14 +23196,14 @@
       </p:sp>
       <p:sp>
         <p:nvSpPr>
-          <p:cNvPr name="Freeform 11" id="11"/>
+          <p:cNvPr name="Freeform 4" id="4"/>
           <p:cNvSpPr/>
           <p:nvPr/>
         </p:nvSpPr>
         <p:spPr>
-          <a:xfrm flipH="true" flipV="false" rot="0">
-            <a:off x="14917961" y="799557"/>
-            <a:ext cx="4032504" cy="4114800"/>
+          <a:xfrm flipH="false" flipV="false" rot="0">
+            <a:off x="-946807" y="-872400"/>
+            <a:ext cx="3951014" cy="2794445"/>
           </a:xfrm>
           <a:custGeom>
             <a:avLst/>
@@ -23211,21 +23212,21 @@
             <a:cxnLst/>
             <a:rect r="r" b="b" t="t" l="l"/>
             <a:pathLst>
-              <a:path h="4114800" w="4032504">
+              <a:path h="2794445" w="3951014">
                 <a:moveTo>
-                  <a:pt x="4032504" y="0"/>
+                  <a:pt x="0" y="0"/>
                 </a:moveTo>
                 <a:lnTo>
+                  <a:pt x="3951014" y="0"/>
+                </a:lnTo>
+                <a:lnTo>
+                  <a:pt x="3951014" y="2794445"/>
+                </a:lnTo>
+                <a:lnTo>
+                  <a:pt x="0" y="2794445"/>
+                </a:lnTo>
+                <a:lnTo>
                   <a:pt x="0" y="0"/>
-                </a:lnTo>
-                <a:lnTo>
-                  <a:pt x="0" y="4114800"/>
-                </a:lnTo>
-                <a:lnTo>
-                  <a:pt x="4032504" y="4114800"/>
-                </a:lnTo>
-                <a:lnTo>
-                  <a:pt x="4032504" y="0"/>
                 </a:lnTo>
                 <a:close/>
               </a:path>
@@ -23247,14 +23248,66 @@
       </p:sp>
       <p:sp>
         <p:nvSpPr>
+          <p:cNvPr name="Freeform 11" id="11"/>
+          <p:cNvSpPr/>
+          <p:nvPr/>
+        </p:nvSpPr>
+        <p:spPr>
+          <a:xfrm flipH="true" flipV="false" rot="0">
+            <a:off x="10722983" y="-369962"/>
+            <a:ext cx="4037087" cy="3222330"/>
+          </a:xfrm>
+          <a:custGeom>
+            <a:avLst/>
+            <a:gdLst/>
+            <a:ahLst/>
+            <a:cxnLst/>
+            <a:rect r="r" b="b" t="t" l="l"/>
+            <a:pathLst>
+              <a:path h="3222330" w="4037087">
+                <a:moveTo>
+                  <a:pt x="4037087" y="0"/>
+                </a:moveTo>
+                <a:lnTo>
+                  <a:pt x="0" y="0"/>
+                </a:lnTo>
+                <a:lnTo>
+                  <a:pt x="0" y="3222329"/>
+                </a:lnTo>
+                <a:lnTo>
+                  <a:pt x="4037087" y="3222329"/>
+                </a:lnTo>
+                <a:lnTo>
+                  <a:pt x="4037087" y="0"/>
+                </a:lnTo>
+                <a:close/>
+              </a:path>
+            </a:pathLst>
+          </a:custGeom>
+          <a:blipFill>
+            <a:blip r:embed="rId7">
+              <a:extLst>
+                <a:ext uri="{96DAC541-7B7A-43D3-8B79-37D633B846F1}">
+                  <asvg:svgBlip xmlns:asvg="http://schemas.microsoft.com/office/drawing/2016/SVG/main" r:embed="rId8"/>
+                </a:ext>
+              </a:extLst>
+            </a:blip>
+            <a:stretch>
+              <a:fillRect l="0" t="0" r="0" b="0"/>
+            </a:stretch>
+          </a:blipFill>
+        </p:spPr>
+      </p:sp>
+      <p:sp>
+        <p:nvSpPr>
           <p:cNvPr id="201" name="Título 201"/>
           <p:cNvSpPr txBox="1"/>
           <p:nvPr/>
         </p:nvSpPr>
         <p:spPr>
           <a:xfrm>
-            <a:off x="3888000" y="360000"/>
-            <a:ext cx="10512000" cy="2520000"/>
+            <a:off x="1908000" y="1296000"/>
+            <a:ext cx="9000000" cy="1584000"/>
           </a:xfrm>
           <a:prstGeom prst="rect">
             <a:avLst/>
@@ -23262,12 +23315,12 @@
           <a:noFill/>
         </p:spPr>
         <p:txBody>
-          <a:bodyPr wrap="square" lIns="0" tIns="0" rIns="0" bIns="0" anchor="ctr" rtlCol="0">
+          <a:bodyPr wrap="square" lIns="0" tIns="0" rIns="0" bIns="0" anchor="t" rtlCol="0">
             <a:noAutofit/>
           </a:bodyPr>
           <a:lstStyle/>
           <a:p>
-            <a:pPr algn="ctr">
+            <a:pPr algn="l">
               <a:lnSpc>
                 <a:spcPct val="88000"/>
               </a:lnSpc>
@@ -23280,7 +23333,7 @@
               <a:buNone/>
             </a:pPr>
             <a:r>
-              <a:rPr lang="pt-BR" sz="5000" b="1" dirty="0">
+              <a:rPr lang="pt-BR" sz="5200" b="1" dirty="0">
                 <a:solidFill>
                   <a:srgbClr val="FFFFFF"/>
                 </a:solidFill>
@@ -23289,12 +23342,12 @@
                 <a:cs typeface="Canva Sans Bold"/>
                 <a:sym typeface="Canva Sans Bold"/>
               </a:rPr>
-              <a:t>PIPA E A ESCOLA</a:t>
-            </a:r>
-            <a:endParaRPr lang="pt-BR" sz="5000" dirty="0"/>
-          </a:p>
-          <a:p>
-            <a:pPr algn="ctr">
+              <a:t>PIPA</a:t>
+            </a:r>
+            <a:endParaRPr lang="pt-BR" sz="5200" dirty="0"/>
+          </a:p>
+          <a:p>
+            <a:pPr algn="l">
               <a:lnSpc>
                 <a:spcPct val="95000"/>
               </a:lnSpc>
@@ -23307,7 +23360,7 @@
               <a:buNone/>
             </a:pPr>
             <a:r>
-              <a:rPr lang="pt-BR" sz="2800" dirty="0">
+              <a:rPr lang="pt-BR" sz="3000" dirty="0">
                 <a:solidFill>
                   <a:srgbClr val="FFFFFF"/>
                 </a:solidFill>
@@ -23316,9 +23369,9 @@
                 <a:cs typeface="Canva Sans"/>
                 <a:sym typeface="Canva Sans"/>
               </a:rPr>
-              <a:t>polo turístico lá fora, salas sem telas lá dentro</a:t>
-            </a:r>
-            <a:endParaRPr lang="pt-BR" sz="2800" dirty="0"/>
+              <a:t>de aldeia de pescadores a polo turístico</a:t>
+            </a:r>
+            <a:endParaRPr lang="pt-BR" sz="3000" dirty="0"/>
           </a:p>
         </p:txBody>
       </p:sp>
@@ -23330,8 +23383,8 @@
         </p:nvSpPr>
         <p:spPr>
           <a:xfrm>
-            <a:off x="3744000" y="2808000"/>
-            <a:ext cx="10800000" cy="1440000"/>
+            <a:off x="1908000" y="3024000"/>
+            <a:ext cx="9180000" cy="1800000"/>
           </a:xfrm>
           <a:prstGeom prst="rect">
             <a:avLst/>
@@ -23339,12 +23392,12 @@
           <a:noFill/>
         </p:spPr>
         <p:txBody>
-          <a:bodyPr wrap="square" lIns="0" tIns="0" rIns="0" bIns="0" anchor="ctr" rtlCol="0">
+          <a:bodyPr wrap="square" lIns="0" tIns="0" rIns="0" bIns="0" anchor="t" rtlCol="0">
             <a:noAutofit/>
           </a:bodyPr>
           <a:lstStyle/>
           <a:p>
-            <a:pPr algn="ctr">
+            <a:pPr algn="l">
               <a:lnSpc>
                 <a:spcPct val="105000"/>
               </a:lnSpc>
@@ -23357,7 +23410,7 @@
               <a:buNone/>
             </a:pPr>
             <a:r>
-              <a:rPr lang="pt-BR" sz="2175" dirty="0">
+              <a:rPr lang="pt-BR" sz="2030" dirty="0">
                 <a:solidFill>
                   <a:srgbClr val="FFFFFF"/>
                 </a:solidFill>
@@ -23366,31 +23419,31 @@
                 <a:cs typeface="Canva Sans"/>
                 <a:sym typeface="Canva Sans"/>
               </a:rPr>
-              <a:t>Vila de pescadores; surfistas desde os anos 1970; turismo internacional a partir dos anos 1990 (AIRES, 2012; ALVES, 2018). Hoje, pousadas, restaurantes e passeios vendidos pela internet.</a:t>
-            </a:r>
-            <a:endParaRPr lang="pt-BR" sz="2175" dirty="0"/>
+              <a:t>Comunidade agrícola e pesqueira nos anos 1970; surfistas desde meados da década; divulgação intensa nos anos 1990 (AIRES, 2012, p. 80-82). Hoje, pousadas, restaurantes e passeios vendidos pela internet.</a:t>
+            </a:r>
+            <a:endParaRPr lang="pt-BR" sz="2030" dirty="0"/>
           </a:p>
         </p:txBody>
       </p:sp>
       <p:pic>
         <p:nvPicPr>
-          <p:cNvPr id="203" name="Foto 203" descr="Vista aérea contemporânea de Pipa e sua orla turística"/>
+          <p:cNvPr id="203" name="Foto 203" descr="Construção artesanal de embarcação na antiga Pipa"/>
           <p:cNvPicPr>
             <a:picLocks noChangeAspect="1"/>
           </p:cNvPicPr>
           <p:nvPr/>
         </p:nvPicPr>
         <p:blipFill>
-          <a:blip r:embed="rId11"/>
-          <a:srcRect l="0" t="10063" r="0" b="10063"/>
+          <a:blip r:embed="rId13"/>
+          <a:srcRect l="0" t="60" r="0" b="60"/>
           <a:stretch>
             <a:fillRect/>
           </a:stretch>
         </p:blipFill>
         <p:spPr>
-          <a:xfrm rot="-72000">
-            <a:off x="936000" y="4680000"/>
-            <a:ext cx="5256000" cy="3096000"/>
+          <a:xfrm rot="-90000">
+            <a:off x="864000" y="5400000"/>
+            <a:ext cx="5112000" cy="3708000"/>
           </a:xfrm>
           <a:prstGeom prst="rect">
             <a:avLst/>
@@ -23411,10 +23464,10 @@
           <p:nvPr/>
         </p:nvPicPr>
         <p:blipFill>
-          <a:blip r:embed="rId12">
+          <a:blip r:embed="rId14">
             <a:extLst>
               <a:ext uri="{96DAC541-7B7A-43D3-8B79-37D633B846F1}">
-                <asvg:svgBlip xmlns:asvg="http://schemas.microsoft.com/office/drawing/2016/SVG/main" r:embed="rId13"/>
+                <asvg:svgBlip xmlns:asvg="http://schemas.microsoft.com/office/drawing/2016/SVG/main" r:embed="rId15"/>
               </a:ext>
             </a:extLst>
           </a:blip>
@@ -23424,7 +23477,7 @@
         </p:blipFill>
         <p:spPr>
           <a:xfrm>
-            <a:off x="3204000" y="4140000"/>
+            <a:off x="3060000" y="4860000"/>
             <a:ext cx="720000" cy="1152000"/>
           </a:xfrm>
           <a:prstGeom prst="rect">
@@ -23434,23 +23487,23 @@
       </p:pic>
       <p:pic>
         <p:nvPicPr>
-          <p:cNvPr id="205" name="Foto 205" descr="Laboratório de informática com equipamentos desligados"/>
+          <p:cNvPr id="205" name="Foto 205" descr="Grupo de surfistas com pranchas, abril de 1991"/>
           <p:cNvPicPr>
             <a:picLocks noChangeAspect="1"/>
           </p:cNvPicPr>
           <p:nvPr/>
         </p:nvPicPr>
         <p:blipFill>
-          <a:blip r:embed="rId14"/>
-          <a:srcRect l="2259" t="0" r="2259" b="0"/>
+          <a:blip r:embed="rId16"/>
+          <a:srcRect l="0" t="5" r="0" b="5"/>
           <a:stretch>
             <a:fillRect/>
           </a:stretch>
         </p:blipFill>
         <p:spPr>
-          <a:xfrm rot="60000">
-            <a:off x="6516000" y="4680000"/>
-            <a:ext cx="5256000" cy="3096000"/>
+          <a:xfrm rot="72000">
+            <a:off x="6624000" y="5400000"/>
+            <a:ext cx="4680000" cy="3708000"/>
           </a:xfrm>
           <a:prstGeom prst="rect">
             <a:avLst/>
@@ -23471,10 +23524,10 @@
           <p:nvPr/>
         </p:nvPicPr>
         <p:blipFill>
-          <a:blip r:embed="rId12">
+          <a:blip r:embed="rId14">
             <a:extLst>
               <a:ext uri="{96DAC541-7B7A-43D3-8B79-37D633B846F1}">
-                <asvg:svgBlip xmlns:asvg="http://schemas.microsoft.com/office/drawing/2016/SVG/main" r:embed="rId13"/>
+                <asvg:svgBlip xmlns:asvg="http://schemas.microsoft.com/office/drawing/2016/SVG/main" r:embed="rId15"/>
               </a:ext>
             </a:extLst>
           </a:blip>
@@ -23484,7 +23537,7 @@
         </p:blipFill>
         <p:spPr>
           <a:xfrm>
-            <a:off x="8784000" y="4140000"/>
+            <a:off x="8604000" y="4860000"/>
             <a:ext cx="720000" cy="1152000"/>
           </a:xfrm>
           <a:prstGeom prst="rect">
@@ -23494,23 +23547,23 @@
       </p:pic>
       <p:pic>
         <p:nvPicPr>
-          <p:cNvPr id="207" name="Foto 207" descr="Alfabeto móvel confeccionado artesanalmente"/>
+          <p:cNvPr id="207" name="Foto 207" descr="Vista aérea contemporânea de Pipa e sua orla turística"/>
           <p:cNvPicPr>
             <a:picLocks noChangeAspect="1"/>
           </p:cNvPicPr>
           <p:nvPr/>
         </p:nvPicPr>
         <p:blipFill>
-          <a:blip r:embed="rId15"/>
-          <a:srcRect l="2259" t="0" r="2259" b="0"/>
+          <a:blip r:embed="rId17"/>
+          <a:srcRect l="0" t="119" r="0" b="119"/>
           <a:stretch>
             <a:fillRect/>
           </a:stretch>
         </p:blipFill>
         <p:spPr>
           <a:xfrm rot="-60000">
-            <a:off x="12096000" y="4680000"/>
-            <a:ext cx="5256000" cy="3096000"/>
+            <a:off x="11952000" y="5400000"/>
+            <a:ext cx="5040000" cy="3708000"/>
           </a:xfrm>
           <a:prstGeom prst="rect">
             <a:avLst/>
@@ -23531,10 +23584,10 @@
           <p:nvPr/>
         </p:nvPicPr>
         <p:blipFill>
-          <a:blip r:embed="rId12">
+          <a:blip r:embed="rId14">
             <a:extLst>
               <a:ext uri="{96DAC541-7B7A-43D3-8B79-37D633B846F1}">
-                <asvg:svgBlip xmlns:asvg="http://schemas.microsoft.com/office/drawing/2016/SVG/main" r:embed="rId13"/>
+                <asvg:svgBlip xmlns:asvg="http://schemas.microsoft.com/office/drawing/2016/SVG/main" r:embed="rId15"/>
               </a:ext>
             </a:extLst>
           </a:blip>
@@ -23544,7 +23597,7 @@
         </p:blipFill>
         <p:spPr>
           <a:xfrm>
-            <a:off x="14364000" y="4140000"/>
+            <a:off x="14112000" y="4860000"/>
             <a:ext cx="720000" cy="1152000"/>
           </a:xfrm>
           <a:prstGeom prst="rect">
@@ -23560,8 +23613,8 @@
         </p:nvSpPr>
         <p:spPr>
           <a:xfrm>
-            <a:off x="936000" y="7884000"/>
-            <a:ext cx="5256000" cy="360000"/>
+            <a:off x="864000" y="9252000"/>
+            <a:ext cx="5112000" cy="360000"/>
           </a:xfrm>
           <a:prstGeom prst="rect">
             <a:avLst/>
@@ -23587,7 +23640,7 @@
               <a:buNone/>
             </a:pPr>
             <a:r>
-              <a:rPr lang="pt-BR" sz="1500" dirty="0">
+              <a:rPr lang="pt-BR" sz="1700" dirty="0">
                 <a:solidFill>
                   <a:srgbClr val="FFFFFF"/>
                 </a:solidFill>
@@ -23596,9 +23649,9 @@
                 <a:cs typeface="Canva Sans"/>
                 <a:sym typeface="Canva Sans"/>
               </a:rPr>
-              <a:t>Pipa hoje (Museu Digital de Pipa)</a:t>
-            </a:r>
-            <a:endParaRPr lang="pt-BR" sz="1500" dirty="0"/>
+              <a:t>Embarcação artesanal</a:t>
+            </a:r>
+            <a:endParaRPr lang="pt-BR" sz="1700" dirty="0"/>
           </a:p>
         </p:txBody>
       </p:sp>
@@ -23610,8 +23663,8 @@
         </p:nvSpPr>
         <p:spPr>
           <a:xfrm>
-            <a:off x="6516000" y="7884000"/>
-            <a:ext cx="5256000" cy="360000"/>
+            <a:off x="6624000" y="9252000"/>
+            <a:ext cx="4680000" cy="360000"/>
           </a:xfrm>
           <a:prstGeom prst="rect">
             <a:avLst/>
@@ -23637,7 +23690,7 @@
               <a:buNone/>
             </a:pPr>
             <a:r>
-              <a:rPr lang="pt-BR" sz="1500" dirty="0">
+              <a:rPr lang="pt-BR" sz="1700" dirty="0">
                 <a:solidFill>
                   <a:srgbClr val="FFFFFF"/>
                 </a:solidFill>
@@ -23646,9 +23699,9 @@
                 <a:cs typeface="Canva Sans"/>
                 <a:sym typeface="Canva Sans"/>
               </a:rPr>
-              <a:t>Laboratório de informática</a:t>
-            </a:r>
-            <a:endParaRPr lang="pt-BR" sz="1500" dirty="0"/>
+              <a:t>Surfistas, abril de 1991</a:t>
+            </a:r>
+            <a:endParaRPr lang="pt-BR" sz="1700" dirty="0"/>
           </a:p>
         </p:txBody>
       </p:sp>
@@ -23660,8 +23713,8 @@
         </p:nvSpPr>
         <p:spPr>
           <a:xfrm>
-            <a:off x="12096000" y="7884000"/>
-            <a:ext cx="5256000" cy="360000"/>
+            <a:off x="11952000" y="9252000"/>
+            <a:ext cx="5040000" cy="360000"/>
           </a:xfrm>
           <a:prstGeom prst="rect">
             <a:avLst/>
@@ -23687,7 +23740,7 @@
               <a:buNone/>
             </a:pPr>
             <a:r>
-              <a:rPr lang="pt-BR" sz="1500" dirty="0">
+              <a:rPr lang="pt-BR" sz="1700" dirty="0">
                 <a:solidFill>
                   <a:srgbClr val="FFFFFF"/>
                 </a:solidFill>
@@ -23696,9 +23749,9 @@
                 <a:cs typeface="Canva Sans"/>
                 <a:sym typeface="Canva Sans"/>
               </a:rPr>
-              <a:t>Alfabeto móvel feito à mão</a:t>
-            </a:r>
-            <a:endParaRPr lang="pt-BR" sz="1500" dirty="0"/>
+              <a:t>Vista aérea atual</a:t>
+            </a:r>
+            <a:endParaRPr lang="pt-BR" sz="1700" dirty="0"/>
           </a:p>
         </p:txBody>
       </p:sp>
@@ -23710,8 +23763,8 @@
         </p:nvSpPr>
         <p:spPr>
           <a:xfrm>
-            <a:off x="936000" y="8424000"/>
-            <a:ext cx="16416000" cy="1728000"/>
+            <a:off x="864000" y="9720000"/>
+            <a:ext cx="16128000" cy="324000"/>
           </a:xfrm>
           <a:prstGeom prst="rect">
             <a:avLst/>
@@ -23719,25 +23772,25 @@
           <a:noFill/>
         </p:spPr>
         <p:txBody>
-          <a:bodyPr wrap="square" lIns="0" tIns="0" rIns="0" bIns="0" anchor="ctr" rtlCol="0">
+          <a:bodyPr wrap="square" lIns="0" tIns="0" rIns="0" bIns="0" anchor="t" rtlCol="0">
             <a:noAutofit/>
           </a:bodyPr>
           <a:lstStyle/>
           <a:p>
             <a:pPr algn="ctr">
               <a:lnSpc>
-                <a:spcPct val="105000"/>
-              </a:lnSpc>
-              <a:spcBef>
-                <a:spcPts val="0"/>
-              </a:spcBef>
-              <a:spcAft>
-                <a:spcPts val="0"/>
-              </a:spcAft>
-              <a:buNone/>
-            </a:pPr>
-            <a:r>
-              <a:rPr lang="pt-BR" sz="2030" dirty="0">
+                <a:spcPct val="95000"/>
+              </a:lnSpc>
+              <a:spcBef>
+                <a:spcPts val="0"/>
+              </a:spcBef>
+              <a:spcAft>
+                <a:spcPts val="0"/>
+              </a:spcAft>
+              <a:buNone/>
+            </a:pPr>
+            <a:r>
+              <a:rPr lang="pt-BR" sz="1300" dirty="0">
                 <a:solidFill>
                   <a:srgbClr val="FFFFFF"/>
                 </a:solidFill>
@@ -23746,33 +23799,9 @@
                 <a:cs typeface="Canva Sans"/>
                 <a:sym typeface="Canva Sans"/>
               </a:rPr>
-              <a:t>Computadores adquiridos pela Prefeitura em 2022, segundo informação preliminar. </a:t>
-            </a:r>
-            <a:r>
-              <a:rPr lang="pt-BR" sz="2030" b="1" dirty="0">
-                <a:solidFill>
-                  <a:srgbClr val="FFFFFF"/>
-                </a:solidFill>
-                <a:latin typeface="Canva Sans Bold"/>
-                <a:ea typeface="Canva Sans Bold"/>
-                <a:cs typeface="Canva Sans Bold"/>
-                <a:sym typeface="Canva Sans Bold"/>
-              </a:rPr>
-              <a:t>Rugosidade tecnológica:</a:t>
-            </a:r>
-            <a:r>
-              <a:rPr lang="pt-BR" sz="2030" dirty="0">
-                <a:solidFill>
-                  <a:srgbClr val="FFFFFF"/>
-                </a:solidFill>
-                <a:latin typeface="Canva Sans"/>
-                <a:ea typeface="Canva Sans"/>
-                <a:cs typeface="Canva Sans"/>
-                <a:sym typeface="Canva Sans"/>
-              </a:rPr>
-              <a:t> a forma “permanece aguardando o próximo movimento dinâmico da sociedade” (SANTOS, 2012, p. 74-75). Fotografias da escola: Acervo da pesquisa (2026).</a:t>
-            </a:r>
-            <a:endParaRPr lang="pt-BR" sz="2030" dirty="0"/>
+              <a:t>Fotografias: Museu Digital de Pipa / Acervo da pesquisa (2026).</a:t>
+            </a:r>
+            <a:endParaRPr lang="pt-BR" sz="1300" dirty="0"/>
           </a:p>
         </p:txBody>
       </p:sp>
@@ -23849,14 +23878,14 @@
       </p:sp>
       <p:sp>
         <p:nvSpPr>
-          <p:cNvPr name="Freeform 3" id="3"/>
+          <p:cNvPr name="Freeform 10" id="10"/>
           <p:cNvSpPr/>
           <p:nvPr/>
         </p:nvSpPr>
         <p:spPr>
-          <a:xfrm flipH="false" flipV="false" rot="0">
-            <a:off x="14230662" y="5938221"/>
-            <a:ext cx="4545747" cy="4864126"/>
+          <a:xfrm flipH="true" flipV="false" rot="0">
+            <a:off x="-703516" y="799557"/>
+            <a:ext cx="4559335" cy="4114800"/>
           </a:xfrm>
           <a:custGeom>
             <a:avLst/>
@@ -23865,21 +23894,21 @@
             <a:cxnLst/>
             <a:rect r="r" b="b" t="t" l="l"/>
             <a:pathLst>
-              <a:path h="4864126" w="4545747">
+              <a:path h="4114800" w="4559335">
                 <a:moveTo>
+                  <a:pt x="4559335" y="0"/>
+                </a:moveTo>
+                <a:lnTo>
                   <a:pt x="0" y="0"/>
-                </a:moveTo>
-                <a:lnTo>
-                  <a:pt x="4545747" y="0"/>
-                </a:lnTo>
-                <a:lnTo>
-                  <a:pt x="4545747" y="4864126"/>
-                </a:lnTo>
-                <a:lnTo>
-                  <a:pt x="0" y="4864126"/>
-                </a:lnTo>
-                <a:lnTo>
-                  <a:pt x="0" y="0"/>
+                </a:lnTo>
+                <a:lnTo>
+                  <a:pt x="0" y="4114800"/>
+                </a:lnTo>
+                <a:lnTo>
+                  <a:pt x="4559335" y="4114800"/>
+                </a:lnTo>
+                <a:lnTo>
+                  <a:pt x="4559335" y="0"/>
                 </a:lnTo>
                 <a:close/>
               </a:path>
@@ -23901,14 +23930,14 @@
       </p:sp>
       <p:sp>
         <p:nvSpPr>
-          <p:cNvPr name="Freeform 4" id="4"/>
+          <p:cNvPr name="Freeform 11" id="11"/>
           <p:cNvSpPr/>
           <p:nvPr/>
         </p:nvSpPr>
         <p:spPr>
-          <a:xfrm flipH="false" flipV="false" rot="867707">
-            <a:off x="-1222503" y="-339746"/>
-            <a:ext cx="3978551" cy="4438545"/>
+          <a:xfrm flipH="true" flipV="false" rot="0">
+            <a:off x="14917961" y="799557"/>
+            <a:ext cx="4032504" cy="4114800"/>
           </a:xfrm>
           <a:custGeom>
             <a:avLst/>
@@ -23917,21 +23946,21 @@
             <a:cxnLst/>
             <a:rect r="r" b="b" t="t" l="l"/>
             <a:pathLst>
-              <a:path h="4438545" w="3978551">
+              <a:path h="4114800" w="4032504">
                 <a:moveTo>
+                  <a:pt x="4032504" y="0"/>
+                </a:moveTo>
+                <a:lnTo>
                   <a:pt x="0" y="0"/>
-                </a:moveTo>
-                <a:lnTo>
-                  <a:pt x="3978551" y="0"/>
-                </a:lnTo>
-                <a:lnTo>
-                  <a:pt x="3978551" y="4438546"/>
-                </a:lnTo>
-                <a:lnTo>
-                  <a:pt x="0" y="4438546"/>
-                </a:lnTo>
-                <a:lnTo>
-                  <a:pt x="0" y="0"/>
+                </a:lnTo>
+                <a:lnTo>
+                  <a:pt x="0" y="4114800"/>
+                </a:lnTo>
+                <a:lnTo>
+                  <a:pt x="4032504" y="4114800"/>
+                </a:lnTo>
+                <a:lnTo>
+                  <a:pt x="4032504" y="0"/>
                 </a:lnTo>
                 <a:close/>
               </a:path>
@@ -23953,118 +23982,14 @@
       </p:sp>
       <p:sp>
         <p:nvSpPr>
-          <p:cNvPr name="Freeform 5" id="5"/>
-          <p:cNvSpPr/>
-          <p:nvPr/>
-        </p:nvSpPr>
-        <p:spPr>
-          <a:xfrm flipH="false" flipV="false" rot="0">
-            <a:off x="14515924" y="-305796"/>
-            <a:ext cx="5081512" cy="4444014"/>
-          </a:xfrm>
-          <a:custGeom>
-            <a:avLst/>
-            <a:gdLst/>
-            <a:ahLst/>
-            <a:cxnLst/>
-            <a:rect r="r" b="b" t="t" l="l"/>
-            <a:pathLst>
-              <a:path h="4444014" w="5081512">
-                <a:moveTo>
-                  <a:pt x="0" y="0"/>
-                </a:moveTo>
-                <a:lnTo>
-                  <a:pt x="5081512" y="0"/>
-                </a:lnTo>
-                <a:lnTo>
-                  <a:pt x="5081512" y="4444014"/>
-                </a:lnTo>
-                <a:lnTo>
-                  <a:pt x="0" y="4444014"/>
-                </a:lnTo>
-                <a:lnTo>
-                  <a:pt x="0" y="0"/>
-                </a:lnTo>
-                <a:close/>
-              </a:path>
-            </a:pathLst>
-          </a:custGeom>
-          <a:blipFill>
-            <a:blip r:embed="rId7">
-              <a:extLst>
-                <a:ext uri="{96DAC541-7B7A-43D3-8B79-37D633B846F1}">
-                  <asvg:svgBlip xmlns:asvg="http://schemas.microsoft.com/office/drawing/2016/SVG/main" r:embed="rId8"/>
-                </a:ext>
-              </a:extLst>
-            </a:blip>
-            <a:stretch>
-              <a:fillRect l="0" t="0" r="0" b="0"/>
-            </a:stretch>
-          </a:blipFill>
-        </p:spPr>
-      </p:sp>
-      <p:sp>
-        <p:nvSpPr>
-          <p:cNvPr name="Freeform 13" id="13"/>
-          <p:cNvSpPr/>
-          <p:nvPr/>
-        </p:nvSpPr>
-        <p:spPr>
-          <a:xfrm flipH="false" flipV="false" rot="0">
-            <a:off x="335153" y="5501478"/>
-            <a:ext cx="4952068" cy="4989489"/>
-          </a:xfrm>
-          <a:custGeom>
-            <a:avLst/>
-            <a:gdLst/>
-            <a:ahLst/>
-            <a:cxnLst/>
-            <a:rect r="r" b="b" t="t" l="l"/>
-            <a:pathLst>
-              <a:path h="4989489" w="4952068">
-                <a:moveTo>
-                  <a:pt x="0" y="0"/>
-                </a:moveTo>
-                <a:lnTo>
-                  <a:pt x="4952068" y="0"/>
-                </a:lnTo>
-                <a:lnTo>
-                  <a:pt x="4952068" y="4989489"/>
-                </a:lnTo>
-                <a:lnTo>
-                  <a:pt x="0" y="4989489"/>
-                </a:lnTo>
-                <a:lnTo>
-                  <a:pt x="0" y="0"/>
-                </a:lnTo>
-                <a:close/>
-              </a:path>
-            </a:pathLst>
-          </a:custGeom>
-          <a:blipFill>
-            <a:blip r:embed="rId11">
-              <a:extLst>
-                <a:ext uri="{96DAC541-7B7A-43D3-8B79-37D633B846F1}">
-                  <asvg:svgBlip xmlns:asvg="http://schemas.microsoft.com/office/drawing/2016/SVG/main" r:embed="rId12"/>
-                </a:ext>
-              </a:extLst>
-            </a:blip>
-            <a:stretch>
-              <a:fillRect l="0" t="0" r="0" b="0"/>
-            </a:stretch>
-          </a:blipFill>
-        </p:spPr>
-      </p:sp>
-      <p:sp>
-        <p:nvSpPr>
-          <p:cNvPr id="201" name="Texto 201"/>
+          <p:cNvPr id="201" name="Título 201"/>
           <p:cNvSpPr txBox="1"/>
           <p:nvPr/>
         </p:nvSpPr>
         <p:spPr>
           <a:xfrm>
-            <a:off x="3240000" y="216000"/>
-            <a:ext cx="10584000" cy="2376000"/>
+            <a:off x="3888000" y="504000"/>
+            <a:ext cx="10512000" cy="2736000"/>
           </a:xfrm>
           <a:prstGeom prst="rect">
             <a:avLst/>
@@ -24072,25 +23997,25 @@
           <a:noFill/>
         </p:spPr>
         <p:txBody>
-          <a:bodyPr wrap="square" lIns="0" tIns="0" rIns="0" bIns="0" anchor="t" rtlCol="0">
+          <a:bodyPr wrap="square" lIns="0" tIns="0" rIns="0" bIns="0" anchor="ctr" rtlCol="0">
             <a:noAutofit/>
           </a:bodyPr>
           <a:lstStyle/>
           <a:p>
             <a:pPr algn="ctr">
               <a:lnSpc>
-                <a:spcPct val="100000"/>
-              </a:lnSpc>
-              <a:spcBef>
-                <a:spcPts val="0"/>
-              </a:spcBef>
-              <a:spcAft>
-                <a:spcPts val="300"/>
-              </a:spcAft>
-              <a:buNone/>
-            </a:pPr>
-            <a:r>
-              <a:rPr lang="pt-BR" sz="3000" b="1" dirty="0">
+                <a:spcPct val="88000"/>
+              </a:lnSpc>
+              <a:spcBef>
+                <a:spcPts val="0"/>
+              </a:spcBef>
+              <a:spcAft>
+                <a:spcPts val="0"/>
+              </a:spcAft>
+              <a:buNone/>
+            </a:pPr>
+            <a:r>
+              <a:rPr lang="pt-BR" sz="5600" b="1" dirty="0">
                 <a:solidFill>
                   <a:srgbClr val="FFFFFF"/>
                 </a:solidFill>
@@ -24099,52 +24024,25 @@
                 <a:cs typeface="Canva Sans Bold"/>
                 <a:sym typeface="Canva Sans Bold"/>
               </a:rPr>
-              <a:t>TESE DE PARTIDA</a:t>
-            </a:r>
-            <a:endParaRPr lang="pt-BR" sz="3000" dirty="0"/>
+              <a:t>A ESCOLA</a:t>
+            </a:r>
+            <a:endParaRPr lang="pt-BR" sz="5600" dirty="0"/>
           </a:p>
           <a:p>
             <a:pPr algn="ctr">
               <a:lnSpc>
-                <a:spcPct val="100000"/>
-              </a:lnSpc>
-              <a:spcBef>
-                <a:spcPts val="0"/>
-              </a:spcBef>
-              <a:spcAft>
-                <a:spcPts val="434"/>
-              </a:spcAft>
-              <a:buNone/>
-            </a:pPr>
-            <a:r>
-              <a:rPr lang="pt-BR" sz="2175" b="1" dirty="0">
-                <a:solidFill>
-                  <a:srgbClr val="FFFFFF"/>
-                </a:solidFill>
-                <a:latin typeface="Canva Sans Bold"/>
-                <a:ea typeface="Canva Sans Bold"/>
-                <a:cs typeface="Canva Sans Bold"/>
-                <a:sym typeface="Canva Sans Bold"/>
-              </a:rPr>
-              <a:t>A forma assumida pela PNED no cotidiano escolar resulta da relação entre o que ela prescreve, o que a rede municipal traduz e as condições sob as quais os profissionais precisam atuar.</a:t>
-            </a:r>
-            <a:endParaRPr lang="pt-BR" sz="2175" dirty="0"/>
-          </a:p>
-          <a:p>
-            <a:pPr algn="ctr">
-              <a:lnSpc>
-                <a:spcPct val="100000"/>
-              </a:lnSpc>
-              <a:spcBef>
-                <a:spcPts val="0"/>
-              </a:spcBef>
-              <a:spcAft>
-                <a:spcPts val="0"/>
-              </a:spcAft>
-              <a:buNone/>
-            </a:pPr>
-            <a:r>
-              <a:rPr lang="pt-BR" sz="1958" dirty="0">
+                <a:spcPct val="95000"/>
+              </a:lnSpc>
+              <a:spcBef>
+                <a:spcPts val="0"/>
+              </a:spcBef>
+              <a:spcAft>
+                <a:spcPts val="0"/>
+              </a:spcAft>
+              <a:buNone/>
+            </a:pPr>
+            <a:r>
+              <a:rPr lang="pt-BR" sz="3000" dirty="0">
                 <a:solidFill>
                   <a:srgbClr val="FFFFFF"/>
                 </a:solidFill>
@@ -24153,25 +24051,55 @@
                 <a:cs typeface="Canva Sans"/>
                 <a:sym typeface="Canva Sans"/>
               </a:rPr>
-              <a:t>Daí podem surgir da adesão à resistência, que permanece hipótese a examinar nos dados.</a:t>
-            </a:r>
-            <a:endParaRPr lang="pt-BR" sz="1958" dirty="0"/>
+              <a:t>laboratório desligado e salas sem telas</a:t>
+            </a:r>
+            <a:endParaRPr lang="pt-BR" sz="3000" dirty="0"/>
           </a:p>
         </p:txBody>
       </p:sp>
       <p:pic>
         <p:nvPicPr>
-          <p:cNvPr id="202" name="Moldura 202" descr=""/>
+          <p:cNvPr id="202" name="Foto 202" descr="Laboratório de informática com equipamentos desligados"/>
           <p:cNvPicPr>
             <a:picLocks noChangeAspect="1"/>
           </p:cNvPicPr>
           <p:nvPr/>
         </p:nvPicPr>
         <p:blipFill>
-          <a:blip r:embed="rId9">
+          <a:blip r:embed="rId11"/>
+          <a:srcRect l="0" t="70" r="0" b="70"/>
+          <a:stretch>
+            <a:fillRect/>
+          </a:stretch>
+        </p:blipFill>
+        <p:spPr>
+          <a:xfrm rot="-72000">
+            <a:off x="936000" y="5112000"/>
+            <a:ext cx="5256000" cy="2952000"/>
+          </a:xfrm>
+          <a:prstGeom prst="rect">
+            <a:avLst/>
+          </a:prstGeom>
+          <a:ln w="63500">
+            <a:solidFill>
+              <a:srgbClr val="111111"/>
+            </a:solidFill>
+          </a:ln>
+        </p:spPr>
+      </p:pic>
+      <p:pic>
+        <p:nvPicPr>
+          <p:cNvPr id="203" name="Tacha 203" descr=""/>
+          <p:cNvPicPr>
+            <a:picLocks noChangeAspect="1"/>
+          </p:cNvPicPr>
+          <p:nvPr/>
+        </p:nvPicPr>
+        <p:blipFill>
+          <a:blip r:embed="rId12">
             <a:extLst>
               <a:ext uri="{96DAC541-7B7A-43D3-8B79-37D633B846F1}">
-                <asvg:svgBlip xmlns:asvg="http://schemas.microsoft.com/office/drawing/2016/SVG/main" r:embed="rId10"/>
+                <asvg:svgBlip xmlns:asvg="http://schemas.microsoft.com/office/drawing/2016/SVG/main" r:embed="rId13"/>
               </a:ext>
             </a:extLst>
           </a:blip>
@@ -24181,104 +24109,57 @@
         </p:blipFill>
         <p:spPr>
           <a:xfrm>
-            <a:off x="1908000" y="2880000"/>
-            <a:ext cx="6912000" cy="3312000"/>
+            <a:off x="3204000" y="4572000"/>
+            <a:ext cx="720000" cy="1152000"/>
           </a:xfrm>
           <a:prstGeom prst="rect">
             <a:avLst/>
           </a:prstGeom>
         </p:spPr>
       </p:pic>
-      <p:sp>
-        <p:nvSpPr>
-          <p:cNvPr id="203" name="Texto 203"/>
-          <p:cNvSpPr txBox="1"/>
-          <p:nvPr/>
-        </p:nvSpPr>
-        <p:spPr>
-          <a:xfrm>
-            <a:off x="2530080" y="3674880"/>
-            <a:ext cx="5667840" cy="2053440"/>
-          </a:xfrm>
-          <a:prstGeom prst="rect">
-            <a:avLst/>
-          </a:prstGeom>
-          <a:noFill/>
-        </p:spPr>
-        <p:txBody>
-          <a:bodyPr wrap="square" lIns="0" tIns="0" rIns="0" bIns="0" anchor="ctr" rtlCol="0">
-            <a:noAutofit/>
-          </a:bodyPr>
-          <a:lstStyle/>
-          <a:p>
-            <a:pPr algn="ctr">
-              <a:lnSpc>
-                <a:spcPct val="100000"/>
-              </a:lnSpc>
-              <a:spcBef>
-                <a:spcPts val="0"/>
-              </a:spcBef>
-              <a:spcAft>
-                <a:spcPts val="580"/>
-              </a:spcAft>
-              <a:buNone/>
-            </a:pPr>
-            <a:r>
-              <a:rPr lang="pt-BR" sz="2755" b="1" dirty="0">
-                <a:solidFill>
-                  <a:srgbClr val="111111"/>
-                </a:solidFill>
-                <a:latin typeface="Canva Sans Bold"/>
-                <a:ea typeface="Canva Sans Bold"/>
-                <a:cs typeface="Canva Sans Bold"/>
-                <a:sym typeface="Canva Sans Bold"/>
-              </a:rPr>
-              <a:t>Habitar o digital</a:t>
-            </a:r>
-            <a:endParaRPr lang="pt-BR" sz="2755" dirty="0"/>
-          </a:p>
-          <a:p>
-            <a:pPr algn="ctr">
-              <a:lnSpc>
-                <a:spcPct val="100000"/>
-              </a:lnSpc>
-              <a:spcBef>
-                <a:spcPts val="0"/>
-              </a:spcBef>
-              <a:spcAft>
-                <a:spcPts val="0"/>
-              </a:spcAft>
-              <a:buNone/>
-            </a:pPr>
-            <a:r>
-              <a:rPr lang="pt-BR" sz="2030" dirty="0">
-                <a:solidFill>
-                  <a:srgbClr val="111111"/>
-                </a:solidFill>
-                <a:latin typeface="Canva Sans"/>
-                <a:ea typeface="Canva Sans"/>
-                <a:cs typeface="Canva Sans"/>
-                <a:sym typeface="Canva Sans"/>
-              </a:rPr>
-              <a:t>Quem consegue habitar o digital, em que condições e com quais possibilidades de participação</a:t>
-            </a:r>
-            <a:endParaRPr lang="pt-BR" sz="2030" dirty="0"/>
-          </a:p>
-        </p:txBody>
-      </p:sp>
       <p:pic>
         <p:nvPicPr>
-          <p:cNvPr id="204" name="Tacha 204" descr=""/>
+          <p:cNvPr id="204" name="Foto 204" descr="Sala de aula dos primeiros anos"/>
           <p:cNvPicPr>
             <a:picLocks noChangeAspect="1"/>
           </p:cNvPicPr>
           <p:nvPr/>
         </p:nvPicPr>
         <p:blipFill>
-          <a:blip r:embed="rId13">
+          <a:blip r:embed="rId14"/>
+          <a:srcRect l="0" t="70" r="0" b="70"/>
+          <a:stretch>
+            <a:fillRect/>
+          </a:stretch>
+        </p:blipFill>
+        <p:spPr>
+          <a:xfrm rot="60000">
+            <a:off x="6516000" y="5112000"/>
+            <a:ext cx="5256000" cy="2952000"/>
+          </a:xfrm>
+          <a:prstGeom prst="rect">
+            <a:avLst/>
+          </a:prstGeom>
+          <a:ln w="63500">
+            <a:solidFill>
+              <a:srgbClr val="111111"/>
+            </a:solidFill>
+          </a:ln>
+        </p:spPr>
+      </p:pic>
+      <p:pic>
+        <p:nvPicPr>
+          <p:cNvPr id="205" name="Tacha 205" descr=""/>
+          <p:cNvPicPr>
+            <a:picLocks noChangeAspect="1"/>
+          </p:cNvPicPr>
+          <p:nvPr/>
+        </p:nvPicPr>
+        <p:blipFill>
+          <a:blip r:embed="rId12">
             <a:extLst>
               <a:ext uri="{96DAC541-7B7A-43D3-8B79-37D633B846F1}">
-                <asvg:svgBlip xmlns:asvg="http://schemas.microsoft.com/office/drawing/2016/SVG/main" r:embed="rId14"/>
+                <asvg:svgBlip xmlns:asvg="http://schemas.microsoft.com/office/drawing/2016/SVG/main" r:embed="rId13"/>
               </a:ext>
             </a:extLst>
           </a:blip>
@@ -24288,8 +24169,8 @@
         </p:blipFill>
         <p:spPr>
           <a:xfrm>
-            <a:off x="4950000" y="2304000"/>
-            <a:ext cx="828000" cy="1332000"/>
+            <a:off x="8784000" y="4572000"/>
+            <a:ext cx="720000" cy="1152000"/>
           </a:xfrm>
           <a:prstGeom prst="rect">
             <a:avLst/>
@@ -24298,17 +24179,47 @@
       </p:pic>
       <p:pic>
         <p:nvPicPr>
-          <p:cNvPr id="205" name="Moldura 205" descr=""/>
+          <p:cNvPr id="206" name="Foto 206" descr="Alfabeto móvel confeccionado artesanalmente"/>
           <p:cNvPicPr>
             <a:picLocks noChangeAspect="1"/>
           </p:cNvPicPr>
           <p:nvPr/>
         </p:nvPicPr>
         <p:blipFill>
-          <a:blip r:embed="rId9">
+          <a:blip r:embed="rId15"/>
+          <a:srcRect l="0" t="70" r="0" b="70"/>
+          <a:stretch>
+            <a:fillRect/>
+          </a:stretch>
+        </p:blipFill>
+        <p:spPr>
+          <a:xfrm rot="-60000">
+            <a:off x="12096000" y="5112000"/>
+            <a:ext cx="5256000" cy="2952000"/>
+          </a:xfrm>
+          <a:prstGeom prst="rect">
+            <a:avLst/>
+          </a:prstGeom>
+          <a:ln w="63500">
+            <a:solidFill>
+              <a:srgbClr val="111111"/>
+            </a:solidFill>
+          </a:ln>
+        </p:spPr>
+      </p:pic>
+      <p:pic>
+        <p:nvPicPr>
+          <p:cNvPr id="207" name="Tacha 207" descr=""/>
+          <p:cNvPicPr>
+            <a:picLocks noChangeAspect="1"/>
+          </p:cNvPicPr>
+          <p:nvPr/>
+        </p:nvPicPr>
+        <p:blipFill>
+          <a:blip r:embed="rId12">
             <a:extLst>
               <a:ext uri="{96DAC541-7B7A-43D3-8B79-37D633B846F1}">
-                <asvg:svgBlip xmlns:asvg="http://schemas.microsoft.com/office/drawing/2016/SVG/main" r:embed="rId10"/>
+                <asvg:svgBlip xmlns:asvg="http://schemas.microsoft.com/office/drawing/2016/SVG/main" r:embed="rId13"/>
               </a:ext>
             </a:extLst>
           </a:blip>
@@ -24318,8 +24229,8 @@
         </p:blipFill>
         <p:spPr>
           <a:xfrm>
-            <a:off x="9468000" y="2880000"/>
-            <a:ext cx="6912000" cy="3312000"/>
+            <a:off x="14364000" y="4572000"/>
+            <a:ext cx="720000" cy="1152000"/>
           </a:xfrm>
           <a:prstGeom prst="rect">
             <a:avLst/>
@@ -24328,14 +24239,164 @@
       </p:pic>
       <p:sp>
         <p:nvSpPr>
-          <p:cNvPr id="206" name="Texto 206"/>
+          <p:cNvPr id="208" name="Texto 208"/>
           <p:cNvSpPr txBox="1"/>
           <p:nvPr/>
         </p:nvSpPr>
         <p:spPr>
           <a:xfrm>
-            <a:off x="10090080" y="3674880"/>
-            <a:ext cx="5667840" cy="2053440"/>
+            <a:off x="936000" y="8172000"/>
+            <a:ext cx="5256000" cy="360000"/>
+          </a:xfrm>
+          <a:prstGeom prst="rect">
+            <a:avLst/>
+          </a:prstGeom>
+          <a:noFill/>
+        </p:spPr>
+        <p:txBody>
+          <a:bodyPr wrap="square" lIns="0" tIns="0" rIns="0" bIns="0" anchor="t" rtlCol="0">
+            <a:noAutofit/>
+          </a:bodyPr>
+          <a:lstStyle/>
+          <a:p>
+            <a:pPr algn="ctr">
+              <a:lnSpc>
+                <a:spcPct val="95000"/>
+              </a:lnSpc>
+              <a:spcBef>
+                <a:spcPts val="0"/>
+              </a:spcBef>
+              <a:spcAft>
+                <a:spcPts val="0"/>
+              </a:spcAft>
+              <a:buNone/>
+            </a:pPr>
+            <a:r>
+              <a:rPr lang="pt-BR" sz="1700" dirty="0">
+                <a:solidFill>
+                  <a:srgbClr val="FFFFFF"/>
+                </a:solidFill>
+                <a:latin typeface="Canva Sans"/>
+                <a:ea typeface="Canva Sans"/>
+                <a:cs typeface="Canva Sans"/>
+                <a:sym typeface="Canva Sans"/>
+              </a:rPr>
+              <a:t>Laboratório de informática</a:t>
+            </a:r>
+            <a:endParaRPr lang="pt-BR" sz="1700" dirty="0"/>
+          </a:p>
+        </p:txBody>
+      </p:sp>
+      <p:sp>
+        <p:nvSpPr>
+          <p:cNvPr id="209" name="Texto 209"/>
+          <p:cNvSpPr txBox="1"/>
+          <p:nvPr/>
+        </p:nvSpPr>
+        <p:spPr>
+          <a:xfrm>
+            <a:off x="6516000" y="8172000"/>
+            <a:ext cx="5256000" cy="360000"/>
+          </a:xfrm>
+          <a:prstGeom prst="rect">
+            <a:avLst/>
+          </a:prstGeom>
+          <a:noFill/>
+        </p:spPr>
+        <p:txBody>
+          <a:bodyPr wrap="square" lIns="0" tIns="0" rIns="0" bIns="0" anchor="t" rtlCol="0">
+            <a:noAutofit/>
+          </a:bodyPr>
+          <a:lstStyle/>
+          <a:p>
+            <a:pPr algn="ctr">
+              <a:lnSpc>
+                <a:spcPct val="95000"/>
+              </a:lnSpc>
+              <a:spcBef>
+                <a:spcPts val="0"/>
+              </a:spcBef>
+              <a:spcAft>
+                <a:spcPts val="0"/>
+              </a:spcAft>
+              <a:buNone/>
+            </a:pPr>
+            <a:r>
+              <a:rPr lang="pt-BR" sz="1700" dirty="0">
+                <a:solidFill>
+                  <a:srgbClr val="FFFFFF"/>
+                </a:solidFill>
+                <a:latin typeface="Canva Sans"/>
+                <a:ea typeface="Canva Sans"/>
+                <a:cs typeface="Canva Sans"/>
+                <a:sym typeface="Canva Sans"/>
+              </a:rPr>
+              <a:t>Sala dos primeiros anos</a:t>
+            </a:r>
+            <a:endParaRPr lang="pt-BR" sz="1700" dirty="0"/>
+          </a:p>
+        </p:txBody>
+      </p:sp>
+      <p:sp>
+        <p:nvSpPr>
+          <p:cNvPr id="210" name="Texto 210"/>
+          <p:cNvSpPr txBox="1"/>
+          <p:nvPr/>
+        </p:nvSpPr>
+        <p:spPr>
+          <a:xfrm>
+            <a:off x="12096000" y="8172000"/>
+            <a:ext cx="5256000" cy="360000"/>
+          </a:xfrm>
+          <a:prstGeom prst="rect">
+            <a:avLst/>
+          </a:prstGeom>
+          <a:noFill/>
+        </p:spPr>
+        <p:txBody>
+          <a:bodyPr wrap="square" lIns="0" tIns="0" rIns="0" bIns="0" anchor="t" rtlCol="0">
+            <a:noAutofit/>
+          </a:bodyPr>
+          <a:lstStyle/>
+          <a:p>
+            <a:pPr algn="ctr">
+              <a:lnSpc>
+                <a:spcPct val="95000"/>
+              </a:lnSpc>
+              <a:spcBef>
+                <a:spcPts val="0"/>
+              </a:spcBef>
+              <a:spcAft>
+                <a:spcPts val="0"/>
+              </a:spcAft>
+              <a:buNone/>
+            </a:pPr>
+            <a:r>
+              <a:rPr lang="pt-BR" sz="1700" dirty="0">
+                <a:solidFill>
+                  <a:srgbClr val="FFFFFF"/>
+                </a:solidFill>
+                <a:latin typeface="Canva Sans"/>
+                <a:ea typeface="Canva Sans"/>
+                <a:cs typeface="Canva Sans"/>
+                <a:sym typeface="Canva Sans"/>
+              </a:rPr>
+              <a:t>Alfabeto móvel feito à mão</a:t>
+            </a:r>
+            <a:endParaRPr lang="pt-BR" sz="1700" dirty="0"/>
+          </a:p>
+        </p:txBody>
+      </p:sp>
+      <p:sp>
+        <p:nvSpPr>
+          <p:cNvPr id="211" name="Texto 211"/>
+          <p:cNvSpPr txBox="1"/>
+          <p:nvPr/>
+        </p:nvSpPr>
+        <p:spPr>
+          <a:xfrm>
+            <a:off x="936000" y="8640000"/>
+            <a:ext cx="16416000" cy="1584000"/>
           </a:xfrm>
           <a:prstGeom prst="rect">
             <a:avLst/>
@@ -24350,226 +24411,56 @@
           <a:p>
             <a:pPr algn="ctr">
               <a:lnSpc>
-                <a:spcPct val="100000"/>
-              </a:lnSpc>
-              <a:spcBef>
-                <a:spcPts val="0"/>
-              </a:spcBef>
-              <a:spcAft>
-                <a:spcPts val="580"/>
-              </a:spcAft>
-              <a:buNone/>
-            </a:pPr>
-            <a:r>
-              <a:rPr lang="pt-BR" sz="2755" b="1" dirty="0">
-                <a:solidFill>
-                  <a:srgbClr val="111111"/>
+                <a:spcPct val="105000"/>
+              </a:lnSpc>
+              <a:spcBef>
+                <a:spcPts val="0"/>
+              </a:spcBef>
+              <a:spcAft>
+                <a:spcPts val="0"/>
+              </a:spcAft>
+              <a:buNone/>
+            </a:pPr>
+            <a:r>
+              <a:rPr lang="pt-BR" sz="2030" dirty="0">
+                <a:solidFill>
+                  <a:srgbClr val="FFFFFF"/>
+                </a:solidFill>
+                <a:latin typeface="Canva Sans"/>
+                <a:ea typeface="Canva Sans"/>
+                <a:cs typeface="Canva Sans"/>
+                <a:sym typeface="Canva Sans"/>
+              </a:rPr>
+              <a:t>Computadores adquiridos pela Prefeitura em 2022, segundo informação preliminar a confirmar. </a:t>
+            </a:r>
+            <a:r>
+              <a:rPr lang="pt-BR" sz="2030" b="1" dirty="0">
+                <a:solidFill>
+                  <a:srgbClr val="FFFFFF"/>
                 </a:solidFill>
                 <a:latin typeface="Canva Sans Bold"/>
                 <a:ea typeface="Canva Sans Bold"/>
                 <a:cs typeface="Canva Sans Bold"/>
                 <a:sym typeface="Canva Sans Bold"/>
               </a:rPr>
-              <a:t>Rugosidade tecnológica</a:t>
-            </a:r>
-            <a:endParaRPr lang="pt-BR" sz="2755" dirty="0"/>
-          </a:p>
-          <a:p>
-            <a:pPr algn="ctr">
-              <a:lnSpc>
-                <a:spcPct val="100000"/>
-              </a:lnSpc>
-              <a:spcBef>
-                <a:spcPts val="0"/>
-              </a:spcBef>
-              <a:spcAft>
-                <a:spcPts val="0"/>
-              </a:spcAft>
-              <a:buNone/>
-            </a:pPr>
+              <a:t>Rugosidade tecnológica:</a:t>
+            </a:r>
             <a:r>
               <a:rPr lang="pt-BR" sz="2030" dirty="0">
                 <a:solidFill>
-                  <a:srgbClr val="111111"/>
+                  <a:srgbClr val="FFFFFF"/>
                 </a:solidFill>
                 <a:latin typeface="Canva Sans"/>
                 <a:ea typeface="Canva Sans"/>
                 <a:cs typeface="Canva Sans"/>
                 <a:sym typeface="Canva Sans"/>
               </a:rPr>
-              <a:t>Equipamentos de 2022, anteriores à lei, chamados a cumprir nova função (com SANTOS, 2012)</a:t>
+              <a:t> a forma “permanece aguardando o próximo movimento dinâmico da sociedade” (SANTOS, 2012, p. 74-75). Fotografias: Acervo da pesquisa (2026).</a:t>
             </a:r>
             <a:endParaRPr lang="pt-BR" sz="2030" dirty="0"/>
           </a:p>
         </p:txBody>
       </p:sp>
-      <p:pic>
-        <p:nvPicPr>
-          <p:cNvPr id="207" name="Tacha 207" descr=""/>
-          <p:cNvPicPr>
-            <a:picLocks noChangeAspect="1"/>
-          </p:cNvPicPr>
-          <p:nvPr/>
-        </p:nvPicPr>
-        <p:blipFill>
-          <a:blip r:embed="rId13">
-            <a:extLst>
-              <a:ext uri="{96DAC541-7B7A-43D3-8B79-37D633B846F1}">
-                <asvg:svgBlip xmlns:asvg="http://schemas.microsoft.com/office/drawing/2016/SVG/main" r:embed="rId14"/>
-              </a:ext>
-            </a:extLst>
-          </a:blip>
-          <a:stretch>
-            <a:fillRect/>
-          </a:stretch>
-        </p:blipFill>
-        <p:spPr>
-          <a:xfrm>
-            <a:off x="12510000" y="2304000"/>
-            <a:ext cx="828000" cy="1332000"/>
-          </a:xfrm>
-          <a:prstGeom prst="rect">
-            <a:avLst/>
-          </a:prstGeom>
-        </p:spPr>
-      </p:pic>
-      <p:pic>
-        <p:nvPicPr>
-          <p:cNvPr id="208" name="Moldura 208" descr=""/>
-          <p:cNvPicPr>
-            <a:picLocks noChangeAspect="1"/>
-          </p:cNvPicPr>
-          <p:nvPr/>
-        </p:nvPicPr>
-        <p:blipFill>
-          <a:blip r:embed="rId9">
-            <a:extLst>
-              <a:ext uri="{96DAC541-7B7A-43D3-8B79-37D633B846F1}">
-                <asvg:svgBlip xmlns:asvg="http://schemas.microsoft.com/office/drawing/2016/SVG/main" r:embed="rId10"/>
-              </a:ext>
-            </a:extLst>
-          </a:blip>
-          <a:stretch>
-            <a:fillRect/>
-          </a:stretch>
-        </p:blipFill>
-        <p:spPr>
-          <a:xfrm>
-            <a:off x="5544000" y="6552000"/>
-            <a:ext cx="6912000" cy="3312000"/>
-          </a:xfrm>
-          <a:prstGeom prst="rect">
-            <a:avLst/>
-          </a:prstGeom>
-        </p:spPr>
-      </p:pic>
-      <p:sp>
-        <p:nvSpPr>
-          <p:cNvPr id="209" name="Texto 209"/>
-          <p:cNvSpPr txBox="1"/>
-          <p:nvPr/>
-        </p:nvSpPr>
-        <p:spPr>
-          <a:xfrm>
-            <a:off x="6166080" y="7346880"/>
-            <a:ext cx="5667840" cy="2053440"/>
-          </a:xfrm>
-          <a:prstGeom prst="rect">
-            <a:avLst/>
-          </a:prstGeom>
-          <a:noFill/>
-        </p:spPr>
-        <p:txBody>
-          <a:bodyPr wrap="square" lIns="0" tIns="0" rIns="0" bIns="0" anchor="ctr" rtlCol="0">
-            <a:noAutofit/>
-          </a:bodyPr>
-          <a:lstStyle/>
-          <a:p>
-            <a:pPr algn="ctr">
-              <a:lnSpc>
-                <a:spcPct val="100000"/>
-              </a:lnSpc>
-              <a:spcBef>
-                <a:spcPts val="0"/>
-              </a:spcBef>
-              <a:spcAft>
-                <a:spcPts val="580"/>
-              </a:spcAft>
-              <a:buNone/>
-            </a:pPr>
-            <a:r>
-              <a:rPr lang="pt-BR" sz="2755" b="1" dirty="0">
-                <a:solidFill>
-                  <a:srgbClr val="111111"/>
-                </a:solidFill>
-                <a:latin typeface="Canva Sans Bold"/>
-                <a:ea typeface="Canva Sans Bold"/>
-                <a:cs typeface="Canva Sans Bold"/>
-                <a:sym typeface="Canva Sans Bold"/>
-              </a:rPr>
-              <a:t>Vazio material</a:t>
-            </a:r>
-            <a:endParaRPr lang="pt-BR" sz="2755" dirty="0"/>
-          </a:p>
-          <a:p>
-            <a:pPr algn="ctr">
-              <a:lnSpc>
-                <a:spcPct val="100000"/>
-              </a:lnSpc>
-              <a:spcBef>
-                <a:spcPts val="0"/>
-              </a:spcBef>
-              <a:spcAft>
-                <a:spcPts val="0"/>
-              </a:spcAft>
-              <a:buNone/>
-            </a:pPr>
-            <a:r>
-              <a:rPr lang="pt-BR" sz="2030" dirty="0">
-                <a:solidFill>
-                  <a:srgbClr val="111111"/>
-                </a:solidFill>
-                <a:latin typeface="Canva Sans"/>
-                <a:ea typeface="Canva Sans"/>
-                <a:cs typeface="Canva Sans"/>
-                <a:sym typeface="Canva Sans"/>
-              </a:rPr>
-              <a:t>Exigência curricular com data marcada e meios sem mecanismo federativo obrigatório</a:t>
-            </a:r>
-            <a:endParaRPr lang="pt-BR" sz="2030" dirty="0"/>
-          </a:p>
-        </p:txBody>
-      </p:sp>
-      <p:pic>
-        <p:nvPicPr>
-          <p:cNvPr id="210" name="Tacha 210" descr=""/>
-          <p:cNvPicPr>
-            <a:picLocks noChangeAspect="1"/>
-          </p:cNvPicPr>
-          <p:nvPr/>
-        </p:nvPicPr>
-        <p:blipFill>
-          <a:blip r:embed="rId13">
-            <a:extLst>
-              <a:ext uri="{96DAC541-7B7A-43D3-8B79-37D633B846F1}">
-                <asvg:svgBlip xmlns:asvg="http://schemas.microsoft.com/office/drawing/2016/SVG/main" r:embed="rId14"/>
-              </a:ext>
-            </a:extLst>
-          </a:blip>
-          <a:stretch>
-            <a:fillRect/>
-          </a:stretch>
-        </p:blipFill>
-        <p:spPr>
-          <a:xfrm>
-            <a:off x="8586000" y="5976000"/>
-            <a:ext cx="828000" cy="1332000"/>
-          </a:xfrm>
-          <a:prstGeom prst="rect">
-            <a:avLst/>
-          </a:prstGeom>
-        </p:spPr>
-      </p:pic>
     </p:spTree>
   </p:cSld>
   <p:clrMapOvr>
@@ -24649,8 +24540,8 @@
         </p:nvSpPr>
         <p:spPr>
           <a:xfrm flipH="false" flipV="false" rot="0">
-            <a:off x="663870" y="389732"/>
-            <a:ext cx="7320803" cy="9507536"/>
+            <a:off x="14230662" y="5938221"/>
+            <a:ext cx="4545747" cy="4864126"/>
           </a:xfrm>
           <a:custGeom>
             <a:avLst/>
@@ -24659,18 +24550,18 @@
             <a:cxnLst/>
             <a:rect r="r" b="b" t="t" l="l"/>
             <a:pathLst>
-              <a:path h="9507536" w="7320803">
+              <a:path h="4864126" w="4545747">
                 <a:moveTo>
                   <a:pt x="0" y="0"/>
                 </a:moveTo>
                 <a:lnTo>
-                  <a:pt x="7320803" y="0"/>
-                </a:lnTo>
-                <a:lnTo>
-                  <a:pt x="7320803" y="9507536"/>
-                </a:lnTo>
-                <a:lnTo>
-                  <a:pt x="0" y="9507536"/>
+                  <a:pt x="4545747" y="0"/>
+                </a:lnTo>
+                <a:lnTo>
+                  <a:pt x="4545747" y="4864126"/>
+                </a:lnTo>
+                <a:lnTo>
+                  <a:pt x="0" y="4864126"/>
                 </a:lnTo>
                 <a:lnTo>
                   <a:pt x="0" y="0"/>
@@ -24700,9 +24591,9 @@
           <p:nvPr/>
         </p:nvSpPr>
         <p:spPr>
-          <a:xfrm flipH="false" flipV="false" rot="755837">
-            <a:off x="6716389" y="624673"/>
-            <a:ext cx="2536569" cy="3461819"/>
+          <a:xfrm flipH="false" flipV="false" rot="867707">
+            <a:off x="-1222503" y="-339746"/>
+            <a:ext cx="3978551" cy="4438545"/>
           </a:xfrm>
           <a:custGeom>
             <a:avLst/>
@@ -24711,18 +24602,18 @@
             <a:cxnLst/>
             <a:rect r="r" b="b" t="t" l="l"/>
             <a:pathLst>
-              <a:path h="3461819" w="2536569">
+              <a:path h="4438545" w="3978551">
                 <a:moveTo>
                   <a:pt x="0" y="0"/>
                 </a:moveTo>
                 <a:lnTo>
-                  <a:pt x="2536569" y="0"/>
-                </a:lnTo>
-                <a:lnTo>
-                  <a:pt x="2536569" y="3461819"/>
-                </a:lnTo>
-                <a:lnTo>
-                  <a:pt x="0" y="3461819"/>
+                  <a:pt x="3978551" y="0"/>
+                </a:lnTo>
+                <a:lnTo>
+                  <a:pt x="3978551" y="4438546"/>
+                </a:lnTo>
+                <a:lnTo>
+                  <a:pt x="0" y="4438546"/>
                 </a:lnTo>
                 <a:lnTo>
                   <a:pt x="0" y="0"/>
@@ -24752,9 +24643,9 @@
           <p:nvPr/>
         </p:nvSpPr>
         <p:spPr>
-          <a:xfrm flipH="false" flipV="false" rot="-1271139">
-            <a:off x="1028984" y="792541"/>
-            <a:ext cx="1715649" cy="2341456"/>
+          <a:xfrm flipH="false" flipV="false" rot="0">
+            <a:off x="14515924" y="-305796"/>
+            <a:ext cx="5081512" cy="4444014"/>
           </a:xfrm>
           <a:custGeom>
             <a:avLst/>
@@ -24763,70 +24654,18 @@
             <a:cxnLst/>
             <a:rect r="r" b="b" t="t" l="l"/>
             <a:pathLst>
-              <a:path h="2341456" w="1715649">
+              <a:path h="4444014" w="5081512">
                 <a:moveTo>
                   <a:pt x="0" y="0"/>
                 </a:moveTo>
                 <a:lnTo>
-                  <a:pt x="1715649" y="0"/>
-                </a:lnTo>
-                <a:lnTo>
-                  <a:pt x="1715649" y="2341456"/>
-                </a:lnTo>
-                <a:lnTo>
-                  <a:pt x="0" y="2341456"/>
-                </a:lnTo>
-                <a:lnTo>
-                  <a:pt x="0" y="0"/>
-                </a:lnTo>
-                <a:close/>
-              </a:path>
-            </a:pathLst>
-          </a:custGeom>
-          <a:blipFill>
-            <a:blip r:embed="rId5">
-              <a:extLst>
-                <a:ext uri="{96DAC541-7B7A-43D3-8B79-37D633B846F1}">
-                  <asvg:svgBlip xmlns:asvg="http://schemas.microsoft.com/office/drawing/2016/SVG/main" r:embed="rId6"/>
-                </a:ext>
-              </a:extLst>
-            </a:blip>
-            <a:stretch>
-              <a:fillRect l="0" t="0" r="0" b="0"/>
-            </a:stretch>
-          </a:blipFill>
-        </p:spPr>
-      </p:sp>
-      <p:sp>
-        <p:nvSpPr>
-          <p:cNvPr name="Freeform 9" id="9"/>
-          <p:cNvSpPr/>
-          <p:nvPr/>
-        </p:nvSpPr>
-        <p:spPr>
-          <a:xfrm flipH="false" flipV="false" rot="0">
-            <a:off x="14216803" y="-508556"/>
-            <a:ext cx="5298582" cy="4633851"/>
-          </a:xfrm>
-          <a:custGeom>
-            <a:avLst/>
-            <a:gdLst/>
-            <a:ahLst/>
-            <a:cxnLst/>
-            <a:rect r="r" b="b" t="t" l="l"/>
-            <a:pathLst>
-              <a:path h="4633851" w="5298582">
-                <a:moveTo>
-                  <a:pt x="0" y="0"/>
-                </a:moveTo>
-                <a:lnTo>
-                  <a:pt x="5298583" y="0"/>
-                </a:lnTo>
-                <a:lnTo>
-                  <a:pt x="5298583" y="4633851"/>
-                </a:lnTo>
-                <a:lnTo>
-                  <a:pt x="0" y="4633851"/>
+                  <a:pt x="5081512" y="0"/>
+                </a:lnTo>
+                <a:lnTo>
+                  <a:pt x="5081512" y="4444014"/>
+                </a:lnTo>
+                <a:lnTo>
+                  <a:pt x="0" y="4444014"/>
                 </a:lnTo>
                 <a:lnTo>
                   <a:pt x="0" y="0"/>
@@ -24851,14 +24690,14 @@
       </p:sp>
       <p:sp>
         <p:nvSpPr>
-          <p:cNvPr name="Freeform 10" id="10"/>
+          <p:cNvPr name="Freeform 13" id="13"/>
           <p:cNvSpPr/>
           <p:nvPr/>
         </p:nvSpPr>
         <p:spPr>
           <a:xfrm flipH="false" flipV="false" rot="0">
-            <a:off x="10110754" y="389732"/>
-            <a:ext cx="3595229" cy="2542807"/>
+            <a:off x="335153" y="5501478"/>
+            <a:ext cx="4952068" cy="4989489"/>
           </a:xfrm>
           <a:custGeom>
             <a:avLst/>
@@ -24867,70 +24706,18 @@
             <a:cxnLst/>
             <a:rect r="r" b="b" t="t" l="l"/>
             <a:pathLst>
-              <a:path h="2542807" w="3595229">
+              <a:path h="4989489" w="4952068">
                 <a:moveTo>
                   <a:pt x="0" y="0"/>
                 </a:moveTo>
                 <a:lnTo>
-                  <a:pt x="3595229" y="0"/>
-                </a:lnTo>
-                <a:lnTo>
-                  <a:pt x="3595229" y="2542807"/>
-                </a:lnTo>
-                <a:lnTo>
-                  <a:pt x="0" y="2542807"/>
-                </a:lnTo>
-                <a:lnTo>
-                  <a:pt x="0" y="0"/>
-                </a:lnTo>
-                <a:close/>
-              </a:path>
-            </a:pathLst>
-          </a:custGeom>
-          <a:blipFill>
-            <a:blip r:embed="rId9">
-              <a:extLst>
-                <a:ext uri="{96DAC541-7B7A-43D3-8B79-37D633B846F1}">
-                  <asvg:svgBlip xmlns:asvg="http://schemas.microsoft.com/office/drawing/2016/SVG/main" r:embed="rId10"/>
-                </a:ext>
-              </a:extLst>
-            </a:blip>
-            <a:stretch>
-              <a:fillRect l="0" t="0" r="0" b="0"/>
-            </a:stretch>
-          </a:blipFill>
-        </p:spPr>
-      </p:sp>
-      <p:sp>
-        <p:nvSpPr>
-          <p:cNvPr name="Freeform 11" id="11"/>
-          <p:cNvSpPr/>
-          <p:nvPr/>
-        </p:nvSpPr>
-        <p:spPr>
-          <a:xfrm flipH="false" flipV="false" rot="1419711">
-            <a:off x="-669291" y="7248429"/>
-            <a:ext cx="3275863" cy="3654614"/>
-          </a:xfrm>
-          <a:custGeom>
-            <a:avLst/>
-            <a:gdLst/>
-            <a:ahLst/>
-            <a:cxnLst/>
-            <a:rect r="r" b="b" t="t" l="l"/>
-            <a:pathLst>
-              <a:path h="3654614" w="3275863">
-                <a:moveTo>
-                  <a:pt x="0" y="0"/>
-                </a:moveTo>
-                <a:lnTo>
-                  <a:pt x="3275863" y="0"/>
-                </a:lnTo>
-                <a:lnTo>
-                  <a:pt x="3275863" y="3654614"/>
-                </a:lnTo>
-                <a:lnTo>
-                  <a:pt x="0" y="3654614"/>
+                  <a:pt x="4952068" y="0"/>
+                </a:lnTo>
+                <a:lnTo>
+                  <a:pt x="4952068" y="4989489"/>
+                </a:lnTo>
+                <a:lnTo>
+                  <a:pt x="0" y="4989489"/>
                 </a:lnTo>
                 <a:lnTo>
                   <a:pt x="0" y="0"/>
@@ -24955,66 +24742,14 @@
       </p:sp>
       <p:sp>
         <p:nvSpPr>
-          <p:cNvPr name="Freeform 12" id="12"/>
-          <p:cNvSpPr/>
-          <p:nvPr/>
-        </p:nvSpPr>
-        <p:spPr>
-          <a:xfrm flipH="false" flipV="false" rot="0">
-            <a:off x="5446635" y="6172200"/>
-            <a:ext cx="3897838" cy="4114800"/>
-          </a:xfrm>
-          <a:custGeom>
-            <a:avLst/>
-            <a:gdLst/>
-            <a:ahLst/>
-            <a:cxnLst/>
-            <a:rect r="r" b="b" t="t" l="l"/>
-            <a:pathLst>
-              <a:path h="4114800" w="3897838">
-                <a:moveTo>
-                  <a:pt x="0" y="0"/>
-                </a:moveTo>
-                <a:lnTo>
-                  <a:pt x="3897838" y="0"/>
-                </a:lnTo>
-                <a:lnTo>
-                  <a:pt x="3897838" y="4114800"/>
-                </a:lnTo>
-                <a:lnTo>
-                  <a:pt x="0" y="4114800"/>
-                </a:lnTo>
-                <a:lnTo>
-                  <a:pt x="0" y="0"/>
-                </a:lnTo>
-                <a:close/>
-              </a:path>
-            </a:pathLst>
-          </a:custGeom>
-          <a:blipFill>
-            <a:blip r:embed="rId13">
-              <a:extLst>
-                <a:ext uri="{96DAC541-7B7A-43D3-8B79-37D633B846F1}">
-                  <asvg:svgBlip xmlns:asvg="http://schemas.microsoft.com/office/drawing/2016/SVG/main" r:embed="rId14"/>
-                </a:ext>
-              </a:extLst>
-            </a:blip>
-            <a:stretch>
-              <a:fillRect l="0" t="0" r="0" b="0"/>
-            </a:stretch>
-          </a:blipFill>
-        </p:spPr>
-      </p:sp>
-      <p:sp>
-        <p:nvSpPr>
-          <p:cNvPr id="201" name="Título 201"/>
+          <p:cNvPr id="201" name="Texto 201"/>
           <p:cNvSpPr txBox="1"/>
           <p:nvPr/>
         </p:nvSpPr>
         <p:spPr>
           <a:xfrm>
-            <a:off x="8496000" y="3024000"/>
-            <a:ext cx="9000000" cy="1080000"/>
+            <a:off x="3240000" y="216000"/>
+            <a:ext cx="10584000" cy="2376000"/>
           </a:xfrm>
           <a:prstGeom prst="rect">
             <a:avLst/>
@@ -25027,20 +24762,20 @@
           </a:bodyPr>
           <a:lstStyle/>
           <a:p>
-            <a:pPr algn="l">
-              <a:lnSpc>
-                <a:spcPct val="88000"/>
-              </a:lnSpc>
-              <a:spcBef>
-                <a:spcPts val="0"/>
-              </a:spcBef>
-              <a:spcAft>
-                <a:spcPts val="0"/>
-              </a:spcAft>
-              <a:buNone/>
-            </a:pPr>
-            <a:r>
-              <a:rPr lang="pt-BR" sz="4400" b="1" dirty="0">
+            <a:pPr algn="ctr">
+              <a:lnSpc>
+                <a:spcPct val="100000"/>
+              </a:lnSpc>
+              <a:spcBef>
+                <a:spcPts val="0"/>
+              </a:spcBef>
+              <a:spcAft>
+                <a:spcPts val="300"/>
+              </a:spcAft>
+              <a:buNone/>
+            </a:pPr>
+            <a:r>
+              <a:rPr lang="pt-BR" sz="3000" b="1" dirty="0">
                 <a:solidFill>
                   <a:srgbClr val="FFFFFF"/>
                 </a:solidFill>
@@ -25049,48 +24784,52 @@
                 <a:cs typeface="Canva Sans Bold"/>
                 <a:sym typeface="Canva Sans Bold"/>
               </a:rPr>
-              <a:t>A QUESTÃO ABERTA</a:t>
-            </a:r>
-            <a:endParaRPr lang="pt-BR" sz="4400" dirty="0"/>
-          </a:p>
-        </p:txBody>
-      </p:sp>
-      <p:sp>
-        <p:nvSpPr>
-          <p:cNvPr id="202" name="Texto 202"/>
-          <p:cNvSpPr txBox="1"/>
-          <p:nvPr/>
-        </p:nvSpPr>
-        <p:spPr>
-          <a:xfrm>
-            <a:off x="8568000" y="4176000"/>
-            <a:ext cx="9216000" cy="1080000"/>
-          </a:xfrm>
-          <a:prstGeom prst="rect">
-            <a:avLst/>
-          </a:prstGeom>
-          <a:noFill/>
-        </p:spPr>
-        <p:txBody>
-          <a:bodyPr wrap="square" lIns="0" tIns="0" rIns="0" bIns="0" anchor="t" rtlCol="0">
-            <a:noAutofit/>
-          </a:bodyPr>
-          <a:lstStyle/>
-          <a:p>
-            <a:pPr algn="l">
-              <a:lnSpc>
-                <a:spcPct val="105000"/>
-              </a:lnSpc>
-              <a:spcBef>
-                <a:spcPts val="0"/>
-              </a:spcBef>
-              <a:spcAft>
-                <a:spcPts val="0"/>
-              </a:spcAft>
-              <a:buNone/>
-            </a:pPr>
-            <a:r>
-              <a:rPr lang="pt-BR" sz="2030" dirty="0">
+              <a:t>TESE DE PARTIDA</a:t>
+            </a:r>
+            <a:endParaRPr lang="pt-BR" sz="3000" dirty="0"/>
+          </a:p>
+          <a:p>
+            <a:pPr algn="ctr">
+              <a:lnSpc>
+                <a:spcPct val="100000"/>
+              </a:lnSpc>
+              <a:spcBef>
+                <a:spcPts val="0"/>
+              </a:spcBef>
+              <a:spcAft>
+                <a:spcPts val="434"/>
+              </a:spcAft>
+              <a:buNone/>
+            </a:pPr>
+            <a:r>
+              <a:rPr lang="pt-BR" sz="2175" b="1" dirty="0">
+                <a:solidFill>
+                  <a:srgbClr val="FFFFFF"/>
+                </a:solidFill>
+                <a:latin typeface="Canva Sans Bold"/>
+                <a:ea typeface="Canva Sans Bold"/>
+                <a:cs typeface="Canva Sans Bold"/>
+                <a:sym typeface="Canva Sans Bold"/>
+              </a:rPr>
+              <a:t>A forma assumida pela PNED no cotidiano escolar resulta da relação entre o que ela prescreve, o que a rede municipal traduz e as condições sob as quais os profissionais precisam atuar.</a:t>
+            </a:r>
+            <a:endParaRPr lang="pt-BR" sz="2175" dirty="0"/>
+          </a:p>
+          <a:p>
+            <a:pPr algn="ctr">
+              <a:lnSpc>
+                <a:spcPct val="100000"/>
+              </a:lnSpc>
+              <a:spcBef>
+                <a:spcPts val="0"/>
+              </a:spcBef>
+              <a:spcAft>
+                <a:spcPts val="0"/>
+              </a:spcAft>
+              <a:buNone/>
+            </a:pPr>
+            <a:r>
+              <a:rPr lang="pt-BR" sz="1958" dirty="0">
                 <a:solidFill>
                   <a:srgbClr val="FFFFFF"/>
                 </a:solidFill>
@@ -25099,44 +24838,65 @@
                 <a:cs typeface="Canva Sans"/>
                 <a:sym typeface="Canva Sans"/>
               </a:rPr>
-              <a:t>A política fez da educação digital um direito e deixou os meios na dependência de cada ente federado. A pergunta de fundo, que só as narrativas podem responder:</a:t>
-            </a:r>
-            <a:endParaRPr lang="pt-BR" sz="2030" dirty="0"/>
+              <a:t>Daí podem surgir da adesão à resistência, que permanece hipótese a examinar nos dados.</a:t>
+            </a:r>
+            <a:endParaRPr lang="pt-BR" sz="1958" dirty="0"/>
           </a:p>
         </p:txBody>
       </p:sp>
-      <p:sp>
-        <p:nvSpPr>
-          <p:cNvPr id="203" name="Cartão 203"/>
-          <p:cNvSpPr/>
-          <p:nvPr/>
-        </p:nvSpPr>
+      <p:pic>
+        <p:nvPicPr>
+          <p:cNvPr id="202" name="Moldura 202" descr=""/>
+          <p:cNvPicPr>
+            <a:picLocks noChangeAspect="1"/>
+          </p:cNvPicPr>
+          <p:nvPr/>
+        </p:nvPicPr>
+        <p:blipFill>
+          <a:blip r:embed="rId9">
+            <a:extLst>
+              <a:ext uri="{96DAC541-7B7A-43D3-8B79-37D633B846F1}">
+                <asvg:svgBlip xmlns:asvg="http://schemas.microsoft.com/office/drawing/2016/SVG/main" r:embed="rId10"/>
+              </a:ext>
+            </a:extLst>
+          </a:blip>
+          <a:stretch>
+            <a:fillRect/>
+          </a:stretch>
+        </p:blipFill>
         <p:spPr>
           <a:xfrm>
-            <a:off x="8568000" y="5292000"/>
-            <a:ext cx="9216000" cy="2376000"/>
-          </a:xfrm>
-          <a:prstGeom prst="roundRect">
-            <a:avLst>
-              <a:gd name="adj" fmla="val 5000"/>
-            </a:avLst>
+            <a:off x="1908000" y="2880000"/>
+            <a:ext cx="6912000" cy="3312000"/>
+          </a:xfrm>
+          <a:prstGeom prst="rect">
+            <a:avLst/>
           </a:prstGeom>
-          <a:solidFill>
-            <a:srgbClr val="FFCE32"/>
-          </a:solidFill>
-          <a:ln w="38100">
-            <a:solidFill>
-              <a:srgbClr val="111111"/>
-            </a:solidFill>
-          </a:ln>
+        </p:spPr>
+      </p:pic>
+      <p:sp>
+        <p:nvSpPr>
+          <p:cNvPr id="203" name="Texto 203"/>
+          <p:cNvSpPr txBox="1"/>
+          <p:nvPr/>
+        </p:nvSpPr>
+        <p:spPr>
+          <a:xfrm>
+            <a:off x="2530080" y="3674880"/>
+            <a:ext cx="5667840" cy="2053440"/>
+          </a:xfrm>
+          <a:prstGeom prst="rect">
+            <a:avLst/>
+          </a:prstGeom>
+          <a:noFill/>
         </p:spPr>
         <p:txBody>
-          <a:bodyPr wrap="square" lIns="216000" tIns="216000" rIns="216000" bIns="216000" anchor="ctr" rtlCol="0">
+          <a:bodyPr wrap="square" lIns="0" tIns="0" rIns="0" bIns="0" anchor="ctr" rtlCol="0">
             <a:noAutofit/>
           </a:bodyPr>
           <a:lstStyle/>
           <a:p>
-            <a:pPr algn="l">
+            <a:pPr algn="ctr">
               <a:lnSpc>
                 <a:spcPct val="100000"/>
               </a:lnSpc>
@@ -25144,12 +24904,12 @@
                 <a:spcPts val="0"/>
               </a:spcBef>
               <a:spcAft>
-                <a:spcPts val="869"/>
-              </a:spcAft>
-              <a:buNone/>
-            </a:pPr>
-            <a:r>
-              <a:rPr lang="pt-BR" sz="2248" b="1" dirty="0">
+                <a:spcPts val="580"/>
+              </a:spcAft>
+              <a:buNone/>
+            </a:pPr>
+            <a:r>
+              <a:rPr lang="pt-BR" sz="2755" b="1" dirty="0">
                 <a:solidFill>
                   <a:srgbClr val="111111"/>
                 </a:solidFill>
@@ -25158,12 +24918,12 @@
                 <a:cs typeface="Canva Sans Bold"/>
                 <a:sym typeface="Canva Sans Bold"/>
               </a:rPr>
-              <a:t>Quando a política não faz chegar o equipamento nem a formação, quem paga, no cotidiano escolar, por esse vazio material e formativo?</a:t>
-            </a:r>
-            <a:endParaRPr lang="pt-BR" sz="2248" dirty="0"/>
-          </a:p>
-          <a:p>
-            <a:pPr algn="l">
+              <a:t>Habitar o digital</a:t>
+            </a:r>
+            <a:endParaRPr lang="pt-BR" sz="2755" dirty="0"/>
+          </a:p>
+          <a:p>
+            <a:pPr algn="ctr">
               <a:lnSpc>
                 <a:spcPct val="100000"/>
               </a:lnSpc>
@@ -25176,7 +24936,117 @@
               <a:buNone/>
             </a:pPr>
             <a:r>
-              <a:rPr lang="pt-BR" sz="2248" b="1" dirty="0">
+              <a:rPr lang="pt-BR" sz="2030" dirty="0">
+                <a:solidFill>
+                  <a:srgbClr val="111111"/>
+                </a:solidFill>
+                <a:latin typeface="Canva Sans"/>
+                <a:ea typeface="Canva Sans"/>
+                <a:cs typeface="Canva Sans"/>
+                <a:sym typeface="Canva Sans"/>
+              </a:rPr>
+              <a:t>Quem consegue habitar o digital, em que condições e com quais possibilidades de participação</a:t>
+            </a:r>
+            <a:endParaRPr lang="pt-BR" sz="2030" dirty="0"/>
+          </a:p>
+        </p:txBody>
+      </p:sp>
+      <p:pic>
+        <p:nvPicPr>
+          <p:cNvPr id="204" name="Tacha 204" descr=""/>
+          <p:cNvPicPr>
+            <a:picLocks noChangeAspect="1"/>
+          </p:cNvPicPr>
+          <p:nvPr/>
+        </p:nvPicPr>
+        <p:blipFill>
+          <a:blip r:embed="rId13">
+            <a:extLst>
+              <a:ext uri="{96DAC541-7B7A-43D3-8B79-37D633B846F1}">
+                <asvg:svgBlip xmlns:asvg="http://schemas.microsoft.com/office/drawing/2016/SVG/main" r:embed="rId14"/>
+              </a:ext>
+            </a:extLst>
+          </a:blip>
+          <a:stretch>
+            <a:fillRect/>
+          </a:stretch>
+        </p:blipFill>
+        <p:spPr>
+          <a:xfrm>
+            <a:off x="4950000" y="2304000"/>
+            <a:ext cx="828000" cy="1332000"/>
+          </a:xfrm>
+          <a:prstGeom prst="rect">
+            <a:avLst/>
+          </a:prstGeom>
+        </p:spPr>
+      </p:pic>
+      <p:pic>
+        <p:nvPicPr>
+          <p:cNvPr id="205" name="Moldura 205" descr=""/>
+          <p:cNvPicPr>
+            <a:picLocks noChangeAspect="1"/>
+          </p:cNvPicPr>
+          <p:nvPr/>
+        </p:nvPicPr>
+        <p:blipFill>
+          <a:blip r:embed="rId9">
+            <a:extLst>
+              <a:ext uri="{96DAC541-7B7A-43D3-8B79-37D633B846F1}">
+                <asvg:svgBlip xmlns:asvg="http://schemas.microsoft.com/office/drawing/2016/SVG/main" r:embed="rId10"/>
+              </a:ext>
+            </a:extLst>
+          </a:blip>
+          <a:stretch>
+            <a:fillRect/>
+          </a:stretch>
+        </p:blipFill>
+        <p:spPr>
+          <a:xfrm>
+            <a:off x="9468000" y="2880000"/>
+            <a:ext cx="6912000" cy="3312000"/>
+          </a:xfrm>
+          <a:prstGeom prst="rect">
+            <a:avLst/>
+          </a:prstGeom>
+        </p:spPr>
+      </p:pic>
+      <p:sp>
+        <p:nvSpPr>
+          <p:cNvPr id="206" name="Texto 206"/>
+          <p:cNvSpPr txBox="1"/>
+          <p:nvPr/>
+        </p:nvSpPr>
+        <p:spPr>
+          <a:xfrm>
+            <a:off x="10090080" y="3674880"/>
+            <a:ext cx="5667840" cy="2053440"/>
+          </a:xfrm>
+          <a:prstGeom prst="rect">
+            <a:avLst/>
+          </a:prstGeom>
+          <a:noFill/>
+        </p:spPr>
+        <p:txBody>
+          <a:bodyPr wrap="square" lIns="0" tIns="0" rIns="0" bIns="0" anchor="ctr" rtlCol="0">
+            <a:noAutofit/>
+          </a:bodyPr>
+          <a:lstStyle/>
+          <a:p>
+            <a:pPr algn="ctr">
+              <a:lnSpc>
+                <a:spcPct val="100000"/>
+              </a:lnSpc>
+              <a:spcBef>
+                <a:spcPts val="0"/>
+              </a:spcBef>
+              <a:spcAft>
+                <a:spcPts val="580"/>
+              </a:spcAft>
+              <a:buNone/>
+            </a:pPr>
+            <a:r>
+              <a:rPr lang="pt-BR" sz="2755" b="1" dirty="0">
                 <a:solidFill>
                   <a:srgbClr val="111111"/>
                 </a:solidFill>
@@ -25185,44 +25055,122 @@
                 <a:cs typeface="Canva Sans Bold"/>
                 <a:sym typeface="Canva Sans Bold"/>
               </a:rPr>
-              <a:t>E o que isso significa para os direitos que a lei prometeu às crianças?</a:t>
-            </a:r>
-            <a:endParaRPr lang="pt-BR" sz="2248" dirty="0"/>
+              <a:t>Rugosidade tecnológica</a:t>
+            </a:r>
+            <a:endParaRPr lang="pt-BR" sz="2755" dirty="0"/>
+          </a:p>
+          <a:p>
+            <a:pPr algn="ctr">
+              <a:lnSpc>
+                <a:spcPct val="100000"/>
+              </a:lnSpc>
+              <a:spcBef>
+                <a:spcPts val="0"/>
+              </a:spcBef>
+              <a:spcAft>
+                <a:spcPts val="0"/>
+              </a:spcAft>
+              <a:buNone/>
+            </a:pPr>
+            <a:r>
+              <a:rPr lang="pt-BR" sz="2030" dirty="0">
+                <a:solidFill>
+                  <a:srgbClr val="111111"/>
+                </a:solidFill>
+                <a:latin typeface="Canva Sans"/>
+                <a:ea typeface="Canva Sans"/>
+                <a:cs typeface="Canva Sans"/>
+                <a:sym typeface="Canva Sans"/>
+              </a:rPr>
+              <a:t>Equipamentos de 2022, anteriores à lei, chamados a cumprir nova função (com SANTOS, 2012)</a:t>
+            </a:r>
+            <a:endParaRPr lang="pt-BR" sz="2030" dirty="0"/>
           </a:p>
         </p:txBody>
       </p:sp>
-      <p:sp>
-        <p:nvSpPr>
-          <p:cNvPr id="204" name="Cartão 204"/>
-          <p:cNvSpPr/>
-          <p:nvPr/>
-        </p:nvSpPr>
+      <p:pic>
+        <p:nvPicPr>
+          <p:cNvPr id="207" name="Tacha 207" descr=""/>
+          <p:cNvPicPr>
+            <a:picLocks noChangeAspect="1"/>
+          </p:cNvPicPr>
+          <p:nvPr/>
+        </p:nvPicPr>
+        <p:blipFill>
+          <a:blip r:embed="rId13">
+            <a:extLst>
+              <a:ext uri="{96DAC541-7B7A-43D3-8B79-37D633B846F1}">
+                <asvg:svgBlip xmlns:asvg="http://schemas.microsoft.com/office/drawing/2016/SVG/main" r:embed="rId14"/>
+              </a:ext>
+            </a:extLst>
+          </a:blip>
+          <a:stretch>
+            <a:fillRect/>
+          </a:stretch>
+        </p:blipFill>
         <p:spPr>
           <a:xfrm>
-            <a:off x="8568000" y="7884000"/>
-            <a:ext cx="9216000" cy="2160000"/>
-          </a:xfrm>
-          <a:prstGeom prst="roundRect">
-            <a:avLst>
-              <a:gd name="adj" fmla="val 5000"/>
-            </a:avLst>
+            <a:off x="12510000" y="2304000"/>
+            <a:ext cx="828000" cy="1332000"/>
+          </a:xfrm>
+          <a:prstGeom prst="rect">
+            <a:avLst/>
           </a:prstGeom>
-          <a:solidFill>
-            <a:srgbClr val="EFE3D4"/>
-          </a:solidFill>
-          <a:ln w="38100">
-            <a:solidFill>
-              <a:srgbClr val="111111"/>
-            </a:solidFill>
-          </a:ln>
+        </p:spPr>
+      </p:pic>
+      <p:pic>
+        <p:nvPicPr>
+          <p:cNvPr id="208" name="Moldura 208" descr=""/>
+          <p:cNvPicPr>
+            <a:picLocks noChangeAspect="1"/>
+          </p:cNvPicPr>
+          <p:nvPr/>
+        </p:nvPicPr>
+        <p:blipFill>
+          <a:blip r:embed="rId9">
+            <a:extLst>
+              <a:ext uri="{96DAC541-7B7A-43D3-8B79-37D633B846F1}">
+                <asvg:svgBlip xmlns:asvg="http://schemas.microsoft.com/office/drawing/2016/SVG/main" r:embed="rId10"/>
+              </a:ext>
+            </a:extLst>
+          </a:blip>
+          <a:stretch>
+            <a:fillRect/>
+          </a:stretch>
+        </p:blipFill>
+        <p:spPr>
+          <a:xfrm>
+            <a:off x="5544000" y="6552000"/>
+            <a:ext cx="6912000" cy="3312000"/>
+          </a:xfrm>
+          <a:prstGeom prst="rect">
+            <a:avLst/>
+          </a:prstGeom>
+        </p:spPr>
+      </p:pic>
+      <p:sp>
+        <p:nvSpPr>
+          <p:cNvPr id="209" name="Texto 209"/>
+          <p:cNvSpPr txBox="1"/>
+          <p:nvPr/>
+        </p:nvSpPr>
+        <p:spPr>
+          <a:xfrm>
+            <a:off x="6166080" y="7346880"/>
+            <a:ext cx="5667840" cy="2053440"/>
+          </a:xfrm>
+          <a:prstGeom prst="rect">
+            <a:avLst/>
+          </a:prstGeom>
+          <a:noFill/>
         </p:spPr>
         <p:txBody>
-          <a:bodyPr wrap="square" lIns="180000" tIns="180000" rIns="180000" bIns="180000" anchor="ctr" rtlCol="0">
+          <a:bodyPr wrap="square" lIns="0" tIns="0" rIns="0" bIns="0" anchor="ctr" rtlCol="0">
             <a:noAutofit/>
           </a:bodyPr>
           <a:lstStyle/>
           <a:p>
-            <a:pPr algn="l">
+            <a:pPr algn="ctr">
               <a:lnSpc>
                 <a:spcPct val="100000"/>
               </a:lnSpc>
@@ -25230,12 +25178,12 @@
                 <a:spcPts val="0"/>
               </a:spcBef>
               <a:spcAft>
-                <a:spcPts val="434"/>
-              </a:spcAft>
-              <a:buNone/>
-            </a:pPr>
-            <a:r>
-              <a:rPr lang="pt-BR" sz="2175" b="1" dirty="0">
+                <a:spcPts val="580"/>
+              </a:spcAft>
+              <a:buNone/>
+            </a:pPr>
+            <a:r>
+              <a:rPr lang="pt-BR" sz="2755" b="1" dirty="0">
                 <a:solidFill>
                   <a:srgbClr val="111111"/>
                 </a:solidFill>
@@ -25244,12 +25192,12 @@
                 <a:cs typeface="Canva Sans Bold"/>
                 <a:sym typeface="Canva Sans Bold"/>
               </a:rPr>
-              <a:t>Próximos passos</a:t>
-            </a:r>
-            <a:endParaRPr lang="pt-BR" sz="2175" dirty="0"/>
-          </a:p>
-          <a:p>
-            <a:pPr algn="l">
+              <a:t>Vazio material</a:t>
+            </a:r>
+            <a:endParaRPr lang="pt-BR" sz="2755" dirty="0"/>
+          </a:p>
+          <a:p>
+            <a:pPr algn="ctr">
               <a:lnSpc>
                 <a:spcPct val="100000"/>
               </a:lnSpc>
@@ -25262,7 +25210,7 @@
               <a:buNone/>
             </a:pPr>
             <a:r>
-              <a:rPr lang="pt-BR" sz="1885" dirty="0">
+              <a:rPr lang="pt-BR" sz="2030" dirty="0">
                 <a:solidFill>
                   <a:srgbClr val="111111"/>
                 </a:solidFill>
@@ -25271,12 +25219,42 @@
                 <a:cs typeface="Canva Sans"/>
                 <a:sym typeface="Canva Sans"/>
               </a:rPr>
-              <a:t>Emenda ao CEP, com a SME coparticipante · campo em dez semanas após a aprovação · análise documental: os documentos da escola já foram solicitados à direção, e os municipais, ao técnico da Secretaria de Educação · capítulo 7, com as narrativas dos profissionais · contribuições da banca</a:t>
-            </a:r>
-            <a:endParaRPr lang="pt-BR" sz="1885" dirty="0"/>
+              <a:t>Exigência curricular com data marcada e meios sem mecanismo federativo obrigatório</a:t>
+            </a:r>
+            <a:endParaRPr lang="pt-BR" sz="2030" dirty="0"/>
           </a:p>
         </p:txBody>
       </p:sp>
+      <p:pic>
+        <p:nvPicPr>
+          <p:cNvPr id="210" name="Tacha 210" descr=""/>
+          <p:cNvPicPr>
+            <a:picLocks noChangeAspect="1"/>
+          </p:cNvPicPr>
+          <p:nvPr/>
+        </p:nvPicPr>
+        <p:blipFill>
+          <a:blip r:embed="rId13">
+            <a:extLst>
+              <a:ext uri="{96DAC541-7B7A-43D3-8B79-37D633B846F1}">
+                <asvg:svgBlip xmlns:asvg="http://schemas.microsoft.com/office/drawing/2016/SVG/main" r:embed="rId14"/>
+              </a:ext>
+            </a:extLst>
+          </a:blip>
+          <a:stretch>
+            <a:fillRect/>
+          </a:stretch>
+        </p:blipFill>
+        <p:spPr>
+          <a:xfrm>
+            <a:off x="8586000" y="5976000"/>
+            <a:ext cx="828000" cy="1332000"/>
+          </a:xfrm>
+          <a:prstGeom prst="rect">
+            <a:avLst/>
+          </a:prstGeom>
+        </p:spPr>
+      </p:pic>
     </p:spTree>
   </p:cSld>
   <p:clrMapOvr>
@@ -25356,8 +25334,8 @@
         </p:nvSpPr>
         <p:spPr>
           <a:xfrm flipH="false" flipV="false" rot="0">
-            <a:off x="-2498597" y="-108828"/>
-            <a:ext cx="6582509" cy="10746953"/>
+            <a:off x="663870" y="389732"/>
+            <a:ext cx="7320803" cy="9507536"/>
           </a:xfrm>
           <a:custGeom>
             <a:avLst/>
@@ -25366,18 +25344,18 @@
             <a:cxnLst/>
             <a:rect r="r" b="b" t="t" l="l"/>
             <a:pathLst>
-              <a:path h="10746953" w="6582509">
+              <a:path h="9507536" w="7320803">
                 <a:moveTo>
                   <a:pt x="0" y="0"/>
                 </a:moveTo>
                 <a:lnTo>
-                  <a:pt x="6582509" y="0"/>
-                </a:lnTo>
-                <a:lnTo>
-                  <a:pt x="6582509" y="10746953"/>
-                </a:lnTo>
-                <a:lnTo>
-                  <a:pt x="0" y="10746953"/>
+                  <a:pt x="7320803" y="0"/>
+                </a:lnTo>
+                <a:lnTo>
+                  <a:pt x="7320803" y="9507536"/>
+                </a:lnTo>
+                <a:lnTo>
+                  <a:pt x="0" y="9507536"/>
                 </a:lnTo>
                 <a:lnTo>
                   <a:pt x="0" y="0"/>
@@ -25407,9 +25385,9 @@
           <p:nvPr/>
         </p:nvSpPr>
         <p:spPr>
-          <a:xfrm flipH="false" flipV="false" rot="-797725">
-            <a:off x="13679956" y="-1054879"/>
-            <a:ext cx="4476702" cy="4994292"/>
+          <a:xfrm flipH="false" flipV="false" rot="755837">
+            <a:off x="6716389" y="624673"/>
+            <a:ext cx="2536569" cy="3461819"/>
           </a:xfrm>
           <a:custGeom>
             <a:avLst/>
@@ -25418,18 +25396,18 @@
             <a:cxnLst/>
             <a:rect r="r" b="b" t="t" l="l"/>
             <a:pathLst>
-              <a:path h="4994292" w="4476702">
+              <a:path h="3461819" w="2536569">
                 <a:moveTo>
                   <a:pt x="0" y="0"/>
                 </a:moveTo>
                 <a:lnTo>
-                  <a:pt x="4476701" y="0"/>
-                </a:lnTo>
-                <a:lnTo>
-                  <a:pt x="4476701" y="4994292"/>
-                </a:lnTo>
-                <a:lnTo>
-                  <a:pt x="0" y="4994292"/>
+                  <a:pt x="2536569" y="0"/>
+                </a:lnTo>
+                <a:lnTo>
+                  <a:pt x="2536569" y="3461819"/>
+                </a:lnTo>
+                <a:lnTo>
+                  <a:pt x="0" y="3461819"/>
                 </a:lnTo>
                 <a:lnTo>
                   <a:pt x="0" y="0"/>
@@ -25459,9 +25437,9 @@
           <p:nvPr/>
         </p:nvSpPr>
         <p:spPr>
-          <a:xfrm flipH="false" flipV="false" rot="0">
-            <a:off x="14944550" y="2366363"/>
-            <a:ext cx="5751911" cy="14071953"/>
+          <a:xfrm flipH="false" flipV="false" rot="-1271139">
+            <a:off x="1028984" y="792541"/>
+            <a:ext cx="1715649" cy="2341456"/>
           </a:xfrm>
           <a:custGeom>
             <a:avLst/>
@@ -25470,18 +25448,70 @@
             <a:cxnLst/>
             <a:rect r="r" b="b" t="t" l="l"/>
             <a:pathLst>
-              <a:path h="14071953" w="5751911">
+              <a:path h="2341456" w="1715649">
                 <a:moveTo>
                   <a:pt x="0" y="0"/>
                 </a:moveTo>
                 <a:lnTo>
-                  <a:pt x="5751911" y="0"/>
-                </a:lnTo>
-                <a:lnTo>
-                  <a:pt x="5751911" y="14071954"/>
-                </a:lnTo>
-                <a:lnTo>
-                  <a:pt x="0" y="14071954"/>
+                  <a:pt x="1715649" y="0"/>
+                </a:lnTo>
+                <a:lnTo>
+                  <a:pt x="1715649" y="2341456"/>
+                </a:lnTo>
+                <a:lnTo>
+                  <a:pt x="0" y="2341456"/>
+                </a:lnTo>
+                <a:lnTo>
+                  <a:pt x="0" y="0"/>
+                </a:lnTo>
+                <a:close/>
+              </a:path>
+            </a:pathLst>
+          </a:custGeom>
+          <a:blipFill>
+            <a:blip r:embed="rId5">
+              <a:extLst>
+                <a:ext uri="{96DAC541-7B7A-43D3-8B79-37D633B846F1}">
+                  <asvg:svgBlip xmlns:asvg="http://schemas.microsoft.com/office/drawing/2016/SVG/main" r:embed="rId6"/>
+                </a:ext>
+              </a:extLst>
+            </a:blip>
+            <a:stretch>
+              <a:fillRect l="0" t="0" r="0" b="0"/>
+            </a:stretch>
+          </a:blipFill>
+        </p:spPr>
+      </p:sp>
+      <p:sp>
+        <p:nvSpPr>
+          <p:cNvPr name="Freeform 9" id="9"/>
+          <p:cNvSpPr/>
+          <p:nvPr/>
+        </p:nvSpPr>
+        <p:spPr>
+          <a:xfrm flipH="false" flipV="false" rot="0">
+            <a:off x="14216803" y="-508556"/>
+            <a:ext cx="5298582" cy="4633851"/>
+          </a:xfrm>
+          <a:custGeom>
+            <a:avLst/>
+            <a:gdLst/>
+            <a:ahLst/>
+            <a:cxnLst/>
+            <a:rect r="r" b="b" t="t" l="l"/>
+            <a:pathLst>
+              <a:path h="4633851" w="5298582">
+                <a:moveTo>
+                  <a:pt x="0" y="0"/>
+                </a:moveTo>
+                <a:lnTo>
+                  <a:pt x="5298583" y="0"/>
+                </a:lnTo>
+                <a:lnTo>
+                  <a:pt x="5298583" y="4633851"/>
+                </a:lnTo>
+                <a:lnTo>
+                  <a:pt x="0" y="4633851"/>
                 </a:lnTo>
                 <a:lnTo>
                   <a:pt x="0" y="0"/>
@@ -25506,14 +25536,14 @@
       </p:sp>
       <p:sp>
         <p:nvSpPr>
-          <p:cNvPr name="Freeform 6" id="6"/>
+          <p:cNvPr name="Freeform 10" id="10"/>
           <p:cNvSpPr/>
           <p:nvPr/>
         </p:nvSpPr>
         <p:spPr>
-          <a:xfrm flipH="true" flipV="false" rot="0">
-            <a:off x="792658" y="5143500"/>
-            <a:ext cx="4946577" cy="5519194"/>
+          <a:xfrm flipH="false" flipV="false" rot="0">
+            <a:off x="10110754" y="389732"/>
+            <a:ext cx="3595229" cy="2542807"/>
           </a:xfrm>
           <a:custGeom>
             <a:avLst/>
@@ -25522,21 +25552,21 @@
             <a:cxnLst/>
             <a:rect r="r" b="b" t="t" l="l"/>
             <a:pathLst>
-              <a:path h="5519194" w="4946577">
+              <a:path h="2542807" w="3595229">
                 <a:moveTo>
-                  <a:pt x="4946577" y="0"/>
+                  <a:pt x="0" y="0"/>
                 </a:moveTo>
                 <a:lnTo>
+                  <a:pt x="3595229" y="0"/>
+                </a:lnTo>
+                <a:lnTo>
+                  <a:pt x="3595229" y="2542807"/>
+                </a:lnTo>
+                <a:lnTo>
+                  <a:pt x="0" y="2542807"/>
+                </a:lnTo>
+                <a:lnTo>
                   <a:pt x="0" y="0"/>
-                </a:lnTo>
-                <a:lnTo>
-                  <a:pt x="0" y="5519194"/>
-                </a:lnTo>
-                <a:lnTo>
-                  <a:pt x="4946577" y="5519194"/>
-                </a:lnTo>
-                <a:lnTo>
-                  <a:pt x="4946577" y="0"/>
                 </a:lnTo>
                 <a:close/>
               </a:path>
@@ -25558,14 +25588,14 @@
       </p:sp>
       <p:sp>
         <p:nvSpPr>
-          <p:cNvPr name="Freeform 7" id="7"/>
+          <p:cNvPr name="Freeform 11" id="11"/>
           <p:cNvSpPr/>
           <p:nvPr/>
         </p:nvSpPr>
         <p:spPr>
-          <a:xfrm flipH="true" flipV="false" rot="0">
-            <a:off x="11066058" y="4957733"/>
-            <a:ext cx="6322410" cy="7438130"/>
+          <a:xfrm flipH="false" flipV="false" rot="1419711">
+            <a:off x="-669291" y="7248429"/>
+            <a:ext cx="3275863" cy="3654614"/>
           </a:xfrm>
           <a:custGeom>
             <a:avLst/>
@@ -25574,21 +25604,21 @@
             <a:cxnLst/>
             <a:rect r="r" b="b" t="t" l="l"/>
             <a:pathLst>
-              <a:path h="7438130" w="6322410">
+              <a:path h="3654614" w="3275863">
                 <a:moveTo>
-                  <a:pt x="6322410" y="0"/>
+                  <a:pt x="0" y="0"/>
                 </a:moveTo>
                 <a:lnTo>
+                  <a:pt x="3275863" y="0"/>
+                </a:lnTo>
+                <a:lnTo>
+                  <a:pt x="3275863" y="3654614"/>
+                </a:lnTo>
+                <a:lnTo>
+                  <a:pt x="0" y="3654614"/>
+                </a:lnTo>
+                <a:lnTo>
                   <a:pt x="0" y="0"/>
-                </a:lnTo>
-                <a:lnTo>
-                  <a:pt x="0" y="7438130"/>
-                </a:lnTo>
-                <a:lnTo>
-                  <a:pt x="6322410" y="7438130"/>
-                </a:lnTo>
-                <a:lnTo>
-                  <a:pt x="6322410" y="0"/>
                 </a:lnTo>
                 <a:close/>
               </a:path>
@@ -25610,14 +25640,14 @@
       </p:sp>
       <p:sp>
         <p:nvSpPr>
-          <p:cNvPr name="Freeform 9" id="9"/>
+          <p:cNvPr name="Freeform 12" id="12"/>
           <p:cNvSpPr/>
           <p:nvPr/>
         </p:nvSpPr>
         <p:spPr>
           <a:xfrm flipH="false" flipV="false" rot="0">
-            <a:off x="5976517" y="-809891"/>
-            <a:ext cx="4294014" cy="3427404"/>
+            <a:off x="5446635" y="6172200"/>
+            <a:ext cx="3897838" cy="4114800"/>
           </a:xfrm>
           <a:custGeom>
             <a:avLst/>
@@ -25626,18 +25656,18 @@
             <a:cxnLst/>
             <a:rect r="r" b="b" t="t" l="l"/>
             <a:pathLst>
-              <a:path h="3427404" w="4294014">
+              <a:path h="4114800" w="3897838">
                 <a:moveTo>
                   <a:pt x="0" y="0"/>
                 </a:moveTo>
                 <a:lnTo>
-                  <a:pt x="4294014" y="0"/>
-                </a:lnTo>
-                <a:lnTo>
-                  <a:pt x="4294014" y="3427404"/>
-                </a:lnTo>
-                <a:lnTo>
-                  <a:pt x="0" y="3427404"/>
+                  <a:pt x="3897838" y="0"/>
+                </a:lnTo>
+                <a:lnTo>
+                  <a:pt x="3897838" y="4114800"/>
+                </a:lnTo>
+                <a:lnTo>
+                  <a:pt x="0" y="4114800"/>
                 </a:lnTo>
                 <a:lnTo>
                   <a:pt x="0" y="0"/>
@@ -25662,116 +25692,14 @@
       </p:sp>
       <p:sp>
         <p:nvSpPr>
-          <p:cNvPr name="Freeform 10" id="10"/>
-          <p:cNvSpPr/>
-          <p:nvPr/>
-        </p:nvSpPr>
-        <p:spPr>
-          <a:xfrm flipH="false" flipV="false" rot="-526312">
-            <a:off x="6081818" y="6805324"/>
-            <a:ext cx="5385775" cy="4905951"/>
-          </a:xfrm>
-          <a:custGeom>
-            <a:avLst/>
-            <a:gdLst/>
-            <a:ahLst/>
-            <a:cxnLst/>
-            <a:rect r="r" b="b" t="t" l="l"/>
-            <a:pathLst>
-              <a:path h="4905951" w="5385775">
-                <a:moveTo>
-                  <a:pt x="0" y="0"/>
-                </a:moveTo>
-                <a:lnTo>
-                  <a:pt x="5385774" y="0"/>
-                </a:lnTo>
-                <a:lnTo>
-                  <a:pt x="5385774" y="4905952"/>
-                </a:lnTo>
-                <a:lnTo>
-                  <a:pt x="0" y="4905952"/>
-                </a:lnTo>
-                <a:lnTo>
-                  <a:pt x="0" y="0"/>
-                </a:lnTo>
-                <a:close/>
-              </a:path>
-            </a:pathLst>
-          </a:custGeom>
-          <a:blipFill>
-            <a:blip r:embed="rId15">
-              <a:extLst>
-                <a:ext uri="{96DAC541-7B7A-43D3-8B79-37D633B846F1}">
-                  <asvg:svgBlip xmlns:asvg="http://schemas.microsoft.com/office/drawing/2016/SVG/main" r:embed="rId16"/>
-                </a:ext>
-              </a:extLst>
-            </a:blip>
-            <a:stretch>
-              <a:fillRect l="0" t="0" r="0" b="0"/>
-            </a:stretch>
-          </a:blipFill>
-        </p:spPr>
-      </p:sp>
-      <p:sp>
-        <p:nvSpPr>
           <p:cNvPr id="201" name="Título 201"/>
           <p:cNvSpPr txBox="1"/>
           <p:nvPr/>
         </p:nvSpPr>
         <p:spPr>
           <a:xfrm>
-            <a:off x="3960000" y="2232000"/>
-            <a:ext cx="10368000" cy="2304000"/>
-          </a:xfrm>
-          <a:prstGeom prst="rect">
-            <a:avLst/>
-          </a:prstGeom>
-          <a:noFill/>
-        </p:spPr>
-        <p:txBody>
-          <a:bodyPr wrap="square" lIns="0" tIns="0" rIns="0" bIns="0" anchor="ctr" rtlCol="0">
-            <a:noAutofit/>
-          </a:bodyPr>
-          <a:lstStyle/>
-          <a:p>
-            <a:pPr algn="ctr">
-              <a:lnSpc>
-                <a:spcPct val="85000"/>
-              </a:lnSpc>
-              <a:spcBef>
-                <a:spcPts val="0"/>
-              </a:spcBef>
-              <a:spcAft>
-                <a:spcPts val="0"/>
-              </a:spcAft>
-              <a:buNone/>
-            </a:pPr>
-            <a:r>
-              <a:rPr lang="pt-BR" sz="11000" b="1" dirty="0">
-                <a:solidFill>
-                  <a:srgbClr val="FFFFFF"/>
-                </a:solidFill>
-                <a:latin typeface="Canva Sans Bold"/>
-                <a:ea typeface="Canva Sans Bold"/>
-                <a:cs typeface="Canva Sans Bold"/>
-                <a:sym typeface="Canva Sans Bold"/>
-              </a:rPr>
-              <a:t>AGRADEÇO</a:t>
-            </a:r>
-            <a:endParaRPr lang="pt-BR" sz="11000" dirty="0"/>
-          </a:p>
-        </p:txBody>
-      </p:sp>
-      <p:sp>
-        <p:nvSpPr>
-          <p:cNvPr id="202" name="Texto 202"/>
-          <p:cNvSpPr txBox="1"/>
-          <p:nvPr/>
-        </p:nvSpPr>
-        <p:spPr>
-          <a:xfrm>
-            <a:off x="3960000" y="4428000"/>
-            <a:ext cx="10368000" cy="648000"/>
+            <a:off x="8496000" y="3024000"/>
+            <a:ext cx="9000000" cy="1080000"/>
           </a:xfrm>
           <a:prstGeom prst="rect">
             <a:avLst/>
@@ -25784,20 +25712,70 @@
           </a:bodyPr>
           <a:lstStyle/>
           <a:p>
-            <a:pPr algn="ctr">
-              <a:lnSpc>
-                <a:spcPct val="95000"/>
-              </a:lnSpc>
-              <a:spcBef>
-                <a:spcPts val="0"/>
-              </a:spcBef>
-              <a:spcAft>
-                <a:spcPts val="0"/>
-              </a:spcAft>
-              <a:buNone/>
-            </a:pPr>
-            <a:r>
-              <a:rPr lang="pt-BR" sz="2900" dirty="0">
+            <a:pPr algn="l">
+              <a:lnSpc>
+                <a:spcPct val="88000"/>
+              </a:lnSpc>
+              <a:spcBef>
+                <a:spcPts val="0"/>
+              </a:spcBef>
+              <a:spcAft>
+                <a:spcPts val="0"/>
+              </a:spcAft>
+              <a:buNone/>
+            </a:pPr>
+            <a:r>
+              <a:rPr lang="pt-BR" sz="4400" b="1" dirty="0">
+                <a:solidFill>
+                  <a:srgbClr val="FFFFFF"/>
+                </a:solidFill>
+                <a:latin typeface="Canva Sans Bold"/>
+                <a:ea typeface="Canva Sans Bold"/>
+                <a:cs typeface="Canva Sans Bold"/>
+                <a:sym typeface="Canva Sans Bold"/>
+              </a:rPr>
+              <a:t>A QUESTÃO ABERTA</a:t>
+            </a:r>
+            <a:endParaRPr lang="pt-BR" sz="4400" dirty="0"/>
+          </a:p>
+        </p:txBody>
+      </p:sp>
+      <p:sp>
+        <p:nvSpPr>
+          <p:cNvPr id="202" name="Texto 202"/>
+          <p:cNvSpPr txBox="1"/>
+          <p:nvPr/>
+        </p:nvSpPr>
+        <p:spPr>
+          <a:xfrm>
+            <a:off x="8568000" y="4176000"/>
+            <a:ext cx="9216000" cy="1080000"/>
+          </a:xfrm>
+          <a:prstGeom prst="rect">
+            <a:avLst/>
+          </a:prstGeom>
+          <a:noFill/>
+        </p:spPr>
+        <p:txBody>
+          <a:bodyPr wrap="square" lIns="0" tIns="0" rIns="0" bIns="0" anchor="t" rtlCol="0">
+            <a:noAutofit/>
+          </a:bodyPr>
+          <a:lstStyle/>
+          <a:p>
+            <a:pPr algn="l">
+              <a:lnSpc>
+                <a:spcPct val="105000"/>
+              </a:lnSpc>
+              <a:spcBef>
+                <a:spcPts val="0"/>
+              </a:spcBef>
+              <a:spcAft>
+                <a:spcPts val="0"/>
+              </a:spcAft>
+              <a:buNone/>
+            </a:pPr>
+            <a:r>
+              <a:rPr lang="pt-BR" sz="2030" dirty="0">
                 <a:solidFill>
                   <a:srgbClr val="FFFFFF"/>
                 </a:solidFill>
@@ -25806,9 +25784,181 @@
                 <a:cs typeface="Canva Sans"/>
                 <a:sym typeface="Canva Sans"/>
               </a:rPr>
-              <a:t>pela atenção e pelas contribuições</a:t>
-            </a:r>
-            <a:endParaRPr lang="pt-BR" sz="2900" dirty="0"/>
+              <a:t>A política fez da educação digital um direito e deixou os meios na dependência de cada ente federado. A pergunta de fundo, que só as narrativas podem responder:</a:t>
+            </a:r>
+            <a:endParaRPr lang="pt-BR" sz="2030" dirty="0"/>
+          </a:p>
+        </p:txBody>
+      </p:sp>
+      <p:sp>
+        <p:nvSpPr>
+          <p:cNvPr id="203" name="Cartão 203"/>
+          <p:cNvSpPr/>
+          <p:nvPr/>
+        </p:nvSpPr>
+        <p:spPr>
+          <a:xfrm>
+            <a:off x="8568000" y="5292000"/>
+            <a:ext cx="9216000" cy="2376000"/>
+          </a:xfrm>
+          <a:prstGeom prst="roundRect">
+            <a:avLst>
+              <a:gd name="adj" fmla="val 5000"/>
+            </a:avLst>
+          </a:prstGeom>
+          <a:solidFill>
+            <a:srgbClr val="FFCE32"/>
+          </a:solidFill>
+          <a:ln w="38100">
+            <a:solidFill>
+              <a:srgbClr val="111111"/>
+            </a:solidFill>
+          </a:ln>
+        </p:spPr>
+        <p:txBody>
+          <a:bodyPr wrap="square" lIns="216000" tIns="216000" rIns="216000" bIns="216000" anchor="ctr" rtlCol="0">
+            <a:noAutofit/>
+          </a:bodyPr>
+          <a:lstStyle/>
+          <a:p>
+            <a:pPr algn="l">
+              <a:lnSpc>
+                <a:spcPct val="100000"/>
+              </a:lnSpc>
+              <a:spcBef>
+                <a:spcPts val="0"/>
+              </a:spcBef>
+              <a:spcAft>
+                <a:spcPts val="869"/>
+              </a:spcAft>
+              <a:buNone/>
+            </a:pPr>
+            <a:r>
+              <a:rPr lang="pt-BR" sz="2248" b="1" dirty="0">
+                <a:solidFill>
+                  <a:srgbClr val="111111"/>
+                </a:solidFill>
+                <a:latin typeface="Canva Sans Bold"/>
+                <a:ea typeface="Canva Sans Bold"/>
+                <a:cs typeface="Canva Sans Bold"/>
+                <a:sym typeface="Canva Sans Bold"/>
+              </a:rPr>
+              <a:t>Quando a política não faz chegar o equipamento nem a formação, quem paga, no cotidiano escolar, por esse vazio material e formativo?</a:t>
+            </a:r>
+            <a:endParaRPr lang="pt-BR" sz="2248" dirty="0"/>
+          </a:p>
+          <a:p>
+            <a:pPr algn="l">
+              <a:lnSpc>
+                <a:spcPct val="100000"/>
+              </a:lnSpc>
+              <a:spcBef>
+                <a:spcPts val="0"/>
+              </a:spcBef>
+              <a:spcAft>
+                <a:spcPts val="0"/>
+              </a:spcAft>
+              <a:buNone/>
+            </a:pPr>
+            <a:r>
+              <a:rPr lang="pt-BR" sz="2248" b="1" dirty="0">
+                <a:solidFill>
+                  <a:srgbClr val="111111"/>
+                </a:solidFill>
+                <a:latin typeface="Canva Sans Bold"/>
+                <a:ea typeface="Canva Sans Bold"/>
+                <a:cs typeface="Canva Sans Bold"/>
+                <a:sym typeface="Canva Sans Bold"/>
+              </a:rPr>
+              <a:t>E o que isso significa para os direitos que a lei prometeu às crianças?</a:t>
+            </a:r>
+            <a:endParaRPr lang="pt-BR" sz="2248" dirty="0"/>
+          </a:p>
+        </p:txBody>
+      </p:sp>
+      <p:sp>
+        <p:nvSpPr>
+          <p:cNvPr id="204" name="Cartão 204"/>
+          <p:cNvSpPr/>
+          <p:nvPr/>
+        </p:nvSpPr>
+        <p:spPr>
+          <a:xfrm>
+            <a:off x="8568000" y="7884000"/>
+            <a:ext cx="9216000" cy="2160000"/>
+          </a:xfrm>
+          <a:prstGeom prst="roundRect">
+            <a:avLst>
+              <a:gd name="adj" fmla="val 5000"/>
+            </a:avLst>
+          </a:prstGeom>
+          <a:solidFill>
+            <a:srgbClr val="EFE3D4"/>
+          </a:solidFill>
+          <a:ln w="38100">
+            <a:solidFill>
+              <a:srgbClr val="111111"/>
+            </a:solidFill>
+          </a:ln>
+        </p:spPr>
+        <p:txBody>
+          <a:bodyPr wrap="square" lIns="180000" tIns="180000" rIns="180000" bIns="180000" anchor="ctr" rtlCol="0">
+            <a:noAutofit/>
+          </a:bodyPr>
+          <a:lstStyle/>
+          <a:p>
+            <a:pPr algn="l">
+              <a:lnSpc>
+                <a:spcPct val="100000"/>
+              </a:lnSpc>
+              <a:spcBef>
+                <a:spcPts val="0"/>
+              </a:spcBef>
+              <a:spcAft>
+                <a:spcPts val="434"/>
+              </a:spcAft>
+              <a:buNone/>
+            </a:pPr>
+            <a:r>
+              <a:rPr lang="pt-BR" sz="2175" b="1" dirty="0">
+                <a:solidFill>
+                  <a:srgbClr val="111111"/>
+                </a:solidFill>
+                <a:latin typeface="Canva Sans Bold"/>
+                <a:ea typeface="Canva Sans Bold"/>
+                <a:cs typeface="Canva Sans Bold"/>
+                <a:sym typeface="Canva Sans Bold"/>
+              </a:rPr>
+              <a:t>Próximos passos</a:t>
+            </a:r>
+            <a:endParaRPr lang="pt-BR" sz="2175" dirty="0"/>
+          </a:p>
+          <a:p>
+            <a:pPr algn="l">
+              <a:lnSpc>
+                <a:spcPct val="100000"/>
+              </a:lnSpc>
+              <a:spcBef>
+                <a:spcPts val="0"/>
+              </a:spcBef>
+              <a:spcAft>
+                <a:spcPts val="0"/>
+              </a:spcAft>
+              <a:buNone/>
+            </a:pPr>
+            <a:r>
+              <a:rPr lang="pt-BR" sz="1885" dirty="0">
+                <a:solidFill>
+                  <a:srgbClr val="111111"/>
+                </a:solidFill>
+                <a:latin typeface="Canva Sans"/>
+                <a:ea typeface="Canva Sans"/>
+                <a:cs typeface="Canva Sans"/>
+                <a:sym typeface="Canva Sans"/>
+              </a:rPr>
+              <a:t>Emenda ao CEP, com a SME coparticipante · campo em dez semanas após a aprovação · análise documental: os documentos da escola já foram solicitados à direção, e os municipais, ao técnico da Secretaria de Educação · capítulo 7, com as narrativas dos profissionais · contribuições da banca</a:t>
+            </a:r>
+            <a:endParaRPr lang="pt-BR" sz="1885" dirty="0"/>
           </a:p>
         </p:txBody>
       </p:sp>
@@ -25885,6 +26035,541 @@
       </p:sp>
       <p:sp>
         <p:nvSpPr>
+          <p:cNvPr name="Freeform 3" id="3"/>
+          <p:cNvSpPr/>
+          <p:nvPr/>
+        </p:nvSpPr>
+        <p:spPr>
+          <a:xfrm flipH="false" flipV="false" rot="0">
+            <a:off x="-2498597" y="-108828"/>
+            <a:ext cx="6582509" cy="10746953"/>
+          </a:xfrm>
+          <a:custGeom>
+            <a:avLst/>
+            <a:gdLst/>
+            <a:ahLst/>
+            <a:cxnLst/>
+            <a:rect r="r" b="b" t="t" l="l"/>
+            <a:pathLst>
+              <a:path h="10746953" w="6582509">
+                <a:moveTo>
+                  <a:pt x="0" y="0"/>
+                </a:moveTo>
+                <a:lnTo>
+                  <a:pt x="6582509" y="0"/>
+                </a:lnTo>
+                <a:lnTo>
+                  <a:pt x="6582509" y="10746953"/>
+                </a:lnTo>
+                <a:lnTo>
+                  <a:pt x="0" y="10746953"/>
+                </a:lnTo>
+                <a:lnTo>
+                  <a:pt x="0" y="0"/>
+                </a:lnTo>
+                <a:close/>
+              </a:path>
+            </a:pathLst>
+          </a:custGeom>
+          <a:blipFill>
+            <a:blip r:embed="rId3">
+              <a:extLst>
+                <a:ext uri="{96DAC541-7B7A-43D3-8B79-37D633B846F1}">
+                  <asvg:svgBlip xmlns:asvg="http://schemas.microsoft.com/office/drawing/2016/SVG/main" r:embed="rId4"/>
+                </a:ext>
+              </a:extLst>
+            </a:blip>
+            <a:stretch>
+              <a:fillRect l="0" t="0" r="0" b="0"/>
+            </a:stretch>
+          </a:blipFill>
+        </p:spPr>
+      </p:sp>
+      <p:sp>
+        <p:nvSpPr>
+          <p:cNvPr name="Freeform 4" id="4"/>
+          <p:cNvSpPr/>
+          <p:nvPr/>
+        </p:nvSpPr>
+        <p:spPr>
+          <a:xfrm flipH="false" flipV="false" rot="-797725">
+            <a:off x="13679956" y="-1054879"/>
+            <a:ext cx="4476702" cy="4994292"/>
+          </a:xfrm>
+          <a:custGeom>
+            <a:avLst/>
+            <a:gdLst/>
+            <a:ahLst/>
+            <a:cxnLst/>
+            <a:rect r="r" b="b" t="t" l="l"/>
+            <a:pathLst>
+              <a:path h="4994292" w="4476702">
+                <a:moveTo>
+                  <a:pt x="0" y="0"/>
+                </a:moveTo>
+                <a:lnTo>
+                  <a:pt x="4476701" y="0"/>
+                </a:lnTo>
+                <a:lnTo>
+                  <a:pt x="4476701" y="4994292"/>
+                </a:lnTo>
+                <a:lnTo>
+                  <a:pt x="0" y="4994292"/>
+                </a:lnTo>
+                <a:lnTo>
+                  <a:pt x="0" y="0"/>
+                </a:lnTo>
+                <a:close/>
+              </a:path>
+            </a:pathLst>
+          </a:custGeom>
+          <a:blipFill>
+            <a:blip r:embed="rId5">
+              <a:extLst>
+                <a:ext uri="{96DAC541-7B7A-43D3-8B79-37D633B846F1}">
+                  <asvg:svgBlip xmlns:asvg="http://schemas.microsoft.com/office/drawing/2016/SVG/main" r:embed="rId6"/>
+                </a:ext>
+              </a:extLst>
+            </a:blip>
+            <a:stretch>
+              <a:fillRect l="0" t="0" r="0" b="0"/>
+            </a:stretch>
+          </a:blipFill>
+        </p:spPr>
+      </p:sp>
+      <p:sp>
+        <p:nvSpPr>
+          <p:cNvPr name="Freeform 5" id="5"/>
+          <p:cNvSpPr/>
+          <p:nvPr/>
+        </p:nvSpPr>
+        <p:spPr>
+          <a:xfrm flipH="false" flipV="false" rot="0">
+            <a:off x="14944550" y="2366363"/>
+            <a:ext cx="5751911" cy="14071953"/>
+          </a:xfrm>
+          <a:custGeom>
+            <a:avLst/>
+            <a:gdLst/>
+            <a:ahLst/>
+            <a:cxnLst/>
+            <a:rect r="r" b="b" t="t" l="l"/>
+            <a:pathLst>
+              <a:path h="14071953" w="5751911">
+                <a:moveTo>
+                  <a:pt x="0" y="0"/>
+                </a:moveTo>
+                <a:lnTo>
+                  <a:pt x="5751911" y="0"/>
+                </a:lnTo>
+                <a:lnTo>
+                  <a:pt x="5751911" y="14071954"/>
+                </a:lnTo>
+                <a:lnTo>
+                  <a:pt x="0" y="14071954"/>
+                </a:lnTo>
+                <a:lnTo>
+                  <a:pt x="0" y="0"/>
+                </a:lnTo>
+                <a:close/>
+              </a:path>
+            </a:pathLst>
+          </a:custGeom>
+          <a:blipFill>
+            <a:blip r:embed="rId7">
+              <a:extLst>
+                <a:ext uri="{96DAC541-7B7A-43D3-8B79-37D633B846F1}">
+                  <asvg:svgBlip xmlns:asvg="http://schemas.microsoft.com/office/drawing/2016/SVG/main" r:embed="rId8"/>
+                </a:ext>
+              </a:extLst>
+            </a:blip>
+            <a:stretch>
+              <a:fillRect l="0" t="0" r="0" b="0"/>
+            </a:stretch>
+          </a:blipFill>
+        </p:spPr>
+      </p:sp>
+      <p:sp>
+        <p:nvSpPr>
+          <p:cNvPr name="Freeform 6" id="6"/>
+          <p:cNvSpPr/>
+          <p:nvPr/>
+        </p:nvSpPr>
+        <p:spPr>
+          <a:xfrm flipH="true" flipV="false" rot="0">
+            <a:off x="792658" y="5143500"/>
+            <a:ext cx="4946577" cy="5519194"/>
+          </a:xfrm>
+          <a:custGeom>
+            <a:avLst/>
+            <a:gdLst/>
+            <a:ahLst/>
+            <a:cxnLst/>
+            <a:rect r="r" b="b" t="t" l="l"/>
+            <a:pathLst>
+              <a:path h="5519194" w="4946577">
+                <a:moveTo>
+                  <a:pt x="4946577" y="0"/>
+                </a:moveTo>
+                <a:lnTo>
+                  <a:pt x="0" y="0"/>
+                </a:lnTo>
+                <a:lnTo>
+                  <a:pt x="0" y="5519194"/>
+                </a:lnTo>
+                <a:lnTo>
+                  <a:pt x="4946577" y="5519194"/>
+                </a:lnTo>
+                <a:lnTo>
+                  <a:pt x="4946577" y="0"/>
+                </a:lnTo>
+                <a:close/>
+              </a:path>
+            </a:pathLst>
+          </a:custGeom>
+          <a:blipFill>
+            <a:blip r:embed="rId9">
+              <a:extLst>
+                <a:ext uri="{96DAC541-7B7A-43D3-8B79-37D633B846F1}">
+                  <asvg:svgBlip xmlns:asvg="http://schemas.microsoft.com/office/drawing/2016/SVG/main" r:embed="rId10"/>
+                </a:ext>
+              </a:extLst>
+            </a:blip>
+            <a:stretch>
+              <a:fillRect l="0" t="0" r="0" b="0"/>
+            </a:stretch>
+          </a:blipFill>
+        </p:spPr>
+      </p:sp>
+      <p:sp>
+        <p:nvSpPr>
+          <p:cNvPr name="Freeform 7" id="7"/>
+          <p:cNvSpPr/>
+          <p:nvPr/>
+        </p:nvSpPr>
+        <p:spPr>
+          <a:xfrm flipH="true" flipV="false" rot="0">
+            <a:off x="11066058" y="4957733"/>
+            <a:ext cx="6322410" cy="7438130"/>
+          </a:xfrm>
+          <a:custGeom>
+            <a:avLst/>
+            <a:gdLst/>
+            <a:ahLst/>
+            <a:cxnLst/>
+            <a:rect r="r" b="b" t="t" l="l"/>
+            <a:pathLst>
+              <a:path h="7438130" w="6322410">
+                <a:moveTo>
+                  <a:pt x="6322410" y="0"/>
+                </a:moveTo>
+                <a:lnTo>
+                  <a:pt x="0" y="0"/>
+                </a:lnTo>
+                <a:lnTo>
+                  <a:pt x="0" y="7438130"/>
+                </a:lnTo>
+                <a:lnTo>
+                  <a:pt x="6322410" y="7438130"/>
+                </a:lnTo>
+                <a:lnTo>
+                  <a:pt x="6322410" y="0"/>
+                </a:lnTo>
+                <a:close/>
+              </a:path>
+            </a:pathLst>
+          </a:custGeom>
+          <a:blipFill>
+            <a:blip r:embed="rId11">
+              <a:extLst>
+                <a:ext uri="{96DAC541-7B7A-43D3-8B79-37D633B846F1}">
+                  <asvg:svgBlip xmlns:asvg="http://schemas.microsoft.com/office/drawing/2016/SVG/main" r:embed="rId12"/>
+                </a:ext>
+              </a:extLst>
+            </a:blip>
+            <a:stretch>
+              <a:fillRect l="0" t="0" r="0" b="0"/>
+            </a:stretch>
+          </a:blipFill>
+        </p:spPr>
+      </p:sp>
+      <p:sp>
+        <p:nvSpPr>
+          <p:cNvPr name="Freeform 9" id="9"/>
+          <p:cNvSpPr/>
+          <p:nvPr/>
+        </p:nvSpPr>
+        <p:spPr>
+          <a:xfrm flipH="false" flipV="false" rot="0">
+            <a:off x="5976517" y="-809891"/>
+            <a:ext cx="4294014" cy="3427404"/>
+          </a:xfrm>
+          <a:custGeom>
+            <a:avLst/>
+            <a:gdLst/>
+            <a:ahLst/>
+            <a:cxnLst/>
+            <a:rect r="r" b="b" t="t" l="l"/>
+            <a:pathLst>
+              <a:path h="3427404" w="4294014">
+                <a:moveTo>
+                  <a:pt x="0" y="0"/>
+                </a:moveTo>
+                <a:lnTo>
+                  <a:pt x="4294014" y="0"/>
+                </a:lnTo>
+                <a:lnTo>
+                  <a:pt x="4294014" y="3427404"/>
+                </a:lnTo>
+                <a:lnTo>
+                  <a:pt x="0" y="3427404"/>
+                </a:lnTo>
+                <a:lnTo>
+                  <a:pt x="0" y="0"/>
+                </a:lnTo>
+                <a:close/>
+              </a:path>
+            </a:pathLst>
+          </a:custGeom>
+          <a:blipFill>
+            <a:blip r:embed="rId13">
+              <a:extLst>
+                <a:ext uri="{96DAC541-7B7A-43D3-8B79-37D633B846F1}">
+                  <asvg:svgBlip xmlns:asvg="http://schemas.microsoft.com/office/drawing/2016/SVG/main" r:embed="rId14"/>
+                </a:ext>
+              </a:extLst>
+            </a:blip>
+            <a:stretch>
+              <a:fillRect l="0" t="0" r="0" b="0"/>
+            </a:stretch>
+          </a:blipFill>
+        </p:spPr>
+      </p:sp>
+      <p:sp>
+        <p:nvSpPr>
+          <p:cNvPr name="Freeform 10" id="10"/>
+          <p:cNvSpPr/>
+          <p:nvPr/>
+        </p:nvSpPr>
+        <p:spPr>
+          <a:xfrm flipH="false" flipV="false" rot="-526312">
+            <a:off x="6081818" y="6805324"/>
+            <a:ext cx="5385775" cy="4905951"/>
+          </a:xfrm>
+          <a:custGeom>
+            <a:avLst/>
+            <a:gdLst/>
+            <a:ahLst/>
+            <a:cxnLst/>
+            <a:rect r="r" b="b" t="t" l="l"/>
+            <a:pathLst>
+              <a:path h="4905951" w="5385775">
+                <a:moveTo>
+                  <a:pt x="0" y="0"/>
+                </a:moveTo>
+                <a:lnTo>
+                  <a:pt x="5385774" y="0"/>
+                </a:lnTo>
+                <a:lnTo>
+                  <a:pt x="5385774" y="4905952"/>
+                </a:lnTo>
+                <a:lnTo>
+                  <a:pt x="0" y="4905952"/>
+                </a:lnTo>
+                <a:lnTo>
+                  <a:pt x="0" y="0"/>
+                </a:lnTo>
+                <a:close/>
+              </a:path>
+            </a:pathLst>
+          </a:custGeom>
+          <a:blipFill>
+            <a:blip r:embed="rId15">
+              <a:extLst>
+                <a:ext uri="{96DAC541-7B7A-43D3-8B79-37D633B846F1}">
+                  <asvg:svgBlip xmlns:asvg="http://schemas.microsoft.com/office/drawing/2016/SVG/main" r:embed="rId16"/>
+                </a:ext>
+              </a:extLst>
+            </a:blip>
+            <a:stretch>
+              <a:fillRect l="0" t="0" r="0" b="0"/>
+            </a:stretch>
+          </a:blipFill>
+        </p:spPr>
+      </p:sp>
+      <p:sp>
+        <p:nvSpPr>
+          <p:cNvPr id="201" name="Título 201"/>
+          <p:cNvSpPr txBox="1"/>
+          <p:nvPr/>
+        </p:nvSpPr>
+        <p:spPr>
+          <a:xfrm>
+            <a:off x="3960000" y="2232000"/>
+            <a:ext cx="10368000" cy="2304000"/>
+          </a:xfrm>
+          <a:prstGeom prst="rect">
+            <a:avLst/>
+          </a:prstGeom>
+          <a:noFill/>
+        </p:spPr>
+        <p:txBody>
+          <a:bodyPr wrap="square" lIns="0" tIns="0" rIns="0" bIns="0" anchor="ctr" rtlCol="0">
+            <a:noAutofit/>
+          </a:bodyPr>
+          <a:lstStyle/>
+          <a:p>
+            <a:pPr algn="ctr">
+              <a:lnSpc>
+                <a:spcPct val="85000"/>
+              </a:lnSpc>
+              <a:spcBef>
+                <a:spcPts val="0"/>
+              </a:spcBef>
+              <a:spcAft>
+                <a:spcPts val="0"/>
+              </a:spcAft>
+              <a:buNone/>
+            </a:pPr>
+            <a:r>
+              <a:rPr lang="pt-BR" sz="11000" b="1" dirty="0">
+                <a:solidFill>
+                  <a:srgbClr val="FFFFFF"/>
+                </a:solidFill>
+                <a:latin typeface="Canva Sans Bold"/>
+                <a:ea typeface="Canva Sans Bold"/>
+                <a:cs typeface="Canva Sans Bold"/>
+                <a:sym typeface="Canva Sans Bold"/>
+              </a:rPr>
+              <a:t>AGRADEÇO</a:t>
+            </a:r>
+            <a:endParaRPr lang="pt-BR" sz="11000" dirty="0"/>
+          </a:p>
+        </p:txBody>
+      </p:sp>
+      <p:sp>
+        <p:nvSpPr>
+          <p:cNvPr id="202" name="Texto 202"/>
+          <p:cNvSpPr txBox="1"/>
+          <p:nvPr/>
+        </p:nvSpPr>
+        <p:spPr>
+          <a:xfrm>
+            <a:off x="3960000" y="4428000"/>
+            <a:ext cx="10368000" cy="648000"/>
+          </a:xfrm>
+          <a:prstGeom prst="rect">
+            <a:avLst/>
+          </a:prstGeom>
+          <a:noFill/>
+        </p:spPr>
+        <p:txBody>
+          <a:bodyPr wrap="square" lIns="0" tIns="0" rIns="0" bIns="0" anchor="t" rtlCol="0">
+            <a:noAutofit/>
+          </a:bodyPr>
+          <a:lstStyle/>
+          <a:p>
+            <a:pPr algn="ctr">
+              <a:lnSpc>
+                <a:spcPct val="95000"/>
+              </a:lnSpc>
+              <a:spcBef>
+                <a:spcPts val="0"/>
+              </a:spcBef>
+              <a:spcAft>
+                <a:spcPts val="0"/>
+              </a:spcAft>
+              <a:buNone/>
+            </a:pPr>
+            <a:r>
+              <a:rPr lang="pt-BR" sz="2900" dirty="0">
+                <a:solidFill>
+                  <a:srgbClr val="FFFFFF"/>
+                </a:solidFill>
+                <a:latin typeface="Canva Sans"/>
+                <a:ea typeface="Canva Sans"/>
+                <a:cs typeface="Canva Sans"/>
+                <a:sym typeface="Canva Sans"/>
+              </a:rPr>
+              <a:t>pela atenção e pelas contribuições</a:t>
+            </a:r>
+            <a:endParaRPr lang="pt-BR" sz="2900" dirty="0"/>
+          </a:p>
+        </p:txBody>
+      </p:sp>
+    </p:spTree>
+  </p:cSld>
+  <p:clrMapOvr>
+    <a:masterClrMapping/>
+  </p:clrMapOvr>
+</p:sld>
+</file>
+
+<file path=ppt/slides/slide40.xml><?xml version="1.0" encoding="utf-8"?>
+<p:sld xmlns:p="http://schemas.openxmlformats.org/presentationml/2006/main" xmlns:a="http://schemas.openxmlformats.org/drawingml/2006/main" xmlns:r="http://schemas.openxmlformats.org/officeDocument/2006/relationships">
+  <p:cSld>
+    <p:spTree>
+      <p:nvGrpSpPr>
+        <p:cNvPr id="1" name=""/>
+        <p:cNvGrpSpPr/>
+        <p:nvPr/>
+      </p:nvGrpSpPr>
+      <p:grpSpPr>
+        <a:xfrm>
+          <a:off x="0" y="0"/>
+          <a:ext cx="0" cy="0"/>
+          <a:chOff x="0" y="0"/>
+          <a:chExt cx="0" cy="0"/>
+        </a:xfrm>
+      </p:grpSpPr>
+      <p:sp>
+        <p:nvSpPr>
+          <p:cNvPr name="Freeform 2" id="2"/>
+          <p:cNvSpPr/>
+          <p:nvPr/>
+        </p:nvSpPr>
+        <p:spPr>
+          <a:xfrm flipH="false" flipV="false" rot="0">
+            <a:off x="0" y="0"/>
+            <a:ext cx="18288000" cy="10287000"/>
+          </a:xfrm>
+          <a:custGeom>
+            <a:avLst/>
+            <a:gdLst/>
+            <a:ahLst/>
+            <a:cxnLst/>
+            <a:rect r="r" b="b" t="t" l="l"/>
+            <a:pathLst>
+              <a:path h="10287000" w="18288000">
+                <a:moveTo>
+                  <a:pt x="0" y="0"/>
+                </a:moveTo>
+                <a:lnTo>
+                  <a:pt x="18288000" y="0"/>
+                </a:lnTo>
+                <a:lnTo>
+                  <a:pt x="18288000" y="10287000"/>
+                </a:lnTo>
+                <a:lnTo>
+                  <a:pt x="0" y="10287000"/>
+                </a:lnTo>
+                <a:lnTo>
+                  <a:pt x="0" y="0"/>
+                </a:lnTo>
+                <a:close/>
+              </a:path>
+            </a:pathLst>
+          </a:custGeom>
+          <a:blipFill>
+            <a:blip r:embed="rId2"/>
+            <a:stretch>
+              <a:fillRect l="0" t="-108024" r="0" b="-108024"/>
+            </a:stretch>
+          </a:blipFill>
+        </p:spPr>
+      </p:sp>
+      <p:sp>
+        <p:nvSpPr>
           <p:cNvPr id="201" name="Título 201"/>
           <p:cNvSpPr txBox="1"/>
           <p:nvPr/>
@@ -27105,7 +27790,7 @@
 </p:sld>
 </file>
 
-<file path=ppt/slides/slide40.xml><?xml version="1.0" encoding="utf-8"?>
+<file path=ppt/slides/slide41.xml><?xml version="1.0" encoding="utf-8"?>
 <p:sld xmlns:p="http://schemas.openxmlformats.org/presentationml/2006/main" xmlns:a="http://schemas.openxmlformats.org/drawingml/2006/main" xmlns:r="http://schemas.openxmlformats.org/officeDocument/2006/relationships">
   <p:cSld>
     <p:spTree>

</xml_diff>

<commit_message>
Transforma o slide 4 em infográfico da questão de pesquisa e atualiza fala, mapa e estudo dirigido
Co-Authored-By: Claude Opus 5.5 <noreply@anthropic.com>
Claude-Session: https://claude.ai/code/session_01HxStpW4pQoDfJdTDYr6zEC
</commit_message>
<xml_diff>
--- a/apresentacao_qualificacao/Qualificacao_PNED_Pipa.pptx
+++ b/apresentacao_qualificacao/Qualificacao_PNED_Pipa.pptx
@@ -5482,131 +5482,6 @@
           </a:blipFill>
         </p:spPr>
       </p:sp>
-      <p:grpSp>
-        <p:nvGrpSpPr>
-          <p:cNvPr name="Group 3" id="3"/>
-          <p:cNvGrpSpPr/>
-          <p:nvPr/>
-        </p:nvGrpSpPr>
-        <p:grpSpPr>
-          <a:xfrm rot="0">
-            <a:off x="8899330" y="1028700"/>
-            <a:ext cx="10534934" cy="8229600"/>
-            <a:chOff x="0" y="0"/>
-            <a:chExt cx="2774633" cy="2167467"/>
-          </a:xfrm>
-        </p:grpSpPr>
-        <p:sp>
-          <p:nvSpPr>
-            <p:cNvPr name="Freeform 4" id="4"/>
-            <p:cNvSpPr/>
-            <p:nvPr/>
-          </p:nvSpPr>
-          <p:spPr>
-            <a:xfrm flipH="false" flipV="false" rot="0">
-              <a:off x="0" y="0"/>
-              <a:ext cx="2774633" cy="2167467"/>
-            </a:xfrm>
-            <a:custGeom>
-              <a:avLst/>
-              <a:gdLst/>
-              <a:ahLst/>
-              <a:cxnLst/>
-              <a:rect r="r" b="b" t="t" l="l"/>
-              <a:pathLst>
-                <a:path h="2167467" w="2774633">
-                  <a:moveTo>
-                    <a:pt x="30865" y="0"/>
-                  </a:moveTo>
-                  <a:lnTo>
-                    <a:pt x="2743768" y="0"/>
-                  </a:lnTo>
-                  <a:cubicBezTo>
-                    <a:pt x="2751954" y="0"/>
-                    <a:pt x="2759804" y="3252"/>
-                    <a:pt x="2765593" y="9040"/>
-                  </a:cubicBezTo>
-                  <a:cubicBezTo>
-                    <a:pt x="2771381" y="14828"/>
-                    <a:pt x="2774633" y="22679"/>
-                    <a:pt x="2774633" y="30865"/>
-                  </a:cubicBezTo>
-                  <a:lnTo>
-                    <a:pt x="2774633" y="2136602"/>
-                  </a:lnTo>
-                  <a:cubicBezTo>
-                    <a:pt x="2774633" y="2144788"/>
-                    <a:pt x="2771381" y="2152638"/>
-                    <a:pt x="2765593" y="2158427"/>
-                  </a:cubicBezTo>
-                  <a:cubicBezTo>
-                    <a:pt x="2759804" y="2164215"/>
-                    <a:pt x="2751954" y="2167467"/>
-                    <a:pt x="2743768" y="2167467"/>
-                  </a:cubicBezTo>
-                  <a:lnTo>
-                    <a:pt x="30865" y="2167467"/>
-                  </a:lnTo>
-                  <a:cubicBezTo>
-                    <a:pt x="22679" y="2167467"/>
-                    <a:pt x="14828" y="2164215"/>
-                    <a:pt x="9040" y="2158427"/>
-                  </a:cubicBezTo>
-                  <a:cubicBezTo>
-                    <a:pt x="3252" y="2152638"/>
-                    <a:pt x="0" y="2144788"/>
-                    <a:pt x="0" y="2136602"/>
-                  </a:cubicBezTo>
-                  <a:lnTo>
-                    <a:pt x="0" y="30865"/>
-                  </a:lnTo>
-                  <a:cubicBezTo>
-                    <a:pt x="0" y="22679"/>
-                    <a:pt x="3252" y="14828"/>
-                    <a:pt x="9040" y="9040"/>
-                  </a:cubicBezTo>
-                  <a:cubicBezTo>
-                    <a:pt x="14828" y="3252"/>
-                    <a:pt x="22679" y="0"/>
-                    <a:pt x="30865" y="0"/>
-                  </a:cubicBezTo>
-                  <a:close/>
-                </a:path>
-              </a:pathLst>
-            </a:custGeom>
-            <a:solidFill>
-              <a:srgbClr val="FFCE32"/>
-            </a:solidFill>
-          </p:spPr>
-        </p:sp>
-        <p:sp>
-          <p:nvSpPr>
-            <p:cNvPr name="TextBox 5" id="5"/>
-            <p:cNvSpPr txBox="true"/>
-            <p:nvPr/>
-          </p:nvSpPr>
-          <p:spPr>
-            <a:xfrm>
-              <a:off x="0" y="-57150"/>
-              <a:ext cx="2774633" cy="2224617"/>
-            </a:xfrm>
-            <a:prstGeom prst="rect">
-              <a:avLst/>
-            </a:prstGeom>
-          </p:spPr>
-          <p:txBody>
-            <a:bodyPr anchor="ctr" rtlCol="false" tIns="50800" lIns="50800" bIns="50800" rIns="50800"/>
-            <a:lstStyle/>
-            <a:p>
-              <a:pPr algn="ctr">
-                <a:lnSpc>
-                  <a:spcPts val="3499"/>
-                </a:lnSpc>
-              </a:pPr>
-            </a:p>
-          </p:txBody>
-        </p:sp>
-      </p:grpSp>
       <p:sp>
         <p:nvSpPr>
           <p:cNvPr name="Freeform 6" id="6"/>
@@ -5615,8 +5490,8 @@
         </p:nvSpPr>
         <p:spPr>
           <a:xfrm flipH="false" flipV="false" rot="0">
-            <a:off x="3732593" y="-476467"/>
-            <a:ext cx="5603193" cy="4900247"/>
+            <a:off x="16056000" y="-216000"/>
+            <a:ext cx="2304000" cy="2016000"/>
           </a:xfrm>
           <a:custGeom>
             <a:avLst/>
@@ -5661,170 +5536,14 @@
       </p:sp>
       <p:sp>
         <p:nvSpPr>
-          <p:cNvPr name="Freeform 7" id="7"/>
-          <p:cNvSpPr/>
-          <p:nvPr/>
-        </p:nvSpPr>
-        <p:spPr>
-          <a:xfrm flipH="false" flipV="false" rot="0">
-            <a:off x="0" y="3196942"/>
-            <a:ext cx="8002332" cy="8046221"/>
-          </a:xfrm>
-          <a:custGeom>
-            <a:avLst/>
-            <a:gdLst/>
-            <a:ahLst/>
-            <a:cxnLst/>
-            <a:rect r="r" b="b" t="t" l="l"/>
-            <a:pathLst>
-              <a:path h="8046221" w="8002332">
-                <a:moveTo>
-                  <a:pt x="0" y="0"/>
-                </a:moveTo>
-                <a:lnTo>
-                  <a:pt x="8002332" y="0"/>
-                </a:lnTo>
-                <a:lnTo>
-                  <a:pt x="8002332" y="8046221"/>
-                </a:lnTo>
-                <a:lnTo>
-                  <a:pt x="0" y="8046221"/>
-                </a:lnTo>
-                <a:lnTo>
-                  <a:pt x="0" y="0"/>
-                </a:lnTo>
-                <a:close/>
-              </a:path>
-            </a:pathLst>
-          </a:custGeom>
-          <a:blipFill>
-            <a:blip r:embed="rId5">
-              <a:extLst>
-                <a:ext uri="{96DAC541-7B7A-43D3-8B79-37D633B846F1}">
-                  <asvg:svgBlip xmlns:asvg="http://schemas.microsoft.com/office/drawing/2016/SVG/main" r:embed="rId6"/>
-                </a:ext>
-              </a:extLst>
-            </a:blip>
-            <a:stretch>
-              <a:fillRect l="0" t="0" r="0" b="0"/>
-            </a:stretch>
-          </a:blipFill>
-        </p:spPr>
-      </p:sp>
-      <p:sp>
-        <p:nvSpPr>
-          <p:cNvPr name="Freeform 8" id="8"/>
-          <p:cNvSpPr/>
-          <p:nvPr/>
-        </p:nvSpPr>
-        <p:spPr>
-          <a:xfrm flipH="false" flipV="false" rot="0">
-            <a:off x="14698286" y="-1028700"/>
-            <a:ext cx="3897838" cy="4114800"/>
-          </a:xfrm>
-          <a:custGeom>
-            <a:avLst/>
-            <a:gdLst/>
-            <a:ahLst/>
-            <a:cxnLst/>
-            <a:rect r="r" b="b" t="t" l="l"/>
-            <a:pathLst>
-              <a:path h="4114800" w="3897838">
-                <a:moveTo>
-                  <a:pt x="0" y="0"/>
-                </a:moveTo>
-                <a:lnTo>
-                  <a:pt x="3897838" y="0"/>
-                </a:lnTo>
-                <a:lnTo>
-                  <a:pt x="3897838" y="4114800"/>
-                </a:lnTo>
-                <a:lnTo>
-                  <a:pt x="0" y="4114800"/>
-                </a:lnTo>
-                <a:lnTo>
-                  <a:pt x="0" y="0"/>
-                </a:lnTo>
-                <a:close/>
-              </a:path>
-            </a:pathLst>
-          </a:custGeom>
-          <a:blipFill>
-            <a:blip r:embed="rId7">
-              <a:extLst>
-                <a:ext uri="{96DAC541-7B7A-43D3-8B79-37D633B846F1}">
-                  <asvg:svgBlip xmlns:asvg="http://schemas.microsoft.com/office/drawing/2016/SVG/main" r:embed="rId8"/>
-                </a:ext>
-              </a:extLst>
-            </a:blip>
-            <a:stretch>
-              <a:fillRect l="0" t="0" r="0" b="0"/>
-            </a:stretch>
-          </a:blipFill>
-        </p:spPr>
-      </p:sp>
-      <p:sp>
-        <p:nvSpPr>
-          <p:cNvPr name="Freeform 9" id="9"/>
-          <p:cNvSpPr/>
-          <p:nvPr/>
-        </p:nvSpPr>
-        <p:spPr>
-          <a:xfrm flipH="false" flipV="false" rot="0">
-            <a:off x="-1070688" y="308980"/>
-            <a:ext cx="4198776" cy="4114800"/>
-          </a:xfrm>
-          <a:custGeom>
-            <a:avLst/>
-            <a:gdLst/>
-            <a:ahLst/>
-            <a:cxnLst/>
-            <a:rect r="r" b="b" t="t" l="l"/>
-            <a:pathLst>
-              <a:path h="4114800" w="4198776">
-                <a:moveTo>
-                  <a:pt x="0" y="0"/>
-                </a:moveTo>
-                <a:lnTo>
-                  <a:pt x="4198776" y="0"/>
-                </a:lnTo>
-                <a:lnTo>
-                  <a:pt x="4198776" y="4114800"/>
-                </a:lnTo>
-                <a:lnTo>
-                  <a:pt x="0" y="4114800"/>
-                </a:lnTo>
-                <a:lnTo>
-                  <a:pt x="0" y="0"/>
-                </a:lnTo>
-                <a:close/>
-              </a:path>
-            </a:pathLst>
-          </a:custGeom>
-          <a:blipFill>
-            <a:blip r:embed="rId9">
-              <a:extLst>
-                <a:ext uri="{96DAC541-7B7A-43D3-8B79-37D633B846F1}">
-                  <asvg:svgBlip xmlns:asvg="http://schemas.microsoft.com/office/drawing/2016/SVG/main" r:embed="rId10"/>
-                </a:ext>
-              </a:extLst>
-            </a:blip>
-            <a:stretch>
-              <a:fillRect l="0" t="0" r="0" b="0"/>
-            </a:stretch>
-          </a:blipFill>
-        </p:spPr>
-      </p:sp>
-      <p:sp>
-        <p:nvSpPr>
           <p:cNvPr id="201" name="Título 201"/>
           <p:cNvSpPr txBox="1"/>
           <p:nvPr/>
         </p:nvSpPr>
         <p:spPr>
           <a:xfrm>
-            <a:off x="9648000" y="1656000"/>
-            <a:ext cx="4896000" cy="1872000"/>
+            <a:off x="612000" y="324000"/>
+            <a:ext cx="10800000" cy="1512000"/>
           </a:xfrm>
           <a:prstGeom prst="rect">
             <a:avLst/>
@@ -5852,7 +5571,7 @@
             <a:r>
               <a:rPr lang="pt-BR" sz="4000" b="1" dirty="0">
                 <a:solidFill>
-                  <a:srgbClr val="111111"/>
+                  <a:srgbClr val="FFFFFF"/>
                 </a:solidFill>
                 <a:latin typeface="Canva Sans Bold"/>
                 <a:ea typeface="Canva Sans Bold"/>
@@ -5863,71 +5582,130 @@
             </a:r>
             <a:endParaRPr lang="pt-BR" sz="4000" dirty="0"/>
           </a:p>
-        </p:txBody>
-      </p:sp>
-      <p:sp>
-        <p:nvSpPr>
-          <p:cNvPr id="202" name="Texto 202"/>
-          <p:cNvSpPr txBox="1"/>
-          <p:nvPr/>
-        </p:nvSpPr>
-        <p:spPr>
-          <a:xfrm>
-            <a:off x="9648000" y="3168000"/>
-            <a:ext cx="7776000" cy="5832000"/>
-          </a:xfrm>
-          <a:prstGeom prst="rect">
-            <a:avLst/>
-          </a:prstGeom>
-          <a:noFill/>
-        </p:spPr>
-        <p:txBody>
-          <a:bodyPr wrap="square" lIns="0" tIns="0" rIns="0" bIns="0" anchor="t" rtlCol="0">
-            <a:noAutofit/>
-          </a:bodyPr>
-          <a:lstStyle/>
           <a:p>
             <a:pPr algn="l">
               <a:lnSpc>
-                <a:spcPct val="103000"/>
-              </a:lnSpc>
-              <a:spcBef>
-                <a:spcPts val="0"/>
-              </a:spcBef>
-              <a:spcAft>
-                <a:spcPts val="869"/>
-              </a:spcAft>
-              <a:buNone/>
-            </a:pPr>
-            <a:r>
-              <a:rPr lang="pt-BR" sz="1958" dirty="0">
-                <a:solidFill>
-                  <a:srgbClr val="111111"/>
+                <a:spcPct val="95000"/>
+              </a:lnSpc>
+              <a:spcBef>
+                <a:spcPts val="0"/>
+              </a:spcBef>
+              <a:spcAft>
+                <a:spcPts val="0"/>
+              </a:spcAft>
+              <a:buNone/>
+            </a:pPr>
+            <a:r>
+              <a:rPr lang="pt-BR" sz="2400" dirty="0">
+                <a:solidFill>
+                  <a:srgbClr val="FFFFFF"/>
                 </a:solidFill>
                 <a:latin typeface="Canva Sans"/>
                 <a:ea typeface="Canva Sans"/>
                 <a:cs typeface="Canva Sans"/>
                 <a:sym typeface="Canva Sans"/>
               </a:rPr>
+              <a:t>como as partes se conectam</a:t>
+            </a:r>
+            <a:endParaRPr lang="pt-BR" sz="2400" dirty="0"/>
+          </a:p>
+        </p:txBody>
+      </p:sp>
+      <p:sp>
+        <p:nvSpPr>
+          <p:cNvPr id="202" name="Texto 202"/>
+          <p:cNvSpPr txBox="1"/>
+          <p:nvPr/>
+        </p:nvSpPr>
+        <p:spPr>
+          <a:xfrm>
+            <a:off x="612000" y="1908000"/>
+            <a:ext cx="15336000" cy="1584000"/>
+          </a:xfrm>
+          <a:prstGeom prst="rect">
+            <a:avLst/>
+          </a:prstGeom>
+          <a:noFill/>
+        </p:spPr>
+        <p:txBody>
+          <a:bodyPr wrap="square" lIns="0" tIns="0" rIns="0" bIns="0" anchor="ctr" rtlCol="0">
+            <a:noAutofit/>
+          </a:bodyPr>
+          <a:lstStyle/>
+          <a:p>
+            <a:pPr algn="l">
+              <a:lnSpc>
+                <a:spcPct val="100000"/>
+              </a:lnSpc>
+              <a:spcBef>
+                <a:spcPts val="0"/>
+              </a:spcBef>
+              <a:spcAft>
+                <a:spcPts val="0"/>
+              </a:spcAft>
+              <a:buNone/>
+            </a:pPr>
+            <a:r>
+              <a:rPr lang="pt-BR" sz="1522" i="1" dirty="0">
+                <a:solidFill>
+                  <a:srgbClr val="FFFFFF"/>
+                </a:solidFill>
+                <a:latin typeface="Canva Sans"/>
+                <a:ea typeface="Canva Sans"/>
+                <a:cs typeface="Canva Sans"/>
+                <a:sym typeface="Canva Sans"/>
+              </a:rPr>
               <a:t>Como a Política Nacional de Educação Digital é recontextualizada pela Secretaria Municipal de Educação de Tibau do Sul (RN), num território municipal que reúne áreas urbanas e rurais, povoados com realidades distintas e uma comunidade quilombola, e como essa recontextualização chega à Escola Municipal Domitila Castelo da Silva, em Pipa, onde os profissionais da educação a encenam, atravessados pelas culturas profissionais, pelas condições materiais e institucionais da escola e pelas especificidades do lugar, produzindo diferentes formas de atuação, entre as quais podem emergir acomodações, negociações, ressignificações e resistências?</a:t>
             </a:r>
-            <a:endParaRPr lang="pt-BR" sz="1958" dirty="0"/>
-          </a:p>
-          <a:p>
-            <a:pPr algn="l">
-              <a:lnSpc>
-                <a:spcPct val="100000"/>
-              </a:lnSpc>
-              <a:spcBef>
+            <a:endParaRPr lang="pt-BR" sz="1522" dirty="0"/>
+          </a:p>
+        </p:txBody>
+      </p:sp>
+      <p:sp>
+        <p:nvSpPr>
+          <p:cNvPr id="203" name="Cartão 203"/>
+          <p:cNvSpPr/>
+          <p:nvPr/>
+        </p:nvSpPr>
+        <p:spPr>
+          <a:xfrm>
+            <a:off x="612000" y="3744000"/>
+            <a:ext cx="2520000" cy="3456000"/>
+          </a:xfrm>
+          <a:prstGeom prst="roundRect">
+            <a:avLst>
+              <a:gd name="adj" fmla="val 9000"/>
+            </a:avLst>
+          </a:prstGeom>
+          <a:solidFill>
+            <a:srgbClr val="FFCE32"/>
+          </a:solidFill>
+          <a:ln w="38100">
+            <a:solidFill>
+              <a:srgbClr val="111111"/>
+            </a:solidFill>
+          </a:ln>
+        </p:spPr>
+        <p:txBody>
+          <a:bodyPr wrap="square" lIns="144000" tIns="144000" rIns="144000" bIns="144000" anchor="ctr" rtlCol="0">
+            <a:noAutofit/>
+          </a:bodyPr>
+          <a:lstStyle/>
+          <a:p>
+            <a:pPr algn="ctr">
+              <a:lnSpc>
+                <a:spcPct val="92000"/>
+              </a:lnSpc>
+              <a:spcBef>
+                <a:spcPts val="0"/>
+              </a:spcBef>
+              <a:spcAft>
                 <a:spcPts val="580"/>
-              </a:spcBef>
-              <a:spcAft>
-                <a:spcPts val="869"/>
-              </a:spcAft>
-              <a:buNone/>
-            </a:pPr>
-            <a:r>
-              <a:rPr lang="pt-BR" sz="1958" b="1" dirty="0">
+              </a:spcAft>
+              <a:buNone/>
+            </a:pPr>
+            <a:r>
+              <a:rPr lang="pt-BR" sz="2030" b="1" dirty="0">
                 <a:solidFill>
                   <a:srgbClr val="111111"/>
                 </a:solidFill>
@@ -5936,9 +5714,1097 @@
                 <a:cs typeface="Canva Sans Bold"/>
                 <a:sym typeface="Canva Sans Bold"/>
               </a:rPr>
-              <a:t>A resistência é uma possibilidade a examinar nos dados, sem ser pressuposta.</a:t>
-            </a:r>
-            <a:endParaRPr lang="pt-BR" sz="1958" dirty="0"/>
+              <a:t>A PNED</a:t>
+            </a:r>
+            <a:endParaRPr lang="pt-BR" sz="2030" dirty="0"/>
+          </a:p>
+          <a:p>
+            <a:pPr algn="ctr">
+              <a:lnSpc>
+                <a:spcPct val="100000"/>
+              </a:lnSpc>
+              <a:spcBef>
+                <a:spcPts val="0"/>
+              </a:spcBef>
+              <a:spcAft>
+                <a:spcPts val="0"/>
+              </a:spcAft>
+              <a:buNone/>
+            </a:pPr>
+            <a:r>
+              <a:rPr lang="pt-BR" sz="1522" dirty="0">
+                <a:solidFill>
+                  <a:srgbClr val="111111"/>
+                </a:solidFill>
+                <a:latin typeface="Canva Sans"/>
+                <a:ea typeface="Canva Sans"/>
+                <a:cs typeface="Canva Sans"/>
+                <a:sym typeface="Canva Sans"/>
+              </a:rPr>
+              <a:t>Lei nº 14.533/2023, eixo Educação Digital Escolar</a:t>
+            </a:r>
+            <a:endParaRPr lang="pt-BR" sz="1522" dirty="0"/>
+          </a:p>
+        </p:txBody>
+      </p:sp>
+      <p:sp>
+        <p:nvSpPr>
+          <p:cNvPr id="204" name="Cartão 204"/>
+          <p:cNvSpPr/>
+          <p:nvPr/>
+        </p:nvSpPr>
+        <p:spPr>
+          <a:xfrm>
+            <a:off x="3708000" y="3744000"/>
+            <a:ext cx="2952000" cy="3456000"/>
+          </a:xfrm>
+          <a:prstGeom prst="roundRect">
+            <a:avLst>
+              <a:gd name="adj" fmla="val 9000"/>
+            </a:avLst>
+          </a:prstGeom>
+          <a:solidFill>
+            <a:srgbClr val="FFFFFF"/>
+          </a:solidFill>
+          <a:ln w="38100">
+            <a:solidFill>
+              <a:srgbClr val="111111"/>
+            </a:solidFill>
+          </a:ln>
+        </p:spPr>
+        <p:txBody>
+          <a:bodyPr wrap="square" lIns="144000" tIns="144000" rIns="144000" bIns="144000" anchor="ctr" rtlCol="0">
+            <a:noAutofit/>
+          </a:bodyPr>
+          <a:lstStyle/>
+          <a:p>
+            <a:pPr algn="ctr">
+              <a:lnSpc>
+                <a:spcPct val="100000"/>
+              </a:lnSpc>
+              <a:spcBef>
+                <a:spcPts val="0"/>
+              </a:spcBef>
+              <a:spcAft>
+                <a:spcPts val="290"/>
+              </a:spcAft>
+              <a:buNone/>
+            </a:pPr>
+            <a:r>
+              <a:rPr lang="pt-BR" sz="1522" i="1" dirty="0">
+                <a:solidFill>
+                  <a:srgbClr val="3F48BA"/>
+                </a:solidFill>
+                <a:latin typeface="Canva Sans"/>
+                <a:ea typeface="Canva Sans"/>
+                <a:cs typeface="Canva Sans"/>
+                <a:sym typeface="Canva Sans"/>
+              </a:rPr>
+              <a:t>é recontextualizada pela</a:t>
+            </a:r>
+            <a:endParaRPr lang="pt-BR" sz="1522" dirty="0"/>
+          </a:p>
+          <a:p>
+            <a:pPr algn="ctr">
+              <a:lnSpc>
+                <a:spcPct val="92000"/>
+              </a:lnSpc>
+              <a:spcBef>
+                <a:spcPts val="0"/>
+              </a:spcBef>
+              <a:spcAft>
+                <a:spcPts val="580"/>
+              </a:spcAft>
+              <a:buNone/>
+            </a:pPr>
+            <a:r>
+              <a:rPr lang="pt-BR" sz="2030" b="1" dirty="0">
+                <a:solidFill>
+                  <a:srgbClr val="111111"/>
+                </a:solidFill>
+                <a:latin typeface="Canva Sans Bold"/>
+                <a:ea typeface="Canva Sans Bold"/>
+                <a:cs typeface="Canva Sans Bold"/>
+                <a:sym typeface="Canva Sans Bold"/>
+              </a:rPr>
+              <a:t>SME DE TIBAU DO SUL</a:t>
+            </a:r>
+            <a:endParaRPr lang="pt-BR" sz="2030" dirty="0"/>
+          </a:p>
+          <a:p>
+            <a:pPr algn="ctr">
+              <a:lnSpc>
+                <a:spcPct val="100000"/>
+              </a:lnSpc>
+              <a:spcBef>
+                <a:spcPts val="0"/>
+              </a:spcBef>
+              <a:spcAft>
+                <a:spcPts val="0"/>
+              </a:spcAft>
+              <a:buNone/>
+            </a:pPr>
+            <a:r>
+              <a:rPr lang="pt-BR" sz="1522" dirty="0">
+                <a:solidFill>
+                  <a:srgbClr val="111111"/>
+                </a:solidFill>
+                <a:latin typeface="Canva Sans"/>
+                <a:ea typeface="Canva Sans"/>
+                <a:cs typeface="Canva Sans"/>
+                <a:sym typeface="Canva Sans"/>
+              </a:rPr>
+              <a:t>traduz a política para um território diverso: sede, áreas rurais, povoados e a comunidade quilombola de Sibaúma</a:t>
+            </a:r>
+            <a:endParaRPr lang="pt-BR" sz="1522" dirty="0"/>
+          </a:p>
+        </p:txBody>
+      </p:sp>
+      <p:sp>
+        <p:nvSpPr>
+          <p:cNvPr id="205" name="Cartão 205"/>
+          <p:cNvSpPr/>
+          <p:nvPr/>
+        </p:nvSpPr>
+        <p:spPr>
+          <a:xfrm>
+            <a:off x="7236000" y="3744000"/>
+            <a:ext cx="2952000" cy="3456000"/>
+          </a:xfrm>
+          <a:prstGeom prst="roundRect">
+            <a:avLst>
+              <a:gd name="adj" fmla="val 9000"/>
+            </a:avLst>
+          </a:prstGeom>
+          <a:solidFill>
+            <a:srgbClr val="FFFFFF"/>
+          </a:solidFill>
+          <a:ln w="38100">
+            <a:solidFill>
+              <a:srgbClr val="111111"/>
+            </a:solidFill>
+          </a:ln>
+        </p:spPr>
+        <p:txBody>
+          <a:bodyPr wrap="square" lIns="144000" tIns="144000" rIns="144000" bIns="144000" anchor="ctr" rtlCol="0">
+            <a:noAutofit/>
+          </a:bodyPr>
+          <a:lstStyle/>
+          <a:p>
+            <a:pPr algn="ctr">
+              <a:lnSpc>
+                <a:spcPct val="100000"/>
+              </a:lnSpc>
+              <a:spcBef>
+                <a:spcPts val="0"/>
+              </a:spcBef>
+              <a:spcAft>
+                <a:spcPts val="290"/>
+              </a:spcAft>
+              <a:buNone/>
+            </a:pPr>
+            <a:r>
+              <a:rPr lang="pt-BR" sz="1522" i="1" dirty="0">
+                <a:solidFill>
+                  <a:srgbClr val="3F48BA"/>
+                </a:solidFill>
+                <a:latin typeface="Canva Sans"/>
+                <a:ea typeface="Canva Sans"/>
+                <a:cs typeface="Canva Sans"/>
+                <a:sym typeface="Canva Sans"/>
+              </a:rPr>
+              <a:t>e é encenada na</a:t>
+            </a:r>
+            <a:endParaRPr lang="pt-BR" sz="1522" dirty="0"/>
+          </a:p>
+          <a:p>
+            <a:pPr algn="ctr">
+              <a:lnSpc>
+                <a:spcPct val="92000"/>
+              </a:lnSpc>
+              <a:spcBef>
+                <a:spcPts val="0"/>
+              </a:spcBef>
+              <a:spcAft>
+                <a:spcPts val="580"/>
+              </a:spcAft>
+              <a:buNone/>
+            </a:pPr>
+            <a:r>
+              <a:rPr lang="pt-BR" sz="2030" b="1" dirty="0">
+                <a:solidFill>
+                  <a:srgbClr val="111111"/>
+                </a:solidFill>
+                <a:latin typeface="Canva Sans Bold"/>
+                <a:ea typeface="Canva Sans Bold"/>
+                <a:cs typeface="Canva Sans Bold"/>
+                <a:sym typeface="Canva Sans Bold"/>
+              </a:rPr>
+              <a:t>ESCOLA DE PIPA</a:t>
+            </a:r>
+            <a:endParaRPr lang="pt-BR" sz="2030" dirty="0"/>
+          </a:p>
+          <a:p>
+            <a:pPr algn="ctr">
+              <a:lnSpc>
+                <a:spcPct val="100000"/>
+              </a:lnSpc>
+              <a:spcBef>
+                <a:spcPts val="0"/>
+              </a:spcBef>
+              <a:spcAft>
+                <a:spcPts val="0"/>
+              </a:spcAft>
+              <a:buNone/>
+            </a:pPr>
+            <a:r>
+              <a:rPr lang="pt-BR" sz="1522" dirty="0">
+                <a:solidFill>
+                  <a:srgbClr val="111111"/>
+                </a:solidFill>
+                <a:latin typeface="Canva Sans"/>
+                <a:ea typeface="Canva Sans"/>
+                <a:cs typeface="Canva Sans"/>
+                <a:sym typeface="Canva Sans"/>
+              </a:rPr>
+              <a:t>EM Domitila Castelo da Silva, pelos profissionais da educação (os atores)</a:t>
+            </a:r>
+            <a:endParaRPr lang="pt-BR" sz="1522" dirty="0"/>
+          </a:p>
+        </p:txBody>
+      </p:sp>
+      <p:sp>
+        <p:nvSpPr>
+          <p:cNvPr id="206" name="Forma 206"/>
+          <p:cNvSpPr/>
+          <p:nvPr/>
+        </p:nvSpPr>
+        <p:spPr>
+          <a:xfrm>
+            <a:off x="3222000" y="5220000"/>
+            <a:ext cx="432000" cy="504000"/>
+          </a:xfrm>
+          <a:prstGeom prst="rightArrow">
+            <a:avLst/>
+          </a:prstGeom>
+          <a:solidFill>
+            <a:srgbClr val="FFCE32"/>
+          </a:solidFill>
+          <a:ln w="19050">
+            <a:solidFill>
+              <a:srgbClr val="111111"/>
+            </a:solidFill>
+          </a:ln>
+        </p:spPr>
+      </p:sp>
+      <p:sp>
+        <p:nvSpPr>
+          <p:cNvPr id="207" name="Forma 207"/>
+          <p:cNvSpPr/>
+          <p:nvPr/>
+        </p:nvSpPr>
+        <p:spPr>
+          <a:xfrm>
+            <a:off x="6750000" y="5220000"/>
+            <a:ext cx="432000" cy="504000"/>
+          </a:xfrm>
+          <a:prstGeom prst="rightArrow">
+            <a:avLst/>
+          </a:prstGeom>
+          <a:solidFill>
+            <a:srgbClr val="FFCE32"/>
+          </a:solidFill>
+          <a:ln w="19050">
+            <a:solidFill>
+              <a:srgbClr val="111111"/>
+            </a:solidFill>
+          </a:ln>
+        </p:spPr>
+      </p:sp>
+      <p:sp>
+        <p:nvSpPr>
+          <p:cNvPr id="208" name="Forma 208"/>
+          <p:cNvSpPr/>
+          <p:nvPr/>
+        </p:nvSpPr>
+        <p:spPr>
+          <a:xfrm>
+            <a:off x="10278000" y="5220000"/>
+            <a:ext cx="432000" cy="504000"/>
+          </a:xfrm>
+          <a:prstGeom prst="rightArrow">
+            <a:avLst/>
+          </a:prstGeom>
+          <a:solidFill>
+            <a:srgbClr val="FFCE32"/>
+          </a:solidFill>
+          <a:ln w="19050">
+            <a:solidFill>
+              <a:srgbClr val="111111"/>
+            </a:solidFill>
+          </a:ln>
+        </p:spPr>
+      </p:sp>
+      <p:sp>
+        <p:nvSpPr>
+          <p:cNvPr id="209" name="Cartão 209"/>
+          <p:cNvSpPr/>
+          <p:nvPr/>
+        </p:nvSpPr>
+        <p:spPr>
+          <a:xfrm>
+            <a:off x="10764000" y="3744000"/>
+            <a:ext cx="3456000" cy="3456000"/>
+          </a:xfrm>
+          <a:prstGeom prst="roundRect">
+            <a:avLst>
+              <a:gd name="adj" fmla="val 9000"/>
+            </a:avLst>
+          </a:prstGeom>
+          <a:solidFill>
+            <a:srgbClr val="EFE3D4"/>
+          </a:solidFill>
+          <a:ln w="38100">
+            <a:solidFill>
+              <a:srgbClr val="111111"/>
+            </a:solidFill>
+          </a:ln>
+        </p:spPr>
+        <p:txBody>
+          <a:bodyPr wrap="square" lIns="126000" tIns="126000" rIns="126000" bIns="126000" anchor="t" rtlCol="0">
+            <a:noAutofit/>
+          </a:bodyPr>
+          <a:lstStyle/>
+          <a:p>
+            <a:pPr algn="ctr">
+              <a:lnSpc>
+                <a:spcPct val="100000"/>
+              </a:lnSpc>
+              <a:spcBef>
+                <a:spcPts val="0"/>
+              </a:spcBef>
+              <a:spcAft>
+                <a:spcPts val="290"/>
+              </a:spcAft>
+              <a:buNone/>
+            </a:pPr>
+            <a:r>
+              <a:rPr lang="pt-BR" sz="1522" i="1" dirty="0">
+                <a:solidFill>
+                  <a:srgbClr val="3F48BA"/>
+                </a:solidFill>
+                <a:latin typeface="Canva Sans"/>
+                <a:ea typeface="Canva Sans"/>
+                <a:cs typeface="Canva Sans"/>
+                <a:sym typeface="Canva Sans"/>
+              </a:rPr>
+              <a:t>atravessada por</a:t>
+            </a:r>
+            <a:endParaRPr lang="pt-BR" sz="1522" dirty="0"/>
+          </a:p>
+        </p:txBody>
+      </p:sp>
+      <p:sp>
+        <p:nvSpPr>
+          <p:cNvPr id="210" name="Cartão 210"/>
+          <p:cNvSpPr/>
+          <p:nvPr/>
+        </p:nvSpPr>
+        <p:spPr>
+          <a:xfrm>
+            <a:off x="10980000" y="4284000"/>
+            <a:ext cx="3024000" cy="810000"/>
+          </a:xfrm>
+          <a:prstGeom prst="roundRect">
+            <a:avLst>
+              <a:gd name="adj" fmla="val 16000"/>
+            </a:avLst>
+          </a:prstGeom>
+          <a:solidFill>
+            <a:srgbClr val="FFFFFF"/>
+          </a:solidFill>
+          <a:ln w="19050">
+            <a:solidFill>
+              <a:srgbClr val="111111"/>
+            </a:solidFill>
+          </a:ln>
+        </p:spPr>
+        <p:txBody>
+          <a:bodyPr wrap="square" lIns="72000" tIns="72000" rIns="72000" bIns="72000" anchor="ctr" rtlCol="0">
+            <a:noAutofit/>
+          </a:bodyPr>
+          <a:lstStyle/>
+          <a:p>
+            <a:pPr algn="ctr">
+              <a:lnSpc>
+                <a:spcPct val="92000"/>
+              </a:lnSpc>
+              <a:spcBef>
+                <a:spcPts val="0"/>
+              </a:spcBef>
+              <a:spcAft>
+                <a:spcPts val="0"/>
+              </a:spcAft>
+              <a:buNone/>
+            </a:pPr>
+            <a:r>
+              <a:rPr lang="pt-BR" sz="1595" b="1" dirty="0">
+                <a:solidFill>
+                  <a:srgbClr val="111111"/>
+                </a:solidFill>
+                <a:latin typeface="Canva Sans Bold"/>
+                <a:ea typeface="Canva Sans Bold"/>
+                <a:cs typeface="Canva Sans Bold"/>
+                <a:sym typeface="Canva Sans Bold"/>
+              </a:rPr>
+              <a:t>Culturas profissionais</a:t>
+            </a:r>
+            <a:endParaRPr lang="pt-BR" sz="1595" dirty="0"/>
+          </a:p>
+        </p:txBody>
+      </p:sp>
+      <p:sp>
+        <p:nvSpPr>
+          <p:cNvPr id="211" name="Cartão 211"/>
+          <p:cNvSpPr/>
+          <p:nvPr/>
+        </p:nvSpPr>
+        <p:spPr>
+          <a:xfrm>
+            <a:off x="10980000" y="5238000"/>
+            <a:ext cx="3024000" cy="810000"/>
+          </a:xfrm>
+          <a:prstGeom prst="roundRect">
+            <a:avLst>
+              <a:gd name="adj" fmla="val 16000"/>
+            </a:avLst>
+          </a:prstGeom>
+          <a:solidFill>
+            <a:srgbClr val="FFFFFF"/>
+          </a:solidFill>
+          <a:ln w="19050">
+            <a:solidFill>
+              <a:srgbClr val="111111"/>
+            </a:solidFill>
+          </a:ln>
+        </p:spPr>
+        <p:txBody>
+          <a:bodyPr wrap="square" lIns="72000" tIns="72000" rIns="72000" bIns="72000" anchor="ctr" rtlCol="0">
+            <a:noAutofit/>
+          </a:bodyPr>
+          <a:lstStyle/>
+          <a:p>
+            <a:pPr algn="ctr">
+              <a:lnSpc>
+                <a:spcPct val="92000"/>
+              </a:lnSpc>
+              <a:spcBef>
+                <a:spcPts val="0"/>
+              </a:spcBef>
+              <a:spcAft>
+                <a:spcPts val="0"/>
+              </a:spcAft>
+              <a:buNone/>
+            </a:pPr>
+            <a:r>
+              <a:rPr lang="pt-BR" sz="1595" b="1" dirty="0">
+                <a:solidFill>
+                  <a:srgbClr val="111111"/>
+                </a:solidFill>
+                <a:latin typeface="Canva Sans Bold"/>
+                <a:ea typeface="Canva Sans Bold"/>
+                <a:cs typeface="Canva Sans Bold"/>
+                <a:sym typeface="Canva Sans Bold"/>
+              </a:rPr>
+              <a:t>Condições materiais e institucionais</a:t>
+            </a:r>
+            <a:endParaRPr lang="pt-BR" sz="1595" dirty="0"/>
+          </a:p>
+        </p:txBody>
+      </p:sp>
+      <p:sp>
+        <p:nvSpPr>
+          <p:cNvPr id="212" name="Cartão 212"/>
+          <p:cNvSpPr/>
+          <p:nvPr/>
+        </p:nvSpPr>
+        <p:spPr>
+          <a:xfrm>
+            <a:off x="10980000" y="6192000"/>
+            <a:ext cx="3024000" cy="810000"/>
+          </a:xfrm>
+          <a:prstGeom prst="roundRect">
+            <a:avLst>
+              <a:gd name="adj" fmla="val 16000"/>
+            </a:avLst>
+          </a:prstGeom>
+          <a:solidFill>
+            <a:srgbClr val="FFFFFF"/>
+          </a:solidFill>
+          <a:ln w="19050">
+            <a:solidFill>
+              <a:srgbClr val="111111"/>
+            </a:solidFill>
+          </a:ln>
+        </p:spPr>
+        <p:txBody>
+          <a:bodyPr wrap="square" lIns="72000" tIns="72000" rIns="72000" bIns="72000" anchor="ctr" rtlCol="0">
+            <a:noAutofit/>
+          </a:bodyPr>
+          <a:lstStyle/>
+          <a:p>
+            <a:pPr algn="ctr">
+              <a:lnSpc>
+                <a:spcPct val="92000"/>
+              </a:lnSpc>
+              <a:spcBef>
+                <a:spcPts val="0"/>
+              </a:spcBef>
+              <a:spcAft>
+                <a:spcPts val="0"/>
+              </a:spcAft>
+              <a:buNone/>
+            </a:pPr>
+            <a:r>
+              <a:rPr lang="pt-BR" sz="1595" b="1" dirty="0">
+                <a:solidFill>
+                  <a:srgbClr val="111111"/>
+                </a:solidFill>
+                <a:latin typeface="Canva Sans Bold"/>
+                <a:ea typeface="Canva Sans Bold"/>
+                <a:cs typeface="Canva Sans Bold"/>
+                <a:sym typeface="Canva Sans Bold"/>
+              </a:rPr>
+              <a:t>Especificidades do lugar (território)</a:t>
+            </a:r>
+            <a:endParaRPr lang="pt-BR" sz="1595" dirty="0"/>
+          </a:p>
+        </p:txBody>
+      </p:sp>
+      <p:sp>
+        <p:nvSpPr>
+          <p:cNvPr id="213" name="Forma 213"/>
+          <p:cNvSpPr/>
+          <p:nvPr/>
+        </p:nvSpPr>
+        <p:spPr>
+          <a:xfrm>
+            <a:off x="14256000" y="5220000"/>
+            <a:ext cx="432000" cy="504000"/>
+          </a:xfrm>
+          <a:prstGeom prst="rightArrow">
+            <a:avLst/>
+          </a:prstGeom>
+          <a:solidFill>
+            <a:srgbClr val="FFCE32"/>
+          </a:solidFill>
+          <a:ln w="19050">
+            <a:solidFill>
+              <a:srgbClr val="111111"/>
+            </a:solidFill>
+          </a:ln>
+        </p:spPr>
+      </p:sp>
+      <p:sp>
+        <p:nvSpPr>
+          <p:cNvPr id="214" name="Cartão 214"/>
+          <p:cNvSpPr/>
+          <p:nvPr/>
+        </p:nvSpPr>
+        <p:spPr>
+          <a:xfrm>
+            <a:off x="14724000" y="3744000"/>
+            <a:ext cx="2952000" cy="3456000"/>
+          </a:xfrm>
+          <a:prstGeom prst="roundRect">
+            <a:avLst>
+              <a:gd name="adj" fmla="val 9000"/>
+            </a:avLst>
+          </a:prstGeom>
+          <a:solidFill>
+            <a:srgbClr val="FFCE32"/>
+          </a:solidFill>
+          <a:ln w="38100">
+            <a:solidFill>
+              <a:srgbClr val="111111"/>
+            </a:solidFill>
+          </a:ln>
+        </p:spPr>
+        <p:txBody>
+          <a:bodyPr wrap="square" lIns="144000" tIns="144000" rIns="144000" bIns="144000" anchor="ctr" rtlCol="0">
+            <a:noAutofit/>
+          </a:bodyPr>
+          <a:lstStyle/>
+          <a:p>
+            <a:pPr algn="ctr">
+              <a:lnSpc>
+                <a:spcPct val="100000"/>
+              </a:lnSpc>
+              <a:spcBef>
+                <a:spcPts val="0"/>
+              </a:spcBef>
+              <a:spcAft>
+                <a:spcPts val="290"/>
+              </a:spcAft>
+              <a:buNone/>
+            </a:pPr>
+            <a:r>
+              <a:rPr lang="pt-BR" sz="1522" i="1" dirty="0">
+                <a:solidFill>
+                  <a:srgbClr val="3F48BA"/>
+                </a:solidFill>
+                <a:latin typeface="Canva Sans"/>
+                <a:ea typeface="Canva Sans"/>
+                <a:cs typeface="Canva Sans"/>
+                <a:sym typeface="Canva Sans"/>
+              </a:rPr>
+              <a:t>e produz</a:t>
+            </a:r>
+            <a:endParaRPr lang="pt-BR" sz="1522" dirty="0"/>
+          </a:p>
+          <a:p>
+            <a:pPr algn="ctr">
+              <a:lnSpc>
+                <a:spcPct val="92000"/>
+              </a:lnSpc>
+              <a:spcBef>
+                <a:spcPts val="0"/>
+              </a:spcBef>
+              <a:spcAft>
+                <a:spcPts val="580"/>
+              </a:spcAft>
+              <a:buNone/>
+            </a:pPr>
+            <a:r>
+              <a:rPr lang="pt-BR" sz="2030" b="1" dirty="0">
+                <a:solidFill>
+                  <a:srgbClr val="111111"/>
+                </a:solidFill>
+                <a:latin typeface="Canva Sans Bold"/>
+                <a:ea typeface="Canva Sans Bold"/>
+                <a:cs typeface="Canva Sans Bold"/>
+                <a:sym typeface="Canva Sans Bold"/>
+              </a:rPr>
+              <a:t>FORMAS DE ATUAÇÃO</a:t>
+            </a:r>
+            <a:endParaRPr lang="pt-BR" sz="2030" dirty="0"/>
+          </a:p>
+          <a:p>
+            <a:pPr algn="ctr">
+              <a:lnSpc>
+                <a:spcPct val="100000"/>
+              </a:lnSpc>
+              <a:spcBef>
+                <a:spcPts val="0"/>
+              </a:spcBef>
+              <a:spcAft>
+                <a:spcPts val="145"/>
+              </a:spcAft>
+              <a:buNone/>
+            </a:pPr>
+            <a:r>
+              <a:rPr lang="pt-BR" sz="1668" dirty="0">
+                <a:solidFill>
+                  <a:srgbClr val="111111"/>
+                </a:solidFill>
+                <a:latin typeface="Canva Sans"/>
+                <a:ea typeface="Canva Sans"/>
+                <a:cs typeface="Canva Sans"/>
+                <a:sym typeface="Canva Sans"/>
+              </a:rPr>
+              <a:t>acomodação</a:t>
+            </a:r>
+            <a:endParaRPr lang="pt-BR" sz="1668" dirty="0"/>
+          </a:p>
+          <a:p>
+            <a:pPr algn="ctr">
+              <a:lnSpc>
+                <a:spcPct val="100000"/>
+              </a:lnSpc>
+              <a:spcBef>
+                <a:spcPts val="0"/>
+              </a:spcBef>
+              <a:spcAft>
+                <a:spcPts val="145"/>
+              </a:spcAft>
+              <a:buNone/>
+            </a:pPr>
+            <a:r>
+              <a:rPr lang="pt-BR" sz="1668" dirty="0">
+                <a:solidFill>
+                  <a:srgbClr val="111111"/>
+                </a:solidFill>
+                <a:latin typeface="Canva Sans"/>
+                <a:ea typeface="Canva Sans"/>
+                <a:cs typeface="Canva Sans"/>
+                <a:sym typeface="Canva Sans"/>
+              </a:rPr>
+              <a:t>negociação</a:t>
+            </a:r>
+            <a:endParaRPr lang="pt-BR" sz="1668" dirty="0"/>
+          </a:p>
+          <a:p>
+            <a:pPr algn="ctr">
+              <a:lnSpc>
+                <a:spcPct val="100000"/>
+              </a:lnSpc>
+              <a:spcBef>
+                <a:spcPts val="0"/>
+              </a:spcBef>
+              <a:spcAft>
+                <a:spcPts val="145"/>
+              </a:spcAft>
+              <a:buNone/>
+            </a:pPr>
+            <a:r>
+              <a:rPr lang="pt-BR" sz="1668" dirty="0">
+                <a:solidFill>
+                  <a:srgbClr val="111111"/>
+                </a:solidFill>
+                <a:latin typeface="Canva Sans"/>
+                <a:ea typeface="Canva Sans"/>
+                <a:cs typeface="Canva Sans"/>
+                <a:sym typeface="Canva Sans"/>
+              </a:rPr>
+              <a:t>ressignificação</a:t>
+            </a:r>
+            <a:endParaRPr lang="pt-BR" sz="1668" dirty="0"/>
+          </a:p>
+          <a:p>
+            <a:pPr algn="ctr">
+              <a:lnSpc>
+                <a:spcPct val="100000"/>
+              </a:lnSpc>
+              <a:spcBef>
+                <a:spcPts val="0"/>
+              </a:spcBef>
+              <a:spcAft>
+                <a:spcPts val="0"/>
+              </a:spcAft>
+              <a:buNone/>
+            </a:pPr>
+            <a:r>
+              <a:rPr lang="pt-BR" sz="1668" b="1" dirty="0">
+                <a:solidFill>
+                  <a:srgbClr val="111111"/>
+                </a:solidFill>
+                <a:latin typeface="Canva Sans Bold"/>
+                <a:ea typeface="Canva Sans Bold"/>
+                <a:cs typeface="Canva Sans Bold"/>
+                <a:sym typeface="Canva Sans Bold"/>
+              </a:rPr>
+              <a:t>resistência*</a:t>
+            </a:r>
+            <a:endParaRPr lang="pt-BR" sz="1668" dirty="0"/>
+          </a:p>
+        </p:txBody>
+      </p:sp>
+      <p:sp>
+        <p:nvSpPr>
+          <p:cNvPr id="215" name="Cartão 215"/>
+          <p:cNvSpPr/>
+          <p:nvPr/>
+        </p:nvSpPr>
+        <p:spPr>
+          <a:xfrm>
+            <a:off x="612000" y="7560000"/>
+            <a:ext cx="4536000" cy="2376000"/>
+          </a:xfrm>
+          <a:prstGeom prst="roundRect">
+            <a:avLst>
+              <a:gd name="adj" fmla="val 9000"/>
+            </a:avLst>
+          </a:prstGeom>
+          <a:solidFill>
+            <a:srgbClr val="FFFFFF"/>
+          </a:solidFill>
+          <a:ln w="31750">
+            <a:solidFill>
+              <a:srgbClr val="111111"/>
+            </a:solidFill>
+          </a:ln>
+        </p:spPr>
+        <p:txBody>
+          <a:bodyPr wrap="square" lIns="144000" tIns="144000" rIns="144000" bIns="144000" anchor="ctr" rtlCol="0">
+            <a:noAutofit/>
+          </a:bodyPr>
+          <a:lstStyle/>
+          <a:p>
+            <a:pPr algn="ctr">
+              <a:lnSpc>
+                <a:spcPct val="100000"/>
+              </a:lnSpc>
+              <a:spcBef>
+                <a:spcPts val="0"/>
+              </a:spcBef>
+              <a:spcAft>
+                <a:spcPts val="290"/>
+              </a:spcAft>
+              <a:buNone/>
+            </a:pPr>
+            <a:r>
+              <a:rPr lang="pt-BR" sz="1595" dirty="0">
+                <a:solidFill>
+                  <a:srgbClr val="111111"/>
+                </a:solidFill>
+                <a:latin typeface="Canva Sans"/>
+                <a:ea typeface="Canva Sans"/>
+                <a:cs typeface="Canva Sans"/>
+                <a:sym typeface="Canva Sans"/>
+              </a:rPr>
+              <a:t>As atuações são</a:t>
+            </a:r>
+            <a:endParaRPr lang="pt-BR" sz="1595" dirty="0"/>
+          </a:p>
+          <a:p>
+            <a:pPr algn="ctr">
+              <a:lnSpc>
+                <a:spcPct val="95000"/>
+              </a:lnSpc>
+              <a:spcBef>
+                <a:spcPts val="0"/>
+              </a:spcBef>
+              <a:spcAft>
+                <a:spcPts val="434"/>
+              </a:spcAft>
+              <a:buNone/>
+            </a:pPr>
+            <a:r>
+              <a:rPr lang="pt-BR" sz="1885" b="1" dirty="0">
+                <a:solidFill>
+                  <a:srgbClr val="111111"/>
+                </a:solidFill>
+                <a:latin typeface="Canva Sans Bold"/>
+                <a:ea typeface="Canva Sans Bold"/>
+                <a:cs typeface="Canva Sans Bold"/>
+                <a:sym typeface="Canva Sans Bold"/>
+              </a:rPr>
+              <a:t>“coletivas, criativas e limitadas”</a:t>
+            </a:r>
+            <a:endParaRPr lang="pt-BR" sz="1885" dirty="0"/>
+          </a:p>
+          <a:p>
+            <a:pPr algn="ctr">
+              <a:lnSpc>
+                <a:spcPct val="100000"/>
+              </a:lnSpc>
+              <a:spcBef>
+                <a:spcPts val="0"/>
+              </a:spcBef>
+              <a:spcAft>
+                <a:spcPts val="0"/>
+              </a:spcAft>
+              <a:buNone/>
+            </a:pPr>
+            <a:r>
+              <a:rPr lang="pt-BR" sz="1378" dirty="0">
+                <a:solidFill>
+                  <a:srgbClr val="111111"/>
+                </a:solidFill>
+                <a:latin typeface="Canva Sans"/>
+                <a:ea typeface="Canva Sans"/>
+                <a:cs typeface="Canva Sans"/>
+                <a:sym typeface="Canva Sans"/>
+              </a:rPr>
+              <a:t>(BALL; MAGUIRE; BRAUN, 2016, p. 103)</a:t>
+            </a:r>
+            <a:endParaRPr lang="pt-BR" sz="1378" dirty="0"/>
+          </a:p>
+        </p:txBody>
+      </p:sp>
+      <p:sp>
+        <p:nvSpPr>
+          <p:cNvPr id="216" name="Cartão 216"/>
+          <p:cNvSpPr/>
+          <p:nvPr/>
+        </p:nvSpPr>
+        <p:spPr>
+          <a:xfrm>
+            <a:off x="5472000" y="7560000"/>
+            <a:ext cx="7776000" cy="2376000"/>
+          </a:xfrm>
+          <a:prstGeom prst="roundRect">
+            <a:avLst>
+              <a:gd name="adj" fmla="val 9000"/>
+            </a:avLst>
+          </a:prstGeom>
+          <a:solidFill>
+            <a:srgbClr val="EFE3D4"/>
+          </a:solidFill>
+          <a:ln w="31750">
+            <a:solidFill>
+              <a:srgbClr val="111111"/>
+            </a:solidFill>
+          </a:ln>
+        </p:spPr>
+        <p:txBody>
+          <a:bodyPr wrap="square" lIns="144000" tIns="144000" rIns="144000" bIns="144000" anchor="ctr" rtlCol="0">
+            <a:noAutofit/>
+          </a:bodyPr>
+          <a:lstStyle/>
+          <a:p>
+            <a:pPr algn="ctr">
+              <a:lnSpc>
+                <a:spcPct val="100000"/>
+              </a:lnSpc>
+              <a:spcBef>
+                <a:spcPts val="0"/>
+              </a:spcBef>
+              <a:spcAft>
+                <a:spcPts val="580"/>
+              </a:spcAft>
+              <a:buNone/>
+            </a:pPr>
+            <a:r>
+              <a:rPr lang="pt-BR" sz="1522" dirty="0">
+                <a:solidFill>
+                  <a:srgbClr val="111111"/>
+                </a:solidFill>
+                <a:latin typeface="Canva Sans"/>
+                <a:ea typeface="Canva Sans"/>
+                <a:cs typeface="Canva Sans"/>
+                <a:sym typeface="Canva Sans"/>
+              </a:rPr>
+              <a:t>Um discurso é “um modo de construir sentidos que influencia e organiza tanto nossas ações quanto a concepção que temos de nós mesmos” (HALL, 2006, p. 50-51; aproximação nossa).</a:t>
+            </a:r>
+            <a:endParaRPr lang="pt-BR" sz="1522" dirty="0"/>
+          </a:p>
+          <a:p>
+            <a:pPr algn="ctr">
+              <a:lnSpc>
+                <a:spcPct val="95000"/>
+              </a:lnSpc>
+              <a:spcBef>
+                <a:spcPts val="0"/>
+              </a:spcBef>
+              <a:spcAft>
+                <a:spcPts val="0"/>
+              </a:spcAft>
+              <a:buNone/>
+            </a:pPr>
+            <a:r>
+              <a:rPr lang="pt-BR" sz="1740" b="1" dirty="0">
+                <a:solidFill>
+                  <a:srgbClr val="111111"/>
+                </a:solidFill>
+                <a:latin typeface="Canva Sans Bold"/>
+                <a:ea typeface="Canva Sans Bold"/>
+                <a:cs typeface="Canva Sans Bold"/>
+                <a:sym typeface="Canva Sans Bold"/>
+              </a:rPr>
+              <a:t>Por isso, as narrativas dos profissionais ocupam o centro da produção de dados.</a:t>
+            </a:r>
+            <a:endParaRPr lang="pt-BR" sz="1740" dirty="0"/>
+          </a:p>
+        </p:txBody>
+      </p:sp>
+      <p:sp>
+        <p:nvSpPr>
+          <p:cNvPr id="217" name="Forma 217"/>
+          <p:cNvSpPr/>
+          <p:nvPr/>
+        </p:nvSpPr>
+        <p:spPr>
+          <a:xfrm>
+            <a:off x="15948000" y="7236000"/>
+            <a:ext cx="432000" cy="360000"/>
+          </a:xfrm>
+          <a:prstGeom prst="downArrow">
+            <a:avLst/>
+          </a:prstGeom>
+          <a:solidFill>
+            <a:srgbClr val="FFCE32"/>
+          </a:solidFill>
+          <a:ln w="19050">
+            <a:solidFill>
+              <a:srgbClr val="111111"/>
+            </a:solidFill>
+          </a:ln>
+        </p:spPr>
+      </p:sp>
+      <p:sp>
+        <p:nvSpPr>
+          <p:cNvPr id="218" name="Cartão 218"/>
+          <p:cNvSpPr/>
+          <p:nvPr/>
+        </p:nvSpPr>
+        <p:spPr>
+          <a:xfrm>
+            <a:off x="13572000" y="7560000"/>
+            <a:ext cx="4104000" cy="2376000"/>
+          </a:xfrm>
+          <a:prstGeom prst="roundRect">
+            <a:avLst>
+              <a:gd name="adj" fmla="val 9000"/>
+            </a:avLst>
+          </a:prstGeom>
+          <a:solidFill>
+            <a:srgbClr val="FFCE32"/>
+          </a:solidFill>
+          <a:ln w="31750">
+            <a:solidFill>
+              <a:srgbClr val="111111"/>
+            </a:solidFill>
+          </a:ln>
+        </p:spPr>
+        <p:txBody>
+          <a:bodyPr wrap="square" lIns="144000" tIns="144000" rIns="144000" bIns="144000" anchor="ctr" rtlCol="0">
+            <a:noAutofit/>
+          </a:bodyPr>
+          <a:lstStyle/>
+          <a:p>
+            <a:pPr algn="ctr">
+              <a:lnSpc>
+                <a:spcPct val="95000"/>
+              </a:lnSpc>
+              <a:spcBef>
+                <a:spcPts val="0"/>
+              </a:spcBef>
+              <a:spcAft>
+                <a:spcPts val="434"/>
+              </a:spcAft>
+              <a:buNone/>
+            </a:pPr>
+            <a:r>
+              <a:rPr lang="pt-BR" sz="1668" b="1" dirty="0">
+                <a:solidFill>
+                  <a:srgbClr val="111111"/>
+                </a:solidFill>
+                <a:latin typeface="Canva Sans Bold"/>
+                <a:ea typeface="Canva Sans Bold"/>
+                <a:cs typeface="Canva Sans Bold"/>
+                <a:sym typeface="Canva Sans Bold"/>
+              </a:rPr>
+              <a:t>* A resistência é uma possibilidade:</a:t>
+            </a:r>
+            <a:endParaRPr lang="pt-BR" sz="1668" dirty="0"/>
+          </a:p>
+          <a:p>
+            <a:pPr algn="ctr">
+              <a:lnSpc>
+                <a:spcPct val="100000"/>
+              </a:lnSpc>
+              <a:spcBef>
+                <a:spcPts val="0"/>
+              </a:spcBef>
+              <a:spcAft>
+                <a:spcPts val="0"/>
+              </a:spcAft>
+              <a:buNone/>
+            </a:pPr>
+            <a:r>
+              <a:rPr lang="pt-BR" sz="1595" dirty="0">
+                <a:solidFill>
+                  <a:srgbClr val="111111"/>
+                </a:solidFill>
+                <a:latin typeface="Canva Sans"/>
+                <a:ea typeface="Canva Sans"/>
+                <a:cs typeface="Canva Sans"/>
+                <a:sym typeface="Canva Sans"/>
+              </a:rPr>
+              <a:t>hipótese a examinar nos dados, sem ser pressuposta.</a:t>
+            </a:r>
+            <a:endParaRPr lang="pt-BR" sz="1595" dirty="0"/>
           </a:p>
         </p:txBody>
       </p:sp>

</xml_diff>

<commit_message>
Encerra a apresentação com frase autoral sobre habitar o digital em Pipa
Co-Authored-By: Claude Opus 5.5 <noreply@anthropic.com>
Claude-Session: https://claude.ai/code/session_01HxStpW4pQoDfJdTDYr6zEC
</commit_message>
<xml_diff>
--- a/apresentacao_qualificacao/Qualificacao_PNED_Pipa.pptx
+++ b/apresentacao_qualificacao/Qualificacao_PNED_Pipa.pptx
@@ -27265,14 +27265,14 @@
       </p:sp>
       <p:sp>
         <p:nvSpPr>
-          <p:cNvPr id="201" name="Título 201"/>
+          <p:cNvPr id="201" name="Texto 201"/>
           <p:cNvSpPr txBox="1"/>
           <p:nvPr/>
         </p:nvSpPr>
         <p:spPr>
           <a:xfrm>
-            <a:off x="3960000" y="2232000"/>
-            <a:ext cx="10368000" cy="2304000"/>
+            <a:off x="3960000" y="2520000"/>
+            <a:ext cx="10368000" cy="1872000"/>
           </a:xfrm>
           <a:prstGeom prst="rect">
             <a:avLst/>
@@ -27287,6 +27287,56 @@
           <a:p>
             <a:pPr algn="ctr">
               <a:lnSpc>
+                <a:spcPct val="105000"/>
+              </a:lnSpc>
+              <a:spcBef>
+                <a:spcPts val="0"/>
+              </a:spcBef>
+              <a:spcAft>
+                <a:spcPts val="0"/>
+              </a:spcAft>
+              <a:buNone/>
+            </a:pPr>
+            <a:r>
+              <a:rPr lang="pt-BR" sz="2200" i="1" dirty="0">
+                <a:solidFill>
+                  <a:srgbClr val="FFFFFF"/>
+                </a:solidFill>
+                <a:latin typeface="Canva Sans"/>
+                <a:ea typeface="Canva Sans"/>
+                <a:cs typeface="Canva Sans"/>
+                <a:sym typeface="Canva Sans"/>
+              </a:rPr>
+              <a:t>Se habitar é estar presente e em relação, habitar o digital depende de condições que o território distribui de modo desigual. Em Pipa, é na escola que essa desigualdade ganha corpo e idade, e é dali que esta pesquisa pergunta quem pode, de fato, habitar o mundo que a lei promete às crianças.</a:t>
+            </a:r>
+            <a:endParaRPr lang="pt-BR" sz="2200" dirty="0"/>
+          </a:p>
+        </p:txBody>
+      </p:sp>
+      <p:sp>
+        <p:nvSpPr>
+          <p:cNvPr id="202" name="Título 202"/>
+          <p:cNvSpPr txBox="1"/>
+          <p:nvPr/>
+        </p:nvSpPr>
+        <p:spPr>
+          <a:xfrm>
+            <a:off x="3960000" y="4464000"/>
+            <a:ext cx="10368000" cy="1440000"/>
+          </a:xfrm>
+          <a:prstGeom prst="rect">
+            <a:avLst/>
+          </a:prstGeom>
+          <a:noFill/>
+        </p:spPr>
+        <p:txBody>
+          <a:bodyPr wrap="square" lIns="0" tIns="0" rIns="0" bIns="0" anchor="ctr" rtlCol="0">
+            <a:noAutofit/>
+          </a:bodyPr>
+          <a:lstStyle/>
+          <a:p>
+            <a:pPr algn="ctr">
+              <a:lnSpc>
                 <a:spcPct val="85000"/>
               </a:lnSpc>
               <a:spcBef>
@@ -27298,7 +27348,7 @@
               <a:buNone/>
             </a:pPr>
             <a:r>
-              <a:rPr lang="pt-BR" sz="11000" b="1" dirty="0">
+              <a:rPr lang="pt-BR" sz="8400" b="1" dirty="0">
                 <a:solidFill>
                   <a:srgbClr val="FFFFFF"/>
                 </a:solidFill>
@@ -27309,20 +27359,20 @@
               </a:rPr>
               <a:t>AGRADEÇO</a:t>
             </a:r>
-            <a:endParaRPr lang="pt-BR" sz="11000" dirty="0"/>
+            <a:endParaRPr lang="pt-BR" sz="8400" dirty="0"/>
           </a:p>
         </p:txBody>
       </p:sp>
       <p:sp>
         <p:nvSpPr>
-          <p:cNvPr id="202" name="Texto 202"/>
+          <p:cNvPr id="203" name="Texto 203"/>
           <p:cNvSpPr txBox="1"/>
           <p:nvPr/>
         </p:nvSpPr>
         <p:spPr>
           <a:xfrm>
-            <a:off x="3960000" y="4428000"/>
-            <a:ext cx="10368000" cy="648000"/>
+            <a:off x="3960000" y="5868000"/>
+            <a:ext cx="10368000" cy="576000"/>
           </a:xfrm>
           <a:prstGeom prst="rect">
             <a:avLst/>
@@ -27348,7 +27398,7 @@
               <a:buNone/>
             </a:pPr>
             <a:r>
-              <a:rPr lang="pt-BR" sz="2900" dirty="0">
+              <a:rPr lang="pt-BR" sz="2610" dirty="0">
                 <a:solidFill>
                   <a:srgbClr val="FFFFFF"/>
                 </a:solidFill>
@@ -27359,7 +27409,7 @@
               </a:rPr>
               <a:t>pela atenção e pelas contribuições</a:t>
             </a:r>
-            <a:endParaRPr lang="pt-BR" sz="2900" dirty="0"/>
+            <a:endParaRPr lang="pt-BR" sz="2610" dirty="0"/>
           </a:p>
         </p:txBody>
       </p:sp>

</xml_diff>

<commit_message>
Desfaz a inclusão da frase de encerramento no slide final e no roteiro
This reverts commit 0538052.

Co-Authored-By: Claude Opus 5.5 <noreply@anthropic.com>
Claude-Session: https://claude.ai/code/session_01HxStpW4pQoDfJdTDYr6zEC
</commit_message>
<xml_diff>
--- a/apresentacao_qualificacao/Qualificacao_PNED_Pipa.pptx
+++ b/apresentacao_qualificacao/Qualificacao_PNED_Pipa.pptx
@@ -27265,14 +27265,14 @@
       </p:sp>
       <p:sp>
         <p:nvSpPr>
-          <p:cNvPr id="201" name="Texto 201"/>
+          <p:cNvPr id="201" name="Título 201"/>
           <p:cNvSpPr txBox="1"/>
           <p:nvPr/>
         </p:nvSpPr>
         <p:spPr>
           <a:xfrm>
-            <a:off x="3960000" y="2520000"/>
-            <a:ext cx="10368000" cy="1872000"/>
+            <a:off x="3960000" y="2232000"/>
+            <a:ext cx="10368000" cy="2304000"/>
           </a:xfrm>
           <a:prstGeom prst="rect">
             <a:avLst/>
@@ -27287,56 +27287,6 @@
           <a:p>
             <a:pPr algn="ctr">
               <a:lnSpc>
-                <a:spcPct val="105000"/>
-              </a:lnSpc>
-              <a:spcBef>
-                <a:spcPts val="0"/>
-              </a:spcBef>
-              <a:spcAft>
-                <a:spcPts val="0"/>
-              </a:spcAft>
-              <a:buNone/>
-            </a:pPr>
-            <a:r>
-              <a:rPr lang="pt-BR" sz="2200" i="1" dirty="0">
-                <a:solidFill>
-                  <a:srgbClr val="FFFFFF"/>
-                </a:solidFill>
-                <a:latin typeface="Canva Sans"/>
-                <a:ea typeface="Canva Sans"/>
-                <a:cs typeface="Canva Sans"/>
-                <a:sym typeface="Canva Sans"/>
-              </a:rPr>
-              <a:t>Se habitar é estar presente e em relação, habitar o digital depende de condições que o território distribui de modo desigual. Em Pipa, é na escola que essa desigualdade ganha corpo e idade, e é dali que esta pesquisa pergunta quem pode, de fato, habitar o mundo que a lei promete às crianças.</a:t>
-            </a:r>
-            <a:endParaRPr lang="pt-BR" sz="2200" dirty="0"/>
-          </a:p>
-        </p:txBody>
-      </p:sp>
-      <p:sp>
-        <p:nvSpPr>
-          <p:cNvPr id="202" name="Título 202"/>
-          <p:cNvSpPr txBox="1"/>
-          <p:nvPr/>
-        </p:nvSpPr>
-        <p:spPr>
-          <a:xfrm>
-            <a:off x="3960000" y="4464000"/>
-            <a:ext cx="10368000" cy="1440000"/>
-          </a:xfrm>
-          <a:prstGeom prst="rect">
-            <a:avLst/>
-          </a:prstGeom>
-          <a:noFill/>
-        </p:spPr>
-        <p:txBody>
-          <a:bodyPr wrap="square" lIns="0" tIns="0" rIns="0" bIns="0" anchor="ctr" rtlCol="0">
-            <a:noAutofit/>
-          </a:bodyPr>
-          <a:lstStyle/>
-          <a:p>
-            <a:pPr algn="ctr">
-              <a:lnSpc>
                 <a:spcPct val="85000"/>
               </a:lnSpc>
               <a:spcBef>
@@ -27348,7 +27298,7 @@
               <a:buNone/>
             </a:pPr>
             <a:r>
-              <a:rPr lang="pt-BR" sz="8400" b="1" dirty="0">
+              <a:rPr lang="pt-BR" sz="11000" b="1" dirty="0">
                 <a:solidFill>
                   <a:srgbClr val="FFFFFF"/>
                 </a:solidFill>
@@ -27359,20 +27309,20 @@
               </a:rPr>
               <a:t>AGRADEÇO</a:t>
             </a:r>
-            <a:endParaRPr lang="pt-BR" sz="8400" dirty="0"/>
+            <a:endParaRPr lang="pt-BR" sz="11000" dirty="0"/>
           </a:p>
         </p:txBody>
       </p:sp>
       <p:sp>
         <p:nvSpPr>
-          <p:cNvPr id="203" name="Texto 203"/>
+          <p:cNvPr id="202" name="Texto 202"/>
           <p:cNvSpPr txBox="1"/>
           <p:nvPr/>
         </p:nvSpPr>
         <p:spPr>
           <a:xfrm>
-            <a:off x="3960000" y="5868000"/>
-            <a:ext cx="10368000" cy="576000"/>
+            <a:off x="3960000" y="4428000"/>
+            <a:ext cx="10368000" cy="648000"/>
           </a:xfrm>
           <a:prstGeom prst="rect">
             <a:avLst/>
@@ -27398,7 +27348,7 @@
               <a:buNone/>
             </a:pPr>
             <a:r>
-              <a:rPr lang="pt-BR" sz="2610" dirty="0">
+              <a:rPr lang="pt-BR" sz="2900" dirty="0">
                 <a:solidFill>
                   <a:srgbClr val="FFFFFF"/>
                 </a:solidFill>
@@ -27409,7 +27359,7 @@
               </a:rPr>
               <a:t>pela atenção e pelas contribuições</a:t>
             </a:r>
-            <a:endParaRPr lang="pt-BR" sz="2610" dirty="0"/>
+            <a:endParaRPr lang="pt-BR" sz="2900" dirty="0"/>
           </a:p>
         </p:txBody>
       </p:sp>

</xml_diff>

<commit_message>
Acrescenta slide com o que foi feito e o que falta fazer, a pedido da orientadora
Co-Authored-By: Claude Opus 5.5 <noreply@anthropic.com>
Claude-Session: https://claude.ai/code/session_01HxStpW4pQoDfJdTDYr6zEC
</commit_message>
<xml_diff>
--- a/apresentacao_qualificacao/Qualificacao_PNED_Pipa.pptx
+++ b/apresentacao_qualificacao/Qualificacao_PNED_Pipa.pptx
@@ -35,6 +35,7 @@
     <p:sldId id="294" r:id="rId47"/>
     <p:sldId id="295" r:id="rId48"/>
     <p:sldId id="296" r:id="rId49"/>
+    <p:sldId id="297" r:id="rId50"/>
   </p:sldIdLst>
   <p:sldSz cx="18288000" cy="10287000"/>
   <p:notesSz cx="6858000" cy="9144000"/>
@@ -26564,7 +26565,7 @@
         </p:nvSpPr>
         <p:spPr>
           <a:xfrm>
-            <a:off x="8496000" y="3024000"/>
+            <a:off x="8496000" y="3240000"/>
             <a:ext cx="9000000" cy="1080000"/>
           </a:xfrm>
           <a:prstGeom prst="rect">
@@ -26614,8 +26615,8 @@
         </p:nvSpPr>
         <p:spPr>
           <a:xfrm>
-            <a:off x="8568000" y="4176000"/>
-            <a:ext cx="9216000" cy="1080000"/>
+            <a:off x="8568000" y="4464000"/>
+            <a:ext cx="9216000" cy="1224000"/>
           </a:xfrm>
           <a:prstGeom prst="rect">
             <a:avLst/>
@@ -26641,7 +26642,7 @@
               <a:buNone/>
             </a:pPr>
             <a:r>
-              <a:rPr lang="pt-BR" sz="2030" dirty="0">
+              <a:rPr lang="pt-BR" sz="2175" dirty="0">
                 <a:solidFill>
                   <a:srgbClr val="FFFFFF"/>
                 </a:solidFill>
@@ -26652,7 +26653,7 @@
               </a:rPr>
               <a:t>A política fez da educação digital um direito e deixou os meios na dependência de cada ente federado. A pergunta de fundo, que só as narrativas podem responder:</a:t>
             </a:r>
-            <a:endParaRPr lang="pt-BR" sz="2030" dirty="0"/>
+            <a:endParaRPr lang="pt-BR" sz="2175" dirty="0"/>
           </a:p>
         </p:txBody>
       </p:sp>
@@ -26664,8 +26665,8 @@
         </p:nvSpPr>
         <p:spPr>
           <a:xfrm>
-            <a:off x="8568000" y="5292000"/>
-            <a:ext cx="9216000" cy="2376000"/>
+            <a:off x="8568000" y="5832000"/>
+            <a:ext cx="9216000" cy="3024000"/>
           </a:xfrm>
           <a:prstGeom prst="roundRect">
             <a:avLst>
@@ -26682,7 +26683,7 @@
           </a:ln>
         </p:spPr>
         <p:txBody>
-          <a:bodyPr wrap="square" lIns="216000" tIns="216000" rIns="216000" bIns="216000" anchor="ctr" rtlCol="0">
+          <a:bodyPr wrap="square" lIns="252000" tIns="252000" rIns="252000" bIns="252000" anchor="ctr" rtlCol="0">
             <a:noAutofit/>
           </a:bodyPr>
           <a:lstStyle/>
@@ -26695,12 +26696,12 @@
                 <a:spcPts val="0"/>
               </a:spcBef>
               <a:spcAft>
-                <a:spcPts val="869"/>
-              </a:spcAft>
-              <a:buNone/>
-            </a:pPr>
-            <a:r>
-              <a:rPr lang="pt-BR" sz="2248" b="1" dirty="0">
+                <a:spcPts val="1160"/>
+              </a:spcAft>
+              <a:buNone/>
+            </a:pPr>
+            <a:r>
+              <a:rPr lang="pt-BR" sz="2465" b="1" dirty="0">
                 <a:solidFill>
                   <a:srgbClr val="111111"/>
                 </a:solidFill>
@@ -26711,7 +26712,7 @@
               </a:rPr>
               <a:t>Quando a política não faz chegar o equipamento nem a formação, quem paga, no cotidiano escolar, por esse vazio material e formativo?</a:t>
             </a:r>
-            <a:endParaRPr lang="pt-BR" sz="2248" dirty="0"/>
+            <a:endParaRPr lang="pt-BR" sz="2465" dirty="0"/>
           </a:p>
           <a:p>
             <a:pPr algn="l">
@@ -26727,7 +26728,7 @@
               <a:buNone/>
             </a:pPr>
             <a:r>
-              <a:rPr lang="pt-BR" sz="2248" b="1" dirty="0">
+              <a:rPr lang="pt-BR" sz="2465" b="1" dirty="0">
                 <a:solidFill>
                   <a:srgbClr val="111111"/>
                 </a:solidFill>
@@ -26738,93 +26739,7 @@
               </a:rPr>
               <a:t>E o que isso significa para os direitos que a lei prometeu às crianças?</a:t>
             </a:r>
-            <a:endParaRPr lang="pt-BR" sz="2248" dirty="0"/>
-          </a:p>
-        </p:txBody>
-      </p:sp>
-      <p:sp>
-        <p:nvSpPr>
-          <p:cNvPr id="204" name="Cartão 204"/>
-          <p:cNvSpPr/>
-          <p:nvPr/>
-        </p:nvSpPr>
-        <p:spPr>
-          <a:xfrm>
-            <a:off x="8568000" y="7884000"/>
-            <a:ext cx="9216000" cy="2160000"/>
-          </a:xfrm>
-          <a:prstGeom prst="roundRect">
-            <a:avLst>
-              <a:gd name="adj" fmla="val 5000"/>
-            </a:avLst>
-          </a:prstGeom>
-          <a:solidFill>
-            <a:srgbClr val="EFE3D4"/>
-          </a:solidFill>
-          <a:ln w="38100">
-            <a:solidFill>
-              <a:srgbClr val="111111"/>
-            </a:solidFill>
-          </a:ln>
-        </p:spPr>
-        <p:txBody>
-          <a:bodyPr wrap="square" lIns="180000" tIns="180000" rIns="180000" bIns="180000" anchor="ctr" rtlCol="0">
-            <a:noAutofit/>
-          </a:bodyPr>
-          <a:lstStyle/>
-          <a:p>
-            <a:pPr algn="l">
-              <a:lnSpc>
-                <a:spcPct val="100000"/>
-              </a:lnSpc>
-              <a:spcBef>
-                <a:spcPts val="0"/>
-              </a:spcBef>
-              <a:spcAft>
-                <a:spcPts val="434"/>
-              </a:spcAft>
-              <a:buNone/>
-            </a:pPr>
-            <a:r>
-              <a:rPr lang="pt-BR" sz="2175" b="1" dirty="0">
-                <a:solidFill>
-                  <a:srgbClr val="111111"/>
-                </a:solidFill>
-                <a:latin typeface="Canva Sans Bold"/>
-                <a:ea typeface="Canva Sans Bold"/>
-                <a:cs typeface="Canva Sans Bold"/>
-                <a:sym typeface="Canva Sans Bold"/>
-              </a:rPr>
-              <a:t>Próximos passos</a:t>
-            </a:r>
-            <a:endParaRPr lang="pt-BR" sz="2175" dirty="0"/>
-          </a:p>
-          <a:p>
-            <a:pPr algn="l">
-              <a:lnSpc>
-                <a:spcPct val="100000"/>
-              </a:lnSpc>
-              <a:spcBef>
-                <a:spcPts val="0"/>
-              </a:spcBef>
-              <a:spcAft>
-                <a:spcPts val="0"/>
-              </a:spcAft>
-              <a:buNone/>
-            </a:pPr>
-            <a:r>
-              <a:rPr lang="pt-BR" sz="1885" dirty="0">
-                <a:solidFill>
-                  <a:srgbClr val="111111"/>
-                </a:solidFill>
-                <a:latin typeface="Canva Sans"/>
-                <a:ea typeface="Canva Sans"/>
-                <a:cs typeface="Canva Sans"/>
-                <a:sym typeface="Canva Sans"/>
-              </a:rPr>
-              <a:t>Emenda ao CEP, com a SME coparticipante · campo em dez semanas após a aprovação · análise documental: os documentos da escola já foram solicitados à direção, e os municipais, ao técnico da Secretaria de Educação · capítulo 7, com as narrativas dos profissionais · contribuições da banca</a:t>
-            </a:r>
-            <a:endParaRPr lang="pt-BR" sz="1885" dirty="0"/>
+            <a:endParaRPr lang="pt-BR" sz="2465" dirty="0"/>
           </a:p>
         </p:txBody>
       </p:sp>
@@ -26906,9 +26821,9 @@
           <p:nvPr/>
         </p:nvSpPr>
         <p:spPr>
-          <a:xfrm flipH="false" flipV="false" rot="0">
-            <a:off x="-2498597" y="-108828"/>
-            <a:ext cx="6582509" cy="10746953"/>
+          <a:xfrm flipH="false" flipV="false" rot="-559059">
+            <a:off x="14704686" y="-67215"/>
+            <a:ext cx="4178322" cy="5381913"/>
           </a:xfrm>
           <a:custGeom>
             <a:avLst/>
@@ -26917,18 +26832,18 @@
             <a:cxnLst/>
             <a:rect r="r" b="b" t="t" l="l"/>
             <a:pathLst>
-              <a:path h="10746953" w="6582509">
+              <a:path h="5381913" w="4178322">
                 <a:moveTo>
                   <a:pt x="0" y="0"/>
                 </a:moveTo>
                 <a:lnTo>
-                  <a:pt x="6582509" y="0"/>
-                </a:lnTo>
-                <a:lnTo>
-                  <a:pt x="6582509" y="10746953"/>
-                </a:lnTo>
-                <a:lnTo>
-                  <a:pt x="0" y="10746953"/>
+                  <a:pt x="4178322" y="0"/>
+                </a:lnTo>
+                <a:lnTo>
+                  <a:pt x="4178322" y="5381913"/>
+                </a:lnTo>
+                <a:lnTo>
+                  <a:pt x="0" y="5381913"/>
                 </a:lnTo>
                 <a:lnTo>
                   <a:pt x="0" y="0"/>
@@ -26958,9 +26873,9 @@
           <p:nvPr/>
         </p:nvSpPr>
         <p:spPr>
-          <a:xfrm flipH="false" flipV="false" rot="-797725">
-            <a:off x="13679956" y="-1054879"/>
-            <a:ext cx="4476702" cy="4994292"/>
+          <a:xfrm flipH="false" flipV="false" rot="0">
+            <a:off x="-946807" y="-872400"/>
+            <a:ext cx="3951014" cy="2794445"/>
           </a:xfrm>
           <a:custGeom>
             <a:avLst/>
@@ -26969,18 +26884,18 @@
             <a:cxnLst/>
             <a:rect r="r" b="b" t="t" l="l"/>
             <a:pathLst>
-              <a:path h="4994292" w="4476702">
+              <a:path h="2794445" w="3951014">
                 <a:moveTo>
                   <a:pt x="0" y="0"/>
                 </a:moveTo>
                 <a:lnTo>
-                  <a:pt x="4476701" y="0"/>
-                </a:lnTo>
-                <a:lnTo>
-                  <a:pt x="4476701" y="4994292"/>
-                </a:lnTo>
-                <a:lnTo>
-                  <a:pt x="0" y="4994292"/>
+                  <a:pt x="3951014" y="0"/>
+                </a:lnTo>
+                <a:lnTo>
+                  <a:pt x="3951014" y="2794445"/>
+                </a:lnTo>
+                <a:lnTo>
+                  <a:pt x="0" y="2794445"/>
                 </a:lnTo>
                 <a:lnTo>
                   <a:pt x="0" y="0"/>
@@ -27003,16 +26918,246 @@
           </a:blipFill>
         </p:spPr>
       </p:sp>
-      <p:sp>
-        <p:nvSpPr>
-          <p:cNvPr name="Freeform 5" id="5"/>
+      <p:grpSp>
+        <p:nvGrpSpPr>
+          <p:cNvPr name="Group 5" id="5"/>
+          <p:cNvGrpSpPr/>
+          <p:nvPr/>
+        </p:nvGrpSpPr>
+        <p:grpSpPr>
+          <a:xfrm rot="0">
+            <a:off x="1897026" y="5143500"/>
+            <a:ext cx="7009322" cy="5579677"/>
+            <a:chOff x="0" y="0"/>
+            <a:chExt cx="1846077" cy="1469545"/>
+          </a:xfrm>
+        </p:grpSpPr>
+        <p:sp>
+          <p:nvSpPr>
+            <p:cNvPr name="Freeform 6" id="6"/>
+            <p:cNvSpPr/>
+            <p:nvPr/>
+          </p:nvSpPr>
+          <p:spPr>
+            <a:xfrm flipH="false" flipV="false" rot="0">
+              <a:off x="0" y="0"/>
+              <a:ext cx="1846076" cy="1469545"/>
+            </a:xfrm>
+            <a:custGeom>
+              <a:avLst/>
+              <a:gdLst/>
+              <a:ahLst/>
+              <a:cxnLst/>
+              <a:rect r="r" b="b" t="t" l="l"/>
+              <a:pathLst>
+                <a:path h="1469545" w="1846076">
+                  <a:moveTo>
+                    <a:pt x="46390" y="0"/>
+                  </a:moveTo>
+                  <a:lnTo>
+                    <a:pt x="1799687" y="0"/>
+                  </a:lnTo>
+                  <a:cubicBezTo>
+                    <a:pt x="1825307" y="0"/>
+                    <a:pt x="1846076" y="20769"/>
+                    <a:pt x="1846076" y="46390"/>
+                  </a:cubicBezTo>
+                  <a:lnTo>
+                    <a:pt x="1846076" y="1423155"/>
+                  </a:lnTo>
+                  <a:cubicBezTo>
+                    <a:pt x="1846076" y="1435458"/>
+                    <a:pt x="1841189" y="1447258"/>
+                    <a:pt x="1832489" y="1455957"/>
+                  </a:cubicBezTo>
+                  <a:cubicBezTo>
+                    <a:pt x="1823789" y="1464657"/>
+                    <a:pt x="1811990" y="1469545"/>
+                    <a:pt x="1799687" y="1469545"/>
+                  </a:cubicBezTo>
+                  <a:lnTo>
+                    <a:pt x="46390" y="1469545"/>
+                  </a:lnTo>
+                  <a:cubicBezTo>
+                    <a:pt x="34086" y="1469545"/>
+                    <a:pt x="22287" y="1464657"/>
+                    <a:pt x="13587" y="1455957"/>
+                  </a:cubicBezTo>
+                  <a:cubicBezTo>
+                    <a:pt x="4887" y="1447258"/>
+                    <a:pt x="0" y="1435458"/>
+                    <a:pt x="0" y="1423155"/>
+                  </a:cubicBezTo>
+                  <a:lnTo>
+                    <a:pt x="0" y="46390"/>
+                  </a:lnTo>
+                  <a:cubicBezTo>
+                    <a:pt x="0" y="20769"/>
+                    <a:pt x="20769" y="0"/>
+                    <a:pt x="46390" y="0"/>
+                  </a:cubicBezTo>
+                  <a:close/>
+                </a:path>
+              </a:pathLst>
+            </a:custGeom>
+            <a:solidFill>
+              <a:srgbClr val="FFCE32"/>
+            </a:solidFill>
+          </p:spPr>
+        </p:sp>
+        <p:sp>
+          <p:nvSpPr>
+            <p:cNvPr name="TextBox 7" id="7"/>
+            <p:cNvSpPr txBox="true"/>
+            <p:nvPr/>
+          </p:nvSpPr>
+          <p:spPr>
+            <a:xfrm>
+              <a:off x="0" y="-57150"/>
+              <a:ext cx="1846077" cy="1526695"/>
+            </a:xfrm>
+            <a:prstGeom prst="rect">
+              <a:avLst/>
+            </a:prstGeom>
+          </p:spPr>
+          <p:txBody>
+            <a:bodyPr anchor="ctr" rtlCol="false" tIns="50800" lIns="50800" bIns="50800" rIns="50800"/>
+            <a:lstStyle/>
+            <a:p>
+              <a:pPr algn="ctr">
+                <a:lnSpc>
+                  <a:spcPts val="3499"/>
+                </a:lnSpc>
+              </a:pPr>
+            </a:p>
+          </p:txBody>
+        </p:sp>
+      </p:grpSp>
+      <p:grpSp>
+        <p:nvGrpSpPr>
+          <p:cNvPr name="Group 8" id="8"/>
+          <p:cNvGrpSpPr/>
+          <p:nvPr/>
+        </p:nvGrpSpPr>
+        <p:grpSpPr>
+          <a:xfrm rot="0">
+            <a:off x="9381652" y="5143500"/>
+            <a:ext cx="7009322" cy="5579677"/>
+            <a:chOff x="0" y="0"/>
+            <a:chExt cx="1846077" cy="1469545"/>
+          </a:xfrm>
+        </p:grpSpPr>
+        <p:sp>
+          <p:nvSpPr>
+            <p:cNvPr name="Freeform 9" id="9"/>
+            <p:cNvSpPr/>
+            <p:nvPr/>
+          </p:nvSpPr>
+          <p:spPr>
+            <a:xfrm flipH="false" flipV="false" rot="0">
+              <a:off x="0" y="0"/>
+              <a:ext cx="1846076" cy="1469545"/>
+            </a:xfrm>
+            <a:custGeom>
+              <a:avLst/>
+              <a:gdLst/>
+              <a:ahLst/>
+              <a:cxnLst/>
+              <a:rect r="r" b="b" t="t" l="l"/>
+              <a:pathLst>
+                <a:path h="1469545" w="1846076">
+                  <a:moveTo>
+                    <a:pt x="46390" y="0"/>
+                  </a:moveTo>
+                  <a:lnTo>
+                    <a:pt x="1799687" y="0"/>
+                  </a:lnTo>
+                  <a:cubicBezTo>
+                    <a:pt x="1825307" y="0"/>
+                    <a:pt x="1846076" y="20769"/>
+                    <a:pt x="1846076" y="46390"/>
+                  </a:cubicBezTo>
+                  <a:lnTo>
+                    <a:pt x="1846076" y="1423155"/>
+                  </a:lnTo>
+                  <a:cubicBezTo>
+                    <a:pt x="1846076" y="1435458"/>
+                    <a:pt x="1841189" y="1447258"/>
+                    <a:pt x="1832489" y="1455957"/>
+                  </a:cubicBezTo>
+                  <a:cubicBezTo>
+                    <a:pt x="1823789" y="1464657"/>
+                    <a:pt x="1811990" y="1469545"/>
+                    <a:pt x="1799687" y="1469545"/>
+                  </a:cubicBezTo>
+                  <a:lnTo>
+                    <a:pt x="46390" y="1469545"/>
+                  </a:lnTo>
+                  <a:cubicBezTo>
+                    <a:pt x="34086" y="1469545"/>
+                    <a:pt x="22287" y="1464657"/>
+                    <a:pt x="13587" y="1455957"/>
+                  </a:cubicBezTo>
+                  <a:cubicBezTo>
+                    <a:pt x="4887" y="1447258"/>
+                    <a:pt x="0" y="1435458"/>
+                    <a:pt x="0" y="1423155"/>
+                  </a:cubicBezTo>
+                  <a:lnTo>
+                    <a:pt x="0" y="46390"/>
+                  </a:lnTo>
+                  <a:cubicBezTo>
+                    <a:pt x="0" y="20769"/>
+                    <a:pt x="20769" y="0"/>
+                    <a:pt x="46390" y="0"/>
+                  </a:cubicBezTo>
+                  <a:close/>
+                </a:path>
+              </a:pathLst>
+            </a:custGeom>
+            <a:solidFill>
+              <a:srgbClr val="FFCE32"/>
+            </a:solidFill>
+          </p:spPr>
+        </p:sp>
+        <p:sp>
+          <p:nvSpPr>
+            <p:cNvPr name="TextBox 10" id="10"/>
+            <p:cNvSpPr txBox="true"/>
+            <p:nvPr/>
+          </p:nvSpPr>
+          <p:spPr>
+            <a:xfrm>
+              <a:off x="0" y="-57150"/>
+              <a:ext cx="1846077" cy="1526695"/>
+            </a:xfrm>
+            <a:prstGeom prst="rect">
+              <a:avLst/>
+            </a:prstGeom>
+          </p:spPr>
+          <p:txBody>
+            <a:bodyPr anchor="ctr" rtlCol="false" tIns="50800" lIns="50800" bIns="50800" rIns="50800"/>
+            <a:lstStyle/>
+            <a:p>
+              <a:pPr algn="ctr">
+                <a:lnSpc>
+                  <a:spcPts val="3499"/>
+                </a:lnSpc>
+              </a:pPr>
+            </a:p>
+          </p:txBody>
+        </p:sp>
+      </p:grpSp>
+      <p:sp>
+        <p:nvSpPr>
+          <p:cNvPr name="Freeform 11" id="11"/>
           <p:cNvSpPr/>
           <p:nvPr/>
         </p:nvSpPr>
         <p:spPr>
-          <a:xfrm flipH="false" flipV="false" rot="0">
-            <a:off x="14944550" y="2366363"/>
-            <a:ext cx="5751911" cy="14071953"/>
+          <a:xfrm flipH="true" flipV="false" rot="0">
+            <a:off x="10722983" y="-369962"/>
+            <a:ext cx="4037087" cy="3222330"/>
           </a:xfrm>
           <a:custGeom>
             <a:avLst/>
@@ -27021,21 +27166,21 @@
             <a:cxnLst/>
             <a:rect r="r" b="b" t="t" l="l"/>
             <a:pathLst>
-              <a:path h="14071953" w="5751911">
+              <a:path h="3222330" w="4037087">
                 <a:moveTo>
+                  <a:pt x="4037087" y="0"/>
+                </a:moveTo>
+                <a:lnTo>
                   <a:pt x="0" y="0"/>
-                </a:moveTo>
-                <a:lnTo>
-                  <a:pt x="5751911" y="0"/>
-                </a:lnTo>
-                <a:lnTo>
-                  <a:pt x="5751911" y="14071954"/>
-                </a:lnTo>
-                <a:lnTo>
-                  <a:pt x="0" y="14071954"/>
-                </a:lnTo>
-                <a:lnTo>
-                  <a:pt x="0" y="0"/>
+                </a:lnTo>
+                <a:lnTo>
+                  <a:pt x="0" y="3222329"/>
+                </a:lnTo>
+                <a:lnTo>
+                  <a:pt x="4037087" y="3222329"/>
+                </a:lnTo>
+                <a:lnTo>
+                  <a:pt x="4037087" y="0"/>
                 </a:lnTo>
                 <a:close/>
               </a:path>
@@ -27057,14 +27202,14 @@
       </p:sp>
       <p:sp>
         <p:nvSpPr>
-          <p:cNvPr name="Freeform 6" id="6"/>
+          <p:cNvPr name="Freeform 15" id="15"/>
           <p:cNvSpPr/>
           <p:nvPr/>
         </p:nvSpPr>
         <p:spPr>
-          <a:xfrm flipH="true" flipV="false" rot="0">
-            <a:off x="792658" y="5143500"/>
-            <a:ext cx="4946577" cy="5519194"/>
+          <a:xfrm flipH="false" flipV="false" rot="0">
+            <a:off x="-946807" y="6298004"/>
+            <a:ext cx="3471862" cy="4114800"/>
           </a:xfrm>
           <a:custGeom>
             <a:avLst/>
@@ -27073,21 +27218,21 @@
             <a:cxnLst/>
             <a:rect r="r" b="b" t="t" l="l"/>
             <a:pathLst>
-              <a:path h="5519194" w="4946577">
+              <a:path h="4114800" w="3471862">
                 <a:moveTo>
-                  <a:pt x="4946577" y="0"/>
+                  <a:pt x="0" y="0"/>
                 </a:moveTo>
                 <a:lnTo>
+                  <a:pt x="3471862" y="0"/>
+                </a:lnTo>
+                <a:lnTo>
+                  <a:pt x="3471862" y="4114800"/>
+                </a:lnTo>
+                <a:lnTo>
+                  <a:pt x="0" y="4114800"/>
+                </a:lnTo>
+                <a:lnTo>
                   <a:pt x="0" y="0"/>
-                </a:lnTo>
-                <a:lnTo>
-                  <a:pt x="0" y="5519194"/>
-                </a:lnTo>
-                <a:lnTo>
-                  <a:pt x="4946577" y="5519194"/>
-                </a:lnTo>
-                <a:lnTo>
-                  <a:pt x="4946577" y="0"/>
                 </a:lnTo>
                 <a:close/>
               </a:path>
@@ -27109,220 +27254,14 @@
       </p:sp>
       <p:sp>
         <p:nvSpPr>
-          <p:cNvPr name="Freeform 7" id="7"/>
-          <p:cNvSpPr/>
-          <p:nvPr/>
-        </p:nvSpPr>
-        <p:spPr>
-          <a:xfrm flipH="true" flipV="false" rot="0">
-            <a:off x="11066058" y="4957733"/>
-            <a:ext cx="6322410" cy="7438130"/>
-          </a:xfrm>
-          <a:custGeom>
-            <a:avLst/>
-            <a:gdLst/>
-            <a:ahLst/>
-            <a:cxnLst/>
-            <a:rect r="r" b="b" t="t" l="l"/>
-            <a:pathLst>
-              <a:path h="7438130" w="6322410">
-                <a:moveTo>
-                  <a:pt x="6322410" y="0"/>
-                </a:moveTo>
-                <a:lnTo>
-                  <a:pt x="0" y="0"/>
-                </a:lnTo>
-                <a:lnTo>
-                  <a:pt x="0" y="7438130"/>
-                </a:lnTo>
-                <a:lnTo>
-                  <a:pt x="6322410" y="7438130"/>
-                </a:lnTo>
-                <a:lnTo>
-                  <a:pt x="6322410" y="0"/>
-                </a:lnTo>
-                <a:close/>
-              </a:path>
-            </a:pathLst>
-          </a:custGeom>
-          <a:blipFill>
-            <a:blip r:embed="rId11">
-              <a:extLst>
-                <a:ext uri="{96DAC541-7B7A-43D3-8B79-37D633B846F1}">
-                  <asvg:svgBlip xmlns:asvg="http://schemas.microsoft.com/office/drawing/2016/SVG/main" r:embed="rId12"/>
-                </a:ext>
-              </a:extLst>
-            </a:blip>
-            <a:stretch>
-              <a:fillRect l="0" t="0" r="0" b="0"/>
-            </a:stretch>
-          </a:blipFill>
-        </p:spPr>
-      </p:sp>
-      <p:sp>
-        <p:nvSpPr>
-          <p:cNvPr name="Freeform 9" id="9"/>
-          <p:cNvSpPr/>
-          <p:nvPr/>
-        </p:nvSpPr>
-        <p:spPr>
-          <a:xfrm flipH="false" flipV="false" rot="0">
-            <a:off x="5976517" y="-809891"/>
-            <a:ext cx="4294014" cy="3427404"/>
-          </a:xfrm>
-          <a:custGeom>
-            <a:avLst/>
-            <a:gdLst/>
-            <a:ahLst/>
-            <a:cxnLst/>
-            <a:rect r="r" b="b" t="t" l="l"/>
-            <a:pathLst>
-              <a:path h="3427404" w="4294014">
-                <a:moveTo>
-                  <a:pt x="0" y="0"/>
-                </a:moveTo>
-                <a:lnTo>
-                  <a:pt x="4294014" y="0"/>
-                </a:lnTo>
-                <a:lnTo>
-                  <a:pt x="4294014" y="3427404"/>
-                </a:lnTo>
-                <a:lnTo>
-                  <a:pt x="0" y="3427404"/>
-                </a:lnTo>
-                <a:lnTo>
-                  <a:pt x="0" y="0"/>
-                </a:lnTo>
-                <a:close/>
-              </a:path>
-            </a:pathLst>
-          </a:custGeom>
-          <a:blipFill>
-            <a:blip r:embed="rId13">
-              <a:extLst>
-                <a:ext uri="{96DAC541-7B7A-43D3-8B79-37D633B846F1}">
-                  <asvg:svgBlip xmlns:asvg="http://schemas.microsoft.com/office/drawing/2016/SVG/main" r:embed="rId14"/>
-                </a:ext>
-              </a:extLst>
-            </a:blip>
-            <a:stretch>
-              <a:fillRect l="0" t="0" r="0" b="0"/>
-            </a:stretch>
-          </a:blipFill>
-        </p:spPr>
-      </p:sp>
-      <p:sp>
-        <p:nvSpPr>
-          <p:cNvPr name="Freeform 10" id="10"/>
-          <p:cNvSpPr/>
-          <p:nvPr/>
-        </p:nvSpPr>
-        <p:spPr>
-          <a:xfrm flipH="false" flipV="false" rot="-526312">
-            <a:off x="6081818" y="6805324"/>
-            <a:ext cx="5385775" cy="4905951"/>
-          </a:xfrm>
-          <a:custGeom>
-            <a:avLst/>
-            <a:gdLst/>
-            <a:ahLst/>
-            <a:cxnLst/>
-            <a:rect r="r" b="b" t="t" l="l"/>
-            <a:pathLst>
-              <a:path h="4905951" w="5385775">
-                <a:moveTo>
-                  <a:pt x="0" y="0"/>
-                </a:moveTo>
-                <a:lnTo>
-                  <a:pt x="5385774" y="0"/>
-                </a:lnTo>
-                <a:lnTo>
-                  <a:pt x="5385774" y="4905952"/>
-                </a:lnTo>
-                <a:lnTo>
-                  <a:pt x="0" y="4905952"/>
-                </a:lnTo>
-                <a:lnTo>
-                  <a:pt x="0" y="0"/>
-                </a:lnTo>
-                <a:close/>
-              </a:path>
-            </a:pathLst>
-          </a:custGeom>
-          <a:blipFill>
-            <a:blip r:embed="rId15">
-              <a:extLst>
-                <a:ext uri="{96DAC541-7B7A-43D3-8B79-37D633B846F1}">
-                  <asvg:svgBlip xmlns:asvg="http://schemas.microsoft.com/office/drawing/2016/SVG/main" r:embed="rId16"/>
-                </a:ext>
-              </a:extLst>
-            </a:blip>
-            <a:stretch>
-              <a:fillRect l="0" t="0" r="0" b="0"/>
-            </a:stretch>
-          </a:blipFill>
-        </p:spPr>
-      </p:sp>
-      <p:sp>
-        <p:nvSpPr>
           <p:cNvPr id="201" name="Título 201"/>
           <p:cNvSpPr txBox="1"/>
           <p:nvPr/>
         </p:nvSpPr>
         <p:spPr>
           <a:xfrm>
-            <a:off x="3960000" y="2232000"/>
-            <a:ext cx="10368000" cy="2304000"/>
-          </a:xfrm>
-          <a:prstGeom prst="rect">
-            <a:avLst/>
-          </a:prstGeom>
-          <a:noFill/>
-        </p:spPr>
-        <p:txBody>
-          <a:bodyPr wrap="square" lIns="0" tIns="0" rIns="0" bIns="0" anchor="ctr" rtlCol="0">
-            <a:noAutofit/>
-          </a:bodyPr>
-          <a:lstStyle/>
-          <a:p>
-            <a:pPr algn="ctr">
-              <a:lnSpc>
-                <a:spcPct val="85000"/>
-              </a:lnSpc>
-              <a:spcBef>
-                <a:spcPts val="0"/>
-              </a:spcBef>
-              <a:spcAft>
-                <a:spcPts val="0"/>
-              </a:spcAft>
-              <a:buNone/>
-            </a:pPr>
-            <a:r>
-              <a:rPr lang="pt-BR" sz="11000" b="1" dirty="0">
-                <a:solidFill>
-                  <a:srgbClr val="FFFFFF"/>
-                </a:solidFill>
-                <a:latin typeface="Canva Sans Bold"/>
-                <a:ea typeface="Canva Sans Bold"/>
-                <a:cs typeface="Canva Sans Bold"/>
-                <a:sym typeface="Canva Sans Bold"/>
-              </a:rPr>
-              <a:t>AGRADEÇO</a:t>
-            </a:r>
-            <a:endParaRPr lang="pt-BR" sz="11000" dirty="0"/>
-          </a:p>
-        </p:txBody>
-      </p:sp>
-      <p:sp>
-        <p:nvSpPr>
-          <p:cNvPr id="202" name="Texto 202"/>
-          <p:cNvSpPr txBox="1"/>
-          <p:nvPr/>
-        </p:nvSpPr>
-        <p:spPr>
-          <a:xfrm>
-            <a:off x="3960000" y="4428000"/>
-            <a:ext cx="10368000" cy="648000"/>
+            <a:off x="1908000" y="1296000"/>
+            <a:ext cx="10800000" cy="2880000"/>
           </a:xfrm>
           <a:prstGeom prst="rect">
             <a:avLst/>
@@ -27335,7 +27274,34 @@
           </a:bodyPr>
           <a:lstStyle/>
           <a:p>
-            <a:pPr algn="ctr">
+            <a:pPr algn="l">
+              <a:lnSpc>
+                <a:spcPct val="88000"/>
+              </a:lnSpc>
+              <a:spcBef>
+                <a:spcPts val="0"/>
+              </a:spcBef>
+              <a:spcAft>
+                <a:spcPts val="0"/>
+              </a:spcAft>
+              <a:buNone/>
+            </a:pPr>
+            <a:r>
+              <a:rPr lang="pt-BR" sz="4800" b="1" dirty="0">
+                <a:solidFill>
+                  <a:srgbClr val="FFFFFF"/>
+                </a:solidFill>
+                <a:latin typeface="Canva Sans Bold"/>
+                <a:ea typeface="Canva Sans Bold"/>
+                <a:cs typeface="Canva Sans Bold"/>
+                <a:sym typeface="Canva Sans Bold"/>
+              </a:rPr>
+              <a:t>O QUE FOI FEITO</a:t>
+            </a:r>
+            <a:endParaRPr lang="pt-BR" sz="4800" dirty="0"/>
+          </a:p>
+          <a:p>
+            <a:pPr algn="l">
               <a:lnSpc>
                 <a:spcPct val="95000"/>
               </a:lnSpc>
@@ -27348,7 +27314,7 @@
               <a:buNone/>
             </a:pPr>
             <a:r>
-              <a:rPr lang="pt-BR" sz="2900" dirty="0">
+              <a:rPr lang="pt-BR" sz="3600" dirty="0">
                 <a:solidFill>
                   <a:srgbClr val="FFFFFF"/>
                 </a:solidFill>
@@ -27357,9 +27323,429 @@
                 <a:cs typeface="Canva Sans"/>
                 <a:sym typeface="Canva Sans"/>
               </a:rPr>
-              <a:t>pela atenção e pelas contribuições</a:t>
-            </a:r>
-            <a:endParaRPr lang="pt-BR" sz="2900" dirty="0"/>
+              <a:t>e o que falta fazer</a:t>
+            </a:r>
+            <a:endParaRPr lang="pt-BR" sz="3600" dirty="0"/>
+          </a:p>
+        </p:txBody>
+      </p:sp>
+      <p:sp>
+        <p:nvSpPr>
+          <p:cNvPr id="202" name="Texto 202"/>
+          <p:cNvSpPr txBox="1"/>
+          <p:nvPr/>
+        </p:nvSpPr>
+        <p:spPr>
+          <a:xfrm>
+            <a:off x="2664000" y="5328000"/>
+            <a:ext cx="6084000" cy="4896000"/>
+          </a:xfrm>
+          <a:prstGeom prst="rect">
+            <a:avLst/>
+          </a:prstGeom>
+          <a:noFill/>
+        </p:spPr>
+        <p:txBody>
+          <a:bodyPr wrap="square" lIns="0" tIns="0" rIns="0" bIns="0" anchor="t" rtlCol="0">
+            <a:noAutofit/>
+          </a:bodyPr>
+          <a:lstStyle/>
+          <a:p>
+            <a:pPr algn="l">
+              <a:lnSpc>
+                <a:spcPct val="100000"/>
+              </a:lnSpc>
+              <a:spcBef>
+                <a:spcPts val="0"/>
+              </a:spcBef>
+              <a:spcAft>
+                <a:spcPts val="725"/>
+              </a:spcAft>
+              <a:buNone/>
+            </a:pPr>
+            <a:r>
+              <a:rPr lang="pt-BR" sz="2392" b="1" dirty="0">
+                <a:solidFill>
+                  <a:srgbClr val="111111"/>
+                </a:solidFill>
+                <a:latin typeface="Canva Sans Bold"/>
+                <a:ea typeface="Canva Sans Bold"/>
+                <a:cs typeface="Canva Sans Bold"/>
+                <a:sym typeface="Canva Sans Bold"/>
+              </a:rPr>
+              <a:t>Feito</a:t>
+            </a:r>
+            <a:endParaRPr lang="pt-BR" sz="2392" dirty="0"/>
+          </a:p>
+          <a:p>
+            <a:pPr algn="l" marL="270000" indent="-270000">
+              <a:lnSpc>
+                <a:spcPct val="100000"/>
+              </a:lnSpc>
+              <a:spcBef>
+                <a:spcPts val="0"/>
+              </a:spcBef>
+              <a:spcAft>
+                <a:spcPts val="725"/>
+              </a:spcAft>
+              <a:buClr>
+                <a:srgbClr val="111111"/>
+              </a:buClr>
+              <a:buSzPct val="100000"/>
+              <a:buFont typeface="Arial"/>
+              <a:buChar char="•"/>
+            </a:pPr>
+            <a:r>
+              <a:rPr lang="pt-BR" sz="1958" dirty="0">
+                <a:solidFill>
+                  <a:srgbClr val="111111"/>
+                </a:solidFill>
+                <a:latin typeface="Canva Sans"/>
+                <a:ea typeface="Canva Sans"/>
+                <a:cs typeface="Canva Sans"/>
+                <a:sym typeface="Canva Sans"/>
+              </a:rPr>
+              <a:t>Componentes curriculares: 315 h de 330 h integralizadas; proficiência em espanhol</a:t>
+            </a:r>
+            <a:endParaRPr lang="pt-BR" sz="1958" dirty="0"/>
+          </a:p>
+          <a:p>
+            <a:pPr algn="l" marL="270000" indent="-270000">
+              <a:lnSpc>
+                <a:spcPct val="100000"/>
+              </a:lnSpc>
+              <a:spcBef>
+                <a:spcPts val="0"/>
+              </a:spcBef>
+              <a:spcAft>
+                <a:spcPts val="725"/>
+              </a:spcAft>
+              <a:buClr>
+                <a:srgbClr val="111111"/>
+              </a:buClr>
+              <a:buSzPct val="100000"/>
+              <a:buFont typeface="Arial"/>
+              <a:buChar char="•"/>
+            </a:pPr>
+            <a:r>
+              <a:rPr lang="pt-BR" sz="1958" dirty="0">
+                <a:solidFill>
+                  <a:srgbClr val="111111"/>
+                </a:solidFill>
+                <a:latin typeface="Canva Sans"/>
+                <a:ea typeface="Canva Sans"/>
+                <a:cs typeface="Canva Sans"/>
+                <a:sym typeface="Canva Sans"/>
+              </a:rPr>
+              <a:t>Aprovação no CEP (Parecer nº 8.038.332; CAAE 91393625.4.0000.5292)</a:t>
+            </a:r>
+            <a:endParaRPr lang="pt-BR" sz="1958" dirty="0"/>
+          </a:p>
+          <a:p>
+            <a:pPr algn="l" marL="270000" indent="-270000">
+              <a:lnSpc>
+                <a:spcPct val="100000"/>
+              </a:lnSpc>
+              <a:spcBef>
+                <a:spcPts val="0"/>
+              </a:spcBef>
+              <a:spcAft>
+                <a:spcPts val="725"/>
+              </a:spcAft>
+              <a:buClr>
+                <a:srgbClr val="111111"/>
+              </a:buClr>
+              <a:buSzPct val="100000"/>
+              <a:buFont typeface="Arial"/>
+              <a:buChar char="•"/>
+            </a:pPr>
+            <a:r>
+              <a:rPr lang="pt-BR" sz="1958" dirty="0">
+                <a:solidFill>
+                  <a:srgbClr val="111111"/>
+                </a:solidFill>
+                <a:latin typeface="Canva Sans"/>
+                <a:ea typeface="Canva Sans"/>
+                <a:cs typeface="Canva Sans"/>
+                <a:sym typeface="Canva Sans"/>
+              </a:rPr>
+              <a:t>Texto de qualificação: RSL, fundamentos, metodologia, agenda e PNED, território de Pipa e escola</a:t>
+            </a:r>
+            <a:endParaRPr lang="pt-BR" sz="1958" dirty="0"/>
+          </a:p>
+          <a:p>
+            <a:pPr algn="l" marL="270000" indent="-270000">
+              <a:lnSpc>
+                <a:spcPct val="100000"/>
+              </a:lnSpc>
+              <a:spcBef>
+                <a:spcPts val="0"/>
+              </a:spcBef>
+              <a:spcAft>
+                <a:spcPts val="725"/>
+              </a:spcAft>
+              <a:buClr>
+                <a:srgbClr val="111111"/>
+              </a:buClr>
+              <a:buSzPct val="100000"/>
+              <a:buFont typeface="Arial"/>
+              <a:buChar char="•"/>
+            </a:pPr>
+            <a:r>
+              <a:rPr lang="pt-BR" sz="1958" dirty="0">
+                <a:solidFill>
+                  <a:srgbClr val="111111"/>
+                </a:solidFill>
+                <a:latin typeface="Canva Sans"/>
+                <a:ea typeface="Canva Sans"/>
+                <a:cs typeface="Canva Sans"/>
+                <a:sym typeface="Canva Sans"/>
+              </a:rPr>
+              <a:t>Registro iconográfico de Pipa e da escola; documentos solicitados à direção e à SME</a:t>
+            </a:r>
+            <a:endParaRPr lang="pt-BR" sz="1958" dirty="0"/>
+          </a:p>
+          <a:p>
+            <a:pPr algn="l" marL="270000" indent="-270000">
+              <a:lnSpc>
+                <a:spcPct val="100000"/>
+              </a:lnSpc>
+              <a:spcBef>
+                <a:spcPts val="0"/>
+              </a:spcBef>
+              <a:spcAft>
+                <a:spcPts val="725"/>
+              </a:spcAft>
+              <a:buClr>
+                <a:srgbClr val="111111"/>
+              </a:buClr>
+              <a:buSzPct val="100000"/>
+              <a:buFont typeface="Arial"/>
+              <a:buChar char="•"/>
+            </a:pPr>
+            <a:r>
+              <a:rPr lang="pt-BR" sz="1958" dirty="0">
+                <a:solidFill>
+                  <a:srgbClr val="111111"/>
+                </a:solidFill>
+                <a:latin typeface="Canva Sans"/>
+                <a:ea typeface="Canva Sans"/>
+                <a:cs typeface="Canva Sans"/>
+                <a:sym typeface="Canva Sans"/>
+              </a:rPr>
+              <a:t>Produção: ConWiTE (2024; 2026, e-book), ConBAlf (2025, anais), V Colóquio de Políticas Educacionais (2025, aprovado)</a:t>
+            </a:r>
+            <a:endParaRPr lang="pt-BR" sz="1958" dirty="0"/>
+          </a:p>
+        </p:txBody>
+      </p:sp>
+      <p:sp>
+        <p:nvSpPr>
+          <p:cNvPr id="203" name="Texto 203"/>
+          <p:cNvSpPr txBox="1"/>
+          <p:nvPr/>
+        </p:nvSpPr>
+        <p:spPr>
+          <a:xfrm>
+            <a:off x="9792000" y="5328000"/>
+            <a:ext cx="6336000" cy="4896000"/>
+          </a:xfrm>
+          <a:prstGeom prst="rect">
+            <a:avLst/>
+          </a:prstGeom>
+          <a:noFill/>
+        </p:spPr>
+        <p:txBody>
+          <a:bodyPr wrap="square" lIns="0" tIns="0" rIns="0" bIns="0" anchor="t" rtlCol="0">
+            <a:noAutofit/>
+          </a:bodyPr>
+          <a:lstStyle/>
+          <a:p>
+            <a:pPr algn="l">
+              <a:lnSpc>
+                <a:spcPct val="100000"/>
+              </a:lnSpc>
+              <a:spcBef>
+                <a:spcPts val="0"/>
+              </a:spcBef>
+              <a:spcAft>
+                <a:spcPts val="725"/>
+              </a:spcAft>
+              <a:buNone/>
+            </a:pPr>
+            <a:r>
+              <a:rPr lang="pt-BR" sz="2392" b="1" dirty="0">
+                <a:solidFill>
+                  <a:srgbClr val="111111"/>
+                </a:solidFill>
+                <a:latin typeface="Canva Sans Bold"/>
+                <a:ea typeface="Canva Sans Bold"/>
+                <a:cs typeface="Canva Sans Bold"/>
+                <a:sym typeface="Canva Sans Bold"/>
+              </a:rPr>
+              <a:t>Falta fazer</a:t>
+            </a:r>
+            <a:endParaRPr lang="pt-BR" sz="2392" dirty="0"/>
+          </a:p>
+          <a:p>
+            <a:pPr algn="l" marL="270000" indent="-270000">
+              <a:lnSpc>
+                <a:spcPct val="100000"/>
+              </a:lnSpc>
+              <a:spcBef>
+                <a:spcPts val="0"/>
+              </a:spcBef>
+              <a:spcAft>
+                <a:spcPts val="725"/>
+              </a:spcAft>
+              <a:buClr>
+                <a:srgbClr val="111111"/>
+              </a:buClr>
+              <a:buSzPct val="100000"/>
+              <a:buFont typeface="Arial"/>
+              <a:buChar char="•"/>
+            </a:pPr>
+            <a:r>
+              <a:rPr lang="pt-BR" sz="1958" dirty="0">
+                <a:solidFill>
+                  <a:srgbClr val="111111"/>
+                </a:solidFill>
+                <a:latin typeface="Canva Sans"/>
+                <a:ea typeface="Canva Sans"/>
+                <a:cs typeface="Canva Sans"/>
+                <a:sym typeface="Canva Sans"/>
+              </a:rPr>
+              <a:t>Emenda ao CEP, com a SME coparticipante e o projeto atualizado à PNED</a:t>
+            </a:r>
+            <a:endParaRPr lang="pt-BR" sz="1958" dirty="0"/>
+          </a:p>
+          <a:p>
+            <a:pPr algn="l" marL="270000" indent="-270000">
+              <a:lnSpc>
+                <a:spcPct val="100000"/>
+              </a:lnSpc>
+              <a:spcBef>
+                <a:spcPts val="0"/>
+              </a:spcBef>
+              <a:spcAft>
+                <a:spcPts val="725"/>
+              </a:spcAft>
+              <a:buClr>
+                <a:srgbClr val="111111"/>
+              </a:buClr>
+              <a:buSzPct val="100000"/>
+              <a:buFont typeface="Arial"/>
+              <a:buChar char="•"/>
+            </a:pPr>
+            <a:r>
+              <a:rPr lang="pt-BR" sz="1958" dirty="0">
+                <a:solidFill>
+                  <a:srgbClr val="111111"/>
+                </a:solidFill>
+                <a:latin typeface="Canva Sans"/>
+                <a:ea typeface="Canva Sans"/>
+                <a:cs typeface="Canva Sans"/>
+                <a:sym typeface="Canva Sans"/>
+              </a:rPr>
+              <a:t>Campo em dez semanas: técnico da SME, questionários, entrevistas e acervo documental</a:t>
+            </a:r>
+            <a:endParaRPr lang="pt-BR" sz="1958" dirty="0"/>
+          </a:p>
+          <a:p>
+            <a:pPr algn="l" marL="270000" indent="-270000">
+              <a:lnSpc>
+                <a:spcPct val="100000"/>
+              </a:lnSpc>
+              <a:spcBef>
+                <a:spcPts val="0"/>
+              </a:spcBef>
+              <a:spcAft>
+                <a:spcPts val="725"/>
+              </a:spcAft>
+              <a:buClr>
+                <a:srgbClr val="111111"/>
+              </a:buClr>
+              <a:buSzPct val="100000"/>
+              <a:buFont typeface="Arial"/>
+              <a:buChar char="•"/>
+            </a:pPr>
+            <a:r>
+              <a:rPr lang="pt-BR" sz="1958" dirty="0">
+                <a:solidFill>
+                  <a:srgbClr val="111111"/>
+                </a:solidFill>
+                <a:latin typeface="Canva Sans"/>
+                <a:ea typeface="Canva Sans"/>
+                <a:cs typeface="Canva Sans"/>
+                <a:sym typeface="Canva Sans"/>
+              </a:rPr>
+              <a:t>Transcrição, análise temática reflexiva e devolutiva à escola e à SME</a:t>
+            </a:r>
+            <a:endParaRPr lang="pt-BR" sz="1958" dirty="0"/>
+          </a:p>
+          <a:p>
+            <a:pPr algn="l" marL="270000" indent="-270000">
+              <a:lnSpc>
+                <a:spcPct val="100000"/>
+              </a:lnSpc>
+              <a:spcBef>
+                <a:spcPts val="0"/>
+              </a:spcBef>
+              <a:spcAft>
+                <a:spcPts val="725"/>
+              </a:spcAft>
+              <a:buClr>
+                <a:srgbClr val="111111"/>
+              </a:buClr>
+              <a:buSzPct val="100000"/>
+              <a:buFont typeface="Arial"/>
+              <a:buChar char="•"/>
+            </a:pPr>
+            <a:r>
+              <a:rPr lang="pt-BR" sz="1958" dirty="0">
+                <a:solidFill>
+                  <a:srgbClr val="111111"/>
+                </a:solidFill>
+                <a:latin typeface="Canva Sans"/>
+                <a:ea typeface="Canva Sans"/>
+                <a:cs typeface="Canva Sans"/>
+                <a:sym typeface="Canva Sans"/>
+              </a:rPr>
+              <a:t>Capítulo 7, revisão dos capítulos com as contribuições da banca e considerações finais</a:t>
+            </a:r>
+            <a:endParaRPr lang="pt-BR" sz="1958" dirty="0"/>
+          </a:p>
+          <a:p>
+            <a:pPr algn="l" marL="270000" indent="-270000">
+              <a:lnSpc>
+                <a:spcPct val="100000"/>
+              </a:lnSpc>
+              <a:spcBef>
+                <a:spcPts val="0"/>
+              </a:spcBef>
+              <a:spcAft>
+                <a:spcPts val="725"/>
+              </a:spcAft>
+              <a:buClr>
+                <a:srgbClr val="111111"/>
+              </a:buClr>
+              <a:buSzPct val="100000"/>
+              <a:buFont typeface="Arial"/>
+              <a:buChar char="•"/>
+            </a:pPr>
+            <a:r>
+              <a:rPr lang="pt-BR" sz="1958" dirty="0">
+                <a:solidFill>
+                  <a:srgbClr val="111111"/>
+                </a:solidFill>
+                <a:latin typeface="Canva Sans"/>
+                <a:ea typeface="Canva Sans"/>
+                <a:cs typeface="Canva Sans"/>
+                <a:sym typeface="Canva Sans"/>
+              </a:rPr>
+              <a:t>Seminário de Formação Doutoral II e Seminário de Pesquisa IV (em curso); proficiência em inglês; artigos; depósito e defesa</a:t>
+            </a:r>
+            <a:endParaRPr lang="pt-BR" sz="1958" dirty="0"/>
           </a:p>
         </p:txBody>
       </p:sp>
@@ -27436,6 +27822,541 @@
       </p:sp>
       <p:sp>
         <p:nvSpPr>
+          <p:cNvPr name="Freeform 3" id="3"/>
+          <p:cNvSpPr/>
+          <p:nvPr/>
+        </p:nvSpPr>
+        <p:spPr>
+          <a:xfrm flipH="false" flipV="false" rot="0">
+            <a:off x="-2498597" y="-108828"/>
+            <a:ext cx="6582509" cy="10746953"/>
+          </a:xfrm>
+          <a:custGeom>
+            <a:avLst/>
+            <a:gdLst/>
+            <a:ahLst/>
+            <a:cxnLst/>
+            <a:rect r="r" b="b" t="t" l="l"/>
+            <a:pathLst>
+              <a:path h="10746953" w="6582509">
+                <a:moveTo>
+                  <a:pt x="0" y="0"/>
+                </a:moveTo>
+                <a:lnTo>
+                  <a:pt x="6582509" y="0"/>
+                </a:lnTo>
+                <a:lnTo>
+                  <a:pt x="6582509" y="10746953"/>
+                </a:lnTo>
+                <a:lnTo>
+                  <a:pt x="0" y="10746953"/>
+                </a:lnTo>
+                <a:lnTo>
+                  <a:pt x="0" y="0"/>
+                </a:lnTo>
+                <a:close/>
+              </a:path>
+            </a:pathLst>
+          </a:custGeom>
+          <a:blipFill>
+            <a:blip r:embed="rId3">
+              <a:extLst>
+                <a:ext uri="{96DAC541-7B7A-43D3-8B79-37D633B846F1}">
+                  <asvg:svgBlip xmlns:asvg="http://schemas.microsoft.com/office/drawing/2016/SVG/main" r:embed="rId4"/>
+                </a:ext>
+              </a:extLst>
+            </a:blip>
+            <a:stretch>
+              <a:fillRect l="0" t="0" r="0" b="0"/>
+            </a:stretch>
+          </a:blipFill>
+        </p:spPr>
+      </p:sp>
+      <p:sp>
+        <p:nvSpPr>
+          <p:cNvPr name="Freeform 4" id="4"/>
+          <p:cNvSpPr/>
+          <p:nvPr/>
+        </p:nvSpPr>
+        <p:spPr>
+          <a:xfrm flipH="false" flipV="false" rot="-797725">
+            <a:off x="13679956" y="-1054879"/>
+            <a:ext cx="4476702" cy="4994292"/>
+          </a:xfrm>
+          <a:custGeom>
+            <a:avLst/>
+            <a:gdLst/>
+            <a:ahLst/>
+            <a:cxnLst/>
+            <a:rect r="r" b="b" t="t" l="l"/>
+            <a:pathLst>
+              <a:path h="4994292" w="4476702">
+                <a:moveTo>
+                  <a:pt x="0" y="0"/>
+                </a:moveTo>
+                <a:lnTo>
+                  <a:pt x="4476701" y="0"/>
+                </a:lnTo>
+                <a:lnTo>
+                  <a:pt x="4476701" y="4994292"/>
+                </a:lnTo>
+                <a:lnTo>
+                  <a:pt x="0" y="4994292"/>
+                </a:lnTo>
+                <a:lnTo>
+                  <a:pt x="0" y="0"/>
+                </a:lnTo>
+                <a:close/>
+              </a:path>
+            </a:pathLst>
+          </a:custGeom>
+          <a:blipFill>
+            <a:blip r:embed="rId5">
+              <a:extLst>
+                <a:ext uri="{96DAC541-7B7A-43D3-8B79-37D633B846F1}">
+                  <asvg:svgBlip xmlns:asvg="http://schemas.microsoft.com/office/drawing/2016/SVG/main" r:embed="rId6"/>
+                </a:ext>
+              </a:extLst>
+            </a:blip>
+            <a:stretch>
+              <a:fillRect l="0" t="0" r="0" b="0"/>
+            </a:stretch>
+          </a:blipFill>
+        </p:spPr>
+      </p:sp>
+      <p:sp>
+        <p:nvSpPr>
+          <p:cNvPr name="Freeform 5" id="5"/>
+          <p:cNvSpPr/>
+          <p:nvPr/>
+        </p:nvSpPr>
+        <p:spPr>
+          <a:xfrm flipH="false" flipV="false" rot="0">
+            <a:off x="14944550" y="2366363"/>
+            <a:ext cx="5751911" cy="14071953"/>
+          </a:xfrm>
+          <a:custGeom>
+            <a:avLst/>
+            <a:gdLst/>
+            <a:ahLst/>
+            <a:cxnLst/>
+            <a:rect r="r" b="b" t="t" l="l"/>
+            <a:pathLst>
+              <a:path h="14071953" w="5751911">
+                <a:moveTo>
+                  <a:pt x="0" y="0"/>
+                </a:moveTo>
+                <a:lnTo>
+                  <a:pt x="5751911" y="0"/>
+                </a:lnTo>
+                <a:lnTo>
+                  <a:pt x="5751911" y="14071954"/>
+                </a:lnTo>
+                <a:lnTo>
+                  <a:pt x="0" y="14071954"/>
+                </a:lnTo>
+                <a:lnTo>
+                  <a:pt x="0" y="0"/>
+                </a:lnTo>
+                <a:close/>
+              </a:path>
+            </a:pathLst>
+          </a:custGeom>
+          <a:blipFill>
+            <a:blip r:embed="rId7">
+              <a:extLst>
+                <a:ext uri="{96DAC541-7B7A-43D3-8B79-37D633B846F1}">
+                  <asvg:svgBlip xmlns:asvg="http://schemas.microsoft.com/office/drawing/2016/SVG/main" r:embed="rId8"/>
+                </a:ext>
+              </a:extLst>
+            </a:blip>
+            <a:stretch>
+              <a:fillRect l="0" t="0" r="0" b="0"/>
+            </a:stretch>
+          </a:blipFill>
+        </p:spPr>
+      </p:sp>
+      <p:sp>
+        <p:nvSpPr>
+          <p:cNvPr name="Freeform 6" id="6"/>
+          <p:cNvSpPr/>
+          <p:nvPr/>
+        </p:nvSpPr>
+        <p:spPr>
+          <a:xfrm flipH="true" flipV="false" rot="0">
+            <a:off x="792658" y="5143500"/>
+            <a:ext cx="4946577" cy="5519194"/>
+          </a:xfrm>
+          <a:custGeom>
+            <a:avLst/>
+            <a:gdLst/>
+            <a:ahLst/>
+            <a:cxnLst/>
+            <a:rect r="r" b="b" t="t" l="l"/>
+            <a:pathLst>
+              <a:path h="5519194" w="4946577">
+                <a:moveTo>
+                  <a:pt x="4946577" y="0"/>
+                </a:moveTo>
+                <a:lnTo>
+                  <a:pt x="0" y="0"/>
+                </a:lnTo>
+                <a:lnTo>
+                  <a:pt x="0" y="5519194"/>
+                </a:lnTo>
+                <a:lnTo>
+                  <a:pt x="4946577" y="5519194"/>
+                </a:lnTo>
+                <a:lnTo>
+                  <a:pt x="4946577" y="0"/>
+                </a:lnTo>
+                <a:close/>
+              </a:path>
+            </a:pathLst>
+          </a:custGeom>
+          <a:blipFill>
+            <a:blip r:embed="rId9">
+              <a:extLst>
+                <a:ext uri="{96DAC541-7B7A-43D3-8B79-37D633B846F1}">
+                  <asvg:svgBlip xmlns:asvg="http://schemas.microsoft.com/office/drawing/2016/SVG/main" r:embed="rId10"/>
+                </a:ext>
+              </a:extLst>
+            </a:blip>
+            <a:stretch>
+              <a:fillRect l="0" t="0" r="0" b="0"/>
+            </a:stretch>
+          </a:blipFill>
+        </p:spPr>
+      </p:sp>
+      <p:sp>
+        <p:nvSpPr>
+          <p:cNvPr name="Freeform 7" id="7"/>
+          <p:cNvSpPr/>
+          <p:nvPr/>
+        </p:nvSpPr>
+        <p:spPr>
+          <a:xfrm flipH="true" flipV="false" rot="0">
+            <a:off x="11066058" y="4957733"/>
+            <a:ext cx="6322410" cy="7438130"/>
+          </a:xfrm>
+          <a:custGeom>
+            <a:avLst/>
+            <a:gdLst/>
+            <a:ahLst/>
+            <a:cxnLst/>
+            <a:rect r="r" b="b" t="t" l="l"/>
+            <a:pathLst>
+              <a:path h="7438130" w="6322410">
+                <a:moveTo>
+                  <a:pt x="6322410" y="0"/>
+                </a:moveTo>
+                <a:lnTo>
+                  <a:pt x="0" y="0"/>
+                </a:lnTo>
+                <a:lnTo>
+                  <a:pt x="0" y="7438130"/>
+                </a:lnTo>
+                <a:lnTo>
+                  <a:pt x="6322410" y="7438130"/>
+                </a:lnTo>
+                <a:lnTo>
+                  <a:pt x="6322410" y="0"/>
+                </a:lnTo>
+                <a:close/>
+              </a:path>
+            </a:pathLst>
+          </a:custGeom>
+          <a:blipFill>
+            <a:blip r:embed="rId11">
+              <a:extLst>
+                <a:ext uri="{96DAC541-7B7A-43D3-8B79-37D633B846F1}">
+                  <asvg:svgBlip xmlns:asvg="http://schemas.microsoft.com/office/drawing/2016/SVG/main" r:embed="rId12"/>
+                </a:ext>
+              </a:extLst>
+            </a:blip>
+            <a:stretch>
+              <a:fillRect l="0" t="0" r="0" b="0"/>
+            </a:stretch>
+          </a:blipFill>
+        </p:spPr>
+      </p:sp>
+      <p:sp>
+        <p:nvSpPr>
+          <p:cNvPr name="Freeform 9" id="9"/>
+          <p:cNvSpPr/>
+          <p:nvPr/>
+        </p:nvSpPr>
+        <p:spPr>
+          <a:xfrm flipH="false" flipV="false" rot="0">
+            <a:off x="5976517" y="-809891"/>
+            <a:ext cx="4294014" cy="3427404"/>
+          </a:xfrm>
+          <a:custGeom>
+            <a:avLst/>
+            <a:gdLst/>
+            <a:ahLst/>
+            <a:cxnLst/>
+            <a:rect r="r" b="b" t="t" l="l"/>
+            <a:pathLst>
+              <a:path h="3427404" w="4294014">
+                <a:moveTo>
+                  <a:pt x="0" y="0"/>
+                </a:moveTo>
+                <a:lnTo>
+                  <a:pt x="4294014" y="0"/>
+                </a:lnTo>
+                <a:lnTo>
+                  <a:pt x="4294014" y="3427404"/>
+                </a:lnTo>
+                <a:lnTo>
+                  <a:pt x="0" y="3427404"/>
+                </a:lnTo>
+                <a:lnTo>
+                  <a:pt x="0" y="0"/>
+                </a:lnTo>
+                <a:close/>
+              </a:path>
+            </a:pathLst>
+          </a:custGeom>
+          <a:blipFill>
+            <a:blip r:embed="rId13">
+              <a:extLst>
+                <a:ext uri="{96DAC541-7B7A-43D3-8B79-37D633B846F1}">
+                  <asvg:svgBlip xmlns:asvg="http://schemas.microsoft.com/office/drawing/2016/SVG/main" r:embed="rId14"/>
+                </a:ext>
+              </a:extLst>
+            </a:blip>
+            <a:stretch>
+              <a:fillRect l="0" t="0" r="0" b="0"/>
+            </a:stretch>
+          </a:blipFill>
+        </p:spPr>
+      </p:sp>
+      <p:sp>
+        <p:nvSpPr>
+          <p:cNvPr name="Freeform 10" id="10"/>
+          <p:cNvSpPr/>
+          <p:nvPr/>
+        </p:nvSpPr>
+        <p:spPr>
+          <a:xfrm flipH="false" flipV="false" rot="-526312">
+            <a:off x="6081818" y="6805324"/>
+            <a:ext cx="5385775" cy="4905951"/>
+          </a:xfrm>
+          <a:custGeom>
+            <a:avLst/>
+            <a:gdLst/>
+            <a:ahLst/>
+            <a:cxnLst/>
+            <a:rect r="r" b="b" t="t" l="l"/>
+            <a:pathLst>
+              <a:path h="4905951" w="5385775">
+                <a:moveTo>
+                  <a:pt x="0" y="0"/>
+                </a:moveTo>
+                <a:lnTo>
+                  <a:pt x="5385774" y="0"/>
+                </a:lnTo>
+                <a:lnTo>
+                  <a:pt x="5385774" y="4905952"/>
+                </a:lnTo>
+                <a:lnTo>
+                  <a:pt x="0" y="4905952"/>
+                </a:lnTo>
+                <a:lnTo>
+                  <a:pt x="0" y="0"/>
+                </a:lnTo>
+                <a:close/>
+              </a:path>
+            </a:pathLst>
+          </a:custGeom>
+          <a:blipFill>
+            <a:blip r:embed="rId15">
+              <a:extLst>
+                <a:ext uri="{96DAC541-7B7A-43D3-8B79-37D633B846F1}">
+                  <asvg:svgBlip xmlns:asvg="http://schemas.microsoft.com/office/drawing/2016/SVG/main" r:embed="rId16"/>
+                </a:ext>
+              </a:extLst>
+            </a:blip>
+            <a:stretch>
+              <a:fillRect l="0" t="0" r="0" b="0"/>
+            </a:stretch>
+          </a:blipFill>
+        </p:spPr>
+      </p:sp>
+      <p:sp>
+        <p:nvSpPr>
+          <p:cNvPr id="201" name="Título 201"/>
+          <p:cNvSpPr txBox="1"/>
+          <p:nvPr/>
+        </p:nvSpPr>
+        <p:spPr>
+          <a:xfrm>
+            <a:off x="3960000" y="2232000"/>
+            <a:ext cx="10368000" cy="2304000"/>
+          </a:xfrm>
+          <a:prstGeom prst="rect">
+            <a:avLst/>
+          </a:prstGeom>
+          <a:noFill/>
+        </p:spPr>
+        <p:txBody>
+          <a:bodyPr wrap="square" lIns="0" tIns="0" rIns="0" bIns="0" anchor="ctr" rtlCol="0">
+            <a:noAutofit/>
+          </a:bodyPr>
+          <a:lstStyle/>
+          <a:p>
+            <a:pPr algn="ctr">
+              <a:lnSpc>
+                <a:spcPct val="85000"/>
+              </a:lnSpc>
+              <a:spcBef>
+                <a:spcPts val="0"/>
+              </a:spcBef>
+              <a:spcAft>
+                <a:spcPts val="0"/>
+              </a:spcAft>
+              <a:buNone/>
+            </a:pPr>
+            <a:r>
+              <a:rPr lang="pt-BR" sz="11000" b="1" dirty="0">
+                <a:solidFill>
+                  <a:srgbClr val="FFFFFF"/>
+                </a:solidFill>
+                <a:latin typeface="Canva Sans Bold"/>
+                <a:ea typeface="Canva Sans Bold"/>
+                <a:cs typeface="Canva Sans Bold"/>
+                <a:sym typeface="Canva Sans Bold"/>
+              </a:rPr>
+              <a:t>AGRADEÇO</a:t>
+            </a:r>
+            <a:endParaRPr lang="pt-BR" sz="11000" dirty="0"/>
+          </a:p>
+        </p:txBody>
+      </p:sp>
+      <p:sp>
+        <p:nvSpPr>
+          <p:cNvPr id="202" name="Texto 202"/>
+          <p:cNvSpPr txBox="1"/>
+          <p:nvPr/>
+        </p:nvSpPr>
+        <p:spPr>
+          <a:xfrm>
+            <a:off x="3960000" y="4428000"/>
+            <a:ext cx="10368000" cy="648000"/>
+          </a:xfrm>
+          <a:prstGeom prst="rect">
+            <a:avLst/>
+          </a:prstGeom>
+          <a:noFill/>
+        </p:spPr>
+        <p:txBody>
+          <a:bodyPr wrap="square" lIns="0" tIns="0" rIns="0" bIns="0" anchor="t" rtlCol="0">
+            <a:noAutofit/>
+          </a:bodyPr>
+          <a:lstStyle/>
+          <a:p>
+            <a:pPr algn="ctr">
+              <a:lnSpc>
+                <a:spcPct val="95000"/>
+              </a:lnSpc>
+              <a:spcBef>
+                <a:spcPts val="0"/>
+              </a:spcBef>
+              <a:spcAft>
+                <a:spcPts val="0"/>
+              </a:spcAft>
+              <a:buNone/>
+            </a:pPr>
+            <a:r>
+              <a:rPr lang="pt-BR" sz="2900" dirty="0">
+                <a:solidFill>
+                  <a:srgbClr val="FFFFFF"/>
+                </a:solidFill>
+                <a:latin typeface="Canva Sans"/>
+                <a:ea typeface="Canva Sans"/>
+                <a:cs typeface="Canva Sans"/>
+                <a:sym typeface="Canva Sans"/>
+              </a:rPr>
+              <a:t>pela atenção e pelas contribuições</a:t>
+            </a:r>
+            <a:endParaRPr lang="pt-BR" sz="2900" dirty="0"/>
+          </a:p>
+        </p:txBody>
+      </p:sp>
+    </p:spTree>
+  </p:cSld>
+  <p:clrMapOvr>
+    <a:masterClrMapping/>
+  </p:clrMapOvr>
+</p:sld>
+</file>
+
+<file path=ppt/slides/slide41.xml><?xml version="1.0" encoding="utf-8"?>
+<p:sld xmlns:p="http://schemas.openxmlformats.org/presentationml/2006/main" xmlns:a="http://schemas.openxmlformats.org/drawingml/2006/main" xmlns:r="http://schemas.openxmlformats.org/officeDocument/2006/relationships">
+  <p:cSld>
+    <p:spTree>
+      <p:nvGrpSpPr>
+        <p:cNvPr id="1" name=""/>
+        <p:cNvGrpSpPr/>
+        <p:nvPr/>
+      </p:nvGrpSpPr>
+      <p:grpSpPr>
+        <a:xfrm>
+          <a:off x="0" y="0"/>
+          <a:ext cx="0" cy="0"/>
+          <a:chOff x="0" y="0"/>
+          <a:chExt cx="0" cy="0"/>
+        </a:xfrm>
+      </p:grpSpPr>
+      <p:sp>
+        <p:nvSpPr>
+          <p:cNvPr name="Freeform 2" id="2"/>
+          <p:cNvSpPr/>
+          <p:nvPr/>
+        </p:nvSpPr>
+        <p:spPr>
+          <a:xfrm flipH="false" flipV="false" rot="0">
+            <a:off x="0" y="0"/>
+            <a:ext cx="18288000" cy="10287000"/>
+          </a:xfrm>
+          <a:custGeom>
+            <a:avLst/>
+            <a:gdLst/>
+            <a:ahLst/>
+            <a:cxnLst/>
+            <a:rect r="r" b="b" t="t" l="l"/>
+            <a:pathLst>
+              <a:path h="10287000" w="18288000">
+                <a:moveTo>
+                  <a:pt x="0" y="0"/>
+                </a:moveTo>
+                <a:lnTo>
+                  <a:pt x="18288000" y="0"/>
+                </a:lnTo>
+                <a:lnTo>
+                  <a:pt x="18288000" y="10287000"/>
+                </a:lnTo>
+                <a:lnTo>
+                  <a:pt x="0" y="10287000"/>
+                </a:lnTo>
+                <a:lnTo>
+                  <a:pt x="0" y="0"/>
+                </a:lnTo>
+                <a:close/>
+              </a:path>
+            </a:pathLst>
+          </a:custGeom>
+          <a:blipFill>
+            <a:blip r:embed="rId2"/>
+            <a:stretch>
+              <a:fillRect l="0" t="-108024" r="0" b="-108024"/>
+            </a:stretch>
+          </a:blipFill>
+        </p:spPr>
+      </p:sp>
+      <p:sp>
+        <p:nvSpPr>
           <p:cNvPr id="201" name="Título 201"/>
           <p:cNvSpPr txBox="1"/>
           <p:nvPr/>
@@ -28656,7 +29577,7 @@
 </p:sld>
 </file>
 
-<file path=ppt/slides/slide41.xml><?xml version="1.0" encoding="utf-8"?>
+<file path=ppt/slides/slide42.xml><?xml version="1.0" encoding="utf-8"?>
 <p:sld xmlns:p="http://schemas.openxmlformats.org/presentationml/2006/main" xmlns:a="http://schemas.openxmlformats.org/drawingml/2006/main" xmlns:r="http://schemas.openxmlformats.org/officeDocument/2006/relationships">
   <p:cSld>
     <p:spTree>

</xml_diff>

<commit_message>
Inclui a cultura digital e o contexto das tecnologias no slide de conceitos e teóricos
Co-Authored-By: Claude Opus 5.5 <noreply@anthropic.com>
Claude-Session: https://claude.ai/code/session_01HxStpW4pQoDfJdTDYr6zEC
</commit_message>
<xml_diff>
--- a/apresentacao_qualificacao/Qualificacao_PNED_Pipa.pptx
+++ b/apresentacao_qualificacao/Qualificacao_PNED_Pipa.pptx
@@ -15417,7 +15417,7 @@
         <p:spPr>
           <a:xfrm>
             <a:off x="612000" y="2232000"/>
-            <a:ext cx="4104000" cy="6408000"/>
+            <a:ext cx="3290400" cy="6408000"/>
           </a:xfrm>
           <a:prstGeom prst="roundRect">
             <a:avLst>
@@ -15447,12 +15447,12 @@
                 <a:spcPts val="0"/>
               </a:spcBef>
               <a:spcAft>
-                <a:spcPts val="1739"/>
-              </a:spcAft>
-              <a:buNone/>
-            </a:pPr>
-            <a:r>
-              <a:rPr lang="pt-BR" sz="2610" b="1" dirty="0">
+                <a:spcPts val="1450"/>
+              </a:spcAft>
+              <a:buNone/>
+            </a:pPr>
+            <a:r>
+              <a:rPr lang="pt-BR" sz="2248" b="1" dirty="0">
                 <a:solidFill>
                   <a:srgbClr val="111111"/>
                 </a:solidFill>
@@ -15463,7 +15463,7 @@
               </a:rPr>
               <a:t>A POLÍTICA</a:t>
             </a:r>
-            <a:endParaRPr lang="pt-BR" sz="2610" dirty="0"/>
+            <a:endParaRPr lang="pt-BR" sz="2248" dirty="0"/>
           </a:p>
           <a:p>
             <a:pPr algn="l">
@@ -15479,7 +15479,7 @@
               <a:buNone/>
             </a:pPr>
             <a:r>
-              <a:rPr lang="pt-BR" sz="2175" b="1" dirty="0">
+              <a:rPr lang="pt-BR" sz="1958" b="1" dirty="0">
                 <a:solidFill>
                   <a:srgbClr val="111111"/>
                 </a:solidFill>
@@ -15490,7 +15490,7 @@
               </a:rPr>
               <a:t>Ciclo de políticas: influência, produção do texto, prática</a:t>
             </a:r>
-            <a:endParaRPr lang="pt-BR" sz="2175" dirty="0"/>
+            <a:endParaRPr lang="pt-BR" sz="1958" dirty="0"/>
           </a:p>
           <a:p>
             <a:pPr algn="l">
@@ -15501,12 +15501,12 @@
                 <a:spcPts val="0"/>
               </a:spcBef>
               <a:spcAft>
-                <a:spcPts val="1739"/>
-              </a:spcAft>
-              <a:buNone/>
-            </a:pPr>
-            <a:r>
-              <a:rPr lang="pt-BR" sz="1958" dirty="0">
+                <a:spcPts val="1450"/>
+              </a:spcAft>
+              <a:buNone/>
+            </a:pPr>
+            <a:r>
+              <a:rPr lang="pt-BR" sz="1812" dirty="0">
                 <a:solidFill>
                   <a:srgbClr val="111111"/>
                 </a:solidFill>
@@ -15517,7 +15517,7 @@
               </a:rPr>
               <a:t>Bowe, Ball e Gold (1992); Mainardes (2006)</a:t>
             </a:r>
-            <a:endParaRPr lang="pt-BR" sz="1958" dirty="0"/>
+            <a:endParaRPr lang="pt-BR" sz="1812" dirty="0"/>
           </a:p>
           <a:p>
             <a:pPr algn="l">
@@ -15533,7 +15533,7 @@
               <a:buNone/>
             </a:pPr>
             <a:r>
-              <a:rPr lang="pt-BR" sz="2175" b="1" dirty="0">
+              <a:rPr lang="pt-BR" sz="1958" b="1" dirty="0">
                 <a:solidFill>
                   <a:srgbClr val="111111"/>
                 </a:solidFill>
@@ -15544,7 +15544,7 @@
               </a:rPr>
               <a:t>Atuação (encenação): interpretar e traduzir</a:t>
             </a:r>
-            <a:endParaRPr lang="pt-BR" sz="2175" dirty="0"/>
+            <a:endParaRPr lang="pt-BR" sz="1958" dirty="0"/>
           </a:p>
           <a:p>
             <a:pPr algn="l">
@@ -15555,12 +15555,12 @@
                 <a:spcPts val="0"/>
               </a:spcBef>
               <a:spcAft>
-                <a:spcPts val="1739"/>
-              </a:spcAft>
-              <a:buNone/>
-            </a:pPr>
-            <a:r>
-              <a:rPr lang="pt-BR" sz="1958" dirty="0">
+                <a:spcPts val="1450"/>
+              </a:spcAft>
+              <a:buNone/>
+            </a:pPr>
+            <a:r>
+              <a:rPr lang="pt-BR" sz="1812" dirty="0">
                 <a:solidFill>
                   <a:srgbClr val="111111"/>
                 </a:solidFill>
@@ -15571,7 +15571,7 @@
               </a:rPr>
               <a:t>Ball, Maguire e Braun (2016)</a:t>
             </a:r>
-            <a:endParaRPr lang="pt-BR" sz="1958" dirty="0"/>
+            <a:endParaRPr lang="pt-BR" sz="1812" dirty="0"/>
           </a:p>
           <a:p>
             <a:pPr algn="l">
@@ -15587,7 +15587,7 @@
               <a:buNone/>
             </a:pPr>
             <a:r>
-              <a:rPr lang="pt-BR" sz="2175" b="1" dirty="0">
+              <a:rPr lang="pt-BR" sz="1958" b="1" dirty="0">
                 <a:solidFill>
                   <a:srgbClr val="111111"/>
                 </a:solidFill>
@@ -15598,7 +15598,7 @@
               </a:rPr>
               <a:t>Recontextualização: a política "recriada" na prática</a:t>
             </a:r>
-            <a:endParaRPr lang="pt-BR" sz="2175" dirty="0"/>
+            <a:endParaRPr lang="pt-BR" sz="1958" dirty="0"/>
           </a:p>
           <a:p>
             <a:pPr algn="l">
@@ -15609,12 +15609,12 @@
                 <a:spcPts val="0"/>
               </a:spcBef>
               <a:spcAft>
-                <a:spcPts val="1739"/>
-              </a:spcAft>
-              <a:buNone/>
-            </a:pPr>
-            <a:r>
-              <a:rPr lang="pt-BR" sz="1958" dirty="0">
+                <a:spcPts val="1450"/>
+              </a:spcAft>
+              <a:buNone/>
+            </a:pPr>
+            <a:r>
+              <a:rPr lang="pt-BR" sz="1812" dirty="0">
                 <a:solidFill>
                   <a:srgbClr val="111111"/>
                 </a:solidFill>
@@ -15625,7 +15625,7 @@
               </a:rPr>
               <a:t>Bowe, Ball e Gold (1992, p. 22)</a:t>
             </a:r>
-            <a:endParaRPr lang="pt-BR" sz="1958" dirty="0"/>
+            <a:endParaRPr lang="pt-BR" sz="1812" dirty="0"/>
           </a:p>
         </p:txBody>
       </p:sp>
@@ -15637,8 +15637,8 @@
         </p:nvSpPr>
         <p:spPr>
           <a:xfrm>
-            <a:off x="4914000" y="2232000"/>
-            <a:ext cx="4104000" cy="6408000"/>
+            <a:off x="4053600" y="2232000"/>
+            <a:ext cx="3290400" cy="6408000"/>
           </a:xfrm>
           <a:prstGeom prst="roundRect">
             <a:avLst>
@@ -15668,12 +15668,12 @@
                 <a:spcPts val="0"/>
               </a:spcBef>
               <a:spcAft>
-                <a:spcPts val="1739"/>
-              </a:spcAft>
-              <a:buNone/>
-            </a:pPr>
-            <a:r>
-              <a:rPr lang="pt-BR" sz="2610" b="1" dirty="0">
+                <a:spcPts val="1450"/>
+              </a:spcAft>
+              <a:buNone/>
+            </a:pPr>
+            <a:r>
+              <a:rPr lang="pt-BR" sz="2248" b="1" dirty="0">
                 <a:solidFill>
                   <a:srgbClr val="111111"/>
                 </a:solidFill>
@@ -15684,7 +15684,7 @@
               </a:rPr>
               <a:t>OS PROFISSIONAIS</a:t>
             </a:r>
-            <a:endParaRPr lang="pt-BR" sz="2610" dirty="0"/>
+            <a:endParaRPr lang="pt-BR" sz="2248" dirty="0"/>
           </a:p>
           <a:p>
             <a:pPr algn="l">
@@ -15700,7 +15700,7 @@
               <a:buNone/>
             </a:pPr>
             <a:r>
-              <a:rPr lang="pt-BR" sz="2175" b="1" dirty="0">
+              <a:rPr lang="pt-BR" sz="1958" b="1" dirty="0">
                 <a:solidFill>
                   <a:srgbClr val="111111"/>
                 </a:solidFill>
@@ -15711,7 +15711,7 @@
               </a:rPr>
               <a:t>Culturas profissionais</a:t>
             </a:r>
-            <a:endParaRPr lang="pt-BR" sz="2175" dirty="0"/>
+            <a:endParaRPr lang="pt-BR" sz="1958" dirty="0"/>
           </a:p>
           <a:p>
             <a:pPr algn="l">
@@ -15722,12 +15722,12 @@
                 <a:spcPts val="0"/>
               </a:spcBef>
               <a:spcAft>
-                <a:spcPts val="1739"/>
-              </a:spcAft>
-              <a:buNone/>
-            </a:pPr>
-            <a:r>
-              <a:rPr lang="pt-BR" sz="1958" dirty="0">
+                <a:spcPts val="1450"/>
+              </a:spcAft>
+              <a:buNone/>
+            </a:pPr>
+            <a:r>
+              <a:rPr lang="pt-BR" sz="1812" dirty="0">
                 <a:solidFill>
                   <a:srgbClr val="111111"/>
                 </a:solidFill>
@@ -15738,7 +15738,7 @@
               </a:rPr>
               <a:t>Hargreaves (2005)</a:t>
             </a:r>
-            <a:endParaRPr lang="pt-BR" sz="1958" dirty="0"/>
+            <a:endParaRPr lang="pt-BR" sz="1812" dirty="0"/>
           </a:p>
           <a:p>
             <a:pPr algn="l">
@@ -15754,7 +15754,7 @@
               <a:buNone/>
             </a:pPr>
             <a:r>
-              <a:rPr lang="pt-BR" sz="2175" b="1" dirty="0">
+              <a:rPr lang="pt-BR" sz="1958" b="1" dirty="0">
                 <a:solidFill>
                   <a:srgbClr val="111111"/>
                 </a:solidFill>
@@ -15765,7 +15765,7 @@
               </a:rPr>
               <a:t>Performatividade e fabricação</a:t>
             </a:r>
-            <a:endParaRPr lang="pt-BR" sz="2175" dirty="0"/>
+            <a:endParaRPr lang="pt-BR" sz="1958" dirty="0"/>
           </a:p>
           <a:p>
             <a:pPr algn="l">
@@ -15776,12 +15776,12 @@
                 <a:spcPts val="0"/>
               </a:spcBef>
               <a:spcAft>
-                <a:spcPts val="1739"/>
-              </a:spcAft>
-              <a:buNone/>
-            </a:pPr>
-            <a:r>
-              <a:rPr lang="pt-BR" sz="1958" dirty="0">
+                <a:spcPts val="1450"/>
+              </a:spcAft>
+              <a:buNone/>
+            </a:pPr>
+            <a:r>
+              <a:rPr lang="pt-BR" sz="1812" dirty="0">
                 <a:solidFill>
                   <a:srgbClr val="111111"/>
                 </a:solidFill>
@@ -15792,7 +15792,7 @@
               </a:rPr>
               <a:t>Ball (2002; 2008)</a:t>
             </a:r>
-            <a:endParaRPr lang="pt-BR" sz="1958" dirty="0"/>
+            <a:endParaRPr lang="pt-BR" sz="1812" dirty="0"/>
           </a:p>
           <a:p>
             <a:pPr algn="l">
@@ -15808,7 +15808,7 @@
               <a:buNone/>
             </a:pPr>
             <a:r>
-              <a:rPr lang="pt-BR" sz="2175" b="1" dirty="0">
+              <a:rPr lang="pt-BR" sz="1958" b="1" dirty="0">
                 <a:solidFill>
                   <a:srgbClr val="111111"/>
                 </a:solidFill>
@@ -15819,7 +15819,7 @@
               </a:rPr>
               <a:t>Poder e resistência</a:t>
             </a:r>
-            <a:endParaRPr lang="pt-BR" sz="2175" dirty="0"/>
+            <a:endParaRPr lang="pt-BR" sz="1958" dirty="0"/>
           </a:p>
           <a:p>
             <a:pPr algn="l">
@@ -15830,12 +15830,12 @@
                 <a:spcPts val="0"/>
               </a:spcBef>
               <a:spcAft>
-                <a:spcPts val="1739"/>
-              </a:spcAft>
-              <a:buNone/>
-            </a:pPr>
-            <a:r>
-              <a:rPr lang="pt-BR" sz="1958" dirty="0">
+                <a:spcPts val="1450"/>
+              </a:spcAft>
+              <a:buNone/>
+            </a:pPr>
+            <a:r>
+              <a:rPr lang="pt-BR" sz="1812" dirty="0">
                 <a:solidFill>
                   <a:srgbClr val="111111"/>
                 </a:solidFill>
@@ -15846,7 +15846,7 @@
               </a:rPr>
               <a:t>Foucault (1999); Ball (2011); Freire (2019)</a:t>
             </a:r>
-            <a:endParaRPr lang="pt-BR" sz="1958" dirty="0"/>
+            <a:endParaRPr lang="pt-BR" sz="1812" dirty="0"/>
           </a:p>
           <a:p>
             <a:pPr algn="l">
@@ -15862,7 +15862,7 @@
               <a:buNone/>
             </a:pPr>
             <a:r>
-              <a:rPr lang="pt-BR" sz="2175" b="1" dirty="0">
+              <a:rPr lang="pt-BR" sz="1958" b="1" dirty="0">
                 <a:solidFill>
                   <a:srgbClr val="111111"/>
                 </a:solidFill>
@@ -15873,7 +15873,7 @@
               </a:rPr>
               <a:t>Sentidos que organizam ações</a:t>
             </a:r>
-            <a:endParaRPr lang="pt-BR" sz="2175" dirty="0"/>
+            <a:endParaRPr lang="pt-BR" sz="1958" dirty="0"/>
           </a:p>
           <a:p>
             <a:pPr algn="l">
@@ -15884,12 +15884,12 @@
                 <a:spcPts val="0"/>
               </a:spcBef>
               <a:spcAft>
-                <a:spcPts val="1739"/>
-              </a:spcAft>
-              <a:buNone/>
-            </a:pPr>
-            <a:r>
-              <a:rPr lang="pt-BR" sz="1958" dirty="0">
+                <a:spcPts val="1450"/>
+              </a:spcAft>
+              <a:buNone/>
+            </a:pPr>
+            <a:r>
+              <a:rPr lang="pt-BR" sz="1812" dirty="0">
                 <a:solidFill>
                   <a:srgbClr val="111111"/>
                 </a:solidFill>
@@ -15900,7 +15900,7 @@
               </a:rPr>
               <a:t>Hall (2006)</a:t>
             </a:r>
-            <a:endParaRPr lang="pt-BR" sz="1958" dirty="0"/>
+            <a:endParaRPr lang="pt-BR" sz="1812" dirty="0"/>
           </a:p>
         </p:txBody>
       </p:sp>
@@ -15912,8 +15912,229 @@
         </p:nvSpPr>
         <p:spPr>
           <a:xfrm>
-            <a:off x="9216000" y="2232000"/>
-            <a:ext cx="4104000" cy="6408000"/>
+            <a:off x="7495200" y="2232000"/>
+            <a:ext cx="3290400" cy="6408000"/>
+          </a:xfrm>
+          <a:prstGeom prst="roundRect">
+            <a:avLst>
+              <a:gd name="adj" fmla="val 7000"/>
+            </a:avLst>
+          </a:prstGeom>
+          <a:solidFill>
+            <a:srgbClr val="FFFFFF"/>
+          </a:solidFill>
+          <a:ln w="38100">
+            <a:solidFill>
+              <a:srgbClr val="111111"/>
+            </a:solidFill>
+          </a:ln>
+        </p:spPr>
+        <p:txBody>
+          <a:bodyPr wrap="square" lIns="198000" tIns="198000" rIns="198000" bIns="198000" anchor="t" rtlCol="0">
+            <a:noAutofit/>
+          </a:bodyPr>
+          <a:lstStyle/>
+          <a:p>
+            <a:pPr algn="ctr">
+              <a:lnSpc>
+                <a:spcPct val="100000"/>
+              </a:lnSpc>
+              <a:spcBef>
+                <a:spcPts val="0"/>
+              </a:spcBef>
+              <a:spcAft>
+                <a:spcPts val="1450"/>
+              </a:spcAft>
+              <a:buNone/>
+            </a:pPr>
+            <a:r>
+              <a:rPr lang="pt-BR" sz="2248" b="1" dirty="0">
+                <a:solidFill>
+                  <a:srgbClr val="111111"/>
+                </a:solidFill>
+                <a:latin typeface="Canva Sans Bold"/>
+                <a:ea typeface="Canva Sans Bold"/>
+                <a:cs typeface="Canva Sans Bold"/>
+                <a:sym typeface="Canva Sans Bold"/>
+              </a:rPr>
+              <a:t>O TERRITÓRIO</a:t>
+            </a:r>
+            <a:endParaRPr lang="pt-BR" sz="2248" dirty="0"/>
+          </a:p>
+          <a:p>
+            <a:pPr algn="l">
+              <a:lnSpc>
+                <a:spcPct val="95000"/>
+              </a:lnSpc>
+              <a:spcBef>
+                <a:spcPts val="0"/>
+              </a:spcBef>
+              <a:spcAft>
+                <a:spcPts val="290"/>
+              </a:spcAft>
+              <a:buNone/>
+            </a:pPr>
+            <a:r>
+              <a:rPr lang="pt-BR" sz="1958" b="1" dirty="0">
+                <a:solidFill>
+                  <a:srgbClr val="111111"/>
+                </a:solidFill>
+                <a:latin typeface="Canva Sans Bold"/>
+                <a:ea typeface="Canva Sans Bold"/>
+                <a:cs typeface="Canva Sans Bold"/>
+                <a:sym typeface="Canva Sans Bold"/>
+              </a:rPr>
+              <a:t>Território usado e rugosidades</a:t>
+            </a:r>
+            <a:endParaRPr lang="pt-BR" sz="1958" dirty="0"/>
+          </a:p>
+          <a:p>
+            <a:pPr algn="l">
+              <a:lnSpc>
+                <a:spcPct val="95000"/>
+              </a:lnSpc>
+              <a:spcBef>
+                <a:spcPts val="0"/>
+              </a:spcBef>
+              <a:spcAft>
+                <a:spcPts val="1450"/>
+              </a:spcAft>
+              <a:buNone/>
+            </a:pPr>
+            <a:r>
+              <a:rPr lang="pt-BR" sz="1812" dirty="0">
+                <a:solidFill>
+                  <a:srgbClr val="111111"/>
+                </a:solidFill>
+                <a:latin typeface="Canva Sans"/>
+                <a:ea typeface="Canva Sans"/>
+                <a:cs typeface="Canva Sans"/>
+                <a:sym typeface="Canva Sans"/>
+              </a:rPr>
+              <a:t>Santos (1999; 2006; 2012)</a:t>
+            </a:r>
+            <a:endParaRPr lang="pt-BR" sz="1812" dirty="0"/>
+          </a:p>
+          <a:p>
+            <a:pPr algn="l">
+              <a:lnSpc>
+                <a:spcPct val="95000"/>
+              </a:lnSpc>
+              <a:spcBef>
+                <a:spcPts val="0"/>
+              </a:spcBef>
+              <a:spcAft>
+                <a:spcPts val="290"/>
+              </a:spcAft>
+              <a:buNone/>
+            </a:pPr>
+            <a:r>
+              <a:rPr lang="pt-BR" sz="1958" b="1" dirty="0">
+                <a:solidFill>
+                  <a:srgbClr val="111111"/>
+                </a:solidFill>
+                <a:latin typeface="Canva Sans Bold"/>
+                <a:ea typeface="Canva Sans Bold"/>
+                <a:cs typeface="Canva Sans Bold"/>
+                <a:sym typeface="Canva Sans Bold"/>
+              </a:rPr>
+              <a:t>Lugar como encontro de trajetórias</a:t>
+            </a:r>
+            <a:endParaRPr lang="pt-BR" sz="1958" dirty="0"/>
+          </a:p>
+          <a:p>
+            <a:pPr algn="l">
+              <a:lnSpc>
+                <a:spcPct val="95000"/>
+              </a:lnSpc>
+              <a:spcBef>
+                <a:spcPts val="0"/>
+              </a:spcBef>
+              <a:spcAft>
+                <a:spcPts val="1450"/>
+              </a:spcAft>
+              <a:buNone/>
+            </a:pPr>
+            <a:r>
+              <a:rPr lang="pt-BR" sz="1812" dirty="0">
+                <a:solidFill>
+                  <a:srgbClr val="111111"/>
+                </a:solidFill>
+                <a:latin typeface="Canva Sans"/>
+                <a:ea typeface="Canva Sans"/>
+                <a:cs typeface="Canva Sans"/>
+                <a:sym typeface="Canva Sans"/>
+              </a:rPr>
+              <a:t>Massey (2008)</a:t>
+            </a:r>
+            <a:endParaRPr lang="pt-BR" sz="1812" dirty="0"/>
+          </a:p>
+          <a:p>
+            <a:pPr algn="l">
+              <a:lnSpc>
+                <a:spcPct val="95000"/>
+              </a:lnSpc>
+              <a:spcBef>
+                <a:spcPts val="0"/>
+              </a:spcBef>
+              <a:spcAft>
+                <a:spcPts val="290"/>
+              </a:spcAft>
+              <a:buNone/>
+            </a:pPr>
+            <a:r>
+              <a:rPr lang="pt-BR" sz="1958" b="1" dirty="0">
+                <a:solidFill>
+                  <a:srgbClr val="111111"/>
+                </a:solidFill>
+                <a:latin typeface="Canva Sans Bold"/>
+                <a:ea typeface="Canva Sans Bold"/>
+                <a:cs typeface="Canva Sans Bold"/>
+                <a:sym typeface="Canva Sans Bold"/>
+              </a:rPr>
+              <a:t>Habitar e Educação OnLIFE</a:t>
+            </a:r>
+            <a:endParaRPr lang="pt-BR" sz="1958" dirty="0"/>
+          </a:p>
+          <a:p>
+            <a:pPr algn="l">
+              <a:lnSpc>
+                <a:spcPct val="95000"/>
+              </a:lnSpc>
+              <a:spcBef>
+                <a:spcPts val="0"/>
+              </a:spcBef>
+              <a:spcAft>
+                <a:spcPts val="1450"/>
+              </a:spcAft>
+              <a:buNone/>
+            </a:pPr>
+            <a:r>
+              <a:rPr lang="pt-BR" sz="1812" dirty="0">
+                <a:solidFill>
+                  <a:srgbClr val="111111"/>
+                </a:solidFill>
+                <a:latin typeface="Canva Sans"/>
+                <a:ea typeface="Canva Sans"/>
+                <a:cs typeface="Canva Sans"/>
+                <a:sym typeface="Canva Sans"/>
+              </a:rPr>
+              <a:t>Schlemmer, Backes e Palagi (2021); Di Felice (2009)</a:t>
+            </a:r>
+            <a:endParaRPr lang="pt-BR" sz="1812" dirty="0"/>
+          </a:p>
+        </p:txBody>
+      </p:sp>
+      <p:sp>
+        <p:nvSpPr>
+          <p:cNvPr id="205" name="Cartão 205"/>
+          <p:cNvSpPr/>
+          <p:nvPr/>
+        </p:nvSpPr>
+        <p:spPr>
+          <a:xfrm>
+            <a:off x="10936800" y="2232000"/>
+            <a:ext cx="3290400" cy="6408000"/>
           </a:xfrm>
           <a:prstGeom prst="roundRect">
             <a:avLst>
@@ -15943,12 +16164,12 @@
                 <a:spcPts val="0"/>
               </a:spcBef>
               <a:spcAft>
-                <a:spcPts val="1739"/>
-              </a:spcAft>
-              <a:buNone/>
-            </a:pPr>
-            <a:r>
-              <a:rPr lang="pt-BR" sz="2610" b="1" dirty="0">
+                <a:spcPts val="1450"/>
+              </a:spcAft>
+              <a:buNone/>
+            </a:pPr>
+            <a:r>
+              <a:rPr lang="pt-BR" sz="2248" b="1" dirty="0">
                 <a:solidFill>
                   <a:srgbClr val="111111"/>
                 </a:solidFill>
@@ -15957,9 +16178,9 @@
                 <a:cs typeface="Canva Sans Bold"/>
                 <a:sym typeface="Canva Sans Bold"/>
               </a:rPr>
-              <a:t>O TERRITÓRIO</a:t>
-            </a:r>
-            <a:endParaRPr lang="pt-BR" sz="2610" dirty="0"/>
+              <a:t>A CULTURA DIGITAL</a:t>
+            </a:r>
+            <a:endParaRPr lang="pt-BR" sz="2248" dirty="0"/>
           </a:p>
           <a:p>
             <a:pPr algn="l">
@@ -15975,7 +16196,7 @@
               <a:buNone/>
             </a:pPr>
             <a:r>
-              <a:rPr lang="pt-BR" sz="2175" b="1" dirty="0">
+              <a:rPr lang="pt-BR" sz="1958" b="1" dirty="0">
                 <a:solidFill>
                   <a:srgbClr val="111111"/>
                 </a:solidFill>
@@ -15984,9 +16205,9 @@
                 <a:cs typeface="Canva Sans Bold"/>
                 <a:sym typeface="Canva Sans Bold"/>
               </a:rPr>
-              <a:t>Território usado e rugosidades</a:t>
-            </a:r>
-            <a:endParaRPr lang="pt-BR" sz="2175" dirty="0"/>
+              <a:t>Participação consciente e democrática</a:t>
+            </a:r>
+            <a:endParaRPr lang="pt-BR" sz="1958" dirty="0"/>
           </a:p>
           <a:p>
             <a:pPr algn="l">
@@ -15997,12 +16218,12 @@
                 <a:spcPts val="0"/>
               </a:spcBef>
               <a:spcAft>
-                <a:spcPts val="1739"/>
-              </a:spcAft>
-              <a:buNone/>
-            </a:pPr>
-            <a:r>
-              <a:rPr lang="pt-BR" sz="1958" dirty="0">
+                <a:spcPts val="1450"/>
+              </a:spcAft>
+              <a:buNone/>
+            </a:pPr>
+            <a:r>
+              <a:rPr lang="pt-BR" sz="1812" dirty="0">
                 <a:solidFill>
                   <a:srgbClr val="111111"/>
                 </a:solidFill>
@@ -16011,9 +16232,9 @@
                 <a:cs typeface="Canva Sans"/>
                 <a:sym typeface="Canva Sans"/>
               </a:rPr>
-              <a:t>Santos (1999; 2006; 2012)</a:t>
-            </a:r>
-            <a:endParaRPr lang="pt-BR" sz="1958" dirty="0"/>
+              <a:t>BRASIL (2023, art. 3º, III); BNCC, competência 5 (BRASIL, 2018)</a:t>
+            </a:r>
+            <a:endParaRPr lang="pt-BR" sz="1812" dirty="0"/>
           </a:p>
           <a:p>
             <a:pPr algn="l">
@@ -16029,7 +16250,7 @@
               <a:buNone/>
             </a:pPr>
             <a:r>
-              <a:rPr lang="pt-BR" sz="2175" b="1" dirty="0">
+              <a:rPr lang="pt-BR" sz="1958" b="1" dirty="0">
                 <a:solidFill>
                   <a:srgbClr val="111111"/>
                 </a:solidFill>
@@ -16038,9 +16259,9 @@
                 <a:cs typeface="Canva Sans Bold"/>
                 <a:sym typeface="Canva Sans Bold"/>
               </a:rPr>
-              <a:t>Lugar como encontro de trajetórias</a:t>
-            </a:r>
-            <a:endParaRPr lang="pt-BR" sz="2175" dirty="0"/>
+              <a:t>Capitalismo de vigilância e dados</a:t>
+            </a:r>
+            <a:endParaRPr lang="pt-BR" sz="1958" dirty="0"/>
           </a:p>
           <a:p>
             <a:pPr algn="l">
@@ -16051,12 +16272,12 @@
                 <a:spcPts val="0"/>
               </a:spcBef>
               <a:spcAft>
-                <a:spcPts val="1739"/>
-              </a:spcAft>
-              <a:buNone/>
-            </a:pPr>
-            <a:r>
-              <a:rPr lang="pt-BR" sz="1958" dirty="0">
+                <a:spcPts val="1450"/>
+              </a:spcAft>
+              <a:buNone/>
+            </a:pPr>
+            <a:r>
+              <a:rPr lang="pt-BR" sz="1812" dirty="0">
                 <a:solidFill>
                   <a:srgbClr val="111111"/>
                 </a:solidFill>
@@ -16065,9 +16286,9 @@
                 <a:cs typeface="Canva Sans"/>
                 <a:sym typeface="Canva Sans"/>
               </a:rPr>
-              <a:t>Massey (2008)</a:t>
-            </a:r>
-            <a:endParaRPr lang="pt-BR" sz="1958" dirty="0"/>
+              <a:t>Zuboff (2021); Silveira (2017)</a:t>
+            </a:r>
+            <a:endParaRPr lang="pt-BR" sz="1812" dirty="0"/>
           </a:p>
           <a:p>
             <a:pPr algn="l">
@@ -16083,7 +16304,7 @@
               <a:buNone/>
             </a:pPr>
             <a:r>
-              <a:rPr lang="pt-BR" sz="2175" b="1" dirty="0">
+              <a:rPr lang="pt-BR" sz="1958" b="1" dirty="0">
                 <a:solidFill>
                   <a:srgbClr val="111111"/>
                 </a:solidFill>
@@ -16092,9 +16313,9 @@
                 <a:cs typeface="Canva Sans Bold"/>
                 <a:sym typeface="Canva Sans Bold"/>
               </a:rPr>
-              <a:t>Habitar e Educação OnLIFE</a:t>
-            </a:r>
-            <a:endParaRPr lang="pt-BR" sz="2175" dirty="0"/>
+              <a:t>Solucionismo</a:t>
+            </a:r>
+            <a:endParaRPr lang="pt-BR" sz="1958" dirty="0"/>
           </a:p>
           <a:p>
             <a:pPr algn="l">
@@ -16105,12 +16326,12 @@
                 <a:spcPts val="0"/>
               </a:spcBef>
               <a:spcAft>
-                <a:spcPts val="1739"/>
-              </a:spcAft>
-              <a:buNone/>
-            </a:pPr>
-            <a:r>
-              <a:rPr lang="pt-BR" sz="1958" dirty="0">
+                <a:spcPts val="1450"/>
+              </a:spcAft>
+              <a:buNone/>
+            </a:pPr>
+            <a:r>
+              <a:rPr lang="pt-BR" sz="1812" dirty="0">
                 <a:solidFill>
                   <a:srgbClr val="111111"/>
                 </a:solidFill>
@@ -16119,22 +16340,76 @@
                 <a:cs typeface="Canva Sans"/>
                 <a:sym typeface="Canva Sans"/>
               </a:rPr>
-              <a:t>Schlemmer, Backes e Palagi (2021); Di Felice (2009)</a:t>
+              <a:t>Morozov (2018)</a:t>
+            </a:r>
+            <a:endParaRPr lang="pt-BR" sz="1812" dirty="0"/>
+          </a:p>
+          <a:p>
+            <a:pPr algn="l">
+              <a:lnSpc>
+                <a:spcPct val="95000"/>
+              </a:lnSpc>
+              <a:spcBef>
+                <a:spcPts val="0"/>
+              </a:spcBef>
+              <a:spcAft>
+                <a:spcPts val="290"/>
+              </a:spcAft>
+              <a:buNone/>
+            </a:pPr>
+            <a:r>
+              <a:rPr lang="pt-BR" sz="1958" b="1" dirty="0">
+                <a:solidFill>
+                  <a:srgbClr val="111111"/>
+                </a:solidFill>
+                <a:latin typeface="Canva Sans Bold"/>
+                <a:ea typeface="Canva Sans Bold"/>
+                <a:cs typeface="Canva Sans Bold"/>
+                <a:sym typeface="Canva Sans Bold"/>
+              </a:rPr>
+              <a:t>Sujeitos produtores de cultura</a:t>
             </a:r>
             <a:endParaRPr lang="pt-BR" sz="1958" dirty="0"/>
           </a:p>
+          <a:p>
+            <a:pPr algn="l">
+              <a:lnSpc>
+                <a:spcPct val="95000"/>
+              </a:lnSpc>
+              <a:spcBef>
+                <a:spcPts val="0"/>
+              </a:spcBef>
+              <a:spcAft>
+                <a:spcPts val="1450"/>
+              </a:spcAft>
+              <a:buNone/>
+            </a:pPr>
+            <a:r>
+              <a:rPr lang="pt-BR" sz="1812" dirty="0">
+                <a:solidFill>
+                  <a:srgbClr val="111111"/>
+                </a:solidFill>
+                <a:latin typeface="Canva Sans"/>
+                <a:ea typeface="Canva Sans"/>
+                <a:cs typeface="Canva Sans"/>
+                <a:sym typeface="Canva Sans"/>
+              </a:rPr>
+              <a:t>Pretto, Cordeiro e Oliveira (2013)</a:t>
+            </a:r>
+            <a:endParaRPr lang="pt-BR" sz="1812" dirty="0"/>
+          </a:p>
         </p:txBody>
       </p:sp>
       <p:sp>
         <p:nvSpPr>
-          <p:cNvPr id="205" name="Cartão 205"/>
+          <p:cNvPr id="206" name="Cartão 206"/>
           <p:cNvSpPr/>
           <p:nvPr/>
         </p:nvSpPr>
         <p:spPr>
           <a:xfrm>
-            <a:off x="13518000" y="2232000"/>
-            <a:ext cx="4104000" cy="6408000"/>
+            <a:off x="14378400" y="2232000"/>
+            <a:ext cx="3290400" cy="6408000"/>
           </a:xfrm>
           <a:prstGeom prst="roundRect">
             <a:avLst>
@@ -16142,7 +16417,7 @@
             </a:avLst>
           </a:prstGeom>
           <a:solidFill>
-            <a:srgbClr val="FFFFFF"/>
+            <a:srgbClr val="FFCE32"/>
           </a:solidFill>
           <a:ln w="38100">
             <a:solidFill>
@@ -16164,12 +16439,12 @@
                 <a:spcPts val="0"/>
               </a:spcBef>
               <a:spcAft>
-                <a:spcPts val="1739"/>
-              </a:spcAft>
-              <a:buNone/>
-            </a:pPr>
-            <a:r>
-              <a:rPr lang="pt-BR" sz="2610" b="1" dirty="0">
+                <a:spcPts val="1450"/>
+              </a:spcAft>
+              <a:buNone/>
+            </a:pPr>
+            <a:r>
+              <a:rPr lang="pt-BR" sz="2248" b="1" dirty="0">
                 <a:solidFill>
                   <a:srgbClr val="111111"/>
                 </a:solidFill>
@@ -16180,7 +16455,7 @@
               </a:rPr>
               <a:t>AS CRIANÇAS</a:t>
             </a:r>
-            <a:endParaRPr lang="pt-BR" sz="2610" dirty="0"/>
+            <a:endParaRPr lang="pt-BR" sz="2248" dirty="0"/>
           </a:p>
           <a:p>
             <a:pPr algn="l">
@@ -16196,7 +16471,7 @@
               <a:buNone/>
             </a:pPr>
             <a:r>
-              <a:rPr lang="pt-BR" sz="2175" b="1" dirty="0">
+              <a:rPr lang="pt-BR" sz="1958" b="1" dirty="0">
                 <a:solidFill>
                   <a:srgbClr val="111111"/>
                 </a:solidFill>
@@ -16207,7 +16482,7 @@
               </a:rPr>
               <a:t>Provisão, proteção e participação no ambiente digital</a:t>
             </a:r>
-            <a:endParaRPr lang="pt-BR" sz="2175" dirty="0"/>
+            <a:endParaRPr lang="pt-BR" sz="1958" dirty="0"/>
           </a:p>
           <a:p>
             <a:pPr algn="l">
@@ -16218,12 +16493,12 @@
                 <a:spcPts val="0"/>
               </a:spcBef>
               <a:spcAft>
-                <a:spcPts val="1739"/>
-              </a:spcAft>
-              <a:buNone/>
-            </a:pPr>
-            <a:r>
-              <a:rPr lang="pt-BR" sz="1958" dirty="0">
+                <a:spcPts val="1450"/>
+              </a:spcAft>
+              <a:buNone/>
+            </a:pPr>
+            <a:r>
+              <a:rPr lang="pt-BR" sz="1812" dirty="0">
                 <a:solidFill>
                   <a:srgbClr val="111111"/>
                 </a:solidFill>
@@ -16234,7 +16509,7 @@
               </a:rPr>
               <a:t>ONU (2021), Comentário Geral nº 25</a:t>
             </a:r>
-            <a:endParaRPr lang="pt-BR" sz="1958" dirty="0"/>
+            <a:endParaRPr lang="pt-BR" sz="1812" dirty="0"/>
           </a:p>
           <a:p>
             <a:pPr algn="l">
@@ -16250,7 +16525,7 @@
               <a:buNone/>
             </a:pPr>
             <a:r>
-              <a:rPr lang="pt-BR" sz="2175" b="1" dirty="0">
+              <a:rPr lang="pt-BR" sz="1958" b="1" dirty="0">
                 <a:solidFill>
                   <a:srgbClr val="111111"/>
                 </a:solidFill>
@@ -16261,7 +16536,7 @@
               </a:rPr>
               <a:t>Direitos do eixo: participação e proteção dos dados</a:t>
             </a:r>
-            <a:endParaRPr lang="pt-BR" sz="2175" dirty="0"/>
+            <a:endParaRPr lang="pt-BR" sz="1958" dirty="0"/>
           </a:p>
           <a:p>
             <a:pPr algn="l">
@@ -16272,12 +16547,12 @@
                 <a:spcPts val="0"/>
               </a:spcBef>
               <a:spcAft>
-                <a:spcPts val="1739"/>
-              </a:spcAft>
-              <a:buNone/>
-            </a:pPr>
-            <a:r>
-              <a:rPr lang="pt-BR" sz="1958" dirty="0">
+                <a:spcPts val="1450"/>
+              </a:spcAft>
+              <a:buNone/>
+            </a:pPr>
+            <a:r>
+              <a:rPr lang="pt-BR" sz="1812" dirty="0">
                 <a:solidFill>
                   <a:srgbClr val="111111"/>
                 </a:solidFill>
@@ -16288,13 +16563,13 @@
               </a:rPr>
               <a:t>BRASIL (2023, art. 3º, III e IV)</a:t>
             </a:r>
-            <a:endParaRPr lang="pt-BR" sz="1958" dirty="0"/>
+            <a:endParaRPr lang="pt-BR" sz="1812" dirty="0"/>
           </a:p>
         </p:txBody>
       </p:sp>
       <p:sp>
         <p:nvSpPr>
-          <p:cNvPr id="206" name="Cartão 206"/>
+          <p:cNvPr id="207" name="Cartão 207"/>
           <p:cNvSpPr/>
           <p:nvPr/>
         </p:nvSpPr>
@@ -30174,7 +30449,7 @@
                 <a:cs typeface="Canva Sans"/>
                 <a:sym typeface="Canva Sans"/>
               </a:rPr>
-              <a:t>BRASIL. </a:t>
+              <a:t>BRASIL. Ministério da Educação. </a:t>
             </a:r>
             <a:r>
               <a:rPr lang="pt-BR" sz="1550" b="1" dirty="0">
@@ -30186,7 +30461,7 @@
                 <a:cs typeface="Canva Sans Bold"/>
                 <a:sym typeface="Canva Sans Bold"/>
               </a:rPr>
-              <a:t>Lei nº 14.533, de 11 de janeiro de 2023</a:t>
+              <a:t>Base Nacional Comum Curricular (BNCC)</a:t>
             </a:r>
             <a:r>
               <a:rPr lang="pt-BR" sz="1550" dirty="0">
@@ -30198,7 +30473,7 @@
                 <a:cs typeface="Canva Sans"/>
                 <a:sym typeface="Canva Sans"/>
               </a:rPr>
-              <a:t>. Institui a Política Nacional de Educação Digital. Brasília, DF: Presidência da República, 2023.</a:t>
+              <a:t>. Brasília, DF: MEC, 2018.</a:t>
             </a:r>
             <a:endParaRPr lang="pt-BR" sz="1550" dirty="0"/>
           </a:p>
@@ -30248,7 +30523,7 @@
                 <a:cs typeface="Canva Sans"/>
                 <a:sym typeface="Canva Sans"/>
               </a:rPr>
-              <a:t>BRASIL. Conselho Nacional de Educação. Câmara de Educação Básica. </a:t>
+              <a:t>BRASIL. </a:t>
             </a:r>
             <a:r>
               <a:rPr lang="pt-BR" sz="1550" b="1" dirty="0">
@@ -30260,7 +30535,7 @@
                 <a:cs typeface="Canva Sans Bold"/>
                 <a:sym typeface="Canva Sans Bold"/>
               </a:rPr>
-              <a:t>Resolução CNE/CEB nº 2, de 21 de março de 2025</a:t>
+              <a:t>Lei nº 14.533, de 11 de janeiro de 2023</a:t>
             </a:r>
             <a:r>
               <a:rPr lang="pt-BR" sz="1550" dirty="0">
@@ -30272,7 +30547,7 @@
                 <a:cs typeface="Canva Sans"/>
                 <a:sym typeface="Canva Sans"/>
               </a:rPr>
-              <a:t>. Institui as Diretrizes Operacionais Nacionais sobre o uso de dispositivos digitais em espaços escolares e integração curricular de educação digital e midiática. Brasília, DF: CNE, 2025.</a:t>
+              <a:t>. Institui a Política Nacional de Educação Digital. Brasília, DF: Presidência da República, 2023.</a:t>
             </a:r>
             <a:endParaRPr lang="pt-BR" sz="1550" dirty="0"/>
           </a:p>
@@ -30299,7 +30574,7 @@
                 <a:cs typeface="Canva Sans"/>
                 <a:sym typeface="Canva Sans"/>
               </a:rPr>
-              <a:t>BRAUN, Virginia; CLARKE, Victoria. Using thematic analysis in psychology. </a:t>
+              <a:t>BRASIL. Conselho Nacional de Educação. Câmara de Educação Básica. </a:t>
             </a:r>
             <a:r>
               <a:rPr lang="pt-BR" sz="1550" b="1" dirty="0">
@@ -30311,7 +30586,7 @@
                 <a:cs typeface="Canva Sans Bold"/>
                 <a:sym typeface="Canva Sans Bold"/>
               </a:rPr>
-              <a:t>Qualitative Research in Psychology</a:t>
+              <a:t>Resolução CNE/CEB nº 2, de 21 de março de 2025</a:t>
             </a:r>
             <a:r>
               <a:rPr lang="pt-BR" sz="1550" dirty="0">
@@ -30323,7 +30598,7 @@
                 <a:cs typeface="Canva Sans"/>
                 <a:sym typeface="Canva Sans"/>
               </a:rPr>
-              <a:t>, v. 3, n. 2, p. 77-101, 2006.</a:t>
+              <a:t>. Institui as Diretrizes Operacionais Nacionais sobre o uso de dispositivos digitais em espaços escolares e integração curricular de educação digital e midiática. Brasília, DF: CNE, 2025.</a:t>
             </a:r>
             <a:endParaRPr lang="pt-BR" sz="1550" dirty="0"/>
           </a:p>
@@ -30350,7 +30625,7 @@
                 <a:cs typeface="Canva Sans"/>
                 <a:sym typeface="Canva Sans"/>
               </a:rPr>
-              <a:t>BRAUN, Virginia; CLARKE, Victoria. Reflecting on reflexive thematic analysis. </a:t>
+              <a:t>BRAUN, Virginia; CLARKE, Victoria. Using thematic analysis in psychology. </a:t>
             </a:r>
             <a:r>
               <a:rPr lang="pt-BR" sz="1550" b="1" dirty="0">
@@ -30362,7 +30637,7 @@
                 <a:cs typeface="Canva Sans Bold"/>
                 <a:sym typeface="Canva Sans Bold"/>
               </a:rPr>
-              <a:t>Qualitative Research in Sport, Exercise and Health</a:t>
+              <a:t>Qualitative Research in Psychology</a:t>
             </a:r>
             <a:r>
               <a:rPr lang="pt-BR" sz="1550" dirty="0">
@@ -30374,7 +30649,7 @@
                 <a:cs typeface="Canva Sans"/>
                 <a:sym typeface="Canva Sans"/>
               </a:rPr>
-              <a:t>, v. 11, n. 4, p. 589-597, 2019.</a:t>
+              <a:t>, v. 3, n. 2, p. 77-101, 2006.</a:t>
             </a:r>
             <a:endParaRPr lang="pt-BR" sz="1550" dirty="0"/>
           </a:p>
@@ -30401,7 +30676,7 @@
                 <a:cs typeface="Canva Sans"/>
                 <a:sym typeface="Canva Sans"/>
               </a:rPr>
-              <a:t>DI FELICE, Massimo. </a:t>
+              <a:t>BRAUN, Virginia; CLARKE, Victoria. Reflecting on reflexive thematic analysis. </a:t>
             </a:r>
             <a:r>
               <a:rPr lang="pt-BR" sz="1550" b="1" dirty="0">
@@ -30413,7 +30688,7 @@
                 <a:cs typeface="Canva Sans Bold"/>
                 <a:sym typeface="Canva Sans Bold"/>
               </a:rPr>
-              <a:t>Paisagens pós-urbanas</a:t>
+              <a:t>Qualitative Research in Sport, Exercise and Health</a:t>
             </a:r>
             <a:r>
               <a:rPr lang="pt-BR" sz="1550" dirty="0">
@@ -30425,7 +30700,7 @@
                 <a:cs typeface="Canva Sans"/>
                 <a:sym typeface="Canva Sans"/>
               </a:rPr>
-              <a:t>: o fim da experiência urbana e as formas comunicativas do habitar. São Paulo: Annablume, 2009.</a:t>
+              <a:t>, v. 11, n. 4, p. 589-597, 2019.</a:t>
             </a:r>
             <a:endParaRPr lang="pt-BR" sz="1550" dirty="0"/>
           </a:p>
@@ -30452,7 +30727,7 @@
                 <a:cs typeface="Canva Sans"/>
                 <a:sym typeface="Canva Sans"/>
               </a:rPr>
-              <a:t>FOUCAULT, Michel. </a:t>
+              <a:t>DI FELICE, Massimo. </a:t>
             </a:r>
             <a:r>
               <a:rPr lang="pt-BR" sz="1550" b="1" dirty="0">
@@ -30464,7 +30739,7 @@
                 <a:cs typeface="Canva Sans Bold"/>
                 <a:sym typeface="Canva Sans Bold"/>
               </a:rPr>
-              <a:t>Vigiar e punir</a:t>
+              <a:t>Paisagens pós-urbanas</a:t>
             </a:r>
             <a:r>
               <a:rPr lang="pt-BR" sz="1550" dirty="0">
@@ -30476,7 +30751,7 @@
                 <a:cs typeface="Canva Sans"/>
                 <a:sym typeface="Canva Sans"/>
               </a:rPr>
-              <a:t>: nascimento da prisão. Tradução de Raquel Ramalhete. 20. ed. Petrópolis: Vozes, 1999.</a:t>
+              <a:t>: o fim da experiência urbana e as formas comunicativas do habitar. São Paulo: Annablume, 2009.</a:t>
             </a:r>
             <a:endParaRPr lang="pt-BR" sz="1550" dirty="0"/>
           </a:p>
@@ -30503,7 +30778,7 @@
                 <a:cs typeface="Canva Sans"/>
                 <a:sym typeface="Canva Sans"/>
               </a:rPr>
-              <a:t>FREIRE, Paulo. </a:t>
+              <a:t>FOUCAULT, Michel. </a:t>
             </a:r>
             <a:r>
               <a:rPr lang="pt-BR" sz="1550" b="1" dirty="0">
@@ -30515,7 +30790,7 @@
                 <a:cs typeface="Canva Sans Bold"/>
                 <a:sym typeface="Canva Sans Bold"/>
               </a:rPr>
-              <a:t>Pedagogia da autonomia</a:t>
+              <a:t>Vigiar e punir</a:t>
             </a:r>
             <a:r>
               <a:rPr lang="pt-BR" sz="1550" dirty="0">
@@ -30527,7 +30802,7 @@
                 <a:cs typeface="Canva Sans"/>
                 <a:sym typeface="Canva Sans"/>
               </a:rPr>
-              <a:t>: saberes necessários à prática educativa. 60. ed. Rio de Janeiro: Paz e Terra, 2019.</a:t>
+              <a:t>: nascimento da prisão. Tradução de Raquel Ramalhete. 20. ed. Petrópolis: Vozes, 1999.</a:t>
             </a:r>
             <a:endParaRPr lang="pt-BR" sz="1550" dirty="0"/>
           </a:p>
@@ -30554,7 +30829,7 @@
                 <a:cs typeface="Canva Sans"/>
                 <a:sym typeface="Canva Sans"/>
               </a:rPr>
-              <a:t>FUNDAÇÃO CULTURAL PALMARES. Portaria nº 26, de 6 de junho de 2005. </a:t>
+              <a:t>FREIRE, Paulo. </a:t>
             </a:r>
             <a:r>
               <a:rPr lang="pt-BR" sz="1550" b="1" dirty="0">
@@ -30566,7 +30841,7 @@
                 <a:cs typeface="Canva Sans Bold"/>
                 <a:sym typeface="Canva Sans Bold"/>
               </a:rPr>
-              <a:t>Diário Oficial da União</a:t>
+              <a:t>Pedagogia da autonomia</a:t>
             </a:r>
             <a:r>
               <a:rPr lang="pt-BR" sz="1550" dirty="0">
@@ -30578,7 +30853,7 @@
                 <a:cs typeface="Canva Sans"/>
                 <a:sym typeface="Canva Sans"/>
               </a:rPr>
-              <a:t>: seção 1, Brasília, DF, 8 jun. 2005.</a:t>
+              <a:t>: saberes necessários à prática educativa. 60. ed. Rio de Janeiro: Paz e Terra, 2019.</a:t>
             </a:r>
             <a:endParaRPr lang="pt-BR" sz="1550" dirty="0"/>
           </a:p>
@@ -30605,7 +30880,7 @@
                 <a:cs typeface="Canva Sans"/>
                 <a:sym typeface="Canva Sans"/>
               </a:rPr>
-              <a:t>HARGREAVES, Andy. </a:t>
+              <a:t>FUNDAÇÃO CULTURAL PALMARES. Portaria nº 26, de 6 de junho de 2005. </a:t>
             </a:r>
             <a:r>
               <a:rPr lang="pt-BR" sz="1550" b="1" dirty="0">
@@ -30617,7 +30892,7 @@
                 <a:cs typeface="Canva Sans Bold"/>
                 <a:sym typeface="Canva Sans Bold"/>
               </a:rPr>
-              <a:t>Profesorado, cultura y postmodernidad</a:t>
+              <a:t>Diário Oficial da União</a:t>
             </a:r>
             <a:r>
               <a:rPr lang="pt-BR" sz="1550" dirty="0">
@@ -30629,7 +30904,7 @@
                 <a:cs typeface="Canva Sans"/>
                 <a:sym typeface="Canva Sans"/>
               </a:rPr>
-              <a:t>: cambian los tiempos, cambia el profesorado. 5. ed. Madrid: Morata, 2005.</a:t>
+              <a:t>: seção 1, Brasília, DF, 8 jun. 2005.</a:t>
             </a:r>
             <a:endParaRPr lang="pt-BR" sz="1550" dirty="0"/>
           </a:p>
@@ -30656,7 +30931,7 @@
                 <a:cs typeface="Canva Sans"/>
                 <a:sym typeface="Canva Sans"/>
               </a:rPr>
-              <a:t>IBGE. </a:t>
+              <a:t>HALL, Stuart. </a:t>
             </a:r>
             <a:r>
               <a:rPr lang="pt-BR" sz="1550" b="1" dirty="0">
@@ -30668,7 +30943,7 @@
                 <a:cs typeface="Canva Sans Bold"/>
                 <a:sym typeface="Canva Sans Bold"/>
               </a:rPr>
-              <a:t>Censo Demográfico 2022</a:t>
+              <a:t>A identidade cultural na pós-modernidade</a:t>
             </a:r>
             <a:r>
               <a:rPr lang="pt-BR" sz="1550" dirty="0">
@@ -30680,7 +30955,7 @@
                 <a:cs typeface="Canva Sans"/>
                 <a:sym typeface="Canva Sans"/>
               </a:rPr>
-              <a:t>: população e domicílios: primeiros resultados. Rio de Janeiro: IBGE, 2023.</a:t>
+              <a:t>. 11. ed. Rio de Janeiro: DP&amp;A, 2006.</a:t>
             </a:r>
             <a:endParaRPr lang="pt-BR" sz="1550" dirty="0"/>
           </a:p>
@@ -30707,7 +30982,7 @@
                 <a:cs typeface="Canva Sans"/>
                 <a:sym typeface="Canva Sans"/>
               </a:rPr>
-              <a:t>IBGE. </a:t>
+              <a:t>HARGREAVES, Andy. </a:t>
             </a:r>
             <a:r>
               <a:rPr lang="pt-BR" sz="1550" b="1" dirty="0">
@@ -30719,7 +30994,7 @@
                 <a:cs typeface="Canva Sans Bold"/>
                 <a:sym typeface="Canva Sans Bold"/>
               </a:rPr>
-              <a:t>Cidades@</a:t>
+              <a:t>Profesorado, cultura y postmodernidad</a:t>
             </a:r>
             <a:r>
               <a:rPr lang="pt-BR" sz="1550" dirty="0">
@@ -30731,7 +31006,58 @@
                 <a:cs typeface="Canva Sans"/>
                 <a:sym typeface="Canva Sans"/>
               </a:rPr>
-              <a:t>: Tibau do Sul. Rio de Janeiro: IBGE, 2025. Disponível em: https://cidades.ibge.gov.br/brasil/rn/tibau-do-sul.</a:t>
+              <a:t>: cambian los tiempos, cambia el profesorado. 5. ed. Madrid: Morata, 2005.</a:t>
+            </a:r>
+            <a:endParaRPr lang="pt-BR" sz="1550" dirty="0"/>
+          </a:p>
+          <a:p>
+            <a:pPr algn="l">
+              <a:lnSpc>
+                <a:spcPct val="98000"/>
+              </a:lnSpc>
+              <a:spcBef>
+                <a:spcPts val="0"/>
+              </a:spcBef>
+              <a:spcAft>
+                <a:spcPts val="600"/>
+              </a:spcAft>
+              <a:buNone/>
+            </a:pPr>
+            <a:r>
+              <a:rPr lang="pt-BR" sz="1550" dirty="0">
+                <a:solidFill>
+                  <a:srgbClr val="111111"/>
+                </a:solidFill>
+                <a:latin typeface="Canva Sans"/>
+                <a:ea typeface="Canva Sans"/>
+                <a:cs typeface="Canva Sans"/>
+                <a:sym typeface="Canva Sans"/>
+              </a:rPr>
+              <a:t>IBGE. </a:t>
+            </a:r>
+            <a:r>
+              <a:rPr lang="pt-BR" sz="1550" b="1" dirty="0">
+                <a:solidFill>
+                  <a:srgbClr val="111111"/>
+                </a:solidFill>
+                <a:latin typeface="Canva Sans Bold"/>
+                <a:ea typeface="Canva Sans Bold"/>
+                <a:cs typeface="Canva Sans Bold"/>
+                <a:sym typeface="Canva Sans Bold"/>
+              </a:rPr>
+              <a:t>Censo Demográfico 2022</a:t>
+            </a:r>
+            <a:r>
+              <a:rPr lang="pt-BR" sz="1550" dirty="0">
+                <a:solidFill>
+                  <a:srgbClr val="111111"/>
+                </a:solidFill>
+                <a:latin typeface="Canva Sans"/>
+                <a:ea typeface="Canva Sans"/>
+                <a:cs typeface="Canva Sans"/>
+                <a:sym typeface="Canva Sans"/>
+              </a:rPr>
+              <a:t>: população e domicílios: primeiros resultados. Rio de Janeiro: IBGE, 2023.</a:t>
             </a:r>
             <a:endParaRPr lang="pt-BR" sz="1550" dirty="0"/>
           </a:p>
@@ -30926,6 +31252,57 @@
             <a:noAutofit/>
           </a:bodyPr>
           <a:lstStyle/>
+          <a:p>
+            <a:pPr algn="l">
+              <a:lnSpc>
+                <a:spcPct val="98000"/>
+              </a:lnSpc>
+              <a:spcBef>
+                <a:spcPts val="0"/>
+              </a:spcBef>
+              <a:spcAft>
+                <a:spcPts val="600"/>
+              </a:spcAft>
+              <a:buNone/>
+            </a:pPr>
+            <a:r>
+              <a:rPr lang="pt-BR" sz="1550" dirty="0">
+                <a:solidFill>
+                  <a:srgbClr val="111111"/>
+                </a:solidFill>
+                <a:latin typeface="Canva Sans"/>
+                <a:ea typeface="Canva Sans"/>
+                <a:cs typeface="Canva Sans"/>
+                <a:sym typeface="Canva Sans"/>
+              </a:rPr>
+              <a:t>IBGE. </a:t>
+            </a:r>
+            <a:r>
+              <a:rPr lang="pt-BR" sz="1550" b="1" dirty="0">
+                <a:solidFill>
+                  <a:srgbClr val="111111"/>
+                </a:solidFill>
+                <a:latin typeface="Canva Sans Bold"/>
+                <a:ea typeface="Canva Sans Bold"/>
+                <a:cs typeface="Canva Sans Bold"/>
+                <a:sym typeface="Canva Sans Bold"/>
+              </a:rPr>
+              <a:t>Cidades@</a:t>
+            </a:r>
+            <a:r>
+              <a:rPr lang="pt-BR" sz="1550" dirty="0">
+                <a:solidFill>
+                  <a:srgbClr val="111111"/>
+                </a:solidFill>
+                <a:latin typeface="Canva Sans"/>
+                <a:ea typeface="Canva Sans"/>
+                <a:cs typeface="Canva Sans"/>
+                <a:sym typeface="Canva Sans"/>
+              </a:rPr>
+              <a:t>: Tibau do Sul. Rio de Janeiro: IBGE, 2025. Disponível em: https://cidades.ibge.gov.br/brasil/rn/tibau-do-sul.</a:t>
+            </a:r>
+            <a:endParaRPr lang="pt-BR" sz="1550" dirty="0"/>
+          </a:p>
           <a:p>
             <a:pPr algn="l">
               <a:lnSpc>

</xml_diff>

<commit_message>
Deixa apenas teóricos no slide de conceitos, sem leis e documentos normativos
Co-Authored-By: Claude Opus 5.5 <noreply@anthropic.com>
Claude-Session: https://claude.ai/code/session_01HxStpW4pQoDfJdTDYr6zEC
</commit_message>
<xml_diff>
--- a/apresentacao_qualificacao/Qualificacao_PNED_Pipa.pptx
+++ b/apresentacao_qualificacao/Qualificacao_PNED_Pipa.pptx
@@ -15417,7 +15417,7 @@
         <p:spPr>
           <a:xfrm>
             <a:off x="612000" y="2232000"/>
-            <a:ext cx="3290400" cy="6408000"/>
+            <a:ext cx="4104000" cy="6408000"/>
           </a:xfrm>
           <a:prstGeom prst="roundRect">
             <a:avLst>
@@ -15447,12 +15447,12 @@
                 <a:spcPts val="0"/>
               </a:spcBef>
               <a:spcAft>
-                <a:spcPts val="1450"/>
-              </a:spcAft>
-              <a:buNone/>
-            </a:pPr>
-            <a:r>
-              <a:rPr lang="pt-BR" sz="2248" b="1" dirty="0">
+                <a:spcPts val="1739"/>
+              </a:spcAft>
+              <a:buNone/>
+            </a:pPr>
+            <a:r>
+              <a:rPr lang="pt-BR" sz="2610" b="1" dirty="0">
                 <a:solidFill>
                   <a:srgbClr val="111111"/>
                 </a:solidFill>
@@ -15463,7 +15463,7 @@
               </a:rPr>
               <a:t>A POLÍTICA</a:t>
             </a:r>
-            <a:endParaRPr lang="pt-BR" sz="2248" dirty="0"/>
+            <a:endParaRPr lang="pt-BR" sz="2610" dirty="0"/>
           </a:p>
           <a:p>
             <a:pPr algn="l">
@@ -15479,7 +15479,7 @@
               <a:buNone/>
             </a:pPr>
             <a:r>
-              <a:rPr lang="pt-BR" sz="1958" b="1" dirty="0">
+              <a:rPr lang="pt-BR" sz="2175" b="1" dirty="0">
                 <a:solidFill>
                   <a:srgbClr val="111111"/>
                 </a:solidFill>
@@ -15490,7 +15490,7 @@
               </a:rPr>
               <a:t>Ciclo de políticas: influência, produção do texto, prática</a:t>
             </a:r>
-            <a:endParaRPr lang="pt-BR" sz="1958" dirty="0"/>
+            <a:endParaRPr lang="pt-BR" sz="2175" dirty="0"/>
           </a:p>
           <a:p>
             <a:pPr algn="l">
@@ -15501,12 +15501,12 @@
                 <a:spcPts val="0"/>
               </a:spcBef>
               <a:spcAft>
-                <a:spcPts val="1450"/>
-              </a:spcAft>
-              <a:buNone/>
-            </a:pPr>
-            <a:r>
-              <a:rPr lang="pt-BR" sz="1812" dirty="0">
+                <a:spcPts val="1739"/>
+              </a:spcAft>
+              <a:buNone/>
+            </a:pPr>
+            <a:r>
+              <a:rPr lang="pt-BR" sz="1958" dirty="0">
                 <a:solidFill>
                   <a:srgbClr val="111111"/>
                 </a:solidFill>
@@ -15517,7 +15517,7 @@
               </a:rPr>
               <a:t>Bowe, Ball e Gold (1992); Mainardes (2006)</a:t>
             </a:r>
-            <a:endParaRPr lang="pt-BR" sz="1812" dirty="0"/>
+            <a:endParaRPr lang="pt-BR" sz="1958" dirty="0"/>
           </a:p>
           <a:p>
             <a:pPr algn="l">
@@ -15533,7 +15533,7 @@
               <a:buNone/>
             </a:pPr>
             <a:r>
-              <a:rPr lang="pt-BR" sz="1958" b="1" dirty="0">
+              <a:rPr lang="pt-BR" sz="2175" b="1" dirty="0">
                 <a:solidFill>
                   <a:srgbClr val="111111"/>
                 </a:solidFill>
@@ -15544,7 +15544,7 @@
               </a:rPr>
               <a:t>Atuação (encenação): interpretar e traduzir</a:t>
             </a:r>
-            <a:endParaRPr lang="pt-BR" sz="1958" dirty="0"/>
+            <a:endParaRPr lang="pt-BR" sz="2175" dirty="0"/>
           </a:p>
           <a:p>
             <a:pPr algn="l">
@@ -15555,12 +15555,12 @@
                 <a:spcPts val="0"/>
               </a:spcBef>
               <a:spcAft>
-                <a:spcPts val="1450"/>
-              </a:spcAft>
-              <a:buNone/>
-            </a:pPr>
-            <a:r>
-              <a:rPr lang="pt-BR" sz="1812" dirty="0">
+                <a:spcPts val="1739"/>
+              </a:spcAft>
+              <a:buNone/>
+            </a:pPr>
+            <a:r>
+              <a:rPr lang="pt-BR" sz="1958" dirty="0">
                 <a:solidFill>
                   <a:srgbClr val="111111"/>
                 </a:solidFill>
@@ -15571,7 +15571,7 @@
               </a:rPr>
               <a:t>Ball, Maguire e Braun (2016)</a:t>
             </a:r>
-            <a:endParaRPr lang="pt-BR" sz="1812" dirty="0"/>
+            <a:endParaRPr lang="pt-BR" sz="1958" dirty="0"/>
           </a:p>
           <a:p>
             <a:pPr algn="l">
@@ -15587,7 +15587,7 @@
               <a:buNone/>
             </a:pPr>
             <a:r>
-              <a:rPr lang="pt-BR" sz="1958" b="1" dirty="0">
+              <a:rPr lang="pt-BR" sz="2175" b="1" dirty="0">
                 <a:solidFill>
                   <a:srgbClr val="111111"/>
                 </a:solidFill>
@@ -15598,7 +15598,7 @@
               </a:rPr>
               <a:t>Recontextualização: a política "recriada" na prática</a:t>
             </a:r>
-            <a:endParaRPr lang="pt-BR" sz="1958" dirty="0"/>
+            <a:endParaRPr lang="pt-BR" sz="2175" dirty="0"/>
           </a:p>
           <a:p>
             <a:pPr algn="l">
@@ -15609,12 +15609,12 @@
                 <a:spcPts val="0"/>
               </a:spcBef>
               <a:spcAft>
-                <a:spcPts val="1450"/>
-              </a:spcAft>
-              <a:buNone/>
-            </a:pPr>
-            <a:r>
-              <a:rPr lang="pt-BR" sz="1812" dirty="0">
+                <a:spcPts val="1739"/>
+              </a:spcAft>
+              <a:buNone/>
+            </a:pPr>
+            <a:r>
+              <a:rPr lang="pt-BR" sz="1958" dirty="0">
                 <a:solidFill>
                   <a:srgbClr val="111111"/>
                 </a:solidFill>
@@ -15625,7 +15625,7 @@
               </a:rPr>
               <a:t>Bowe, Ball e Gold (1992, p. 22)</a:t>
             </a:r>
-            <a:endParaRPr lang="pt-BR" sz="1812" dirty="0"/>
+            <a:endParaRPr lang="pt-BR" sz="1958" dirty="0"/>
           </a:p>
         </p:txBody>
       </p:sp>
@@ -15637,8 +15637,8 @@
         </p:nvSpPr>
         <p:spPr>
           <a:xfrm>
-            <a:off x="4053600" y="2232000"/>
-            <a:ext cx="3290400" cy="6408000"/>
+            <a:off x="4914000" y="2232000"/>
+            <a:ext cx="4104000" cy="6408000"/>
           </a:xfrm>
           <a:prstGeom prst="roundRect">
             <a:avLst>
@@ -15668,12 +15668,12 @@
                 <a:spcPts val="0"/>
               </a:spcBef>
               <a:spcAft>
-                <a:spcPts val="1450"/>
-              </a:spcAft>
-              <a:buNone/>
-            </a:pPr>
-            <a:r>
-              <a:rPr lang="pt-BR" sz="2248" b="1" dirty="0">
+                <a:spcPts val="1739"/>
+              </a:spcAft>
+              <a:buNone/>
+            </a:pPr>
+            <a:r>
+              <a:rPr lang="pt-BR" sz="2610" b="1" dirty="0">
                 <a:solidFill>
                   <a:srgbClr val="111111"/>
                 </a:solidFill>
@@ -15684,7 +15684,7 @@
               </a:rPr>
               <a:t>OS PROFISSIONAIS</a:t>
             </a:r>
-            <a:endParaRPr lang="pt-BR" sz="2248" dirty="0"/>
+            <a:endParaRPr lang="pt-BR" sz="2610" dirty="0"/>
           </a:p>
           <a:p>
             <a:pPr algn="l">
@@ -15700,7 +15700,7 @@
               <a:buNone/>
             </a:pPr>
             <a:r>
-              <a:rPr lang="pt-BR" sz="1958" b="1" dirty="0">
+              <a:rPr lang="pt-BR" sz="2175" b="1" dirty="0">
                 <a:solidFill>
                   <a:srgbClr val="111111"/>
                 </a:solidFill>
@@ -15711,7 +15711,7 @@
               </a:rPr>
               <a:t>Culturas profissionais</a:t>
             </a:r>
-            <a:endParaRPr lang="pt-BR" sz="1958" dirty="0"/>
+            <a:endParaRPr lang="pt-BR" sz="2175" dirty="0"/>
           </a:p>
           <a:p>
             <a:pPr algn="l">
@@ -15722,12 +15722,12 @@
                 <a:spcPts val="0"/>
               </a:spcBef>
               <a:spcAft>
-                <a:spcPts val="1450"/>
-              </a:spcAft>
-              <a:buNone/>
-            </a:pPr>
-            <a:r>
-              <a:rPr lang="pt-BR" sz="1812" dirty="0">
+                <a:spcPts val="1739"/>
+              </a:spcAft>
+              <a:buNone/>
+            </a:pPr>
+            <a:r>
+              <a:rPr lang="pt-BR" sz="1958" dirty="0">
                 <a:solidFill>
                   <a:srgbClr val="111111"/>
                 </a:solidFill>
@@ -15738,7 +15738,7 @@
               </a:rPr>
               <a:t>Hargreaves (2005)</a:t>
             </a:r>
-            <a:endParaRPr lang="pt-BR" sz="1812" dirty="0"/>
+            <a:endParaRPr lang="pt-BR" sz="1958" dirty="0"/>
           </a:p>
           <a:p>
             <a:pPr algn="l">
@@ -15754,7 +15754,7 @@
               <a:buNone/>
             </a:pPr>
             <a:r>
-              <a:rPr lang="pt-BR" sz="1958" b="1" dirty="0">
+              <a:rPr lang="pt-BR" sz="2175" b="1" dirty="0">
                 <a:solidFill>
                   <a:srgbClr val="111111"/>
                 </a:solidFill>
@@ -15765,7 +15765,7 @@
               </a:rPr>
               <a:t>Performatividade e fabricação</a:t>
             </a:r>
-            <a:endParaRPr lang="pt-BR" sz="1958" dirty="0"/>
+            <a:endParaRPr lang="pt-BR" sz="2175" dirty="0"/>
           </a:p>
           <a:p>
             <a:pPr algn="l">
@@ -15776,12 +15776,12 @@
                 <a:spcPts val="0"/>
               </a:spcBef>
               <a:spcAft>
-                <a:spcPts val="1450"/>
-              </a:spcAft>
-              <a:buNone/>
-            </a:pPr>
-            <a:r>
-              <a:rPr lang="pt-BR" sz="1812" dirty="0">
+                <a:spcPts val="1739"/>
+              </a:spcAft>
+              <a:buNone/>
+            </a:pPr>
+            <a:r>
+              <a:rPr lang="pt-BR" sz="1958" dirty="0">
                 <a:solidFill>
                   <a:srgbClr val="111111"/>
                 </a:solidFill>
@@ -15792,7 +15792,7 @@
               </a:rPr>
               <a:t>Ball (2002; 2008)</a:t>
             </a:r>
-            <a:endParaRPr lang="pt-BR" sz="1812" dirty="0"/>
+            <a:endParaRPr lang="pt-BR" sz="1958" dirty="0"/>
           </a:p>
           <a:p>
             <a:pPr algn="l">
@@ -15808,7 +15808,7 @@
               <a:buNone/>
             </a:pPr>
             <a:r>
-              <a:rPr lang="pt-BR" sz="1958" b="1" dirty="0">
+              <a:rPr lang="pt-BR" sz="2175" b="1" dirty="0">
                 <a:solidFill>
                   <a:srgbClr val="111111"/>
                 </a:solidFill>
@@ -15819,7 +15819,7 @@
               </a:rPr>
               <a:t>Poder e resistência</a:t>
             </a:r>
-            <a:endParaRPr lang="pt-BR" sz="1958" dirty="0"/>
+            <a:endParaRPr lang="pt-BR" sz="2175" dirty="0"/>
           </a:p>
           <a:p>
             <a:pPr algn="l">
@@ -15830,12 +15830,12 @@
                 <a:spcPts val="0"/>
               </a:spcBef>
               <a:spcAft>
-                <a:spcPts val="1450"/>
-              </a:spcAft>
-              <a:buNone/>
-            </a:pPr>
-            <a:r>
-              <a:rPr lang="pt-BR" sz="1812" dirty="0">
+                <a:spcPts val="1739"/>
+              </a:spcAft>
+              <a:buNone/>
+            </a:pPr>
+            <a:r>
+              <a:rPr lang="pt-BR" sz="1958" dirty="0">
                 <a:solidFill>
                   <a:srgbClr val="111111"/>
                 </a:solidFill>
@@ -15846,7 +15846,7 @@
               </a:rPr>
               <a:t>Foucault (1999); Ball (2011); Freire (2019)</a:t>
             </a:r>
-            <a:endParaRPr lang="pt-BR" sz="1812" dirty="0"/>
+            <a:endParaRPr lang="pt-BR" sz="1958" dirty="0"/>
           </a:p>
           <a:p>
             <a:pPr algn="l">
@@ -15862,7 +15862,7 @@
               <a:buNone/>
             </a:pPr>
             <a:r>
-              <a:rPr lang="pt-BR" sz="1958" b="1" dirty="0">
+              <a:rPr lang="pt-BR" sz="2175" b="1" dirty="0">
                 <a:solidFill>
                   <a:srgbClr val="111111"/>
                 </a:solidFill>
@@ -15873,7 +15873,7 @@
               </a:rPr>
               <a:t>Sentidos que organizam ações</a:t>
             </a:r>
-            <a:endParaRPr lang="pt-BR" sz="1958" dirty="0"/>
+            <a:endParaRPr lang="pt-BR" sz="2175" dirty="0"/>
           </a:p>
           <a:p>
             <a:pPr algn="l">
@@ -15884,12 +15884,12 @@
                 <a:spcPts val="0"/>
               </a:spcBef>
               <a:spcAft>
-                <a:spcPts val="1450"/>
-              </a:spcAft>
-              <a:buNone/>
-            </a:pPr>
-            <a:r>
-              <a:rPr lang="pt-BR" sz="1812" dirty="0">
+                <a:spcPts val="1739"/>
+              </a:spcAft>
+              <a:buNone/>
+            </a:pPr>
+            <a:r>
+              <a:rPr lang="pt-BR" sz="1958" dirty="0">
                 <a:solidFill>
                   <a:srgbClr val="111111"/>
                 </a:solidFill>
@@ -15900,7 +15900,7 @@
               </a:rPr>
               <a:t>Hall (2006)</a:t>
             </a:r>
-            <a:endParaRPr lang="pt-BR" sz="1812" dirty="0"/>
+            <a:endParaRPr lang="pt-BR" sz="1958" dirty="0"/>
           </a:p>
         </p:txBody>
       </p:sp>
@@ -15912,8 +15912,8 @@
         </p:nvSpPr>
         <p:spPr>
           <a:xfrm>
-            <a:off x="7495200" y="2232000"/>
-            <a:ext cx="3290400" cy="6408000"/>
+            <a:off x="9216000" y="2232000"/>
+            <a:ext cx="4104000" cy="6408000"/>
           </a:xfrm>
           <a:prstGeom prst="roundRect">
             <a:avLst>
@@ -15943,12 +15943,12 @@
                 <a:spcPts val="0"/>
               </a:spcBef>
               <a:spcAft>
-                <a:spcPts val="1450"/>
-              </a:spcAft>
-              <a:buNone/>
-            </a:pPr>
-            <a:r>
-              <a:rPr lang="pt-BR" sz="2248" b="1" dirty="0">
+                <a:spcPts val="1739"/>
+              </a:spcAft>
+              <a:buNone/>
+            </a:pPr>
+            <a:r>
+              <a:rPr lang="pt-BR" sz="2610" b="1" dirty="0">
                 <a:solidFill>
                   <a:srgbClr val="111111"/>
                 </a:solidFill>
@@ -15959,7 +15959,7 @@
               </a:rPr>
               <a:t>O TERRITÓRIO</a:t>
             </a:r>
-            <a:endParaRPr lang="pt-BR" sz="2248" dirty="0"/>
+            <a:endParaRPr lang="pt-BR" sz="2610" dirty="0"/>
           </a:p>
           <a:p>
             <a:pPr algn="l">
@@ -15975,7 +15975,7 @@
               <a:buNone/>
             </a:pPr>
             <a:r>
-              <a:rPr lang="pt-BR" sz="1958" b="1" dirty="0">
+              <a:rPr lang="pt-BR" sz="2175" b="1" dirty="0">
                 <a:solidFill>
                   <a:srgbClr val="111111"/>
                 </a:solidFill>
@@ -15986,7 +15986,7 @@
               </a:rPr>
               <a:t>Território usado e rugosidades</a:t>
             </a:r>
-            <a:endParaRPr lang="pt-BR" sz="1958" dirty="0"/>
+            <a:endParaRPr lang="pt-BR" sz="2175" dirty="0"/>
           </a:p>
           <a:p>
             <a:pPr algn="l">
@@ -15997,12 +15997,12 @@
                 <a:spcPts val="0"/>
               </a:spcBef>
               <a:spcAft>
-                <a:spcPts val="1450"/>
-              </a:spcAft>
-              <a:buNone/>
-            </a:pPr>
-            <a:r>
-              <a:rPr lang="pt-BR" sz="1812" dirty="0">
+                <a:spcPts val="1739"/>
+              </a:spcAft>
+              <a:buNone/>
+            </a:pPr>
+            <a:r>
+              <a:rPr lang="pt-BR" sz="1958" dirty="0">
                 <a:solidFill>
                   <a:srgbClr val="111111"/>
                 </a:solidFill>
@@ -16013,7 +16013,7 @@
               </a:rPr>
               <a:t>Santos (1999; 2006; 2012)</a:t>
             </a:r>
-            <a:endParaRPr lang="pt-BR" sz="1812" dirty="0"/>
+            <a:endParaRPr lang="pt-BR" sz="1958" dirty="0"/>
           </a:p>
           <a:p>
             <a:pPr algn="l">
@@ -16029,7 +16029,7 @@
               <a:buNone/>
             </a:pPr>
             <a:r>
-              <a:rPr lang="pt-BR" sz="1958" b="1" dirty="0">
+              <a:rPr lang="pt-BR" sz="2175" b="1" dirty="0">
                 <a:solidFill>
                   <a:srgbClr val="111111"/>
                 </a:solidFill>
@@ -16040,7 +16040,7 @@
               </a:rPr>
               <a:t>Lugar como encontro de trajetórias</a:t>
             </a:r>
-            <a:endParaRPr lang="pt-BR" sz="1958" dirty="0"/>
+            <a:endParaRPr lang="pt-BR" sz="2175" dirty="0"/>
           </a:p>
           <a:p>
             <a:pPr algn="l">
@@ -16051,12 +16051,12 @@
                 <a:spcPts val="0"/>
               </a:spcBef>
               <a:spcAft>
-                <a:spcPts val="1450"/>
-              </a:spcAft>
-              <a:buNone/>
-            </a:pPr>
-            <a:r>
-              <a:rPr lang="pt-BR" sz="1812" dirty="0">
+                <a:spcPts val="1739"/>
+              </a:spcAft>
+              <a:buNone/>
+            </a:pPr>
+            <a:r>
+              <a:rPr lang="pt-BR" sz="1958" dirty="0">
                 <a:solidFill>
                   <a:srgbClr val="111111"/>
                 </a:solidFill>
@@ -16067,7 +16067,7 @@
               </a:rPr>
               <a:t>Massey (2008)</a:t>
             </a:r>
-            <a:endParaRPr lang="pt-BR" sz="1812" dirty="0"/>
+            <a:endParaRPr lang="pt-BR" sz="1958" dirty="0"/>
           </a:p>
           <a:p>
             <a:pPr algn="l">
@@ -16083,7 +16083,7 @@
               <a:buNone/>
             </a:pPr>
             <a:r>
-              <a:rPr lang="pt-BR" sz="1958" b="1" dirty="0">
+              <a:rPr lang="pt-BR" sz="2175" b="1" dirty="0">
                 <a:solidFill>
                   <a:srgbClr val="111111"/>
                 </a:solidFill>
@@ -16094,7 +16094,7 @@
               </a:rPr>
               <a:t>Habitar e Educação OnLIFE</a:t>
             </a:r>
-            <a:endParaRPr lang="pt-BR" sz="1958" dirty="0"/>
+            <a:endParaRPr lang="pt-BR" sz="2175" dirty="0"/>
           </a:p>
           <a:p>
             <a:pPr algn="l">
@@ -16105,12 +16105,12 @@
                 <a:spcPts val="0"/>
               </a:spcBef>
               <a:spcAft>
-                <a:spcPts val="1450"/>
-              </a:spcAft>
-              <a:buNone/>
-            </a:pPr>
-            <a:r>
-              <a:rPr lang="pt-BR" sz="1812" dirty="0">
+                <a:spcPts val="1739"/>
+              </a:spcAft>
+              <a:buNone/>
+            </a:pPr>
+            <a:r>
+              <a:rPr lang="pt-BR" sz="1958" dirty="0">
                 <a:solidFill>
                   <a:srgbClr val="111111"/>
                 </a:solidFill>
@@ -16121,7 +16121,7 @@
               </a:rPr>
               <a:t>Schlemmer, Backes e Palagi (2021); Di Felice (2009)</a:t>
             </a:r>
-            <a:endParaRPr lang="pt-BR" sz="1812" dirty="0"/>
+            <a:endParaRPr lang="pt-BR" sz="1958" dirty="0"/>
           </a:p>
         </p:txBody>
       </p:sp>
@@ -16133,8 +16133,8 @@
         </p:nvSpPr>
         <p:spPr>
           <a:xfrm>
-            <a:off x="10936800" y="2232000"/>
-            <a:ext cx="3290400" cy="6408000"/>
+            <a:off x="13518000" y="2232000"/>
+            <a:ext cx="4104000" cy="6408000"/>
           </a:xfrm>
           <a:prstGeom prst="roundRect">
             <a:avLst>
@@ -16164,12 +16164,12 @@
                 <a:spcPts val="0"/>
               </a:spcBef>
               <a:spcAft>
-                <a:spcPts val="1450"/>
-              </a:spcAft>
-              <a:buNone/>
-            </a:pPr>
-            <a:r>
-              <a:rPr lang="pt-BR" sz="2248" b="1" dirty="0">
+                <a:spcPts val="1739"/>
+              </a:spcAft>
+              <a:buNone/>
+            </a:pPr>
+            <a:r>
+              <a:rPr lang="pt-BR" sz="2610" b="1" dirty="0">
                 <a:solidFill>
                   <a:srgbClr val="111111"/>
                 </a:solidFill>
@@ -16180,7 +16180,7 @@
               </a:rPr>
               <a:t>A CULTURA DIGITAL</a:t>
             </a:r>
-            <a:endParaRPr lang="pt-BR" sz="2248" dirty="0"/>
+            <a:endParaRPr lang="pt-BR" sz="2610" dirty="0"/>
           </a:p>
           <a:p>
             <a:pPr algn="l">
@@ -16196,7 +16196,7 @@
               <a:buNone/>
             </a:pPr>
             <a:r>
-              <a:rPr lang="pt-BR" sz="1958" b="1" dirty="0">
+              <a:rPr lang="pt-BR" sz="2175" b="1" dirty="0">
                 <a:solidFill>
                   <a:srgbClr val="111111"/>
                 </a:solidFill>
@@ -16205,9 +16205,9 @@
                 <a:cs typeface="Canva Sans Bold"/>
                 <a:sym typeface="Canva Sans Bold"/>
               </a:rPr>
-              <a:t>Participação consciente e democrática</a:t>
-            </a:r>
-            <a:endParaRPr lang="pt-BR" sz="1958" dirty="0"/>
+              <a:t>Capitalismo de vigilância e dados</a:t>
+            </a:r>
+            <a:endParaRPr lang="pt-BR" sz="2175" dirty="0"/>
           </a:p>
           <a:p>
             <a:pPr algn="l">
@@ -16218,12 +16218,12 @@
                 <a:spcPts val="0"/>
               </a:spcBef>
               <a:spcAft>
-                <a:spcPts val="1450"/>
-              </a:spcAft>
-              <a:buNone/>
-            </a:pPr>
-            <a:r>
-              <a:rPr lang="pt-BR" sz="1812" dirty="0">
+                <a:spcPts val="1739"/>
+              </a:spcAft>
+              <a:buNone/>
+            </a:pPr>
+            <a:r>
+              <a:rPr lang="pt-BR" sz="1958" dirty="0">
                 <a:solidFill>
                   <a:srgbClr val="111111"/>
                 </a:solidFill>
@@ -16232,9 +16232,9 @@
                 <a:cs typeface="Canva Sans"/>
                 <a:sym typeface="Canva Sans"/>
               </a:rPr>
-              <a:t>BRASIL (2023, art. 3º, III); BNCC, competência 5 (BRASIL, 2018)</a:t>
-            </a:r>
-            <a:endParaRPr lang="pt-BR" sz="1812" dirty="0"/>
+              <a:t>Zuboff (2021); Silveira (2017)</a:t>
+            </a:r>
+            <a:endParaRPr lang="pt-BR" sz="1958" dirty="0"/>
           </a:p>
           <a:p>
             <a:pPr algn="l">
@@ -16250,7 +16250,7 @@
               <a:buNone/>
             </a:pPr>
             <a:r>
-              <a:rPr lang="pt-BR" sz="1958" b="1" dirty="0">
+              <a:rPr lang="pt-BR" sz="2175" b="1" dirty="0">
                 <a:solidFill>
                   <a:srgbClr val="111111"/>
                 </a:solidFill>
@@ -16259,9 +16259,9 @@
                 <a:cs typeface="Canva Sans Bold"/>
                 <a:sym typeface="Canva Sans Bold"/>
               </a:rPr>
-              <a:t>Capitalismo de vigilância e dados</a:t>
-            </a:r>
-            <a:endParaRPr lang="pt-BR" sz="1958" dirty="0"/>
+              <a:t>Solucionismo</a:t>
+            </a:r>
+            <a:endParaRPr lang="pt-BR" sz="2175" dirty="0"/>
           </a:p>
           <a:p>
             <a:pPr algn="l">
@@ -16272,12 +16272,12 @@
                 <a:spcPts val="0"/>
               </a:spcBef>
               <a:spcAft>
-                <a:spcPts val="1450"/>
-              </a:spcAft>
-              <a:buNone/>
-            </a:pPr>
-            <a:r>
-              <a:rPr lang="pt-BR" sz="1812" dirty="0">
+                <a:spcPts val="1739"/>
+              </a:spcAft>
+              <a:buNone/>
+            </a:pPr>
+            <a:r>
+              <a:rPr lang="pt-BR" sz="1958" dirty="0">
                 <a:solidFill>
                   <a:srgbClr val="111111"/>
                 </a:solidFill>
@@ -16286,9 +16286,9 @@
                 <a:cs typeface="Canva Sans"/>
                 <a:sym typeface="Canva Sans"/>
               </a:rPr>
-              <a:t>Zuboff (2021); Silveira (2017)</a:t>
-            </a:r>
-            <a:endParaRPr lang="pt-BR" sz="1812" dirty="0"/>
+              <a:t>Morozov (2018)</a:t>
+            </a:r>
+            <a:endParaRPr lang="pt-BR" sz="1958" dirty="0"/>
           </a:p>
           <a:p>
             <a:pPr algn="l">
@@ -16304,7 +16304,7 @@
               <a:buNone/>
             </a:pPr>
             <a:r>
-              <a:rPr lang="pt-BR" sz="1958" b="1" dirty="0">
+              <a:rPr lang="pt-BR" sz="2175" b="1" dirty="0">
                 <a:solidFill>
                   <a:srgbClr val="111111"/>
                 </a:solidFill>
@@ -16313,9 +16313,9 @@
                 <a:cs typeface="Canva Sans Bold"/>
                 <a:sym typeface="Canva Sans Bold"/>
               </a:rPr>
-              <a:t>Solucionismo</a:t>
-            </a:r>
-            <a:endParaRPr lang="pt-BR" sz="1958" dirty="0"/>
+              <a:t>Sujeitos produtores de cultura</a:t>
+            </a:r>
+            <a:endParaRPr lang="pt-BR" sz="2175" dirty="0"/>
           </a:p>
           <a:p>
             <a:pPr algn="l">
@@ -16326,12 +16326,12 @@
                 <a:spcPts val="0"/>
               </a:spcBef>
               <a:spcAft>
-                <a:spcPts val="1450"/>
-              </a:spcAft>
-              <a:buNone/>
-            </a:pPr>
-            <a:r>
-              <a:rPr lang="pt-BR" sz="1812" dirty="0">
+                <a:spcPts val="1739"/>
+              </a:spcAft>
+              <a:buNone/>
+            </a:pPr>
+            <a:r>
+              <a:rPr lang="pt-BR" sz="1958" dirty="0">
                 <a:solidFill>
                   <a:srgbClr val="111111"/>
                 </a:solidFill>
@@ -16340,236 +16340,15 @@
                 <a:cs typeface="Canva Sans"/>
                 <a:sym typeface="Canva Sans"/>
               </a:rPr>
-              <a:t>Morozov (2018)</a:t>
-            </a:r>
-            <a:endParaRPr lang="pt-BR" sz="1812" dirty="0"/>
-          </a:p>
-          <a:p>
-            <a:pPr algn="l">
-              <a:lnSpc>
-                <a:spcPct val="95000"/>
-              </a:lnSpc>
-              <a:spcBef>
-                <a:spcPts val="0"/>
-              </a:spcBef>
-              <a:spcAft>
-                <a:spcPts val="290"/>
-              </a:spcAft>
-              <a:buNone/>
-            </a:pPr>
-            <a:r>
-              <a:rPr lang="pt-BR" sz="1958" b="1" dirty="0">
-                <a:solidFill>
-                  <a:srgbClr val="111111"/>
-                </a:solidFill>
-                <a:latin typeface="Canva Sans Bold"/>
-                <a:ea typeface="Canva Sans Bold"/>
-                <a:cs typeface="Canva Sans Bold"/>
-                <a:sym typeface="Canva Sans Bold"/>
-              </a:rPr>
-              <a:t>Sujeitos produtores de cultura</a:t>
+              <a:t>Pretto, Cordeiro e Oliveira (2013)</a:t>
             </a:r>
             <a:endParaRPr lang="pt-BR" sz="1958" dirty="0"/>
           </a:p>
-          <a:p>
-            <a:pPr algn="l">
-              <a:lnSpc>
-                <a:spcPct val="95000"/>
-              </a:lnSpc>
-              <a:spcBef>
-                <a:spcPts val="0"/>
-              </a:spcBef>
-              <a:spcAft>
-                <a:spcPts val="1450"/>
-              </a:spcAft>
-              <a:buNone/>
-            </a:pPr>
-            <a:r>
-              <a:rPr lang="pt-BR" sz="1812" dirty="0">
-                <a:solidFill>
-                  <a:srgbClr val="111111"/>
-                </a:solidFill>
-                <a:latin typeface="Canva Sans"/>
-                <a:ea typeface="Canva Sans"/>
-                <a:cs typeface="Canva Sans"/>
-                <a:sym typeface="Canva Sans"/>
-              </a:rPr>
-              <a:t>Pretto, Cordeiro e Oliveira (2013)</a:t>
-            </a:r>
-            <a:endParaRPr lang="pt-BR" sz="1812" dirty="0"/>
-          </a:p>
         </p:txBody>
       </p:sp>
       <p:sp>
         <p:nvSpPr>
           <p:cNvPr id="206" name="Cartão 206"/>
-          <p:cNvSpPr/>
-          <p:nvPr/>
-        </p:nvSpPr>
-        <p:spPr>
-          <a:xfrm>
-            <a:off x="14378400" y="2232000"/>
-            <a:ext cx="3290400" cy="6408000"/>
-          </a:xfrm>
-          <a:prstGeom prst="roundRect">
-            <a:avLst>
-              <a:gd name="adj" fmla="val 7000"/>
-            </a:avLst>
-          </a:prstGeom>
-          <a:solidFill>
-            <a:srgbClr val="FFCE32"/>
-          </a:solidFill>
-          <a:ln w="38100">
-            <a:solidFill>
-              <a:srgbClr val="111111"/>
-            </a:solidFill>
-          </a:ln>
-        </p:spPr>
-        <p:txBody>
-          <a:bodyPr wrap="square" lIns="198000" tIns="198000" rIns="198000" bIns="198000" anchor="t" rtlCol="0">
-            <a:noAutofit/>
-          </a:bodyPr>
-          <a:lstStyle/>
-          <a:p>
-            <a:pPr algn="ctr">
-              <a:lnSpc>
-                <a:spcPct val="100000"/>
-              </a:lnSpc>
-              <a:spcBef>
-                <a:spcPts val="0"/>
-              </a:spcBef>
-              <a:spcAft>
-                <a:spcPts val="1450"/>
-              </a:spcAft>
-              <a:buNone/>
-            </a:pPr>
-            <a:r>
-              <a:rPr lang="pt-BR" sz="2248" b="1" dirty="0">
-                <a:solidFill>
-                  <a:srgbClr val="111111"/>
-                </a:solidFill>
-                <a:latin typeface="Canva Sans Bold"/>
-                <a:ea typeface="Canva Sans Bold"/>
-                <a:cs typeface="Canva Sans Bold"/>
-                <a:sym typeface="Canva Sans Bold"/>
-              </a:rPr>
-              <a:t>AS CRIANÇAS</a:t>
-            </a:r>
-            <a:endParaRPr lang="pt-BR" sz="2248" dirty="0"/>
-          </a:p>
-          <a:p>
-            <a:pPr algn="l">
-              <a:lnSpc>
-                <a:spcPct val="95000"/>
-              </a:lnSpc>
-              <a:spcBef>
-                <a:spcPts val="0"/>
-              </a:spcBef>
-              <a:spcAft>
-                <a:spcPts val="290"/>
-              </a:spcAft>
-              <a:buNone/>
-            </a:pPr>
-            <a:r>
-              <a:rPr lang="pt-BR" sz="1958" b="1" dirty="0">
-                <a:solidFill>
-                  <a:srgbClr val="111111"/>
-                </a:solidFill>
-                <a:latin typeface="Canva Sans Bold"/>
-                <a:ea typeface="Canva Sans Bold"/>
-                <a:cs typeface="Canva Sans Bold"/>
-                <a:sym typeface="Canva Sans Bold"/>
-              </a:rPr>
-              <a:t>Provisão, proteção e participação no ambiente digital</a:t>
-            </a:r>
-            <a:endParaRPr lang="pt-BR" sz="1958" dirty="0"/>
-          </a:p>
-          <a:p>
-            <a:pPr algn="l">
-              <a:lnSpc>
-                <a:spcPct val="95000"/>
-              </a:lnSpc>
-              <a:spcBef>
-                <a:spcPts val="0"/>
-              </a:spcBef>
-              <a:spcAft>
-                <a:spcPts val="1450"/>
-              </a:spcAft>
-              <a:buNone/>
-            </a:pPr>
-            <a:r>
-              <a:rPr lang="pt-BR" sz="1812" dirty="0">
-                <a:solidFill>
-                  <a:srgbClr val="111111"/>
-                </a:solidFill>
-                <a:latin typeface="Canva Sans"/>
-                <a:ea typeface="Canva Sans"/>
-                <a:cs typeface="Canva Sans"/>
-                <a:sym typeface="Canva Sans"/>
-              </a:rPr>
-              <a:t>ONU (2021), Comentário Geral nº 25</a:t>
-            </a:r>
-            <a:endParaRPr lang="pt-BR" sz="1812" dirty="0"/>
-          </a:p>
-          <a:p>
-            <a:pPr algn="l">
-              <a:lnSpc>
-                <a:spcPct val="95000"/>
-              </a:lnSpc>
-              <a:spcBef>
-                <a:spcPts val="0"/>
-              </a:spcBef>
-              <a:spcAft>
-                <a:spcPts val="290"/>
-              </a:spcAft>
-              <a:buNone/>
-            </a:pPr>
-            <a:r>
-              <a:rPr lang="pt-BR" sz="1958" b="1" dirty="0">
-                <a:solidFill>
-                  <a:srgbClr val="111111"/>
-                </a:solidFill>
-                <a:latin typeface="Canva Sans Bold"/>
-                <a:ea typeface="Canva Sans Bold"/>
-                <a:cs typeface="Canva Sans Bold"/>
-                <a:sym typeface="Canva Sans Bold"/>
-              </a:rPr>
-              <a:t>Direitos do eixo: participação e proteção dos dados</a:t>
-            </a:r>
-            <a:endParaRPr lang="pt-BR" sz="1958" dirty="0"/>
-          </a:p>
-          <a:p>
-            <a:pPr algn="l">
-              <a:lnSpc>
-                <a:spcPct val="95000"/>
-              </a:lnSpc>
-              <a:spcBef>
-                <a:spcPts val="0"/>
-              </a:spcBef>
-              <a:spcAft>
-                <a:spcPts val="1450"/>
-              </a:spcAft>
-              <a:buNone/>
-            </a:pPr>
-            <a:r>
-              <a:rPr lang="pt-BR" sz="1812" dirty="0">
-                <a:solidFill>
-                  <a:srgbClr val="111111"/>
-                </a:solidFill>
-                <a:latin typeface="Canva Sans"/>
-                <a:ea typeface="Canva Sans"/>
-                <a:cs typeface="Canva Sans"/>
-                <a:sym typeface="Canva Sans"/>
-              </a:rPr>
-              <a:t>BRASIL (2023, art. 3º, III e IV)</a:t>
-            </a:r>
-            <a:endParaRPr lang="pt-BR" sz="1812" dirty="0"/>
-          </a:p>
-        </p:txBody>
-      </p:sp>
-      <p:sp>
-        <p:nvSpPr>
-          <p:cNvPr id="207" name="Cartão 207"/>
           <p:cNvSpPr/>
           <p:nvPr/>
         </p:nvSpPr>
@@ -30449,7 +30228,7 @@
                 <a:cs typeface="Canva Sans"/>
                 <a:sym typeface="Canva Sans"/>
               </a:rPr>
-              <a:t>BRASIL. Ministério da Educação. </a:t>
+              <a:t>BRASIL. </a:t>
             </a:r>
             <a:r>
               <a:rPr lang="pt-BR" sz="1550" b="1" dirty="0">
@@ -30461,7 +30240,7 @@
                 <a:cs typeface="Canva Sans Bold"/>
                 <a:sym typeface="Canva Sans Bold"/>
               </a:rPr>
-              <a:t>Base Nacional Comum Curricular (BNCC)</a:t>
+              <a:t>Lei nº 14.533, de 11 de janeiro de 2023</a:t>
             </a:r>
             <a:r>
               <a:rPr lang="pt-BR" sz="1550" dirty="0">
@@ -30473,7 +30252,7 @@
                 <a:cs typeface="Canva Sans"/>
                 <a:sym typeface="Canva Sans"/>
               </a:rPr>
-              <a:t>. Brasília, DF: MEC, 2018.</a:t>
+              <a:t>. Institui a Política Nacional de Educação Digital. Brasília, DF: Presidência da República, 2023.</a:t>
             </a:r>
             <a:endParaRPr lang="pt-BR" sz="1550" dirty="0"/>
           </a:p>
@@ -30500,57 +30279,6 @@
             <a:noAutofit/>
           </a:bodyPr>
           <a:lstStyle/>
-          <a:p>
-            <a:pPr algn="l">
-              <a:lnSpc>
-                <a:spcPct val="98000"/>
-              </a:lnSpc>
-              <a:spcBef>
-                <a:spcPts val="0"/>
-              </a:spcBef>
-              <a:spcAft>
-                <a:spcPts val="600"/>
-              </a:spcAft>
-              <a:buNone/>
-            </a:pPr>
-            <a:r>
-              <a:rPr lang="pt-BR" sz="1550" dirty="0">
-                <a:solidFill>
-                  <a:srgbClr val="111111"/>
-                </a:solidFill>
-                <a:latin typeface="Canva Sans"/>
-                <a:ea typeface="Canva Sans"/>
-                <a:cs typeface="Canva Sans"/>
-                <a:sym typeface="Canva Sans"/>
-              </a:rPr>
-              <a:t>BRASIL. </a:t>
-            </a:r>
-            <a:r>
-              <a:rPr lang="pt-BR" sz="1550" b="1" dirty="0">
-                <a:solidFill>
-                  <a:srgbClr val="111111"/>
-                </a:solidFill>
-                <a:latin typeface="Canva Sans Bold"/>
-                <a:ea typeface="Canva Sans Bold"/>
-                <a:cs typeface="Canva Sans Bold"/>
-                <a:sym typeface="Canva Sans Bold"/>
-              </a:rPr>
-              <a:t>Lei nº 14.533, de 11 de janeiro de 2023</a:t>
-            </a:r>
-            <a:r>
-              <a:rPr lang="pt-BR" sz="1550" dirty="0">
-                <a:solidFill>
-                  <a:srgbClr val="111111"/>
-                </a:solidFill>
-                <a:latin typeface="Canva Sans"/>
-                <a:ea typeface="Canva Sans"/>
-                <a:cs typeface="Canva Sans"/>
-                <a:sym typeface="Canva Sans"/>
-              </a:rPr>
-              <a:t>. Institui a Política Nacional de Educação Digital. Brasília, DF: Presidência da República, 2023.</a:t>
-            </a:r>
-            <a:endParaRPr lang="pt-BR" sz="1550" dirty="0"/>
-          </a:p>
           <a:p>
             <a:pPr algn="l">
               <a:lnSpc>

</xml_diff>

<commit_message>
Retira o objetivo (a) e divide o antigo (d) em formas de atuação e implicações para as crianças
Co-Authored-By: Claude Opus 5.5 <noreply@anthropic.com>
Claude-Session: https://claude.ai/code/session_01HxStpW4pQoDfJdTDYr6zEC
</commit_message>
<xml_diff>
--- a/apresentacao_qualificacao/Qualificacao_PNED_Pipa.pptx
+++ b/apresentacao_qualificacao/Qualificacao_PNED_Pipa.pptx
@@ -7148,7 +7148,7 @@
                 <a:cs typeface="Canva Sans Bold"/>
                 <a:sym typeface="Canva Sans Bold"/>
               </a:rPr>
-              <a:t>DO MUNICÍPIO A PIPA</a:t>
+              <a:t>INTERPRETAÇÃO</a:t>
             </a:r>
             <a:endParaRPr lang="pt-BR" sz="2175" dirty="0"/>
           </a:p>
@@ -7166,7 +7166,7 @@
               <a:buNone/>
             </a:pPr>
             <a:r>
-              <a:rPr lang="pt-BR" sz="1812" dirty="0">
+              <a:rPr lang="pt-BR" sz="1958" dirty="0">
                 <a:solidFill>
                   <a:srgbClr val="111111"/>
                 </a:solidFill>
@@ -7178,7 +7178,7 @@
               <a:t>a) </a:t>
             </a:r>
             <a:r>
-              <a:rPr lang="pt-BR" sz="1812" b="1" dirty="0">
+              <a:rPr lang="pt-BR" sz="1958" b="1" dirty="0">
                 <a:solidFill>
                   <a:srgbClr val="111111"/>
                 </a:solidFill>
@@ -7187,10 +7187,10 @@
                 <a:cs typeface="Canva Sans Bold"/>
                 <a:sym typeface="Canva Sans Bold"/>
               </a:rPr>
-              <a:t>Analisar</a:t>
-            </a:r>
-            <a:r>
-              <a:rPr lang="pt-BR" sz="1812" dirty="0">
+              <a:t>Compreender</a:t>
+            </a:r>
+            <a:r>
+              <a:rPr lang="pt-BR" sz="1958" dirty="0">
                 <a:solidFill>
                   <a:srgbClr val="111111"/>
                 </a:solidFill>
@@ -7199,9 +7199,9 @@
                 <a:cs typeface="Canva Sans"/>
                 <a:sym typeface="Canva Sans"/>
               </a:rPr>
-              <a:t> a recontextualização da PNED pela Secretaria Municipal de Educação em planos, currículos, formações e orientações para a rede, considerando as especificidades das localidades do município, entre elas as áreas rurais e a comunidade quilombola de Sibaúma, até chegar a Pipa;</a:t>
-            </a:r>
-            <a:endParaRPr lang="pt-BR" sz="1812" dirty="0"/>
+              <a:t> a interpretação da PNED e das orientações municipais pelos profissionais da escola, à luz de suas experiências, crenças, valores e formas de organização do trabalho;</a:t>
+            </a:r>
+            <a:endParaRPr lang="pt-BR" sz="1958" dirty="0"/>
           </a:p>
         </p:txBody>
       </p:sp>
@@ -7309,7 +7309,7 @@
                 <a:cs typeface="Canva Sans Bold"/>
                 <a:sym typeface="Canva Sans Bold"/>
               </a:rPr>
-              <a:t>INTERPRETAÇÃO</a:t>
+              <a:t>CONDIÇÕES E TERRITÓRIO</a:t>
             </a:r>
             <a:endParaRPr lang="pt-BR" sz="2175" dirty="0"/>
           </a:p>
@@ -7327,7 +7327,7 @@
               <a:buNone/>
             </a:pPr>
             <a:r>
-              <a:rPr lang="pt-BR" sz="1812" dirty="0">
+              <a:rPr lang="pt-BR" sz="1958" dirty="0">
                 <a:solidFill>
                   <a:srgbClr val="111111"/>
                 </a:solidFill>
@@ -7339,7 +7339,7 @@
               <a:t>b) </a:t>
             </a:r>
             <a:r>
-              <a:rPr lang="pt-BR" sz="1812" b="1" dirty="0">
+              <a:rPr lang="pt-BR" sz="1958" b="1" dirty="0">
                 <a:solidFill>
                   <a:srgbClr val="111111"/>
                 </a:solidFill>
@@ -7348,10 +7348,10 @@
                 <a:cs typeface="Canva Sans Bold"/>
                 <a:sym typeface="Canva Sans Bold"/>
               </a:rPr>
-              <a:t>Compreender</a:t>
-            </a:r>
-            <a:r>
-              <a:rPr lang="pt-BR" sz="1812" dirty="0">
+              <a:t>Examinar</a:t>
+            </a:r>
+            <a:r>
+              <a:rPr lang="pt-BR" sz="1958" dirty="0">
                 <a:solidFill>
                   <a:srgbClr val="111111"/>
                 </a:solidFill>
@@ -7360,9 +7360,9 @@
                 <a:cs typeface="Canva Sans"/>
                 <a:sym typeface="Canva Sans"/>
               </a:rPr>
-              <a:t> a interpretação da PNED e das orientações municipais pelos profissionais da escola, à luz de suas experiências, crenças, valores e formas de organização do trabalho;</a:t>
-            </a:r>
-            <a:endParaRPr lang="pt-BR" sz="1812" dirty="0"/>
+              <a:t> a relação entre as condições materiais e institucionais da escola, articuladas às especificidades de Pipa no território municipal, e a tradução da política em ações, escolhas e práticas cotidianas;</a:t>
+            </a:r>
+            <a:endParaRPr lang="pt-BR" sz="1958" dirty="0"/>
           </a:p>
         </p:txBody>
       </p:sp>
@@ -7470,7 +7470,7 @@
                 <a:cs typeface="Canva Sans Bold"/>
                 <a:sym typeface="Canva Sans Bold"/>
               </a:rPr>
-              <a:t>CONDIÇÕES E TERRITÓRIO</a:t>
+              <a:t>FORMAS DE ATUAÇÃO</a:t>
             </a:r>
             <a:endParaRPr lang="pt-BR" sz="2175" dirty="0"/>
           </a:p>
@@ -7488,7 +7488,7 @@
               <a:buNone/>
             </a:pPr>
             <a:r>
-              <a:rPr lang="pt-BR" sz="1812" dirty="0">
+              <a:rPr lang="pt-BR" sz="1958" dirty="0">
                 <a:solidFill>
                   <a:srgbClr val="111111"/>
                 </a:solidFill>
@@ -7500,7 +7500,7 @@
               <a:t>c) </a:t>
             </a:r>
             <a:r>
-              <a:rPr lang="pt-BR" sz="1812" b="1" dirty="0">
+              <a:rPr lang="pt-BR" sz="1958" b="1" dirty="0">
                 <a:solidFill>
                   <a:srgbClr val="111111"/>
                 </a:solidFill>
@@ -7509,10 +7509,10 @@
                 <a:cs typeface="Canva Sans Bold"/>
                 <a:sym typeface="Canva Sans Bold"/>
               </a:rPr>
-              <a:t>Examinar</a:t>
-            </a:r>
-            <a:r>
-              <a:rPr lang="pt-BR" sz="1812" dirty="0">
+              <a:t>Identificar</a:t>
+            </a:r>
+            <a:r>
+              <a:rPr lang="pt-BR" sz="1958" dirty="0">
                 <a:solidFill>
                   <a:srgbClr val="111111"/>
                 </a:solidFill>
@@ -7521,9 +7521,9 @@
                 <a:cs typeface="Canva Sans"/>
                 <a:sym typeface="Canva Sans"/>
               </a:rPr>
-              <a:t> a relação entre as condições materiais e institucionais da escola, articuladas às especificidades de Pipa no território municipal, e a tradução da política em ações, escolhas e práticas cotidianas;</a:t>
-            </a:r>
-            <a:endParaRPr lang="pt-BR" sz="1812" dirty="0"/>
+              <a:t> as formas de atuação produzidas diante da política e das orientações municipais, da adesão à resistência;</a:t>
+            </a:r>
+            <a:endParaRPr lang="pt-BR" sz="1958" dirty="0"/>
           </a:p>
         </p:txBody>
       </p:sp>
@@ -7631,7 +7631,7 @@
                 <a:cs typeface="Canva Sans Bold"/>
                 <a:sym typeface="Canva Sans Bold"/>
               </a:rPr>
-              <a:t>FORMAS DE ATUAÇÃO E CRIANÇAS</a:t>
+              <a:t>CRIANÇAS</a:t>
             </a:r>
             <a:endParaRPr lang="pt-BR" sz="2175" dirty="0"/>
           </a:p>
@@ -7649,7 +7649,7 @@
               <a:buNone/>
             </a:pPr>
             <a:r>
-              <a:rPr lang="pt-BR" sz="1812" dirty="0">
+              <a:rPr lang="pt-BR" sz="1958" dirty="0">
                 <a:solidFill>
                   <a:srgbClr val="111111"/>
                 </a:solidFill>
@@ -7661,7 +7661,7 @@
               <a:t>d) </a:t>
             </a:r>
             <a:r>
-              <a:rPr lang="pt-BR" sz="1812" b="1" dirty="0">
+              <a:rPr lang="pt-BR" sz="1958" b="1" dirty="0">
                 <a:solidFill>
                   <a:srgbClr val="111111"/>
                 </a:solidFill>
@@ -7670,10 +7670,10 @@
                 <a:cs typeface="Canva Sans Bold"/>
                 <a:sym typeface="Canva Sans Bold"/>
               </a:rPr>
-              <a:t>Identificar</a:t>
-            </a:r>
-            <a:r>
-              <a:rPr lang="pt-BR" sz="1812" dirty="0">
+              <a:t>Discutir</a:t>
+            </a:r>
+            <a:r>
+              <a:rPr lang="pt-BR" sz="1958" dirty="0">
                 <a:solidFill>
                   <a:srgbClr val="111111"/>
                 </a:solidFill>
@@ -7682,9 +7682,9 @@
                 <a:cs typeface="Canva Sans"/>
                 <a:sym typeface="Canva Sans"/>
               </a:rPr>
-              <a:t> as formas de atuação produzidas diante da política e das orientações municipais, da adesão à resistência, e suas implicações para a provisão, a proteção e a participação das crianças no ambiente digital.</a:t>
-            </a:r>
-            <a:endParaRPr lang="pt-BR" sz="1812" dirty="0"/>
+              <a:t> as implicações dessas formas de atuação para a provisão, a proteção e a participação das crianças no ambiente digital.</a:t>
+            </a:r>
+            <a:endParaRPr lang="pt-BR" sz="1958" dirty="0"/>
           </a:p>
         </p:txBody>
       </p:sp>

</xml_diff>

<commit_message>
Reorganiza os slides teóricos sem repetição e dá ao digital um slide próprio
Slide 15 passa a tratar do digital (habitar o digital, por que ensiná-lo e o
ambiente de plataformas e dados); o território fica no slide 14, com Castells;
as condições de trabalho (Queiroz e Paiva) entram no slide 13. Referências
equilibradas por tamanho.

Co-Authored-By: Claude Opus 5.5 <noreply@anthropic.com>
Claude-Session: https://claude.ai/code/session_01HxStpW4pQoDfJdTDYr6zEC
</commit_message>
<xml_diff>
--- a/apresentacao_qualificacao/Qualificacao_PNED_Pipa.pptx
+++ b/apresentacao_qualificacao/Qualificacao_PNED_Pipa.pptx
@@ -14283,7 +14283,7 @@
                 <a:cs typeface="Canva Sans"/>
                 <a:sym typeface="Canva Sans"/>
               </a:rPr>
-              <a:t>Prestação de contas por julgamentos, comparações e exposições (BALL, 2008, p. 49); fabricação: a escola produzida para ser vista (BALL, 2002)</a:t>
+              <a:t>Prestação de contas por julgamentos, comparações e exposições (BALL, 2008, p. 49); fabricação (BALL, 2002); sobre um tempo de trabalho já ocupado (QUEIROZ; PAIVA, 2014)</a:t>
             </a:r>
             <a:endParaRPr lang="pt-BR" sz="1958" dirty="0"/>
           </a:p>
@@ -14952,7 +14952,7 @@
                 <a:cs typeface="Canva Sans"/>
                 <a:sym typeface="Canva Sans"/>
               </a:rPr>
-              <a:t>território, lugar e habitar o digital</a:t>
+              <a:t>território e lugar</a:t>
             </a:r>
             <a:endParaRPr lang="pt-BR" sz="3000" dirty="0"/>
           </a:p>
@@ -15148,12 +15148,12 @@
                 <a:cs typeface="Canva Sans Bold"/>
                 <a:sym typeface="Canva Sans Bold"/>
               </a:rPr>
-              <a:t>Habitar o digital</a:t>
+              <a:t>Em Pipa</a:t>
             </a:r>
             <a:endParaRPr lang="pt-BR" sz="2755" dirty="0"/>
           </a:p>
           <a:p>
-            <a:pPr algn="l">
+            <a:pPr algn="l" marL="270000" indent="-270000">
               <a:lnSpc>
                 <a:spcPct val="100000"/>
               </a:lnSpc>
@@ -15161,39 +15161,17 @@
                 <a:spcPts val="0"/>
               </a:spcBef>
               <a:spcAft>
-                <a:spcPts val="869"/>
-              </a:spcAft>
-              <a:buNone/>
-            </a:pPr>
-            <a:r>
-              <a:rPr lang="pt-BR" sz="2030" b="1" dirty="0">
-                <a:solidFill>
-                  <a:srgbClr val="111111"/>
-                </a:solidFill>
-                <a:latin typeface="Canva Sans Bold"/>
-                <a:ea typeface="Canva Sans Bold"/>
-                <a:cs typeface="Canva Sans Bold"/>
-                <a:sym typeface="Canva Sans Bold"/>
-              </a:rPr>
-              <a:t>Maneiras pelas quais as tecnologias digitais atravessam os espaços, as relações e as práticas cotidianas de um território, produzindo possibilidades desiguais de acesso, participação e apropriação.</a:t>
-            </a:r>
-            <a:endParaRPr lang="pt-BR" sz="2030" dirty="0"/>
-          </a:p>
-          <a:p>
-            <a:pPr algn="l">
-              <a:lnSpc>
-                <a:spcPct val="100000"/>
-              </a:lnSpc>
-              <a:spcBef>
-                <a:spcPts val="0"/>
-              </a:spcBef>
-              <a:spcAft>
-                <a:spcPts val="869"/>
-              </a:spcAft>
-              <a:buNone/>
-            </a:pPr>
-            <a:r>
-              <a:rPr lang="pt-BR" sz="1885" dirty="0">
+                <a:spcPts val="725"/>
+              </a:spcAft>
+              <a:buClr>
+                <a:srgbClr val="111111"/>
+              </a:buClr>
+              <a:buSzPct val="100000"/>
+              <a:buFont typeface="Arial"/>
+              <a:buChar char="•"/>
+            </a:pPr>
+            <a:r>
+              <a:rPr lang="pt-BR" sz="2030" dirty="0">
                 <a:solidFill>
                   <a:srgbClr val="111111"/>
                 </a:solidFill>
@@ -15202,9 +15180,73 @@
                 <a:cs typeface="Canva Sans"/>
                 <a:sym typeface="Canva Sans"/>
               </a:rPr>
-              <a:t>Com Schlemmer, Backes e Palagi (2021) e Di Felice (2009); plataformas e dados como contexto (ZUBOFF, 2021; SILVEIRA, 2017; MOROZOV, 2018; PRETTO; CORDEIRO; OLIVEIRA, 2013).</a:t>
-            </a:r>
-            <a:endParaRPr lang="pt-BR" sz="1885" dirty="0"/>
+              <a:t>“Dissonância entre os usos econômicos e os usos sociais dos mesmos recursos” (SANTOS, 1999, p. 20-21): densidade tecnológica no turismo, escassez nas salas da escola</a:t>
+            </a:r>
+            <a:endParaRPr lang="pt-BR" sz="2030" dirty="0"/>
+          </a:p>
+          <a:p>
+            <a:pPr algn="l" marL="270000" indent="-270000">
+              <a:lnSpc>
+                <a:spcPct val="100000"/>
+              </a:lnSpc>
+              <a:spcBef>
+                <a:spcPts val="0"/>
+              </a:spcBef>
+              <a:spcAft>
+                <a:spcPts val="725"/>
+              </a:spcAft>
+              <a:buClr>
+                <a:srgbClr val="111111"/>
+              </a:buClr>
+              <a:buSzPct val="100000"/>
+              <a:buFont typeface="Arial"/>
+              <a:buChar char="•"/>
+            </a:pPr>
+            <a:r>
+              <a:rPr lang="pt-BR" sz="2030" dirty="0">
+                <a:solidFill>
+                  <a:srgbClr val="111111"/>
+                </a:solidFill>
+                <a:latin typeface="Canva Sans"/>
+                <a:ea typeface="Canva Sans"/>
+                <a:cs typeface="Canva Sans"/>
+                <a:sym typeface="Canva Sans"/>
+              </a:rPr>
+              <a:t>Espaço de fluxos: circuitos que ultrapassam o lugar (CASTELLS, 2013, p. 437)</a:t>
+            </a:r>
+            <a:endParaRPr lang="pt-BR" sz="2030" dirty="0"/>
+          </a:p>
+          <a:p>
+            <a:pPr algn="l" marL="270000" indent="-270000">
+              <a:lnSpc>
+                <a:spcPct val="100000"/>
+              </a:lnSpc>
+              <a:spcBef>
+                <a:spcPts val="0"/>
+              </a:spcBef>
+              <a:spcAft>
+                <a:spcPts val="725"/>
+              </a:spcAft>
+              <a:buClr>
+                <a:srgbClr val="111111"/>
+              </a:buClr>
+              <a:buSzPct val="100000"/>
+              <a:buFont typeface="Arial"/>
+              <a:buChar char="•"/>
+            </a:pPr>
+            <a:r>
+              <a:rPr lang="pt-BR" sz="2030" dirty="0">
+                <a:solidFill>
+                  <a:srgbClr val="111111"/>
+                </a:solidFill>
+                <a:latin typeface="Canva Sans"/>
+                <a:ea typeface="Canva Sans"/>
+                <a:cs typeface="Canva Sans"/>
+                <a:sym typeface="Canva Sans"/>
+              </a:rPr>
+              <a:t>Contra a operação que “transforma a geografia em história, o espaço em tempo” (MASSEY, 2008, p. 24): escola e polo turístico são contemporâneos</a:t>
+            </a:r>
+            <a:endParaRPr lang="pt-BR" sz="2030" dirty="0"/>
           </a:p>
         </p:txBody>
       </p:sp>
@@ -15375,7 +15417,7 @@
                 <a:cs typeface="Canva Sans Bold"/>
                 <a:sym typeface="Canva Sans Bold"/>
               </a:rPr>
-              <a:t>CONCEITOS E TEÓRICOS</a:t>
+              <a:t>O DIGITAL</a:t>
             </a:r>
             <a:endParaRPr lang="pt-BR" sz="4000" dirty="0"/>
           </a:p>
@@ -15402,7 +15444,7 @@
                 <a:cs typeface="Canva Sans"/>
                 <a:sym typeface="Canva Sans"/>
               </a:rPr>
-              <a:t>o que guia a leitura da tese</a:t>
+              <a:t>o que atravessa a tese e por que ela é necessária</a:t>
             </a:r>
             <a:endParaRPr lang="pt-BR" sz="2400" dirty="0"/>
           </a:p>
@@ -15416,8 +15458,8 @@
         </p:nvSpPr>
         <p:spPr>
           <a:xfrm>
-            <a:off x="612000" y="2232000"/>
-            <a:ext cx="4104000" cy="6408000"/>
+            <a:off x="612000" y="2160000"/>
+            <a:ext cx="5526000" cy="6804000"/>
           </a:xfrm>
           <a:prstGeom prst="roundRect">
             <a:avLst>
@@ -15434,7 +15476,7 @@
           </a:ln>
         </p:spPr>
         <p:txBody>
-          <a:bodyPr wrap="square" lIns="198000" tIns="198000" rIns="198000" bIns="198000" anchor="t" rtlCol="0">
+          <a:bodyPr wrap="square" lIns="216000" tIns="216000" rIns="216000" bIns="216000" anchor="t" rtlCol="0">
             <a:noAutofit/>
           </a:bodyPr>
           <a:lstStyle/>
@@ -15452,7 +15494,7 @@
               <a:buNone/>
             </a:pPr>
             <a:r>
-              <a:rPr lang="pt-BR" sz="2610" b="1" dirty="0">
+              <a:rPr lang="pt-BR" sz="2465" b="1" dirty="0">
                 <a:solidFill>
                   <a:srgbClr val="111111"/>
                 </a:solidFill>
@@ -15461,20 +15503,20 @@
                 <a:cs typeface="Canva Sans Bold"/>
                 <a:sym typeface="Canva Sans Bold"/>
               </a:rPr>
-              <a:t>A POLÍTICA</a:t>
-            </a:r>
-            <a:endParaRPr lang="pt-BR" sz="2610" dirty="0"/>
+              <a:t>HABITAR O DIGITAL</a:t>
+            </a:r>
+            <a:endParaRPr lang="pt-BR" sz="2465" dirty="0"/>
           </a:p>
           <a:p>
             <a:pPr algn="l">
               <a:lnSpc>
-                <a:spcPct val="95000"/>
-              </a:lnSpc>
-              <a:spcBef>
-                <a:spcPts val="0"/>
-              </a:spcBef>
-              <a:spcAft>
-                <a:spcPts val="290"/>
+                <a:spcPct val="98000"/>
+              </a:lnSpc>
+              <a:spcBef>
+                <a:spcPts val="0"/>
+              </a:spcBef>
+              <a:spcAft>
+                <a:spcPts val="1739"/>
               </a:spcAft>
               <a:buNone/>
             </a:pPr>
@@ -15488,25 +15530,25 @@
                 <a:cs typeface="Canva Sans Bold"/>
                 <a:sym typeface="Canva Sans Bold"/>
               </a:rPr>
-              <a:t>Ciclo de políticas: influência, produção do texto, prática</a:t>
+              <a:t>Maneiras pelas quais as tecnologias digitais atravessam os espaços, as relações e as práticas cotidianas de um território, produzindo possibilidades desiguais de acesso, participação e apropriação.</a:t>
             </a:r>
             <a:endParaRPr lang="pt-BR" sz="2175" dirty="0"/>
           </a:p>
           <a:p>
             <a:pPr algn="l">
               <a:lnSpc>
-                <a:spcPct val="95000"/>
-              </a:lnSpc>
-              <a:spcBef>
-                <a:spcPts val="0"/>
-              </a:spcBef>
-              <a:spcAft>
-                <a:spcPts val="1739"/>
-              </a:spcAft>
-              <a:buNone/>
-            </a:pPr>
-            <a:r>
-              <a:rPr lang="pt-BR" sz="1958" dirty="0">
+                <a:spcPct val="98000"/>
+              </a:lnSpc>
+              <a:spcBef>
+                <a:spcPts val="0"/>
+              </a:spcBef>
+              <a:spcAft>
+                <a:spcPts val="145"/>
+              </a:spcAft>
+              <a:buNone/>
+            </a:pPr>
+            <a:r>
+              <a:rPr lang="pt-BR" sz="2102" dirty="0">
                 <a:solidFill>
                   <a:srgbClr val="111111"/>
                 </a:solidFill>
@@ -15515,9 +15557,9 @@
                 <a:cs typeface="Canva Sans"/>
                 <a:sym typeface="Canva Sans"/>
               </a:rPr>
-              <a:t>Bowe, Ball e Gold (1992); Mainardes (2006)</a:t>
-            </a:r>
-            <a:endParaRPr lang="pt-BR" sz="1958" dirty="0"/>
+              <a:t>Habitar “tem o significado de estar presente” e “natureza relacional”</a:t>
+            </a:r>
+            <a:endParaRPr lang="pt-BR" sz="2102" dirty="0"/>
           </a:p>
           <a:p>
             <a:pPr algn="l">
@@ -15528,12 +15570,12 @@
                 <a:spcPts val="0"/>
               </a:spcBef>
               <a:spcAft>
-                <a:spcPts val="290"/>
-              </a:spcAft>
-              <a:buNone/>
-            </a:pPr>
-            <a:r>
-              <a:rPr lang="pt-BR" sz="2175" b="1" dirty="0">
+                <a:spcPts val="1739"/>
+              </a:spcAft>
+              <a:buNone/>
+            </a:pPr>
+            <a:r>
+              <a:rPr lang="pt-BR" sz="1885" b="1" dirty="0">
                 <a:solidFill>
                   <a:srgbClr val="111111"/>
                 </a:solidFill>
@@ -15542,25 +15584,25 @@
                 <a:cs typeface="Canva Sans Bold"/>
                 <a:sym typeface="Canva Sans Bold"/>
               </a:rPr>
-              <a:t>Atuação (encenação): interpretar e traduzir</a:t>
-            </a:r>
-            <a:endParaRPr lang="pt-BR" sz="2175" dirty="0"/>
+              <a:t>Schlemmer, Backes e Palagi (2021, p. 15)</a:t>
+            </a:r>
+            <a:endParaRPr lang="pt-BR" sz="1885" dirty="0"/>
           </a:p>
           <a:p>
             <a:pPr algn="l">
               <a:lnSpc>
-                <a:spcPct val="95000"/>
-              </a:lnSpc>
-              <a:spcBef>
-                <a:spcPts val="0"/>
-              </a:spcBef>
-              <a:spcAft>
-                <a:spcPts val="1739"/>
-              </a:spcAft>
-              <a:buNone/>
-            </a:pPr>
-            <a:r>
-              <a:rPr lang="pt-BR" sz="1958" dirty="0">
+                <a:spcPct val="98000"/>
+              </a:lnSpc>
+              <a:spcBef>
+                <a:spcPts val="0"/>
+              </a:spcBef>
+              <a:spcAft>
+                <a:spcPts val="145"/>
+              </a:spcAft>
+              <a:buNone/>
+            </a:pPr>
+            <a:r>
+              <a:rPr lang="pt-BR" sz="2102" dirty="0">
                 <a:solidFill>
                   <a:srgbClr val="111111"/>
                 </a:solidFill>
@@ -15569,9 +15611,9 @@
                 <a:cs typeface="Canva Sans"/>
                 <a:sym typeface="Canva Sans"/>
               </a:rPr>
-              <a:t>Ball, Maguire e Braun (2016)</a:t>
-            </a:r>
-            <a:endParaRPr lang="pt-BR" sz="1958" dirty="0"/>
+              <a:t>Habitar atópico, em ecossistemas informativos</a:t>
+            </a:r>
+            <a:endParaRPr lang="pt-BR" sz="2102" dirty="0"/>
           </a:p>
           <a:p>
             <a:pPr algn="l">
@@ -15582,12 +15624,12 @@
                 <a:spcPts val="0"/>
               </a:spcBef>
               <a:spcAft>
-                <a:spcPts val="290"/>
-              </a:spcAft>
-              <a:buNone/>
-            </a:pPr>
-            <a:r>
-              <a:rPr lang="pt-BR" sz="2175" b="1" dirty="0">
+                <a:spcPts val="1739"/>
+              </a:spcAft>
+              <a:buNone/>
+            </a:pPr>
+            <a:r>
+              <a:rPr lang="pt-BR" sz="1885" b="1" dirty="0">
                 <a:solidFill>
                   <a:srgbClr val="111111"/>
                 </a:solidFill>
@@ -15596,36 +15638,9 @@
                 <a:cs typeface="Canva Sans Bold"/>
                 <a:sym typeface="Canva Sans Bold"/>
               </a:rPr>
-              <a:t>Recontextualização: a política "recriada" na prática</a:t>
-            </a:r>
-            <a:endParaRPr lang="pt-BR" sz="2175" dirty="0"/>
-          </a:p>
-          <a:p>
-            <a:pPr algn="l">
-              <a:lnSpc>
-                <a:spcPct val="95000"/>
-              </a:lnSpc>
-              <a:spcBef>
-                <a:spcPts val="0"/>
-              </a:spcBef>
-              <a:spcAft>
-                <a:spcPts val="1739"/>
-              </a:spcAft>
-              <a:buNone/>
-            </a:pPr>
-            <a:r>
-              <a:rPr lang="pt-BR" sz="1958" dirty="0">
-                <a:solidFill>
-                  <a:srgbClr val="111111"/>
-                </a:solidFill>
-                <a:latin typeface="Canva Sans"/>
-                <a:ea typeface="Canva Sans"/>
-                <a:cs typeface="Canva Sans"/>
-                <a:sym typeface="Canva Sans"/>
-              </a:rPr>
-              <a:t>Bowe, Ball e Gold (1992, p. 22)</a:t>
-            </a:r>
-            <a:endParaRPr lang="pt-BR" sz="1958" dirty="0"/>
+              <a:t>Di Felice (2009)</a:t>
+            </a:r>
+            <a:endParaRPr lang="pt-BR" sz="1885" dirty="0"/>
           </a:p>
         </p:txBody>
       </p:sp>
@@ -15637,8 +15652,8 @@
         </p:nvSpPr>
         <p:spPr>
           <a:xfrm>
-            <a:off x="4914000" y="2232000"/>
-            <a:ext cx="4104000" cy="6408000"/>
+            <a:off x="6354000" y="2160000"/>
+            <a:ext cx="5526000" cy="6804000"/>
           </a:xfrm>
           <a:prstGeom prst="roundRect">
             <a:avLst>
@@ -15655,7 +15670,7 @@
           </a:ln>
         </p:spPr>
         <p:txBody>
-          <a:bodyPr wrap="square" lIns="198000" tIns="198000" rIns="198000" bIns="198000" anchor="t" rtlCol="0">
+          <a:bodyPr wrap="square" lIns="216000" tIns="216000" rIns="216000" bIns="216000" anchor="t" rtlCol="0">
             <a:noAutofit/>
           </a:bodyPr>
           <a:lstStyle/>
@@ -15673,7 +15688,7 @@
               <a:buNone/>
             </a:pPr>
             <a:r>
-              <a:rPr lang="pt-BR" sz="2610" b="1" dirty="0">
+              <a:rPr lang="pt-BR" sz="2465" b="1" dirty="0">
                 <a:solidFill>
                   <a:srgbClr val="111111"/>
                 </a:solidFill>
@@ -15682,25 +15697,52 @@
                 <a:cs typeface="Canva Sans Bold"/>
                 <a:sym typeface="Canva Sans Bold"/>
               </a:rPr>
-              <a:t>OS PROFISSIONAIS</a:t>
-            </a:r>
-            <a:endParaRPr lang="pt-BR" sz="2610" dirty="0"/>
+              <a:t>POR QUE ENSINAR O DIGITAL</a:t>
+            </a:r>
+            <a:endParaRPr lang="pt-BR" sz="2465" dirty="0"/>
           </a:p>
           <a:p>
             <a:pPr algn="l">
               <a:lnSpc>
+                <a:spcPct val="98000"/>
+              </a:lnSpc>
+              <a:spcBef>
+                <a:spcPts val="0"/>
+              </a:spcBef>
+              <a:spcAft>
+                <a:spcPts val="145"/>
+              </a:spcAft>
+              <a:buNone/>
+            </a:pPr>
+            <a:r>
+              <a:rPr lang="pt-BR" sz="2102" dirty="0">
+                <a:solidFill>
+                  <a:srgbClr val="111111"/>
+                </a:solidFill>
+                <a:latin typeface="Canva Sans"/>
+                <a:ea typeface="Canva Sans"/>
+                <a:cs typeface="Canva Sans"/>
+                <a:sym typeface="Canva Sans"/>
+              </a:rPr>
+              <a:t>“As crianças não sabem ‘naturalmente’ como usar computadores”</a:t>
+            </a:r>
+            <a:endParaRPr lang="pt-BR" sz="2102" dirty="0"/>
+          </a:p>
+          <a:p>
+            <a:pPr algn="l">
+              <a:lnSpc>
                 <a:spcPct val="95000"/>
               </a:lnSpc>
               <a:spcBef>
                 <a:spcPts val="0"/>
               </a:spcBef>
               <a:spcAft>
-                <a:spcPts val="290"/>
-              </a:spcAft>
-              <a:buNone/>
-            </a:pPr>
-            <a:r>
-              <a:rPr lang="pt-BR" sz="2175" b="1" dirty="0">
+                <a:spcPts val="1739"/>
+              </a:spcAft>
+              <a:buNone/>
+            </a:pPr>
+            <a:r>
+              <a:rPr lang="pt-BR" sz="1885" b="1" dirty="0">
                 <a:solidFill>
                   <a:srgbClr val="111111"/>
                 </a:solidFill>
@@ -15709,25 +15751,25 @@
                 <a:cs typeface="Canva Sans Bold"/>
                 <a:sym typeface="Canva Sans Bold"/>
               </a:rPr>
-              <a:t>Culturas profissionais</a:t>
-            </a:r>
-            <a:endParaRPr lang="pt-BR" sz="2175" dirty="0"/>
+              <a:t>Buckingham (2006, p. 39)</a:t>
+            </a:r>
+            <a:endParaRPr lang="pt-BR" sz="1885" dirty="0"/>
           </a:p>
           <a:p>
             <a:pPr algn="l">
               <a:lnSpc>
-                <a:spcPct val="95000"/>
-              </a:lnSpc>
-              <a:spcBef>
-                <a:spcPts val="0"/>
-              </a:spcBef>
-              <a:spcAft>
-                <a:spcPts val="1739"/>
-              </a:spcAft>
-              <a:buNone/>
-            </a:pPr>
-            <a:r>
-              <a:rPr lang="pt-BR" sz="1958" dirty="0">
+                <a:spcPct val="98000"/>
+              </a:lnSpc>
+              <a:spcBef>
+                <a:spcPts val="0"/>
+              </a:spcBef>
+              <a:spcAft>
+                <a:spcPts val="145"/>
+              </a:spcAft>
+              <a:buNone/>
+            </a:pPr>
+            <a:r>
+              <a:rPr lang="pt-BR" sz="2102" dirty="0">
                 <a:solidFill>
                   <a:srgbClr val="111111"/>
                 </a:solidFill>
@@ -15736,9 +15778,9 @@
                 <a:cs typeface="Canva Sans"/>
                 <a:sym typeface="Canva Sans"/>
               </a:rPr>
-              <a:t>Hargreaves (2005)</a:t>
-            </a:r>
-            <a:endParaRPr lang="pt-BR" sz="1958" dirty="0"/>
+              <a:t>Computadores “sem o devido preparo de professores e da comunidade escolar” não trazem os benefícios esperados</a:t>
+            </a:r>
+            <a:endParaRPr lang="pt-BR" sz="2102" dirty="0"/>
           </a:p>
           <a:p>
             <a:pPr algn="l">
@@ -15749,12 +15791,12 @@
                 <a:spcPts val="0"/>
               </a:spcBef>
               <a:spcAft>
-                <a:spcPts val="290"/>
-              </a:spcAft>
-              <a:buNone/>
-            </a:pPr>
-            <a:r>
-              <a:rPr lang="pt-BR" sz="2175" b="1" dirty="0">
+                <a:spcPts val="1739"/>
+              </a:spcAft>
+              <a:buNone/>
+            </a:pPr>
+            <a:r>
+              <a:rPr lang="pt-BR" sz="1885" b="1" dirty="0">
                 <a:solidFill>
                   <a:srgbClr val="111111"/>
                 </a:solidFill>
@@ -15763,25 +15805,25 @@
                 <a:cs typeface="Canva Sans Bold"/>
                 <a:sym typeface="Canva Sans Bold"/>
               </a:rPr>
-              <a:t>Performatividade e fabricação</a:t>
-            </a:r>
-            <a:endParaRPr lang="pt-BR" sz="2175" dirty="0"/>
+              <a:t>Valente (1999, p. 83)</a:t>
+            </a:r>
+            <a:endParaRPr lang="pt-BR" sz="1885" dirty="0"/>
           </a:p>
           <a:p>
             <a:pPr algn="l">
               <a:lnSpc>
-                <a:spcPct val="95000"/>
-              </a:lnSpc>
-              <a:spcBef>
-                <a:spcPts val="0"/>
-              </a:spcBef>
-              <a:spcAft>
-                <a:spcPts val="1739"/>
-              </a:spcAft>
-              <a:buNone/>
-            </a:pPr>
-            <a:r>
-              <a:rPr lang="pt-BR" sz="1958" dirty="0">
+                <a:spcPct val="98000"/>
+              </a:lnSpc>
+              <a:spcBef>
+                <a:spcPts val="0"/>
+              </a:spcBef>
+              <a:spcAft>
+                <a:spcPts val="145"/>
+              </a:spcAft>
+              <a:buNone/>
+            </a:pPr>
+            <a:r>
+              <a:rPr lang="pt-BR" sz="2102" dirty="0">
                 <a:solidFill>
                   <a:srgbClr val="111111"/>
                 </a:solidFill>
@@ -15790,9 +15832,9 @@
                 <a:cs typeface="Canva Sans"/>
                 <a:sym typeface="Canva Sans"/>
               </a:rPr>
-              <a:t>Ball (2002; 2008)</a:t>
-            </a:r>
-            <a:endParaRPr lang="pt-BR" sz="1958" dirty="0"/>
+              <a:t>Ser excluído das redes é “uma das formas mais danosas de exclusão”</a:t>
+            </a:r>
+            <a:endParaRPr lang="pt-BR" sz="2102" dirty="0"/>
           </a:p>
           <a:p>
             <a:pPr algn="l">
@@ -15803,12 +15845,12 @@
                 <a:spcPts val="0"/>
               </a:spcBef>
               <a:spcAft>
-                <a:spcPts val="290"/>
-              </a:spcAft>
-              <a:buNone/>
-            </a:pPr>
-            <a:r>
-              <a:rPr lang="pt-BR" sz="2175" b="1" dirty="0">
+                <a:spcPts val="1739"/>
+              </a:spcAft>
+              <a:buNone/>
+            </a:pPr>
+            <a:r>
+              <a:rPr lang="pt-BR" sz="1885" b="1" dirty="0">
                 <a:solidFill>
                   <a:srgbClr val="111111"/>
                 </a:solidFill>
@@ -15817,25 +15859,25 @@
                 <a:cs typeface="Canva Sans Bold"/>
                 <a:sym typeface="Canva Sans Bold"/>
               </a:rPr>
-              <a:t>Poder e resistência</a:t>
-            </a:r>
-            <a:endParaRPr lang="pt-BR" sz="2175" dirty="0"/>
+              <a:t>Castells (2003, p. 8)</a:t>
+            </a:r>
+            <a:endParaRPr lang="pt-BR" sz="1885" dirty="0"/>
           </a:p>
           <a:p>
             <a:pPr algn="l">
               <a:lnSpc>
-                <a:spcPct val="95000"/>
-              </a:lnSpc>
-              <a:spcBef>
-                <a:spcPts val="0"/>
-              </a:spcBef>
-              <a:spcAft>
-                <a:spcPts val="1739"/>
-              </a:spcAft>
-              <a:buNone/>
-            </a:pPr>
-            <a:r>
-              <a:rPr lang="pt-BR" sz="1958" dirty="0">
+                <a:spcPct val="98000"/>
+              </a:lnSpc>
+              <a:spcBef>
+                <a:spcPts val="0"/>
+              </a:spcBef>
+              <a:spcAft>
+                <a:spcPts val="0"/>
+              </a:spcAft>
+              <a:buNone/>
+            </a:pPr>
+            <a:r>
+              <a:rPr lang="pt-BR" sz="2102" i="1" dirty="0">
                 <a:solidFill>
                   <a:srgbClr val="111111"/>
                 </a:solidFill>
@@ -15844,63 +15886,9 @@
                 <a:cs typeface="Canva Sans"/>
                 <a:sym typeface="Canva Sans"/>
               </a:rPr>
-              <a:t>Foucault (1999); Ball (2011); Freire (2019)</a:t>
-            </a:r>
-            <a:endParaRPr lang="pt-BR" sz="1958" dirty="0"/>
-          </a:p>
-          <a:p>
-            <a:pPr algn="l">
-              <a:lnSpc>
-                <a:spcPct val="95000"/>
-              </a:lnSpc>
-              <a:spcBef>
-                <a:spcPts val="0"/>
-              </a:spcBef>
-              <a:spcAft>
-                <a:spcPts val="290"/>
-              </a:spcAft>
-              <a:buNone/>
-            </a:pPr>
-            <a:r>
-              <a:rPr lang="pt-BR" sz="2175" b="1" dirty="0">
-                <a:solidFill>
-                  <a:srgbClr val="111111"/>
-                </a:solidFill>
-                <a:latin typeface="Canva Sans Bold"/>
-                <a:ea typeface="Canva Sans Bold"/>
-                <a:cs typeface="Canva Sans Bold"/>
-                <a:sym typeface="Canva Sans Bold"/>
-              </a:rPr>
-              <a:t>Sentidos que organizam ações</a:t>
-            </a:r>
-            <a:endParaRPr lang="pt-BR" sz="2175" dirty="0"/>
-          </a:p>
-          <a:p>
-            <a:pPr algn="l">
-              <a:lnSpc>
-                <a:spcPct val="95000"/>
-              </a:lnSpc>
-              <a:spcBef>
-                <a:spcPts val="0"/>
-              </a:spcBef>
-              <a:spcAft>
-                <a:spcPts val="1739"/>
-              </a:spcAft>
-              <a:buNone/>
-            </a:pPr>
-            <a:r>
-              <a:rPr lang="pt-BR" sz="1958" dirty="0">
-                <a:solidFill>
-                  <a:srgbClr val="111111"/>
-                </a:solidFill>
-                <a:latin typeface="Canva Sans"/>
-                <a:ea typeface="Canva Sans"/>
-                <a:cs typeface="Canva Sans"/>
-                <a:sym typeface="Canva Sans"/>
-              </a:rPr>
-              <a:t>Hall (2006)</a:t>
-            </a:r>
-            <a:endParaRPr lang="pt-BR" sz="1958" dirty="0"/>
+              <a:t>A compreensão do ambiente digital precisa ser ensinada, e é essa tarefa que a PNED atribui à escola.</a:t>
+            </a:r>
+            <a:endParaRPr lang="pt-BR" sz="2102" dirty="0"/>
           </a:p>
         </p:txBody>
       </p:sp>
@@ -15912,229 +15900,8 @@
         </p:nvSpPr>
         <p:spPr>
           <a:xfrm>
-            <a:off x="9216000" y="2232000"/>
-            <a:ext cx="4104000" cy="6408000"/>
-          </a:xfrm>
-          <a:prstGeom prst="roundRect">
-            <a:avLst>
-              <a:gd name="adj" fmla="val 7000"/>
-            </a:avLst>
-          </a:prstGeom>
-          <a:solidFill>
-            <a:srgbClr val="FFFFFF"/>
-          </a:solidFill>
-          <a:ln w="38100">
-            <a:solidFill>
-              <a:srgbClr val="111111"/>
-            </a:solidFill>
-          </a:ln>
-        </p:spPr>
-        <p:txBody>
-          <a:bodyPr wrap="square" lIns="198000" tIns="198000" rIns="198000" bIns="198000" anchor="t" rtlCol="0">
-            <a:noAutofit/>
-          </a:bodyPr>
-          <a:lstStyle/>
-          <a:p>
-            <a:pPr algn="ctr">
-              <a:lnSpc>
-                <a:spcPct val="100000"/>
-              </a:lnSpc>
-              <a:spcBef>
-                <a:spcPts val="0"/>
-              </a:spcBef>
-              <a:spcAft>
-                <a:spcPts val="1739"/>
-              </a:spcAft>
-              <a:buNone/>
-            </a:pPr>
-            <a:r>
-              <a:rPr lang="pt-BR" sz="2610" b="1" dirty="0">
-                <a:solidFill>
-                  <a:srgbClr val="111111"/>
-                </a:solidFill>
-                <a:latin typeface="Canva Sans Bold"/>
-                <a:ea typeface="Canva Sans Bold"/>
-                <a:cs typeface="Canva Sans Bold"/>
-                <a:sym typeface="Canva Sans Bold"/>
-              </a:rPr>
-              <a:t>O TERRITÓRIO</a:t>
-            </a:r>
-            <a:endParaRPr lang="pt-BR" sz="2610" dirty="0"/>
-          </a:p>
-          <a:p>
-            <a:pPr algn="l">
-              <a:lnSpc>
-                <a:spcPct val="95000"/>
-              </a:lnSpc>
-              <a:spcBef>
-                <a:spcPts val="0"/>
-              </a:spcBef>
-              <a:spcAft>
-                <a:spcPts val="290"/>
-              </a:spcAft>
-              <a:buNone/>
-            </a:pPr>
-            <a:r>
-              <a:rPr lang="pt-BR" sz="2175" b="1" dirty="0">
-                <a:solidFill>
-                  <a:srgbClr val="111111"/>
-                </a:solidFill>
-                <a:latin typeface="Canva Sans Bold"/>
-                <a:ea typeface="Canva Sans Bold"/>
-                <a:cs typeface="Canva Sans Bold"/>
-                <a:sym typeface="Canva Sans Bold"/>
-              </a:rPr>
-              <a:t>Território usado e rugosidades</a:t>
-            </a:r>
-            <a:endParaRPr lang="pt-BR" sz="2175" dirty="0"/>
-          </a:p>
-          <a:p>
-            <a:pPr algn="l">
-              <a:lnSpc>
-                <a:spcPct val="95000"/>
-              </a:lnSpc>
-              <a:spcBef>
-                <a:spcPts val="0"/>
-              </a:spcBef>
-              <a:spcAft>
-                <a:spcPts val="1739"/>
-              </a:spcAft>
-              <a:buNone/>
-            </a:pPr>
-            <a:r>
-              <a:rPr lang="pt-BR" sz="1958" dirty="0">
-                <a:solidFill>
-                  <a:srgbClr val="111111"/>
-                </a:solidFill>
-                <a:latin typeface="Canva Sans"/>
-                <a:ea typeface="Canva Sans"/>
-                <a:cs typeface="Canva Sans"/>
-                <a:sym typeface="Canva Sans"/>
-              </a:rPr>
-              <a:t>Santos (1999; 2006; 2012)</a:t>
-            </a:r>
-            <a:endParaRPr lang="pt-BR" sz="1958" dirty="0"/>
-          </a:p>
-          <a:p>
-            <a:pPr algn="l">
-              <a:lnSpc>
-                <a:spcPct val="95000"/>
-              </a:lnSpc>
-              <a:spcBef>
-                <a:spcPts val="0"/>
-              </a:spcBef>
-              <a:spcAft>
-                <a:spcPts val="290"/>
-              </a:spcAft>
-              <a:buNone/>
-            </a:pPr>
-            <a:r>
-              <a:rPr lang="pt-BR" sz="2175" b="1" dirty="0">
-                <a:solidFill>
-                  <a:srgbClr val="111111"/>
-                </a:solidFill>
-                <a:latin typeface="Canva Sans Bold"/>
-                <a:ea typeface="Canva Sans Bold"/>
-                <a:cs typeface="Canva Sans Bold"/>
-                <a:sym typeface="Canva Sans Bold"/>
-              </a:rPr>
-              <a:t>Lugar como encontro de trajetórias</a:t>
-            </a:r>
-            <a:endParaRPr lang="pt-BR" sz="2175" dirty="0"/>
-          </a:p>
-          <a:p>
-            <a:pPr algn="l">
-              <a:lnSpc>
-                <a:spcPct val="95000"/>
-              </a:lnSpc>
-              <a:spcBef>
-                <a:spcPts val="0"/>
-              </a:spcBef>
-              <a:spcAft>
-                <a:spcPts val="1739"/>
-              </a:spcAft>
-              <a:buNone/>
-            </a:pPr>
-            <a:r>
-              <a:rPr lang="pt-BR" sz="1958" dirty="0">
-                <a:solidFill>
-                  <a:srgbClr val="111111"/>
-                </a:solidFill>
-                <a:latin typeface="Canva Sans"/>
-                <a:ea typeface="Canva Sans"/>
-                <a:cs typeface="Canva Sans"/>
-                <a:sym typeface="Canva Sans"/>
-              </a:rPr>
-              <a:t>Massey (2008)</a:t>
-            </a:r>
-            <a:endParaRPr lang="pt-BR" sz="1958" dirty="0"/>
-          </a:p>
-          <a:p>
-            <a:pPr algn="l">
-              <a:lnSpc>
-                <a:spcPct val="95000"/>
-              </a:lnSpc>
-              <a:spcBef>
-                <a:spcPts val="0"/>
-              </a:spcBef>
-              <a:spcAft>
-                <a:spcPts val="290"/>
-              </a:spcAft>
-              <a:buNone/>
-            </a:pPr>
-            <a:r>
-              <a:rPr lang="pt-BR" sz="2175" b="1" dirty="0">
-                <a:solidFill>
-                  <a:srgbClr val="111111"/>
-                </a:solidFill>
-                <a:latin typeface="Canva Sans Bold"/>
-                <a:ea typeface="Canva Sans Bold"/>
-                <a:cs typeface="Canva Sans Bold"/>
-                <a:sym typeface="Canva Sans Bold"/>
-              </a:rPr>
-              <a:t>Habitar e Educação OnLIFE</a:t>
-            </a:r>
-            <a:endParaRPr lang="pt-BR" sz="2175" dirty="0"/>
-          </a:p>
-          <a:p>
-            <a:pPr algn="l">
-              <a:lnSpc>
-                <a:spcPct val="95000"/>
-              </a:lnSpc>
-              <a:spcBef>
-                <a:spcPts val="0"/>
-              </a:spcBef>
-              <a:spcAft>
-                <a:spcPts val="1739"/>
-              </a:spcAft>
-              <a:buNone/>
-            </a:pPr>
-            <a:r>
-              <a:rPr lang="pt-BR" sz="1958" dirty="0">
-                <a:solidFill>
-                  <a:srgbClr val="111111"/>
-                </a:solidFill>
-                <a:latin typeface="Canva Sans"/>
-                <a:ea typeface="Canva Sans"/>
-                <a:cs typeface="Canva Sans"/>
-                <a:sym typeface="Canva Sans"/>
-              </a:rPr>
-              <a:t>Schlemmer, Backes e Palagi (2021); Di Felice (2009)</a:t>
-            </a:r>
-            <a:endParaRPr lang="pt-BR" sz="1958" dirty="0"/>
-          </a:p>
-        </p:txBody>
-      </p:sp>
-      <p:sp>
-        <p:nvSpPr>
-          <p:cNvPr id="205" name="Cartão 205"/>
-          <p:cNvSpPr/>
-          <p:nvPr/>
-        </p:nvSpPr>
-        <p:spPr>
-          <a:xfrm>
-            <a:off x="13518000" y="2232000"/>
-            <a:ext cx="4104000" cy="6408000"/>
+            <a:off x="12096000" y="2160000"/>
+            <a:ext cx="5526000" cy="6804000"/>
           </a:xfrm>
           <a:prstGeom prst="roundRect">
             <a:avLst>
@@ -16151,7 +15918,7 @@
           </a:ln>
         </p:spPr>
         <p:txBody>
-          <a:bodyPr wrap="square" lIns="198000" tIns="198000" rIns="198000" bIns="198000" anchor="t" rtlCol="0">
+          <a:bodyPr wrap="square" lIns="216000" tIns="216000" rIns="216000" bIns="216000" anchor="t" rtlCol="0">
             <a:noAutofit/>
           </a:bodyPr>
           <a:lstStyle/>
@@ -16169,7 +15936,7 @@
               <a:buNone/>
             </a:pPr>
             <a:r>
-              <a:rPr lang="pt-BR" sz="2610" b="1" dirty="0">
+              <a:rPr lang="pt-BR" sz="2465" b="1" dirty="0">
                 <a:solidFill>
                   <a:srgbClr val="111111"/>
                 </a:solidFill>
@@ -16178,25 +15945,52 @@
                 <a:cs typeface="Canva Sans Bold"/>
                 <a:sym typeface="Canva Sans Bold"/>
               </a:rPr>
-              <a:t>A CULTURA DIGITAL</a:t>
-            </a:r>
-            <a:endParaRPr lang="pt-BR" sz="2610" dirty="0"/>
+              <a:t>O AMBIENTE EM QUE ACONTECE</a:t>
+            </a:r>
+            <a:endParaRPr lang="pt-BR" sz="2465" dirty="0"/>
           </a:p>
           <a:p>
             <a:pPr algn="l">
               <a:lnSpc>
+                <a:spcPct val="98000"/>
+              </a:lnSpc>
+              <a:spcBef>
+                <a:spcPts val="0"/>
+              </a:spcBef>
+              <a:spcAft>
+                <a:spcPts val="145"/>
+              </a:spcAft>
+              <a:buNone/>
+            </a:pPr>
+            <a:r>
+              <a:rPr lang="pt-BR" sz="2102" dirty="0">
+                <a:solidFill>
+                  <a:srgbClr val="111111"/>
+                </a:solidFill>
+                <a:latin typeface="Canva Sans"/>
+                <a:ea typeface="Canva Sans"/>
+                <a:cs typeface="Canva Sans"/>
+                <a:sym typeface="Canva Sans"/>
+              </a:rPr>
+              <a:t>Capitalismo de vigilância: a experiência humana como matéria-prima</a:t>
+            </a:r>
+            <a:endParaRPr lang="pt-BR" sz="2102" dirty="0"/>
+          </a:p>
+          <a:p>
+            <a:pPr algn="l">
+              <a:lnSpc>
                 <a:spcPct val="95000"/>
               </a:lnSpc>
               <a:spcBef>
                 <a:spcPts val="0"/>
               </a:spcBef>
               <a:spcAft>
-                <a:spcPts val="290"/>
-              </a:spcAft>
-              <a:buNone/>
-            </a:pPr>
-            <a:r>
-              <a:rPr lang="pt-BR" sz="2175" b="1" dirty="0">
+                <a:spcPts val="1739"/>
+              </a:spcAft>
+              <a:buNone/>
+            </a:pPr>
+            <a:r>
+              <a:rPr lang="pt-BR" sz="1885" b="1" dirty="0">
                 <a:solidFill>
                   <a:srgbClr val="111111"/>
                 </a:solidFill>
@@ -16205,25 +15999,25 @@
                 <a:cs typeface="Canva Sans Bold"/>
                 <a:sym typeface="Canva Sans Bold"/>
               </a:rPr>
-              <a:t>Capitalismo de vigilância e dados</a:t>
-            </a:r>
-            <a:endParaRPr lang="pt-BR" sz="2175" dirty="0"/>
+              <a:t>Zuboff (2021)</a:t>
+            </a:r>
+            <a:endParaRPr lang="pt-BR" sz="1885" dirty="0"/>
           </a:p>
           <a:p>
             <a:pPr algn="l">
               <a:lnSpc>
-                <a:spcPct val="95000"/>
-              </a:lnSpc>
-              <a:spcBef>
-                <a:spcPts val="0"/>
-              </a:spcBef>
-              <a:spcAft>
-                <a:spcPts val="1739"/>
-              </a:spcAft>
-              <a:buNone/>
-            </a:pPr>
-            <a:r>
-              <a:rPr lang="pt-BR" sz="1958" dirty="0">
+                <a:spcPct val="98000"/>
+              </a:lnSpc>
+              <a:spcBef>
+                <a:spcPts val="0"/>
+              </a:spcBef>
+              <a:spcAft>
+                <a:spcPts val="145"/>
+              </a:spcAft>
+              <a:buNone/>
+            </a:pPr>
+            <a:r>
+              <a:rPr lang="pt-BR" sz="2102" dirty="0">
                 <a:solidFill>
                   <a:srgbClr val="111111"/>
                 </a:solidFill>
@@ -16232,9 +16026,9 @@
                 <a:cs typeface="Canva Sans"/>
                 <a:sym typeface="Canva Sans"/>
               </a:rPr>
-              <a:t>Zuboff (2021); Silveira (2017)</a:t>
-            </a:r>
-            <a:endParaRPr lang="pt-BR" sz="1958" dirty="0"/>
+              <a:t>Dados pessoais como matéria-prima; a privacidade como adversária</a:t>
+            </a:r>
+            <a:endParaRPr lang="pt-BR" sz="2102" dirty="0"/>
           </a:p>
           <a:p>
             <a:pPr algn="l">
@@ -16245,12 +16039,12 @@
                 <a:spcPts val="0"/>
               </a:spcBef>
               <a:spcAft>
-                <a:spcPts val="290"/>
-              </a:spcAft>
-              <a:buNone/>
-            </a:pPr>
-            <a:r>
-              <a:rPr lang="pt-BR" sz="2175" b="1" dirty="0">
+                <a:spcPts val="1739"/>
+              </a:spcAft>
+              <a:buNone/>
+            </a:pPr>
+            <a:r>
+              <a:rPr lang="pt-BR" sz="1885" b="1" dirty="0">
                 <a:solidFill>
                   <a:srgbClr val="111111"/>
                 </a:solidFill>
@@ -16259,25 +16053,25 @@
                 <a:cs typeface="Canva Sans Bold"/>
                 <a:sym typeface="Canva Sans Bold"/>
               </a:rPr>
-              <a:t>Solucionismo</a:t>
-            </a:r>
-            <a:endParaRPr lang="pt-BR" sz="2175" dirty="0"/>
+              <a:t>Silveira (2017, p. 34; 37)</a:t>
+            </a:r>
+            <a:endParaRPr lang="pt-BR" sz="1885" dirty="0"/>
           </a:p>
           <a:p>
             <a:pPr algn="l">
               <a:lnSpc>
-                <a:spcPct val="95000"/>
-              </a:lnSpc>
-              <a:spcBef>
-                <a:spcPts val="0"/>
-              </a:spcBef>
-              <a:spcAft>
-                <a:spcPts val="1739"/>
-              </a:spcAft>
-              <a:buNone/>
-            </a:pPr>
-            <a:r>
-              <a:rPr lang="pt-BR" sz="1958" dirty="0">
+                <a:spcPct val="98000"/>
+              </a:lnSpc>
+              <a:spcBef>
+                <a:spcPts val="0"/>
+              </a:spcBef>
+              <a:spcAft>
+                <a:spcPts val="145"/>
+              </a:spcAft>
+              <a:buNone/>
+            </a:pPr>
+            <a:r>
+              <a:rPr lang="pt-BR" sz="2102" dirty="0">
                 <a:solidFill>
                   <a:srgbClr val="111111"/>
                 </a:solidFill>
@@ -16286,9 +16080,9 @@
                 <a:cs typeface="Canva Sans"/>
                 <a:sym typeface="Canva Sans"/>
               </a:rPr>
-              <a:t>Morozov (2018)</a:t>
-            </a:r>
-            <a:endParaRPr lang="pt-BR" sz="1958" dirty="0"/>
+              <a:t>Solucionismo: problemas “resolvidos” por aplicativos</a:t>
+            </a:r>
+            <a:endParaRPr lang="pt-BR" sz="2102" dirty="0"/>
           </a:p>
           <a:p>
             <a:pPr algn="l">
@@ -16299,12 +16093,12 @@
                 <a:spcPts val="0"/>
               </a:spcBef>
               <a:spcAft>
-                <a:spcPts val="290"/>
-              </a:spcAft>
-              <a:buNone/>
-            </a:pPr>
-            <a:r>
-              <a:rPr lang="pt-BR" sz="2175" b="1" dirty="0">
+                <a:spcPts val="1739"/>
+              </a:spcAft>
+              <a:buNone/>
+            </a:pPr>
+            <a:r>
+              <a:rPr lang="pt-BR" sz="1885" b="1" dirty="0">
                 <a:solidFill>
                   <a:srgbClr val="111111"/>
                 </a:solidFill>
@@ -16313,25 +16107,25 @@
                 <a:cs typeface="Canva Sans Bold"/>
                 <a:sym typeface="Canva Sans Bold"/>
               </a:rPr>
-              <a:t>Sujeitos produtores de cultura</a:t>
-            </a:r>
-            <a:endParaRPr lang="pt-BR" sz="2175" dirty="0"/>
+              <a:t>Morozov (2018, p. 88)</a:t>
+            </a:r>
+            <a:endParaRPr lang="pt-BR" sz="1885" dirty="0"/>
           </a:p>
           <a:p>
             <a:pPr algn="l">
               <a:lnSpc>
-                <a:spcPct val="95000"/>
-              </a:lnSpc>
-              <a:spcBef>
-                <a:spcPts val="0"/>
-              </a:spcBef>
-              <a:spcAft>
-                <a:spcPts val="1739"/>
-              </a:spcAft>
-              <a:buNone/>
-            </a:pPr>
-            <a:r>
-              <a:rPr lang="pt-BR" sz="1958" dirty="0">
+                <a:spcPct val="98000"/>
+              </a:lnSpc>
+              <a:spcBef>
+                <a:spcPts val="0"/>
+              </a:spcBef>
+              <a:spcAft>
+                <a:spcPts val="145"/>
+              </a:spcAft>
+              <a:buNone/>
+            </a:pPr>
+            <a:r>
+              <a:rPr lang="pt-BR" sz="2102" dirty="0">
                 <a:solidFill>
                   <a:srgbClr val="111111"/>
                 </a:solidFill>
@@ -16340,22 +16134,49 @@
                 <a:cs typeface="Canva Sans"/>
                 <a:sym typeface="Canva Sans"/>
               </a:rPr>
-              <a:t>Pretto, Cordeiro e Oliveira (2013)</a:t>
-            </a:r>
-            <a:endParaRPr lang="pt-BR" sz="1958" dirty="0"/>
+              <a:t>Crianças como “produtores ativos de cultura”</a:t>
+            </a:r>
+            <a:endParaRPr lang="pt-BR" sz="2102" dirty="0"/>
+          </a:p>
+          <a:p>
+            <a:pPr algn="l">
+              <a:lnSpc>
+                <a:spcPct val="95000"/>
+              </a:lnSpc>
+              <a:spcBef>
+                <a:spcPts val="0"/>
+              </a:spcBef>
+              <a:spcAft>
+                <a:spcPts val="1739"/>
+              </a:spcAft>
+              <a:buNone/>
+            </a:pPr>
+            <a:r>
+              <a:rPr lang="pt-BR" sz="1885" b="1" dirty="0">
+                <a:solidFill>
+                  <a:srgbClr val="111111"/>
+                </a:solidFill>
+                <a:latin typeface="Canva Sans Bold"/>
+                <a:ea typeface="Canva Sans Bold"/>
+                <a:cs typeface="Canva Sans Bold"/>
+                <a:sym typeface="Canva Sans Bold"/>
+              </a:rPr>
+              <a:t>Pretto, Cordeiro e Oliveira (2013, p. 35)</a:t>
+            </a:r>
+            <a:endParaRPr lang="pt-BR" sz="1885" dirty="0"/>
           </a:p>
         </p:txBody>
       </p:sp>
       <p:sp>
         <p:nvSpPr>
-          <p:cNvPr id="206" name="Cartão 206"/>
+          <p:cNvPr id="205" name="Cartão 205"/>
           <p:cNvSpPr/>
           <p:nvPr/>
         </p:nvSpPr>
         <p:spPr>
           <a:xfrm>
-            <a:off x="612000" y="8892000"/>
-            <a:ext cx="17010000" cy="1152000"/>
+            <a:off x="612000" y="9144000"/>
+            <a:ext cx="17010000" cy="900000"/>
           </a:xfrm>
           <a:prstGeom prst="roundRect">
             <a:avLst>
@@ -16390,19 +16211,7 @@
               <a:buNone/>
             </a:pPr>
             <a:r>
-              <a:rPr lang="pt-BR" sz="2175" b="1" dirty="0">
-                <a:solidFill>
-                  <a:srgbClr val="111111"/>
-                </a:solidFill>
-                <a:latin typeface="Canva Sans Bold"/>
-                <a:ea typeface="Canva Sans Bold"/>
-                <a:cs typeface="Canva Sans Bold"/>
-                <a:sym typeface="Canva Sans Bold"/>
-              </a:rPr>
-              <a:t>Formulações da tese:</a:t>
-            </a:r>
-            <a:r>
-              <a:rPr lang="pt-BR" sz="2175" dirty="0">
+              <a:rPr lang="pt-BR" sz="1885" dirty="0">
                 <a:solidFill>
                   <a:srgbClr val="111111"/>
                 </a:solidFill>
@@ -16411,9 +16220,9 @@
                 <a:cs typeface="Canva Sans"/>
                 <a:sym typeface="Canva Sans"/>
               </a:rPr>
-              <a:t> habitar o digital · rugosidade tecnológica · vazio material</a:t>
-            </a:r>
-            <a:endParaRPr lang="pt-BR" sz="2175" dirty="0"/>
+              <a:t>Plataformas e dados são contexto teórico: entram no campo pelo Eixo 6 da entrevista, sem virar categoria de análise.</a:t>
+            </a:r>
+            <a:endParaRPr lang="pt-BR" sz="1885" dirty="0"/>
           </a:p>
         </p:txBody>
       </p:sp>
@@ -29704,12 +29513,12 @@
                 <a:spcPts val="0"/>
               </a:spcBef>
               <a:spcAft>
-                <a:spcPts val="600"/>
-              </a:spcAft>
-              <a:buNone/>
-            </a:pPr>
-            <a:r>
-              <a:rPr lang="pt-BR" sz="1550" dirty="0">
+                <a:spcPts val="500"/>
+              </a:spcAft>
+              <a:buNone/>
+            </a:pPr>
+            <a:r>
+              <a:rPr lang="pt-BR" sz="1500" dirty="0">
                 <a:solidFill>
                   <a:srgbClr val="111111"/>
                 </a:solidFill>
@@ -29721,7 +29530,7 @@
               <a:t>AIRES, Jussara Danielle Martins. </a:t>
             </a:r>
             <a:r>
-              <a:rPr lang="pt-BR" sz="1550" b="1" dirty="0">
+              <a:rPr lang="pt-BR" sz="1500" b="1" dirty="0">
                 <a:solidFill>
                   <a:srgbClr val="111111"/>
                 </a:solidFill>
@@ -29733,7 +29542,7 @@
               <a:t>Histórias e relatos sobre Pipa</a:t>
             </a:r>
             <a:r>
-              <a:rPr lang="pt-BR" sz="1550" dirty="0">
+              <a:rPr lang="pt-BR" sz="1500" dirty="0">
                 <a:solidFill>
                   <a:srgbClr val="111111"/>
                 </a:solidFill>
@@ -29744,7 +29553,7 @@
               </a:rPr>
               <a:t>: a praia internacional do Rio Grande do Norte. 2012. 114 f. Dissertação (Mestrado em Ciências Sociais) – Programa de Pós-Graduação em Ciências Sociais, Universidade Federal do Rio Grande do Norte, Natal, 2012.</a:t>
             </a:r>
-            <a:endParaRPr lang="pt-BR" sz="1550" dirty="0"/>
+            <a:endParaRPr lang="pt-BR" sz="1500" dirty="0"/>
           </a:p>
           <a:p>
             <a:pPr algn="l">
@@ -29755,12 +29564,12 @@
                 <a:spcPts val="0"/>
               </a:spcBef>
               <a:spcAft>
-                <a:spcPts val="600"/>
-              </a:spcAft>
-              <a:buNone/>
-            </a:pPr>
-            <a:r>
-              <a:rPr lang="pt-BR" sz="1550" dirty="0">
+                <a:spcPts val="500"/>
+              </a:spcAft>
+              <a:buNone/>
+            </a:pPr>
+            <a:r>
+              <a:rPr lang="pt-BR" sz="1500" dirty="0">
                 <a:solidFill>
                   <a:srgbClr val="111111"/>
                 </a:solidFill>
@@ -29772,7 +29581,7 @@
               <a:t>ALVES, Josemery Araújo. </a:t>
             </a:r>
             <a:r>
-              <a:rPr lang="pt-BR" sz="1550" b="1" dirty="0">
+              <a:rPr lang="pt-BR" sz="1500" b="1" dirty="0">
                 <a:solidFill>
                   <a:srgbClr val="111111"/>
                 </a:solidFill>
@@ -29784,7 +29593,7 @@
               <a:t>Turismo, recursos de uso comum e conflitos socioambientais em Pipa-Tibau do Sul/RN</a:t>
             </a:r>
             <a:r>
-              <a:rPr lang="pt-BR" sz="1550" dirty="0">
+              <a:rPr lang="pt-BR" sz="1500" dirty="0">
                 <a:solidFill>
                   <a:srgbClr val="111111"/>
                 </a:solidFill>
@@ -29795,7 +29604,7 @@
               </a:rPr>
               <a:t>: uma perspectiva à luz dos princípios de Ostrom. 2018. Tese (Doutorado em Recursos Naturais) – Universidade Federal de Campina Grande, Campina Grande, 2018.</a:t>
             </a:r>
-            <a:endParaRPr lang="pt-BR" sz="1550" dirty="0"/>
+            <a:endParaRPr lang="pt-BR" sz="1500" dirty="0"/>
           </a:p>
           <a:p>
             <a:pPr algn="l">
@@ -29806,12 +29615,12 @@
                 <a:spcPts val="0"/>
               </a:spcBef>
               <a:spcAft>
-                <a:spcPts val="600"/>
-              </a:spcAft>
-              <a:buNone/>
-            </a:pPr>
-            <a:r>
-              <a:rPr lang="pt-BR" sz="1550" dirty="0">
+                <a:spcPts val="500"/>
+              </a:spcAft>
+              <a:buNone/>
+            </a:pPr>
+            <a:r>
+              <a:rPr lang="pt-BR" sz="1500" dirty="0">
                 <a:solidFill>
                   <a:srgbClr val="111111"/>
                 </a:solidFill>
@@ -29823,7 +29632,7 @@
               <a:t>BALL, Stephen J. Reformar escolas/reformar professores e os terrores da performatividade. </a:t>
             </a:r>
             <a:r>
-              <a:rPr lang="pt-BR" sz="1550" b="1" dirty="0">
+              <a:rPr lang="pt-BR" sz="1500" b="1" dirty="0">
                 <a:solidFill>
                   <a:srgbClr val="111111"/>
                 </a:solidFill>
@@ -29835,7 +29644,7 @@
               <a:t>Revista Portuguesa de Educação</a:t>
             </a:r>
             <a:r>
-              <a:rPr lang="pt-BR" sz="1550" dirty="0">
+              <a:rPr lang="pt-BR" sz="1500" dirty="0">
                 <a:solidFill>
                   <a:srgbClr val="111111"/>
                 </a:solidFill>
@@ -29846,7 +29655,7 @@
               </a:rPr>
               <a:t>, Braga, v. 15, n. 2, p. 3-23, 2002.</a:t>
             </a:r>
-            <a:endParaRPr lang="pt-BR" sz="1550" dirty="0"/>
+            <a:endParaRPr lang="pt-BR" sz="1500" dirty="0"/>
           </a:p>
           <a:p>
             <a:pPr algn="l">
@@ -29857,12 +29666,12 @@
                 <a:spcPts val="0"/>
               </a:spcBef>
               <a:spcAft>
-                <a:spcPts val="600"/>
-              </a:spcAft>
-              <a:buNone/>
-            </a:pPr>
-            <a:r>
-              <a:rPr lang="pt-BR" sz="1550" dirty="0">
+                <a:spcPts val="500"/>
+              </a:spcAft>
+              <a:buNone/>
+            </a:pPr>
+            <a:r>
+              <a:rPr lang="pt-BR" sz="1500" dirty="0">
                 <a:solidFill>
                   <a:srgbClr val="111111"/>
                 </a:solidFill>
@@ -29874,7 +29683,7 @@
               <a:t>BALL, Stephen J. </a:t>
             </a:r>
             <a:r>
-              <a:rPr lang="pt-BR" sz="1550" b="1" dirty="0">
+              <a:rPr lang="pt-BR" sz="1500" b="1" dirty="0">
                 <a:solidFill>
                   <a:srgbClr val="111111"/>
                 </a:solidFill>
@@ -29886,7 +29695,7 @@
               <a:t>The education debate</a:t>
             </a:r>
             <a:r>
-              <a:rPr lang="pt-BR" sz="1550" dirty="0">
+              <a:rPr lang="pt-BR" sz="1500" dirty="0">
                 <a:solidFill>
                   <a:srgbClr val="111111"/>
                 </a:solidFill>
@@ -29897,7 +29706,7 @@
               </a:rPr>
               <a:t>. Bristol: The Policy Press, 2008.</a:t>
             </a:r>
-            <a:endParaRPr lang="pt-BR" sz="1550" dirty="0"/>
+            <a:endParaRPr lang="pt-BR" sz="1500" dirty="0"/>
           </a:p>
           <a:p>
             <a:pPr algn="l">
@@ -29908,12 +29717,12 @@
                 <a:spcPts val="0"/>
               </a:spcBef>
               <a:spcAft>
-                <a:spcPts val="600"/>
-              </a:spcAft>
-              <a:buNone/>
-            </a:pPr>
-            <a:r>
-              <a:rPr lang="pt-BR" sz="1550" dirty="0">
+                <a:spcPts val="500"/>
+              </a:spcAft>
+              <a:buNone/>
+            </a:pPr>
+            <a:r>
+              <a:rPr lang="pt-BR" sz="1500" dirty="0">
                 <a:solidFill>
                   <a:srgbClr val="111111"/>
                 </a:solidFill>
@@ -29925,7 +29734,7 @@
               <a:t>BALL, Stephen J. Sociologia das políticas educacionais e pesquisa crítico-social: uma revisão pessoal das políticas educacionais e da pesquisa em política educacional. In: BALL, Stephen J.; MAINARDES, Jefferson (org.). </a:t>
             </a:r>
             <a:r>
-              <a:rPr lang="pt-BR" sz="1550" b="1" dirty="0">
+              <a:rPr lang="pt-BR" sz="1500" b="1" dirty="0">
                 <a:solidFill>
                   <a:srgbClr val="111111"/>
                 </a:solidFill>
@@ -29937,7 +29746,7 @@
               <a:t>Políticas educacionais</a:t>
             </a:r>
             <a:r>
-              <a:rPr lang="pt-BR" sz="1550" dirty="0">
+              <a:rPr lang="pt-BR" sz="1500" dirty="0">
                 <a:solidFill>
                   <a:srgbClr val="111111"/>
                 </a:solidFill>
@@ -29948,7 +29757,7 @@
               </a:rPr>
               <a:t>: questões e dilemas. São Paulo: Cortez, 2011. p. 21-53.</a:t>
             </a:r>
-            <a:endParaRPr lang="pt-BR" sz="1550" dirty="0"/>
+            <a:endParaRPr lang="pt-BR" sz="1500" dirty="0"/>
           </a:p>
           <a:p>
             <a:pPr algn="l">
@@ -29959,12 +29768,12 @@
                 <a:spcPts val="0"/>
               </a:spcBef>
               <a:spcAft>
-                <a:spcPts val="600"/>
-              </a:spcAft>
-              <a:buNone/>
-            </a:pPr>
-            <a:r>
-              <a:rPr lang="pt-BR" sz="1550" dirty="0">
+                <a:spcPts val="500"/>
+              </a:spcAft>
+              <a:buNone/>
+            </a:pPr>
+            <a:r>
+              <a:rPr lang="pt-BR" sz="1500" dirty="0">
                 <a:solidFill>
                   <a:srgbClr val="111111"/>
                 </a:solidFill>
@@ -29976,7 +29785,7 @@
               <a:t>BALL, Stephen J.; MAGUIRE, Meg; BRAUN, Annette. </a:t>
             </a:r>
             <a:r>
-              <a:rPr lang="pt-BR" sz="1550" b="1" dirty="0">
+              <a:rPr lang="pt-BR" sz="1500" b="1" dirty="0">
                 <a:solidFill>
                   <a:srgbClr val="111111"/>
                 </a:solidFill>
@@ -29988,7 +29797,7 @@
               <a:t>Como as escolas fazem as políticas</a:t>
             </a:r>
             <a:r>
-              <a:rPr lang="pt-BR" sz="1550" dirty="0">
+              <a:rPr lang="pt-BR" sz="1500" dirty="0">
                 <a:solidFill>
                   <a:srgbClr val="111111"/>
                 </a:solidFill>
@@ -29999,7 +29808,7 @@
               </a:rPr>
               <a:t>: atuação em escolas secundárias. Tradução de Janete Bridon. Ponta Grossa: Editora UEPG, 2016.</a:t>
             </a:r>
-            <a:endParaRPr lang="pt-BR" sz="1550" dirty="0"/>
+            <a:endParaRPr lang="pt-BR" sz="1500" dirty="0"/>
           </a:p>
           <a:p>
             <a:pPr algn="l">
@@ -30010,12 +29819,12 @@
                 <a:spcPts val="0"/>
               </a:spcBef>
               <a:spcAft>
-                <a:spcPts val="600"/>
-              </a:spcAft>
-              <a:buNone/>
-            </a:pPr>
-            <a:r>
-              <a:rPr lang="pt-BR" sz="1550" dirty="0">
+                <a:spcPts val="500"/>
+              </a:spcAft>
+              <a:buNone/>
+            </a:pPr>
+            <a:r>
+              <a:rPr lang="pt-BR" sz="1500" dirty="0">
                 <a:solidFill>
                   <a:srgbClr val="111111"/>
                 </a:solidFill>
@@ -30027,7 +29836,7 @@
               <a:t>BANCO MUNDIAL. </a:t>
             </a:r>
             <a:r>
-              <a:rPr lang="pt-BR" sz="1550" b="1" dirty="0">
+              <a:rPr lang="pt-BR" sz="1500" b="1" dirty="0">
                 <a:solidFill>
                   <a:srgbClr val="111111"/>
                 </a:solidFill>
@@ -30039,7 +29848,7 @@
               <a:t>Reimagining Human Connections</a:t>
             </a:r>
             <a:r>
-              <a:rPr lang="pt-BR" sz="1550" dirty="0">
+              <a:rPr lang="pt-BR" sz="1500" dirty="0">
                 <a:solidFill>
                   <a:srgbClr val="111111"/>
                 </a:solidFill>
@@ -30050,7 +29859,7 @@
               </a:rPr>
               <a:t>: Technology and Innovation in Education at the World Bank. Washington, DC: World Bank, 2020.</a:t>
             </a:r>
-            <a:endParaRPr lang="pt-BR" sz="1550" dirty="0"/>
+            <a:endParaRPr lang="pt-BR" sz="1500" dirty="0"/>
           </a:p>
           <a:p>
             <a:pPr algn="l">
@@ -30061,12 +29870,12 @@
                 <a:spcPts val="0"/>
               </a:spcBef>
               <a:spcAft>
-                <a:spcPts val="600"/>
-              </a:spcAft>
-              <a:buNone/>
-            </a:pPr>
-            <a:r>
-              <a:rPr lang="pt-BR" sz="1550" dirty="0">
+                <a:spcPts val="500"/>
+              </a:spcAft>
+              <a:buNone/>
+            </a:pPr>
+            <a:r>
+              <a:rPr lang="pt-BR" sz="1500" dirty="0">
                 <a:solidFill>
                   <a:srgbClr val="111111"/>
                 </a:solidFill>
@@ -30078,7 +29887,7 @@
               <a:t>BOWE, Richard; BALL, Stephen J.; GOLD, Anne. </a:t>
             </a:r>
             <a:r>
-              <a:rPr lang="pt-BR" sz="1550" b="1" dirty="0">
+              <a:rPr lang="pt-BR" sz="1500" b="1" dirty="0">
                 <a:solidFill>
                   <a:srgbClr val="111111"/>
                 </a:solidFill>
@@ -30090,7 +29899,7 @@
               <a:t>Reforming education and changing schools</a:t>
             </a:r>
             <a:r>
-              <a:rPr lang="pt-BR" sz="1550" dirty="0">
+              <a:rPr lang="pt-BR" sz="1500" dirty="0">
                 <a:solidFill>
                   <a:srgbClr val="111111"/>
                 </a:solidFill>
@@ -30101,7 +29910,7 @@
               </a:rPr>
               <a:t>: case studies in policy sociology. London: Routledge, 1992.</a:t>
             </a:r>
-            <a:endParaRPr lang="pt-BR" sz="1550" dirty="0"/>
+            <a:endParaRPr lang="pt-BR" sz="1500" dirty="0"/>
           </a:p>
           <a:p>
             <a:pPr algn="l">
@@ -30112,12 +29921,12 @@
                 <a:spcPts val="0"/>
               </a:spcBef>
               <a:spcAft>
-                <a:spcPts val="600"/>
-              </a:spcAft>
-              <a:buNone/>
-            </a:pPr>
-            <a:r>
-              <a:rPr lang="pt-BR" sz="1550" dirty="0">
+                <a:spcPts val="500"/>
+              </a:spcAft>
+              <a:buNone/>
+            </a:pPr>
+            <a:r>
+              <a:rPr lang="pt-BR" sz="1500" dirty="0">
                 <a:solidFill>
                   <a:srgbClr val="111111"/>
                 </a:solidFill>
@@ -30129,7 +29938,7 @@
               <a:t>BRASIL. Conselho Nacional de Saúde. </a:t>
             </a:r>
             <a:r>
-              <a:rPr lang="pt-BR" sz="1550" b="1" dirty="0">
+              <a:rPr lang="pt-BR" sz="1500" b="1" dirty="0">
                 <a:solidFill>
                   <a:srgbClr val="111111"/>
                 </a:solidFill>
@@ -30141,7 +29950,7 @@
               <a:t>Resolução nº 466, de 12 de dezembro de 2012</a:t>
             </a:r>
             <a:r>
-              <a:rPr lang="pt-BR" sz="1550" dirty="0">
+              <a:rPr lang="pt-BR" sz="1500" dirty="0">
                 <a:solidFill>
                   <a:srgbClr val="111111"/>
                 </a:solidFill>
@@ -30152,7 +29961,7 @@
               </a:rPr>
               <a:t>. Aprova diretrizes e normas regulamentadoras de pesquisas envolvendo seres humanos. Brasília, DF: CNS, 2012.</a:t>
             </a:r>
-            <a:endParaRPr lang="pt-BR" sz="1550" dirty="0"/>
+            <a:endParaRPr lang="pt-BR" sz="1500" dirty="0"/>
           </a:p>
           <a:p>
             <a:pPr algn="l">
@@ -30163,12 +29972,12 @@
                 <a:spcPts val="0"/>
               </a:spcBef>
               <a:spcAft>
-                <a:spcPts val="600"/>
-              </a:spcAft>
-              <a:buNone/>
-            </a:pPr>
-            <a:r>
-              <a:rPr lang="pt-BR" sz="1550" dirty="0">
+                <a:spcPts val="500"/>
+              </a:spcAft>
+              <a:buNone/>
+            </a:pPr>
+            <a:r>
+              <a:rPr lang="pt-BR" sz="1500" dirty="0">
                 <a:solidFill>
                   <a:srgbClr val="111111"/>
                 </a:solidFill>
@@ -30180,7 +29989,7 @@
               <a:t>BRASIL. Conselho Nacional de Saúde. </a:t>
             </a:r>
             <a:r>
-              <a:rPr lang="pt-BR" sz="1550" b="1" dirty="0">
+              <a:rPr lang="pt-BR" sz="1500" b="1" dirty="0">
                 <a:solidFill>
                   <a:srgbClr val="111111"/>
                 </a:solidFill>
@@ -30192,7 +30001,7 @@
               <a:t>Resolução nº 510, de 7 de abril de 2016</a:t>
             </a:r>
             <a:r>
-              <a:rPr lang="pt-BR" sz="1550" dirty="0">
+              <a:rPr lang="pt-BR" sz="1500" dirty="0">
                 <a:solidFill>
                   <a:srgbClr val="111111"/>
                 </a:solidFill>
@@ -30203,7 +30012,7 @@
               </a:rPr>
               <a:t>. Dispõe sobre as normas aplicáveis a pesquisas em Ciências Humanas e Sociais. Brasília, DF: CNS, 2016.</a:t>
             </a:r>
-            <a:endParaRPr lang="pt-BR" sz="1550" dirty="0"/>
+            <a:endParaRPr lang="pt-BR" sz="1500" dirty="0"/>
           </a:p>
           <a:p>
             <a:pPr algn="l">
@@ -30214,12 +30023,12 @@
                 <a:spcPts val="0"/>
               </a:spcBef>
               <a:spcAft>
-                <a:spcPts val="600"/>
-              </a:spcAft>
-              <a:buNone/>
-            </a:pPr>
-            <a:r>
-              <a:rPr lang="pt-BR" sz="1550" dirty="0">
+                <a:spcPts val="500"/>
+              </a:spcAft>
+              <a:buNone/>
+            </a:pPr>
+            <a:r>
+              <a:rPr lang="pt-BR" sz="1500" dirty="0">
                 <a:solidFill>
                   <a:srgbClr val="111111"/>
                 </a:solidFill>
@@ -30231,7 +30040,7 @@
               <a:t>BRASIL. </a:t>
             </a:r>
             <a:r>
-              <a:rPr lang="pt-BR" sz="1550" b="1" dirty="0">
+              <a:rPr lang="pt-BR" sz="1500" b="1" dirty="0">
                 <a:solidFill>
                   <a:srgbClr val="111111"/>
                 </a:solidFill>
@@ -30243,7 +30052,7 @@
               <a:t>Lei nº 14.533, de 11 de janeiro de 2023</a:t>
             </a:r>
             <a:r>
-              <a:rPr lang="pt-BR" sz="1550" dirty="0">
+              <a:rPr lang="pt-BR" sz="1500" dirty="0">
                 <a:solidFill>
                   <a:srgbClr val="111111"/>
                 </a:solidFill>
@@ -30254,7 +30063,7 @@
               </a:rPr>
               <a:t>. Institui a Política Nacional de Educação Digital. Brasília, DF: Presidência da República, 2023.</a:t>
             </a:r>
-            <a:endParaRPr lang="pt-BR" sz="1550" dirty="0"/>
+            <a:endParaRPr lang="pt-BR" sz="1500" dirty="0"/>
           </a:p>
         </p:txBody>
       </p:sp>
@@ -30288,12 +30097,12 @@
                 <a:spcPts val="0"/>
               </a:spcBef>
               <a:spcAft>
-                <a:spcPts val="600"/>
-              </a:spcAft>
-              <a:buNone/>
-            </a:pPr>
-            <a:r>
-              <a:rPr lang="pt-BR" sz="1550" dirty="0">
+                <a:spcPts val="500"/>
+              </a:spcAft>
+              <a:buNone/>
+            </a:pPr>
+            <a:r>
+              <a:rPr lang="pt-BR" sz="1500" dirty="0">
                 <a:solidFill>
                   <a:srgbClr val="111111"/>
                 </a:solidFill>
@@ -30305,7 +30114,7 @@
               <a:t>BRASIL. Conselho Nacional de Educação. Câmara de Educação Básica. </a:t>
             </a:r>
             <a:r>
-              <a:rPr lang="pt-BR" sz="1550" b="1" dirty="0">
+              <a:rPr lang="pt-BR" sz="1500" b="1" dirty="0">
                 <a:solidFill>
                   <a:srgbClr val="111111"/>
                 </a:solidFill>
@@ -30317,7 +30126,7 @@
               <a:t>Resolução CNE/CEB nº 2, de 21 de março de 2025</a:t>
             </a:r>
             <a:r>
-              <a:rPr lang="pt-BR" sz="1550" dirty="0">
+              <a:rPr lang="pt-BR" sz="1500" dirty="0">
                 <a:solidFill>
                   <a:srgbClr val="111111"/>
                 </a:solidFill>
@@ -30328,7 +30137,7 @@
               </a:rPr>
               <a:t>. Institui as Diretrizes Operacionais Nacionais sobre o uso de dispositivos digitais em espaços escolares e integração curricular de educação digital e midiática. Brasília, DF: CNE, 2025.</a:t>
             </a:r>
-            <a:endParaRPr lang="pt-BR" sz="1550" dirty="0"/>
+            <a:endParaRPr lang="pt-BR" sz="1500" dirty="0"/>
           </a:p>
           <a:p>
             <a:pPr algn="l">
@@ -30339,12 +30148,12 @@
                 <a:spcPts val="0"/>
               </a:spcBef>
               <a:spcAft>
-                <a:spcPts val="600"/>
-              </a:spcAft>
-              <a:buNone/>
-            </a:pPr>
-            <a:r>
-              <a:rPr lang="pt-BR" sz="1550" dirty="0">
+                <a:spcPts val="500"/>
+              </a:spcAft>
+              <a:buNone/>
+            </a:pPr>
+            <a:r>
+              <a:rPr lang="pt-BR" sz="1500" dirty="0">
                 <a:solidFill>
                   <a:srgbClr val="111111"/>
                 </a:solidFill>
@@ -30356,7 +30165,7 @@
               <a:t>BRAUN, Virginia; CLARKE, Victoria. Using thematic analysis in psychology. </a:t>
             </a:r>
             <a:r>
-              <a:rPr lang="pt-BR" sz="1550" b="1" dirty="0">
+              <a:rPr lang="pt-BR" sz="1500" b="1" dirty="0">
                 <a:solidFill>
                   <a:srgbClr val="111111"/>
                 </a:solidFill>
@@ -30368,7 +30177,7 @@
               <a:t>Qualitative Research in Psychology</a:t>
             </a:r>
             <a:r>
-              <a:rPr lang="pt-BR" sz="1550" dirty="0">
+              <a:rPr lang="pt-BR" sz="1500" dirty="0">
                 <a:solidFill>
                   <a:srgbClr val="111111"/>
                 </a:solidFill>
@@ -30379,7 +30188,7 @@
               </a:rPr>
               <a:t>, v. 3, n. 2, p. 77-101, 2006.</a:t>
             </a:r>
-            <a:endParaRPr lang="pt-BR" sz="1550" dirty="0"/>
+            <a:endParaRPr lang="pt-BR" sz="1500" dirty="0"/>
           </a:p>
           <a:p>
             <a:pPr algn="l">
@@ -30390,12 +30199,12 @@
                 <a:spcPts val="0"/>
               </a:spcBef>
               <a:spcAft>
-                <a:spcPts val="600"/>
-              </a:spcAft>
-              <a:buNone/>
-            </a:pPr>
-            <a:r>
-              <a:rPr lang="pt-BR" sz="1550" dirty="0">
+                <a:spcPts val="500"/>
+              </a:spcAft>
+              <a:buNone/>
+            </a:pPr>
+            <a:r>
+              <a:rPr lang="pt-BR" sz="1500" dirty="0">
                 <a:solidFill>
                   <a:srgbClr val="111111"/>
                 </a:solidFill>
@@ -30407,7 +30216,7 @@
               <a:t>BRAUN, Virginia; CLARKE, Victoria. Reflecting on reflexive thematic analysis. </a:t>
             </a:r>
             <a:r>
-              <a:rPr lang="pt-BR" sz="1550" b="1" dirty="0">
+              <a:rPr lang="pt-BR" sz="1500" b="1" dirty="0">
                 <a:solidFill>
                   <a:srgbClr val="111111"/>
                 </a:solidFill>
@@ -30419,7 +30228,7 @@
               <a:t>Qualitative Research in Sport, Exercise and Health</a:t>
             </a:r>
             <a:r>
-              <a:rPr lang="pt-BR" sz="1550" dirty="0">
+              <a:rPr lang="pt-BR" sz="1500" dirty="0">
                 <a:solidFill>
                   <a:srgbClr val="111111"/>
                 </a:solidFill>
@@ -30430,7 +30239,7 @@
               </a:rPr>
               <a:t>, v. 11, n. 4, p. 589-597, 2019.</a:t>
             </a:r>
-            <a:endParaRPr lang="pt-BR" sz="1550" dirty="0"/>
+            <a:endParaRPr lang="pt-BR" sz="1500" dirty="0"/>
           </a:p>
           <a:p>
             <a:pPr algn="l">
@@ -30441,12 +30250,12 @@
                 <a:spcPts val="0"/>
               </a:spcBef>
               <a:spcAft>
-                <a:spcPts val="600"/>
-              </a:spcAft>
-              <a:buNone/>
-            </a:pPr>
-            <a:r>
-              <a:rPr lang="pt-BR" sz="1550" dirty="0">
+                <a:spcPts val="500"/>
+              </a:spcAft>
+              <a:buNone/>
+            </a:pPr>
+            <a:r>
+              <a:rPr lang="pt-BR" sz="1500" dirty="0">
                 <a:solidFill>
                   <a:srgbClr val="111111"/>
                 </a:solidFill>
@@ -30455,10 +30264,10 @@
                 <a:cs typeface="Canva Sans"/>
                 <a:sym typeface="Canva Sans"/>
               </a:rPr>
-              <a:t>DI FELICE, Massimo. </a:t>
-            </a:r>
-            <a:r>
-              <a:rPr lang="pt-BR" sz="1550" b="1" dirty="0">
+              <a:t>BUCKINGHAM, David. </a:t>
+            </a:r>
+            <a:r>
+              <a:rPr lang="pt-BR" sz="1500" b="1" dirty="0">
                 <a:solidFill>
                   <a:srgbClr val="111111"/>
                 </a:solidFill>
@@ -30467,10 +30276,10 @@
                 <a:cs typeface="Canva Sans Bold"/>
                 <a:sym typeface="Canva Sans Bold"/>
               </a:rPr>
-              <a:t>Paisagens pós-urbanas</a:t>
-            </a:r>
-            <a:r>
-              <a:rPr lang="pt-BR" sz="1550" dirty="0">
+              <a:t>Crescer na era das mídias</a:t>
+            </a:r>
+            <a:r>
+              <a:rPr lang="pt-BR" sz="1500" dirty="0">
                 <a:solidFill>
                   <a:srgbClr val="111111"/>
                 </a:solidFill>
@@ -30479,9 +30288,9 @@
                 <a:cs typeface="Canva Sans"/>
                 <a:sym typeface="Canva Sans"/>
               </a:rPr>
-              <a:t>: o fim da experiência urbana e as formas comunicativas do habitar. São Paulo: Annablume, 2009.</a:t>
-            </a:r>
-            <a:endParaRPr lang="pt-BR" sz="1550" dirty="0"/>
+              <a:t>: após a morte da infância. Tradução de Gilka Girardello e Isabel Orofino. Florianópolis: [s. n.], 2006.</a:t>
+            </a:r>
+            <a:endParaRPr lang="pt-BR" sz="1500" dirty="0"/>
           </a:p>
           <a:p>
             <a:pPr algn="l">
@@ -30492,12 +30301,12 @@
                 <a:spcPts val="0"/>
               </a:spcBef>
               <a:spcAft>
-                <a:spcPts val="600"/>
-              </a:spcAft>
-              <a:buNone/>
-            </a:pPr>
-            <a:r>
-              <a:rPr lang="pt-BR" sz="1550" dirty="0">
+                <a:spcPts val="500"/>
+              </a:spcAft>
+              <a:buNone/>
+            </a:pPr>
+            <a:r>
+              <a:rPr lang="pt-BR" sz="1500" dirty="0">
                 <a:solidFill>
                   <a:srgbClr val="111111"/>
                 </a:solidFill>
@@ -30506,10 +30315,10 @@
                 <a:cs typeface="Canva Sans"/>
                 <a:sym typeface="Canva Sans"/>
               </a:rPr>
-              <a:t>FOUCAULT, Michel. </a:t>
-            </a:r>
-            <a:r>
-              <a:rPr lang="pt-BR" sz="1550" b="1" dirty="0">
+              <a:t>CASTELLS, Manuel. </a:t>
+            </a:r>
+            <a:r>
+              <a:rPr lang="pt-BR" sz="1500" b="1" dirty="0">
                 <a:solidFill>
                   <a:srgbClr val="111111"/>
                 </a:solidFill>
@@ -30518,10 +30327,10 @@
                 <a:cs typeface="Canva Sans Bold"/>
                 <a:sym typeface="Canva Sans Bold"/>
               </a:rPr>
-              <a:t>Vigiar e punir</a:t>
-            </a:r>
-            <a:r>
-              <a:rPr lang="pt-BR" sz="1550" dirty="0">
+              <a:t>A galáxia da internet</a:t>
+            </a:r>
+            <a:r>
+              <a:rPr lang="pt-BR" sz="1500" dirty="0">
                 <a:solidFill>
                   <a:srgbClr val="111111"/>
                 </a:solidFill>
@@ -30530,9 +30339,9 @@
                 <a:cs typeface="Canva Sans"/>
                 <a:sym typeface="Canva Sans"/>
               </a:rPr>
-              <a:t>: nascimento da prisão. Tradução de Raquel Ramalhete. 20. ed. Petrópolis: Vozes, 1999.</a:t>
-            </a:r>
-            <a:endParaRPr lang="pt-BR" sz="1550" dirty="0"/>
+              <a:t>: reflexões sobre a internet, os negócios e a sociedade. Rio de Janeiro: Zahar, 2003.</a:t>
+            </a:r>
+            <a:endParaRPr lang="pt-BR" sz="1500" dirty="0"/>
           </a:p>
           <a:p>
             <a:pPr algn="l">
@@ -30543,12 +30352,12 @@
                 <a:spcPts val="0"/>
               </a:spcBef>
               <a:spcAft>
-                <a:spcPts val="600"/>
-              </a:spcAft>
-              <a:buNone/>
-            </a:pPr>
-            <a:r>
-              <a:rPr lang="pt-BR" sz="1550" dirty="0">
+                <a:spcPts val="500"/>
+              </a:spcAft>
+              <a:buNone/>
+            </a:pPr>
+            <a:r>
+              <a:rPr lang="pt-BR" sz="1500" dirty="0">
                 <a:solidFill>
                   <a:srgbClr val="111111"/>
                 </a:solidFill>
@@ -30557,10 +30366,10 @@
                 <a:cs typeface="Canva Sans"/>
                 <a:sym typeface="Canva Sans"/>
               </a:rPr>
-              <a:t>FREIRE, Paulo. </a:t>
-            </a:r>
-            <a:r>
-              <a:rPr lang="pt-BR" sz="1550" b="1" dirty="0">
+              <a:t>CASTELLS, Manuel. </a:t>
+            </a:r>
+            <a:r>
+              <a:rPr lang="pt-BR" sz="1500" b="1" dirty="0">
                 <a:solidFill>
                   <a:srgbClr val="111111"/>
                 </a:solidFill>
@@ -30569,10 +30378,10 @@
                 <a:cs typeface="Canva Sans Bold"/>
                 <a:sym typeface="Canva Sans Bold"/>
               </a:rPr>
-              <a:t>Pedagogia da autonomia</a:t>
-            </a:r>
-            <a:r>
-              <a:rPr lang="pt-BR" sz="1550" dirty="0">
+              <a:t>A sociedade em rede</a:t>
+            </a:r>
+            <a:r>
+              <a:rPr lang="pt-BR" sz="1500" dirty="0">
                 <a:solidFill>
                   <a:srgbClr val="111111"/>
                 </a:solidFill>
@@ -30581,9 +30390,9 @@
                 <a:cs typeface="Canva Sans"/>
                 <a:sym typeface="Canva Sans"/>
               </a:rPr>
-              <a:t>: saberes necessários à prática educativa. 60. ed. Rio de Janeiro: Paz e Terra, 2019.</a:t>
-            </a:r>
-            <a:endParaRPr lang="pt-BR" sz="1550" dirty="0"/>
+              <a:t>. 14. ed. São Paulo: Paz e Terra, 2013. (A era da informação: economia, sociedade e cultura, v. 1).</a:t>
+            </a:r>
+            <a:endParaRPr lang="pt-BR" sz="1500" dirty="0"/>
           </a:p>
           <a:p>
             <a:pPr algn="l">
@@ -30594,12 +30403,12 @@
                 <a:spcPts val="0"/>
               </a:spcBef>
               <a:spcAft>
-                <a:spcPts val="600"/>
-              </a:spcAft>
-              <a:buNone/>
-            </a:pPr>
-            <a:r>
-              <a:rPr lang="pt-BR" sz="1550" dirty="0">
+                <a:spcPts val="500"/>
+              </a:spcAft>
+              <a:buNone/>
+            </a:pPr>
+            <a:r>
+              <a:rPr lang="pt-BR" sz="1500" dirty="0">
                 <a:solidFill>
                   <a:srgbClr val="111111"/>
                 </a:solidFill>
@@ -30608,10 +30417,10 @@
                 <a:cs typeface="Canva Sans"/>
                 <a:sym typeface="Canva Sans"/>
               </a:rPr>
-              <a:t>FUNDAÇÃO CULTURAL PALMARES. Portaria nº 26, de 6 de junho de 2005. </a:t>
-            </a:r>
-            <a:r>
-              <a:rPr lang="pt-BR" sz="1550" b="1" dirty="0">
+              <a:t>DI FELICE, Massimo. </a:t>
+            </a:r>
+            <a:r>
+              <a:rPr lang="pt-BR" sz="1500" b="1" dirty="0">
                 <a:solidFill>
                   <a:srgbClr val="111111"/>
                 </a:solidFill>
@@ -30620,10 +30429,10 @@
                 <a:cs typeface="Canva Sans Bold"/>
                 <a:sym typeface="Canva Sans Bold"/>
               </a:rPr>
-              <a:t>Diário Oficial da União</a:t>
-            </a:r>
-            <a:r>
-              <a:rPr lang="pt-BR" sz="1550" dirty="0">
+              <a:t>Paisagens pós-urbanas</a:t>
+            </a:r>
+            <a:r>
+              <a:rPr lang="pt-BR" sz="1500" dirty="0">
                 <a:solidFill>
                   <a:srgbClr val="111111"/>
                 </a:solidFill>
@@ -30632,9 +30441,9 @@
                 <a:cs typeface="Canva Sans"/>
                 <a:sym typeface="Canva Sans"/>
               </a:rPr>
-              <a:t>: seção 1, Brasília, DF, 8 jun. 2005.</a:t>
-            </a:r>
-            <a:endParaRPr lang="pt-BR" sz="1550" dirty="0"/>
+              <a:t>: o fim da experiência urbana e as formas comunicativas do habitar. São Paulo: Annablume, 2009.</a:t>
+            </a:r>
+            <a:endParaRPr lang="pt-BR" sz="1500" dirty="0"/>
           </a:p>
           <a:p>
             <a:pPr algn="l">
@@ -30645,12 +30454,12 @@
                 <a:spcPts val="0"/>
               </a:spcBef>
               <a:spcAft>
-                <a:spcPts val="600"/>
-              </a:spcAft>
-              <a:buNone/>
-            </a:pPr>
-            <a:r>
-              <a:rPr lang="pt-BR" sz="1550" dirty="0">
+                <a:spcPts val="500"/>
+              </a:spcAft>
+              <a:buNone/>
+            </a:pPr>
+            <a:r>
+              <a:rPr lang="pt-BR" sz="1500" dirty="0">
                 <a:solidFill>
                   <a:srgbClr val="111111"/>
                 </a:solidFill>
@@ -30659,10 +30468,10 @@
                 <a:cs typeface="Canva Sans"/>
                 <a:sym typeface="Canva Sans"/>
               </a:rPr>
-              <a:t>HALL, Stuart. </a:t>
-            </a:r>
-            <a:r>
-              <a:rPr lang="pt-BR" sz="1550" b="1" dirty="0">
+              <a:t>FOUCAULT, Michel. </a:t>
+            </a:r>
+            <a:r>
+              <a:rPr lang="pt-BR" sz="1500" b="1" dirty="0">
                 <a:solidFill>
                   <a:srgbClr val="111111"/>
                 </a:solidFill>
@@ -30671,10 +30480,10 @@
                 <a:cs typeface="Canva Sans Bold"/>
                 <a:sym typeface="Canva Sans Bold"/>
               </a:rPr>
-              <a:t>A identidade cultural na pós-modernidade</a:t>
-            </a:r>
-            <a:r>
-              <a:rPr lang="pt-BR" sz="1550" dirty="0">
+              <a:t>Vigiar e punir</a:t>
+            </a:r>
+            <a:r>
+              <a:rPr lang="pt-BR" sz="1500" dirty="0">
                 <a:solidFill>
                   <a:srgbClr val="111111"/>
                 </a:solidFill>
@@ -30683,9 +30492,9 @@
                 <a:cs typeface="Canva Sans"/>
                 <a:sym typeface="Canva Sans"/>
               </a:rPr>
-              <a:t>. 11. ed. Rio de Janeiro: DP&amp;A, 2006.</a:t>
-            </a:r>
-            <a:endParaRPr lang="pt-BR" sz="1550" dirty="0"/>
+              <a:t>: nascimento da prisão. Tradução de Raquel Ramalhete. 20. ed. Petrópolis: Vozes, 1999.</a:t>
+            </a:r>
+            <a:endParaRPr lang="pt-BR" sz="1500" dirty="0"/>
           </a:p>
           <a:p>
             <a:pPr algn="l">
@@ -30696,12 +30505,12 @@
                 <a:spcPts val="0"/>
               </a:spcBef>
               <a:spcAft>
-                <a:spcPts val="600"/>
-              </a:spcAft>
-              <a:buNone/>
-            </a:pPr>
-            <a:r>
-              <a:rPr lang="pt-BR" sz="1550" dirty="0">
+                <a:spcPts val="500"/>
+              </a:spcAft>
+              <a:buNone/>
+            </a:pPr>
+            <a:r>
+              <a:rPr lang="pt-BR" sz="1500" dirty="0">
                 <a:solidFill>
                   <a:srgbClr val="111111"/>
                 </a:solidFill>
@@ -30710,10 +30519,10 @@
                 <a:cs typeface="Canva Sans"/>
                 <a:sym typeface="Canva Sans"/>
               </a:rPr>
-              <a:t>HARGREAVES, Andy. </a:t>
-            </a:r>
-            <a:r>
-              <a:rPr lang="pt-BR" sz="1550" b="1" dirty="0">
+              <a:t>FREIRE, Paulo. </a:t>
+            </a:r>
+            <a:r>
+              <a:rPr lang="pt-BR" sz="1500" b="1" dirty="0">
                 <a:solidFill>
                   <a:srgbClr val="111111"/>
                 </a:solidFill>
@@ -30722,10 +30531,10 @@
                 <a:cs typeface="Canva Sans Bold"/>
                 <a:sym typeface="Canva Sans Bold"/>
               </a:rPr>
-              <a:t>Profesorado, cultura y postmodernidad</a:t>
-            </a:r>
-            <a:r>
-              <a:rPr lang="pt-BR" sz="1550" dirty="0">
+              <a:t>Pedagogia da autonomia</a:t>
+            </a:r>
+            <a:r>
+              <a:rPr lang="pt-BR" sz="1500" dirty="0">
                 <a:solidFill>
                   <a:srgbClr val="111111"/>
                 </a:solidFill>
@@ -30734,9 +30543,9 @@
                 <a:cs typeface="Canva Sans"/>
                 <a:sym typeface="Canva Sans"/>
               </a:rPr>
-              <a:t>: cambian los tiempos, cambia el profesorado. 5. ed. Madrid: Morata, 2005.</a:t>
-            </a:r>
-            <a:endParaRPr lang="pt-BR" sz="1550" dirty="0"/>
+              <a:t>: saberes necessários à prática educativa. 60. ed. Rio de Janeiro: Paz e Terra, 2019.</a:t>
+            </a:r>
+            <a:endParaRPr lang="pt-BR" sz="1500" dirty="0"/>
           </a:p>
           <a:p>
             <a:pPr algn="l">
@@ -30747,12 +30556,12 @@
                 <a:spcPts val="0"/>
               </a:spcBef>
               <a:spcAft>
-                <a:spcPts val="600"/>
-              </a:spcAft>
-              <a:buNone/>
-            </a:pPr>
-            <a:r>
-              <a:rPr lang="pt-BR" sz="1550" dirty="0">
+                <a:spcPts val="500"/>
+              </a:spcAft>
+              <a:buNone/>
+            </a:pPr>
+            <a:r>
+              <a:rPr lang="pt-BR" sz="1500" dirty="0">
                 <a:solidFill>
                   <a:srgbClr val="111111"/>
                 </a:solidFill>
@@ -30761,10 +30570,10 @@
                 <a:cs typeface="Canva Sans"/>
                 <a:sym typeface="Canva Sans"/>
               </a:rPr>
-              <a:t>IBGE. </a:t>
-            </a:r>
-            <a:r>
-              <a:rPr lang="pt-BR" sz="1550" b="1" dirty="0">
+              <a:t>FUNDAÇÃO CULTURAL PALMARES. Portaria nº 26, de 6 de junho de 2005. </a:t>
+            </a:r>
+            <a:r>
+              <a:rPr lang="pt-BR" sz="1500" b="1" dirty="0">
                 <a:solidFill>
                   <a:srgbClr val="111111"/>
                 </a:solidFill>
@@ -30773,10 +30582,10 @@
                 <a:cs typeface="Canva Sans Bold"/>
                 <a:sym typeface="Canva Sans Bold"/>
               </a:rPr>
-              <a:t>Censo Demográfico 2022</a:t>
-            </a:r>
-            <a:r>
-              <a:rPr lang="pt-BR" sz="1550" dirty="0">
+              <a:t>Diário Oficial da União</a:t>
+            </a:r>
+            <a:r>
+              <a:rPr lang="pt-BR" sz="1500" dirty="0">
                 <a:solidFill>
                   <a:srgbClr val="111111"/>
                 </a:solidFill>
@@ -30785,9 +30594,162 @@
                 <a:cs typeface="Canva Sans"/>
                 <a:sym typeface="Canva Sans"/>
               </a:rPr>
+              <a:t>: seção 1, Brasília, DF, 8 jun. 2005.</a:t>
+            </a:r>
+            <a:endParaRPr lang="pt-BR" sz="1500" dirty="0"/>
+          </a:p>
+          <a:p>
+            <a:pPr algn="l">
+              <a:lnSpc>
+                <a:spcPct val="98000"/>
+              </a:lnSpc>
+              <a:spcBef>
+                <a:spcPts val="0"/>
+              </a:spcBef>
+              <a:spcAft>
+                <a:spcPts val="500"/>
+              </a:spcAft>
+              <a:buNone/>
+            </a:pPr>
+            <a:r>
+              <a:rPr lang="pt-BR" sz="1500" dirty="0">
+                <a:solidFill>
+                  <a:srgbClr val="111111"/>
+                </a:solidFill>
+                <a:latin typeface="Canva Sans"/>
+                <a:ea typeface="Canva Sans"/>
+                <a:cs typeface="Canva Sans"/>
+                <a:sym typeface="Canva Sans"/>
+              </a:rPr>
+              <a:t>HALL, Stuart. </a:t>
+            </a:r>
+            <a:r>
+              <a:rPr lang="pt-BR" sz="1500" b="1" dirty="0">
+                <a:solidFill>
+                  <a:srgbClr val="111111"/>
+                </a:solidFill>
+                <a:latin typeface="Canva Sans Bold"/>
+                <a:ea typeface="Canva Sans Bold"/>
+                <a:cs typeface="Canva Sans Bold"/>
+                <a:sym typeface="Canva Sans Bold"/>
+              </a:rPr>
+              <a:t>A identidade cultural na pós-modernidade</a:t>
+            </a:r>
+            <a:r>
+              <a:rPr lang="pt-BR" sz="1500" dirty="0">
+                <a:solidFill>
+                  <a:srgbClr val="111111"/>
+                </a:solidFill>
+                <a:latin typeface="Canva Sans"/>
+                <a:ea typeface="Canva Sans"/>
+                <a:cs typeface="Canva Sans"/>
+                <a:sym typeface="Canva Sans"/>
+              </a:rPr>
+              <a:t>. 11. ed. Rio de Janeiro: DP&amp;A, 2006.</a:t>
+            </a:r>
+            <a:endParaRPr lang="pt-BR" sz="1500" dirty="0"/>
+          </a:p>
+          <a:p>
+            <a:pPr algn="l">
+              <a:lnSpc>
+                <a:spcPct val="98000"/>
+              </a:lnSpc>
+              <a:spcBef>
+                <a:spcPts val="0"/>
+              </a:spcBef>
+              <a:spcAft>
+                <a:spcPts val="500"/>
+              </a:spcAft>
+              <a:buNone/>
+            </a:pPr>
+            <a:r>
+              <a:rPr lang="pt-BR" sz="1500" dirty="0">
+                <a:solidFill>
+                  <a:srgbClr val="111111"/>
+                </a:solidFill>
+                <a:latin typeface="Canva Sans"/>
+                <a:ea typeface="Canva Sans"/>
+                <a:cs typeface="Canva Sans"/>
+                <a:sym typeface="Canva Sans"/>
+              </a:rPr>
+              <a:t>HARGREAVES, Andy. </a:t>
+            </a:r>
+            <a:r>
+              <a:rPr lang="pt-BR" sz="1500" b="1" dirty="0">
+                <a:solidFill>
+                  <a:srgbClr val="111111"/>
+                </a:solidFill>
+                <a:latin typeface="Canva Sans Bold"/>
+                <a:ea typeface="Canva Sans Bold"/>
+                <a:cs typeface="Canva Sans Bold"/>
+                <a:sym typeface="Canva Sans Bold"/>
+              </a:rPr>
+              <a:t>Profesorado, cultura y postmodernidad</a:t>
+            </a:r>
+            <a:r>
+              <a:rPr lang="pt-BR" sz="1500" dirty="0">
+                <a:solidFill>
+                  <a:srgbClr val="111111"/>
+                </a:solidFill>
+                <a:latin typeface="Canva Sans"/>
+                <a:ea typeface="Canva Sans"/>
+                <a:cs typeface="Canva Sans"/>
+                <a:sym typeface="Canva Sans"/>
+              </a:rPr>
+              <a:t>: cambian los tiempos, cambia el profesorado. 5. ed. Madrid: Morata, 2005.</a:t>
+            </a:r>
+            <a:endParaRPr lang="pt-BR" sz="1500" dirty="0"/>
+          </a:p>
+          <a:p>
+            <a:pPr algn="l">
+              <a:lnSpc>
+                <a:spcPct val="98000"/>
+              </a:lnSpc>
+              <a:spcBef>
+                <a:spcPts val="0"/>
+              </a:spcBef>
+              <a:spcAft>
+                <a:spcPts val="500"/>
+              </a:spcAft>
+              <a:buNone/>
+            </a:pPr>
+            <a:r>
+              <a:rPr lang="pt-BR" sz="1500" dirty="0">
+                <a:solidFill>
+                  <a:srgbClr val="111111"/>
+                </a:solidFill>
+                <a:latin typeface="Canva Sans"/>
+                <a:ea typeface="Canva Sans"/>
+                <a:cs typeface="Canva Sans"/>
+                <a:sym typeface="Canva Sans"/>
+              </a:rPr>
+              <a:t>IBGE. </a:t>
+            </a:r>
+            <a:r>
+              <a:rPr lang="pt-BR" sz="1500" b="1" dirty="0">
+                <a:solidFill>
+                  <a:srgbClr val="111111"/>
+                </a:solidFill>
+                <a:latin typeface="Canva Sans Bold"/>
+                <a:ea typeface="Canva Sans Bold"/>
+                <a:cs typeface="Canva Sans Bold"/>
+                <a:sym typeface="Canva Sans Bold"/>
+              </a:rPr>
+              <a:t>Censo Demográfico 2022</a:t>
+            </a:r>
+            <a:r>
+              <a:rPr lang="pt-BR" sz="1500" dirty="0">
+                <a:solidFill>
+                  <a:srgbClr val="111111"/>
+                </a:solidFill>
+                <a:latin typeface="Canva Sans"/>
+                <a:ea typeface="Canva Sans"/>
+                <a:cs typeface="Canva Sans"/>
+                <a:sym typeface="Canva Sans"/>
+              </a:rPr>
               <a:t>: população e domicílios: primeiros resultados. Rio de Janeiro: IBGE, 2023.</a:t>
             </a:r>
-            <a:endParaRPr lang="pt-BR" sz="1550" dirty="0"/>
+            <a:endParaRPr lang="pt-BR" sz="1500" dirty="0"/>
           </a:p>
         </p:txBody>
       </p:sp>
@@ -30989,12 +30951,12 @@
                 <a:spcPts val="0"/>
               </a:spcBef>
               <a:spcAft>
-                <a:spcPts val="600"/>
-              </a:spcAft>
-              <a:buNone/>
-            </a:pPr>
-            <a:r>
-              <a:rPr lang="pt-BR" sz="1550" dirty="0">
+                <a:spcPts val="500"/>
+              </a:spcAft>
+              <a:buNone/>
+            </a:pPr>
+            <a:r>
+              <a:rPr lang="pt-BR" sz="1500" dirty="0">
                 <a:solidFill>
                   <a:srgbClr val="111111"/>
                 </a:solidFill>
@@ -31006,7 +30968,7 @@
               <a:t>IBGE. </a:t>
             </a:r>
             <a:r>
-              <a:rPr lang="pt-BR" sz="1550" b="1" dirty="0">
+              <a:rPr lang="pt-BR" sz="1500" b="1" dirty="0">
                 <a:solidFill>
                   <a:srgbClr val="111111"/>
                 </a:solidFill>
@@ -31018,7 +30980,7 @@
               <a:t>Cidades@</a:t>
             </a:r>
             <a:r>
-              <a:rPr lang="pt-BR" sz="1550" dirty="0">
+              <a:rPr lang="pt-BR" sz="1500" dirty="0">
                 <a:solidFill>
                   <a:srgbClr val="111111"/>
                 </a:solidFill>
@@ -31029,7 +30991,7 @@
               </a:rPr>
               <a:t>: Tibau do Sul. Rio de Janeiro: IBGE, 2025. Disponível em: https://cidades.ibge.gov.br/brasil/rn/tibau-do-sul.</a:t>
             </a:r>
-            <a:endParaRPr lang="pt-BR" sz="1550" dirty="0"/>
+            <a:endParaRPr lang="pt-BR" sz="1500" dirty="0"/>
           </a:p>
           <a:p>
             <a:pPr algn="l">
@@ -31040,12 +31002,12 @@
                 <a:spcPts val="0"/>
               </a:spcBef>
               <a:spcAft>
-                <a:spcPts val="600"/>
-              </a:spcAft>
-              <a:buNone/>
-            </a:pPr>
-            <a:r>
-              <a:rPr lang="pt-BR" sz="1550" dirty="0">
+                <a:spcPts val="500"/>
+              </a:spcAft>
+              <a:buNone/>
+            </a:pPr>
+            <a:r>
+              <a:rPr lang="pt-BR" sz="1500" dirty="0">
                 <a:solidFill>
                   <a:srgbClr val="111111"/>
                 </a:solidFill>
@@ -31057,7 +31019,7 @@
               <a:t>LOCKWOOD, Craig et al. Qualitative research synthesis: methodological guidance for systematic reviewers utilizing meta-aggregation. </a:t>
             </a:r>
             <a:r>
-              <a:rPr lang="pt-BR" sz="1550" b="1" dirty="0">
+              <a:rPr lang="pt-BR" sz="1500" b="1" dirty="0">
                 <a:solidFill>
                   <a:srgbClr val="111111"/>
                 </a:solidFill>
@@ -31069,7 +31031,7 @@
               <a:t>International Journal of Evidence-Based Healthcare</a:t>
             </a:r>
             <a:r>
-              <a:rPr lang="pt-BR" sz="1550" dirty="0">
+              <a:rPr lang="pt-BR" sz="1500" dirty="0">
                 <a:solidFill>
                   <a:srgbClr val="111111"/>
                 </a:solidFill>
@@ -31080,7 +31042,7 @@
               </a:rPr>
               <a:t>, v. 13, n. 3, p. 179-187, 2015.</a:t>
             </a:r>
-            <a:endParaRPr lang="pt-BR" sz="1550" dirty="0"/>
+            <a:endParaRPr lang="pt-BR" sz="1500" dirty="0"/>
           </a:p>
           <a:p>
             <a:pPr algn="l">
@@ -31091,12 +31053,12 @@
                 <a:spcPts val="0"/>
               </a:spcBef>
               <a:spcAft>
-                <a:spcPts val="600"/>
-              </a:spcAft>
-              <a:buNone/>
-            </a:pPr>
-            <a:r>
-              <a:rPr lang="pt-BR" sz="1550" dirty="0">
+                <a:spcPts val="500"/>
+              </a:spcAft>
+              <a:buNone/>
+            </a:pPr>
+            <a:r>
+              <a:rPr lang="pt-BR" sz="1500" dirty="0">
                 <a:solidFill>
                   <a:srgbClr val="111111"/>
                 </a:solidFill>
@@ -31108,7 +31070,7 @@
               <a:t>MAINARDES, Jefferson. Abordagem do ciclo de políticas: uma contribuição para a análise de políticas educacionais. </a:t>
             </a:r>
             <a:r>
-              <a:rPr lang="pt-BR" sz="1550" b="1" dirty="0">
+              <a:rPr lang="pt-BR" sz="1500" b="1" dirty="0">
                 <a:solidFill>
                   <a:srgbClr val="111111"/>
                 </a:solidFill>
@@ -31120,7 +31082,7 @@
               <a:t>Educação &amp; Sociedade</a:t>
             </a:r>
             <a:r>
-              <a:rPr lang="pt-BR" sz="1550" dirty="0">
+              <a:rPr lang="pt-BR" sz="1500" dirty="0">
                 <a:solidFill>
                   <a:srgbClr val="111111"/>
                 </a:solidFill>
@@ -31131,7 +31093,7 @@
               </a:rPr>
               <a:t>, Campinas, v. 27, n. 94, p. 47-69, jan./abr. 2006.</a:t>
             </a:r>
-            <a:endParaRPr lang="pt-BR" sz="1550" dirty="0"/>
+            <a:endParaRPr lang="pt-BR" sz="1500" dirty="0"/>
           </a:p>
           <a:p>
             <a:pPr algn="l">
@@ -31142,12 +31104,12 @@
                 <a:spcPts val="0"/>
               </a:spcBef>
               <a:spcAft>
-                <a:spcPts val="600"/>
-              </a:spcAft>
-              <a:buNone/>
-            </a:pPr>
-            <a:r>
-              <a:rPr lang="pt-BR" sz="1550" dirty="0">
+                <a:spcPts val="500"/>
+              </a:spcAft>
+              <a:buNone/>
+            </a:pPr>
+            <a:r>
+              <a:rPr lang="pt-BR" sz="1500" dirty="0">
                 <a:solidFill>
                   <a:srgbClr val="111111"/>
                 </a:solidFill>
@@ -31159,7 +31121,7 @@
               <a:t>MASSEY, Doreen. </a:t>
             </a:r>
             <a:r>
-              <a:rPr lang="pt-BR" sz="1550" b="1" dirty="0">
+              <a:rPr lang="pt-BR" sz="1500" b="1" dirty="0">
                 <a:solidFill>
                   <a:srgbClr val="111111"/>
                 </a:solidFill>
@@ -31171,7 +31133,7 @@
               <a:t>Pelo espaço</a:t>
             </a:r>
             <a:r>
-              <a:rPr lang="pt-BR" sz="1550" dirty="0">
+              <a:rPr lang="pt-BR" sz="1500" dirty="0">
                 <a:solidFill>
                   <a:srgbClr val="111111"/>
                 </a:solidFill>
@@ -31182,7 +31144,7 @@
               </a:rPr>
               <a:t>: uma nova política da espacialidade. Tradução de Hilda Pareto Maciel e Rogério Haesbaert. Rio de Janeiro: Bertrand Brasil, 2008.</a:t>
             </a:r>
-            <a:endParaRPr lang="pt-BR" sz="1550" dirty="0"/>
+            <a:endParaRPr lang="pt-BR" sz="1500" dirty="0"/>
           </a:p>
           <a:p>
             <a:pPr algn="l">
@@ -31193,12 +31155,12 @@
                 <a:spcPts val="0"/>
               </a:spcBef>
               <a:spcAft>
-                <a:spcPts val="600"/>
-              </a:spcAft>
-              <a:buNone/>
-            </a:pPr>
-            <a:r>
-              <a:rPr lang="pt-BR" sz="1550" dirty="0">
+                <a:spcPts val="500"/>
+              </a:spcAft>
+              <a:buNone/>
+            </a:pPr>
+            <a:r>
+              <a:rPr lang="pt-BR" sz="1500" dirty="0">
                 <a:solidFill>
                   <a:srgbClr val="111111"/>
                 </a:solidFill>
@@ -31210,7 +31172,7 @@
               <a:t>MINAYO, Maria Cecília de Souza (org.). </a:t>
             </a:r>
             <a:r>
-              <a:rPr lang="pt-BR" sz="1550" b="1" dirty="0">
+              <a:rPr lang="pt-BR" sz="1500" b="1" dirty="0">
                 <a:solidFill>
                   <a:srgbClr val="111111"/>
                 </a:solidFill>
@@ -31222,7 +31184,7 @@
               <a:t>Pesquisa social</a:t>
             </a:r>
             <a:r>
-              <a:rPr lang="pt-BR" sz="1550" dirty="0">
+              <a:rPr lang="pt-BR" sz="1500" dirty="0">
                 <a:solidFill>
                   <a:srgbClr val="111111"/>
                 </a:solidFill>
@@ -31233,7 +31195,7 @@
               </a:rPr>
               <a:t>: teoria, método e criatividade. 28. ed. Petrópolis: Vozes, 2009.</a:t>
             </a:r>
-            <a:endParaRPr lang="pt-BR" sz="1550" dirty="0"/>
+            <a:endParaRPr lang="pt-BR" sz="1500" dirty="0"/>
           </a:p>
           <a:p>
             <a:pPr algn="l">
@@ -31244,12 +31206,12 @@
                 <a:spcPts val="0"/>
               </a:spcBef>
               <a:spcAft>
-                <a:spcPts val="600"/>
-              </a:spcAft>
-              <a:buNone/>
-            </a:pPr>
-            <a:r>
-              <a:rPr lang="pt-BR" sz="1550" dirty="0">
+                <a:spcPts val="500"/>
+              </a:spcAft>
+              <a:buNone/>
+            </a:pPr>
+            <a:r>
+              <a:rPr lang="pt-BR" sz="1500" dirty="0">
                 <a:solidFill>
                   <a:srgbClr val="111111"/>
                 </a:solidFill>
@@ -31261,7 +31223,7 @@
               <a:t>MOROZOV, Evgeny. </a:t>
             </a:r>
             <a:r>
-              <a:rPr lang="pt-BR" sz="1550" b="1" dirty="0">
+              <a:rPr lang="pt-BR" sz="1500" b="1" dirty="0">
                 <a:solidFill>
                   <a:srgbClr val="111111"/>
                 </a:solidFill>
@@ -31273,7 +31235,7 @@
               <a:t>Big Tech</a:t>
             </a:r>
             <a:r>
-              <a:rPr lang="pt-BR" sz="1550" dirty="0">
+              <a:rPr lang="pt-BR" sz="1500" dirty="0">
                 <a:solidFill>
                   <a:srgbClr val="111111"/>
                 </a:solidFill>
@@ -31284,7 +31246,7 @@
               </a:rPr>
               <a:t>: a ascensão dos dados e a morte da política. Tradução de Claudio Marcondes. São Paulo: Ubu Editora, 2018.</a:t>
             </a:r>
-            <a:endParaRPr lang="pt-BR" sz="1550" dirty="0"/>
+            <a:endParaRPr lang="pt-BR" sz="1500" dirty="0"/>
           </a:p>
           <a:p>
             <a:pPr algn="l">
@@ -31295,12 +31257,12 @@
                 <a:spcPts val="0"/>
               </a:spcBef>
               <a:spcAft>
-                <a:spcPts val="600"/>
-              </a:spcAft>
-              <a:buNone/>
-            </a:pPr>
-            <a:r>
-              <a:rPr lang="pt-BR" sz="1550" dirty="0">
+                <a:spcPts val="500"/>
+              </a:spcAft>
+              <a:buNone/>
+            </a:pPr>
+            <a:r>
+              <a:rPr lang="pt-BR" sz="1500" dirty="0">
                 <a:solidFill>
                   <a:srgbClr val="111111"/>
                 </a:solidFill>
@@ -31312,7 +31274,7 @@
               <a:t>OCDE. </a:t>
             </a:r>
             <a:r>
-              <a:rPr lang="pt-BR" sz="1550" b="1" dirty="0">
+              <a:rPr lang="pt-BR" sz="1500" b="1" dirty="0">
                 <a:solidFill>
                   <a:srgbClr val="111111"/>
                 </a:solidFill>
@@ -31324,7 +31286,7 @@
               <a:t>Students, computers and learning</a:t>
             </a:r>
             <a:r>
-              <a:rPr lang="pt-BR" sz="1550" dirty="0">
+              <a:rPr lang="pt-BR" sz="1500" dirty="0">
                 <a:solidFill>
                   <a:srgbClr val="111111"/>
                 </a:solidFill>
@@ -31335,7 +31297,7 @@
               </a:rPr>
               <a:t>: making the connection. Paris: OECD Publishing, 2015.</a:t>
             </a:r>
-            <a:endParaRPr lang="pt-BR" sz="1550" dirty="0"/>
+            <a:endParaRPr lang="pt-BR" sz="1500" dirty="0"/>
           </a:p>
           <a:p>
             <a:pPr algn="l">
@@ -31346,12 +31308,12 @@
                 <a:spcPts val="0"/>
               </a:spcBef>
               <a:spcAft>
-                <a:spcPts val="600"/>
-              </a:spcAft>
-              <a:buNone/>
-            </a:pPr>
-            <a:r>
-              <a:rPr lang="pt-BR" sz="1550" dirty="0">
+                <a:spcPts val="500"/>
+              </a:spcAft>
+              <a:buNone/>
+            </a:pPr>
+            <a:r>
+              <a:rPr lang="pt-BR" sz="1500" dirty="0">
                 <a:solidFill>
                   <a:srgbClr val="111111"/>
                 </a:solidFill>
@@ -31363,7 +31325,7 @@
               <a:t>ONU. Comitê dos Direitos da Criança. </a:t>
             </a:r>
             <a:r>
-              <a:rPr lang="pt-BR" sz="1550" b="1" dirty="0">
+              <a:rPr lang="pt-BR" sz="1500" b="1" dirty="0">
                 <a:solidFill>
                   <a:srgbClr val="111111"/>
                 </a:solidFill>
@@ -31375,7 +31337,7 @@
               <a:t>Comentário Geral nº 25 (2021) sobre os direitos das crianças em relação ao ambiente digital</a:t>
             </a:r>
             <a:r>
-              <a:rPr lang="pt-BR" sz="1550" dirty="0">
+              <a:rPr lang="pt-BR" sz="1500" dirty="0">
                 <a:solidFill>
                   <a:srgbClr val="111111"/>
                 </a:solidFill>
@@ -31386,7 +31348,7 @@
               </a:rPr>
               <a:t>. Genebra: Organização das Nações Unidas, 2021.</a:t>
             </a:r>
-            <a:endParaRPr lang="pt-BR" sz="1550" dirty="0"/>
+            <a:endParaRPr lang="pt-BR" sz="1500" dirty="0"/>
           </a:p>
           <a:p>
             <a:pPr algn="l">
@@ -31397,12 +31359,12 @@
                 <a:spcPts val="0"/>
               </a:spcBef>
               <a:spcAft>
-                <a:spcPts val="600"/>
-              </a:spcAft>
-              <a:buNone/>
-            </a:pPr>
-            <a:r>
-              <a:rPr lang="pt-BR" sz="1550" dirty="0">
+                <a:spcPts val="500"/>
+              </a:spcAft>
+              <a:buNone/>
+            </a:pPr>
+            <a:r>
+              <a:rPr lang="pt-BR" sz="1500" dirty="0">
                 <a:solidFill>
                   <a:srgbClr val="111111"/>
                 </a:solidFill>
@@ -31414,7 +31376,7 @@
               <a:t>PAGE, Matthew J. et al. A declaração PRISMA 2020: diretriz atualizada para relatar revisões sistemáticas. </a:t>
             </a:r>
             <a:r>
-              <a:rPr lang="pt-BR" sz="1550" b="1" dirty="0">
+              <a:rPr lang="pt-BR" sz="1500" b="1" dirty="0">
                 <a:solidFill>
                   <a:srgbClr val="111111"/>
                 </a:solidFill>
@@ -31426,7 +31388,7 @@
               <a:t>Epidemiologia e Serviços de Saúde</a:t>
             </a:r>
             <a:r>
-              <a:rPr lang="pt-BR" sz="1550" dirty="0">
+              <a:rPr lang="pt-BR" sz="1500" dirty="0">
                 <a:solidFill>
                   <a:srgbClr val="111111"/>
                 </a:solidFill>
@@ -31437,7 +31399,7 @@
               </a:rPr>
               <a:t>, Brasília, v. 31, n. 2, e2022107, 2022.</a:t>
             </a:r>
-            <a:endParaRPr lang="pt-BR" sz="1550" dirty="0"/>
+            <a:endParaRPr lang="pt-BR" sz="1500" dirty="0"/>
           </a:p>
           <a:p>
             <a:pPr algn="l">
@@ -31448,12 +31410,12 @@
                 <a:spcPts val="0"/>
               </a:spcBef>
               <a:spcAft>
-                <a:spcPts val="600"/>
-              </a:spcAft>
-              <a:buNone/>
-            </a:pPr>
-            <a:r>
-              <a:rPr lang="pt-BR" sz="1550" dirty="0">
+                <a:spcPts val="500"/>
+              </a:spcAft>
+              <a:buNone/>
+            </a:pPr>
+            <a:r>
+              <a:rPr lang="pt-BR" sz="1500" dirty="0">
                 <a:solidFill>
                   <a:srgbClr val="111111"/>
                 </a:solidFill>
@@ -31465,7 +31427,7 @@
               <a:t>PRETTO, Nelson De Luca; CORDEIRO, Salete Noro; OLIVEIRA, Washington dos Santos. Produção cultural e compartilhamento de saberes em rede: entraves e possibilidades para a cultura e a educação. </a:t>
             </a:r>
             <a:r>
-              <a:rPr lang="pt-BR" sz="1550" b="1" dirty="0">
+              <a:rPr lang="pt-BR" sz="1500" b="1" dirty="0">
                 <a:solidFill>
                   <a:srgbClr val="111111"/>
                 </a:solidFill>
@@ -31477,7 +31439,7 @@
               <a:t>Educação em Revista</a:t>
             </a:r>
             <a:r>
-              <a:rPr lang="pt-BR" sz="1550" dirty="0">
+              <a:rPr lang="pt-BR" sz="1500" dirty="0">
                 <a:solidFill>
                   <a:srgbClr val="111111"/>
                 </a:solidFill>
@@ -31488,7 +31450,7 @@
               </a:rPr>
               <a:t>, Belo Horizonte, v. 29, n. 3, p. 17-40, set. 2013.</a:t>
             </a:r>
-            <a:endParaRPr lang="pt-BR" sz="1550" dirty="0"/>
+            <a:endParaRPr lang="pt-BR" sz="1500" dirty="0"/>
           </a:p>
           <a:p>
             <a:pPr algn="l">
@@ -31499,12 +31461,12 @@
                 <a:spcPts val="0"/>
               </a:spcBef>
               <a:spcAft>
-                <a:spcPts val="600"/>
-              </a:spcAft>
-              <a:buNone/>
-            </a:pPr>
-            <a:r>
-              <a:rPr lang="pt-BR" sz="1550" dirty="0">
+                <a:spcPts val="500"/>
+              </a:spcAft>
+              <a:buNone/>
+            </a:pPr>
+            <a:r>
+              <a:rPr lang="pt-BR" sz="1500" dirty="0">
                 <a:solidFill>
                   <a:srgbClr val="111111"/>
                 </a:solidFill>
@@ -31513,10 +31475,10 @@
                 <a:cs typeface="Canva Sans"/>
                 <a:sym typeface="Canva Sans"/>
               </a:rPr>
-              <a:t>SANTOS, Milton. O território e o saber local: algumas categorias de análise. </a:t>
-            </a:r>
-            <a:r>
-              <a:rPr lang="pt-BR" sz="1550" b="1" dirty="0">
+              <a:t>QUEIROZ, Maria Aparecida de; PAIVA, Maria Cristina Leandro de. A valorização do trabalho docente e a formação profissional. In: FRANÇA, Magna; MOMO, Mariângela (org.). </a:t>
+            </a:r>
+            <a:r>
+              <a:rPr lang="pt-BR" sz="1500" b="1" dirty="0">
                 <a:solidFill>
                   <a:srgbClr val="111111"/>
                 </a:solidFill>
@@ -31525,10 +31487,10 @@
                 <a:cs typeface="Canva Sans Bold"/>
                 <a:sym typeface="Canva Sans Bold"/>
               </a:rPr>
-              <a:t>Cadernos IPPUR</a:t>
-            </a:r>
-            <a:r>
-              <a:rPr lang="pt-BR" sz="1550" dirty="0">
+              <a:t>Processo democrático participativo</a:t>
+            </a:r>
+            <a:r>
+              <a:rPr lang="pt-BR" sz="1500" dirty="0">
                 <a:solidFill>
                   <a:srgbClr val="111111"/>
                 </a:solidFill>
@@ -31537,9 +31499,60 @@
                 <a:cs typeface="Canva Sans"/>
                 <a:sym typeface="Canva Sans"/>
               </a:rPr>
+              <a:t>: a construção do PNE. Campinas: Mercado de Letras, 2014. p. 249-286.</a:t>
+            </a:r>
+            <a:endParaRPr lang="pt-BR" sz="1500" dirty="0"/>
+          </a:p>
+          <a:p>
+            <a:pPr algn="l">
+              <a:lnSpc>
+                <a:spcPct val="98000"/>
+              </a:lnSpc>
+              <a:spcBef>
+                <a:spcPts val="0"/>
+              </a:spcBef>
+              <a:spcAft>
+                <a:spcPts val="500"/>
+              </a:spcAft>
+              <a:buNone/>
+            </a:pPr>
+            <a:r>
+              <a:rPr lang="pt-BR" sz="1500" dirty="0">
+                <a:solidFill>
+                  <a:srgbClr val="111111"/>
+                </a:solidFill>
+                <a:latin typeface="Canva Sans"/>
+                <a:ea typeface="Canva Sans"/>
+                <a:cs typeface="Canva Sans"/>
+                <a:sym typeface="Canva Sans"/>
+              </a:rPr>
+              <a:t>SANTOS, Milton. O território e o saber local: algumas categorias de análise. </a:t>
+            </a:r>
+            <a:r>
+              <a:rPr lang="pt-BR" sz="1500" b="1" dirty="0">
+                <a:solidFill>
+                  <a:srgbClr val="111111"/>
+                </a:solidFill>
+                <a:latin typeface="Canva Sans Bold"/>
+                <a:ea typeface="Canva Sans Bold"/>
+                <a:cs typeface="Canva Sans Bold"/>
+                <a:sym typeface="Canva Sans Bold"/>
+              </a:rPr>
+              <a:t>Cadernos IPPUR</a:t>
+            </a:r>
+            <a:r>
+              <a:rPr lang="pt-BR" sz="1500" dirty="0">
+                <a:solidFill>
+                  <a:srgbClr val="111111"/>
+                </a:solidFill>
+                <a:latin typeface="Canva Sans"/>
+                <a:ea typeface="Canva Sans"/>
+                <a:cs typeface="Canva Sans"/>
+                <a:sym typeface="Canva Sans"/>
+              </a:rPr>
               <a:t>, Rio de Janeiro, ano 13, n. 2, p. 15-26, 1999.</a:t>
             </a:r>
-            <a:endParaRPr lang="pt-BR" sz="1550" dirty="0"/>
+            <a:endParaRPr lang="pt-BR" sz="1500" dirty="0"/>
           </a:p>
         </p:txBody>
       </p:sp>
@@ -31573,12 +31586,12 @@
                 <a:spcPts val="0"/>
               </a:spcBef>
               <a:spcAft>
-                <a:spcPts val="600"/>
-              </a:spcAft>
-              <a:buNone/>
-            </a:pPr>
-            <a:r>
-              <a:rPr lang="pt-BR" sz="1550" dirty="0">
+                <a:spcPts val="500"/>
+              </a:spcAft>
+              <a:buNone/>
+            </a:pPr>
+            <a:r>
+              <a:rPr lang="pt-BR" sz="1500" dirty="0">
                 <a:solidFill>
                   <a:srgbClr val="111111"/>
                 </a:solidFill>
@@ -31590,7 +31603,7 @@
               <a:t>SANTOS, Milton. </a:t>
             </a:r>
             <a:r>
-              <a:rPr lang="pt-BR" sz="1550" b="1" dirty="0">
+              <a:rPr lang="pt-BR" sz="1500" b="1" dirty="0">
                 <a:solidFill>
                   <a:srgbClr val="111111"/>
                 </a:solidFill>
@@ -31602,7 +31615,7 @@
               <a:t>A natureza do espaço</a:t>
             </a:r>
             <a:r>
-              <a:rPr lang="pt-BR" sz="1550" dirty="0">
+              <a:rPr lang="pt-BR" sz="1500" dirty="0">
                 <a:solidFill>
                   <a:srgbClr val="111111"/>
                 </a:solidFill>
@@ -31613,7 +31626,7 @@
               </a:rPr>
               <a:t>: técnica e tempo, razão e emoção. 4. ed. 2. reimpr. São Paulo: Editora da Universidade de São Paulo, 2006.</a:t>
             </a:r>
-            <a:endParaRPr lang="pt-BR" sz="1550" dirty="0"/>
+            <a:endParaRPr lang="pt-BR" sz="1500" dirty="0"/>
           </a:p>
           <a:p>
             <a:pPr algn="l">
@@ -31624,12 +31637,12 @@
                 <a:spcPts val="0"/>
               </a:spcBef>
               <a:spcAft>
-                <a:spcPts val="600"/>
-              </a:spcAft>
-              <a:buNone/>
-            </a:pPr>
-            <a:r>
-              <a:rPr lang="pt-BR" sz="1550" dirty="0">
+                <a:spcPts val="500"/>
+              </a:spcAft>
+              <a:buNone/>
+            </a:pPr>
+            <a:r>
+              <a:rPr lang="pt-BR" sz="1500" dirty="0">
                 <a:solidFill>
                   <a:srgbClr val="111111"/>
                 </a:solidFill>
@@ -31641,7 +31654,7 @@
               <a:t>SANTOS, Milton. </a:t>
             </a:r>
             <a:r>
-              <a:rPr lang="pt-BR" sz="1550" b="1" dirty="0">
+              <a:rPr lang="pt-BR" sz="1500" b="1" dirty="0">
                 <a:solidFill>
                   <a:srgbClr val="111111"/>
                 </a:solidFill>
@@ -31653,7 +31666,7 @@
               <a:t>Espaço e método</a:t>
             </a:r>
             <a:r>
-              <a:rPr lang="pt-BR" sz="1550" dirty="0">
+              <a:rPr lang="pt-BR" sz="1500" dirty="0">
                 <a:solidFill>
                   <a:srgbClr val="111111"/>
                 </a:solidFill>
@@ -31664,7 +31677,7 @@
               </a:rPr>
               <a:t>. 5. ed., 1. reimpr. São Paulo: Editora da Universidade de São Paulo, 2012.</a:t>
             </a:r>
-            <a:endParaRPr lang="pt-BR" sz="1550" dirty="0"/>
+            <a:endParaRPr lang="pt-BR" sz="1500" dirty="0"/>
           </a:p>
           <a:p>
             <a:pPr algn="l">
@@ -31675,12 +31688,12 @@
                 <a:spcPts val="0"/>
               </a:spcBef>
               <a:spcAft>
-                <a:spcPts val="600"/>
-              </a:spcAft>
-              <a:buNone/>
-            </a:pPr>
-            <a:r>
-              <a:rPr lang="pt-BR" sz="1550" dirty="0">
+                <a:spcPts val="500"/>
+              </a:spcAft>
+              <a:buNone/>
+            </a:pPr>
+            <a:r>
+              <a:rPr lang="pt-BR" sz="1500" dirty="0">
                 <a:solidFill>
                   <a:srgbClr val="111111"/>
                 </a:solidFill>
@@ -31692,7 +31705,7 @@
               <a:t>SCHLEMMER, Eliane; BACKES, Luciana; PALAGI, Ana Maria Marques. O habitar do ensinar e do aprender OnLIFE: vivências na educação contemporânea. In: SCHLEMMER, Eliane et al. (org.). </a:t>
             </a:r>
             <a:r>
-              <a:rPr lang="pt-BR" sz="1550" b="1" dirty="0">
+              <a:rPr lang="pt-BR" sz="1500" b="1" dirty="0">
                 <a:solidFill>
                   <a:srgbClr val="111111"/>
                 </a:solidFill>
@@ -31704,7 +31717,7 @@
               <a:t>O habitar do ensinar e do aprender OnLIFE</a:t>
             </a:r>
             <a:r>
-              <a:rPr lang="pt-BR" sz="1550" dirty="0">
+              <a:rPr lang="pt-BR" sz="1500" dirty="0">
                 <a:solidFill>
                   <a:srgbClr val="111111"/>
                 </a:solidFill>
@@ -31715,7 +31728,7 @@
               </a:rPr>
               <a:t>: vivências na educação contemporânea. São Leopoldo: Casa Leiria, 2021. p. 15-34.</a:t>
             </a:r>
-            <a:endParaRPr lang="pt-BR" sz="1550" dirty="0"/>
+            <a:endParaRPr lang="pt-BR" sz="1500" dirty="0"/>
           </a:p>
           <a:p>
             <a:pPr algn="l">
@@ -31726,12 +31739,12 @@
                 <a:spcPts val="0"/>
               </a:spcBef>
               <a:spcAft>
-                <a:spcPts val="600"/>
-              </a:spcAft>
-              <a:buNone/>
-            </a:pPr>
-            <a:r>
-              <a:rPr lang="pt-BR" sz="1550" dirty="0">
+                <a:spcPts val="500"/>
+              </a:spcAft>
+              <a:buNone/>
+            </a:pPr>
+            <a:r>
+              <a:rPr lang="pt-BR" sz="1500" dirty="0">
                 <a:solidFill>
                   <a:srgbClr val="111111"/>
                 </a:solidFill>
@@ -31743,7 +31756,7 @@
               <a:t>SILVA, Terezinha Martins da. </a:t>
             </a:r>
             <a:r>
-              <a:rPr lang="pt-BR" sz="1550" b="1" dirty="0">
+              <a:rPr lang="pt-BR" sz="1500" b="1" dirty="0">
                 <a:solidFill>
                   <a:srgbClr val="111111"/>
                 </a:solidFill>
@@ -31755,7 +31768,7 @@
               <a:t>A educação escolar na comunidade negra de Sibaúma</a:t>
             </a:r>
             <a:r>
-              <a:rPr lang="pt-BR" sz="1550" dirty="0">
+              <a:rPr lang="pt-BR" sz="1500" dirty="0">
                 <a:solidFill>
                   <a:srgbClr val="111111"/>
                 </a:solidFill>
@@ -31766,7 +31779,7 @@
               </a:rPr>
               <a:t>: a trajetória educacional da Escola Municipal Armando de Paiva. 2011. 139 f. Dissertação (Mestrado em Educação) – Universidade Federal do Rio Grande do Norte, Natal, 2011.</a:t>
             </a:r>
-            <a:endParaRPr lang="pt-BR" sz="1550" dirty="0"/>
+            <a:endParaRPr lang="pt-BR" sz="1500" dirty="0"/>
           </a:p>
           <a:p>
             <a:pPr algn="l">
@@ -31777,12 +31790,12 @@
                 <a:spcPts val="0"/>
               </a:spcBef>
               <a:spcAft>
-                <a:spcPts val="600"/>
-              </a:spcAft>
-              <a:buNone/>
-            </a:pPr>
-            <a:r>
-              <a:rPr lang="pt-BR" sz="1550" dirty="0">
+                <a:spcPts val="500"/>
+              </a:spcAft>
+              <a:buNone/>
+            </a:pPr>
+            <a:r>
+              <a:rPr lang="pt-BR" sz="1500" dirty="0">
                 <a:solidFill>
                   <a:srgbClr val="111111"/>
                 </a:solidFill>
@@ -31794,7 +31807,7 @@
               <a:t>SILVEIRA, Sergio Amadeu da. </a:t>
             </a:r>
             <a:r>
-              <a:rPr lang="pt-BR" sz="1550" b="1" dirty="0">
+              <a:rPr lang="pt-BR" sz="1500" b="1" dirty="0">
                 <a:solidFill>
                   <a:srgbClr val="111111"/>
                 </a:solidFill>
@@ -31806,7 +31819,7 @@
               <a:t>Tudo sobre tod@s</a:t>
             </a:r>
             <a:r>
-              <a:rPr lang="pt-BR" sz="1550" dirty="0">
+              <a:rPr lang="pt-BR" sz="1500" dirty="0">
                 <a:solidFill>
                   <a:srgbClr val="111111"/>
                 </a:solidFill>
@@ -31817,7 +31830,7 @@
               </a:rPr>
               <a:t>: redes digitais, privacidade e venda de dados pessoais. São Paulo: Edições Sesc São Paulo, 2017. E-book.</a:t>
             </a:r>
-            <a:endParaRPr lang="pt-BR" sz="1550" dirty="0"/>
+            <a:endParaRPr lang="pt-BR" sz="1500" dirty="0"/>
           </a:p>
           <a:p>
             <a:pPr algn="l">
@@ -31828,12 +31841,12 @@
                 <a:spcPts val="0"/>
               </a:spcBef>
               <a:spcAft>
-                <a:spcPts val="600"/>
-              </a:spcAft>
-              <a:buNone/>
-            </a:pPr>
-            <a:r>
-              <a:rPr lang="pt-BR" sz="1550" dirty="0">
+                <a:spcPts val="500"/>
+              </a:spcAft>
+              <a:buNone/>
+            </a:pPr>
+            <a:r>
+              <a:rPr lang="pt-BR" sz="1500" dirty="0">
                 <a:solidFill>
                   <a:srgbClr val="111111"/>
                 </a:solidFill>
@@ -31845,7 +31858,7 @@
               <a:t>THOMAS, James; HARDEN, Angela. Methods for the thematic synthesis of qualitative research in systematic reviews. </a:t>
             </a:r>
             <a:r>
-              <a:rPr lang="pt-BR" sz="1550" b="1" dirty="0">
+              <a:rPr lang="pt-BR" sz="1500" b="1" dirty="0">
                 <a:solidFill>
                   <a:srgbClr val="111111"/>
                 </a:solidFill>
@@ -31857,7 +31870,7 @@
               <a:t>BMC Medical Research Methodology</a:t>
             </a:r>
             <a:r>
-              <a:rPr lang="pt-BR" sz="1550" dirty="0">
+              <a:rPr lang="pt-BR" sz="1500" dirty="0">
                 <a:solidFill>
                   <a:srgbClr val="111111"/>
                 </a:solidFill>
@@ -31868,7 +31881,7 @@
               </a:rPr>
               <a:t>, v. 8, art. 45, 2008.</a:t>
             </a:r>
-            <a:endParaRPr lang="pt-BR" sz="1550" dirty="0"/>
+            <a:endParaRPr lang="pt-BR" sz="1500" dirty="0"/>
           </a:p>
           <a:p>
             <a:pPr algn="l">
@@ -31879,12 +31892,12 @@
                 <a:spcPts val="0"/>
               </a:spcBef>
               <a:spcAft>
-                <a:spcPts val="600"/>
-              </a:spcAft>
-              <a:buNone/>
-            </a:pPr>
-            <a:r>
-              <a:rPr lang="pt-BR" sz="1550" dirty="0">
+                <a:spcPts val="500"/>
+              </a:spcAft>
+              <a:buNone/>
+            </a:pPr>
+            <a:r>
+              <a:rPr lang="pt-BR" sz="1500" dirty="0">
                 <a:solidFill>
                   <a:srgbClr val="111111"/>
                 </a:solidFill>
@@ -31896,7 +31909,7 @@
               <a:t>TIBAU DO SUL. Secretaria de Educação. </a:t>
             </a:r>
             <a:r>
-              <a:rPr lang="pt-BR" sz="1550" b="1" dirty="0">
+              <a:rPr lang="pt-BR" sz="1500" b="1" dirty="0">
                 <a:solidFill>
                   <a:srgbClr val="111111"/>
                 </a:solidFill>
@@ -31908,7 +31921,7 @@
               <a:t>Relatório sintético de turmas</a:t>
             </a:r>
             <a:r>
-              <a:rPr lang="pt-BR" sz="1550" dirty="0">
+              <a:rPr lang="pt-BR" sz="1500" dirty="0">
                 <a:solidFill>
                   <a:srgbClr val="111111"/>
                 </a:solidFill>
@@ -31919,7 +31932,7 @@
               </a:rPr>
               <a:t>: EM Domitila Castelo da Silva, Ensino Fundamental – anos iniciais, ano 2026. Tibau do Sul: Portal SIGEduc, 2026.</a:t>
             </a:r>
-            <a:endParaRPr lang="pt-BR" sz="1550" dirty="0"/>
+            <a:endParaRPr lang="pt-BR" sz="1500" dirty="0"/>
           </a:p>
           <a:p>
             <a:pPr algn="l">
@@ -31930,12 +31943,12 @@
                 <a:spcPts val="0"/>
               </a:spcBef>
               <a:spcAft>
-                <a:spcPts val="600"/>
-              </a:spcAft>
-              <a:buNone/>
-            </a:pPr>
-            <a:r>
-              <a:rPr lang="pt-BR" sz="1550" dirty="0">
+                <a:spcPts val="500"/>
+              </a:spcAft>
+              <a:buNone/>
+            </a:pPr>
+            <a:r>
+              <a:rPr lang="pt-BR" sz="1500" dirty="0">
                 <a:solidFill>
                   <a:srgbClr val="111111"/>
                 </a:solidFill>
@@ -31947,7 +31960,7 @@
               <a:t>UNESCO. </a:t>
             </a:r>
             <a:r>
-              <a:rPr lang="pt-BR" sz="1550" b="1" dirty="0">
+              <a:rPr lang="pt-BR" sz="1500" b="1" dirty="0">
                 <a:solidFill>
                   <a:srgbClr val="111111"/>
                 </a:solidFill>
@@ -31959,7 +31972,7 @@
               <a:t>Relatório de monitoramento global da educação 2023</a:t>
             </a:r>
             <a:r>
-              <a:rPr lang="pt-BR" sz="1550" dirty="0">
+              <a:rPr lang="pt-BR" sz="1500" dirty="0">
                 <a:solidFill>
                   <a:srgbClr val="111111"/>
                 </a:solidFill>
@@ -31970,7 +31983,7 @@
               </a:rPr>
               <a:t>: tecnologia na educação: uma ferramenta nos termos de quem? Paris: UNESCO, 2023.</a:t>
             </a:r>
-            <a:endParaRPr lang="pt-BR" sz="1550" dirty="0"/>
+            <a:endParaRPr lang="pt-BR" sz="1500" dirty="0"/>
           </a:p>
           <a:p>
             <a:pPr algn="l">
@@ -31981,12 +31994,12 @@
                 <a:spcPts val="0"/>
               </a:spcBef>
               <a:spcAft>
-                <a:spcPts val="600"/>
-              </a:spcAft>
-              <a:buNone/>
-            </a:pPr>
-            <a:r>
-              <a:rPr lang="pt-BR" sz="1550" dirty="0">
+                <a:spcPts val="500"/>
+              </a:spcAft>
+              <a:buNone/>
+            </a:pPr>
+            <a:r>
+              <a:rPr lang="pt-BR" sz="1500" dirty="0">
                 <a:solidFill>
                   <a:srgbClr val="111111"/>
                 </a:solidFill>
@@ -31995,10 +32008,10 @@
                 <a:cs typeface="Canva Sans"/>
                 <a:sym typeface="Canva Sans"/>
               </a:rPr>
-              <a:t>YIN, Robert K. </a:t>
-            </a:r>
-            <a:r>
-              <a:rPr lang="pt-BR" sz="1550" b="1" dirty="0">
+              <a:t>VALENTE, José Armando (org.). </a:t>
+            </a:r>
+            <a:r>
+              <a:rPr lang="pt-BR" sz="1500" b="1" dirty="0">
                 <a:solidFill>
                   <a:srgbClr val="111111"/>
                 </a:solidFill>
@@ -32007,10 +32020,10 @@
                 <a:cs typeface="Canva Sans Bold"/>
                 <a:sym typeface="Canva Sans Bold"/>
               </a:rPr>
-              <a:t>Estudo de caso</a:t>
-            </a:r>
-            <a:r>
-              <a:rPr lang="pt-BR" sz="1550" dirty="0">
+              <a:t>O computador na sociedade do conhecimento</a:t>
+            </a:r>
+            <a:r>
+              <a:rPr lang="pt-BR" sz="1500" dirty="0">
                 <a:solidFill>
                   <a:srgbClr val="111111"/>
                 </a:solidFill>
@@ -32019,9 +32032,9 @@
                 <a:cs typeface="Canva Sans"/>
                 <a:sym typeface="Canva Sans"/>
               </a:rPr>
-              <a:t>: planejamento e métodos. 2. ed. Porto Alegre: Bookman, 2001.</a:t>
-            </a:r>
-            <a:endParaRPr lang="pt-BR" sz="1550" dirty="0"/>
+              <a:t>. Campinas: Unicamp/NIED, 1999.</a:t>
+            </a:r>
+            <a:endParaRPr lang="pt-BR" sz="1500" dirty="0"/>
           </a:p>
           <a:p>
             <a:pPr algn="l">
@@ -32032,12 +32045,12 @@
                 <a:spcPts val="0"/>
               </a:spcBef>
               <a:spcAft>
-                <a:spcPts val="600"/>
-              </a:spcAft>
-              <a:buNone/>
-            </a:pPr>
-            <a:r>
-              <a:rPr lang="pt-BR" sz="1550" dirty="0">
+                <a:spcPts val="500"/>
+              </a:spcAft>
+              <a:buNone/>
+            </a:pPr>
+            <a:r>
+              <a:rPr lang="pt-BR" sz="1500" dirty="0">
                 <a:solidFill>
                   <a:srgbClr val="111111"/>
                 </a:solidFill>
@@ -32046,10 +32059,10 @@
                 <a:cs typeface="Canva Sans"/>
                 <a:sym typeface="Canva Sans"/>
               </a:rPr>
-              <a:t>ZUBOFF, Shoshana. </a:t>
-            </a:r>
-            <a:r>
-              <a:rPr lang="pt-BR" sz="1550" b="1" dirty="0">
+              <a:t>YIN, Robert K. </a:t>
+            </a:r>
+            <a:r>
+              <a:rPr lang="pt-BR" sz="1500" b="1" dirty="0">
                 <a:solidFill>
                   <a:srgbClr val="111111"/>
                 </a:solidFill>
@@ -32058,10 +32071,10 @@
                 <a:cs typeface="Canva Sans Bold"/>
                 <a:sym typeface="Canva Sans Bold"/>
               </a:rPr>
-              <a:t>A era do capitalismo de vigilância</a:t>
-            </a:r>
-            <a:r>
-              <a:rPr lang="pt-BR" sz="1550" dirty="0">
+              <a:t>Estudo de caso</a:t>
+            </a:r>
+            <a:r>
+              <a:rPr lang="pt-BR" sz="1500" dirty="0">
                 <a:solidFill>
                   <a:srgbClr val="111111"/>
                 </a:solidFill>
@@ -32070,9 +32083,60 @@
                 <a:cs typeface="Canva Sans"/>
                 <a:sym typeface="Canva Sans"/>
               </a:rPr>
+              <a:t>: planejamento e métodos. 2. ed. Porto Alegre: Bookman, 2001.</a:t>
+            </a:r>
+            <a:endParaRPr lang="pt-BR" sz="1500" dirty="0"/>
+          </a:p>
+          <a:p>
+            <a:pPr algn="l">
+              <a:lnSpc>
+                <a:spcPct val="98000"/>
+              </a:lnSpc>
+              <a:spcBef>
+                <a:spcPts val="0"/>
+              </a:spcBef>
+              <a:spcAft>
+                <a:spcPts val="500"/>
+              </a:spcAft>
+              <a:buNone/>
+            </a:pPr>
+            <a:r>
+              <a:rPr lang="pt-BR" sz="1500" dirty="0">
+                <a:solidFill>
+                  <a:srgbClr val="111111"/>
+                </a:solidFill>
+                <a:latin typeface="Canva Sans"/>
+                <a:ea typeface="Canva Sans"/>
+                <a:cs typeface="Canva Sans"/>
+                <a:sym typeface="Canva Sans"/>
+              </a:rPr>
+              <a:t>ZUBOFF, Shoshana. </a:t>
+            </a:r>
+            <a:r>
+              <a:rPr lang="pt-BR" sz="1500" b="1" dirty="0">
+                <a:solidFill>
+                  <a:srgbClr val="111111"/>
+                </a:solidFill>
+                <a:latin typeface="Canva Sans Bold"/>
+                <a:ea typeface="Canva Sans Bold"/>
+                <a:cs typeface="Canva Sans Bold"/>
+                <a:sym typeface="Canva Sans Bold"/>
+              </a:rPr>
+              <a:t>A era do capitalismo de vigilância</a:t>
+            </a:r>
+            <a:r>
+              <a:rPr lang="pt-BR" sz="1500" dirty="0">
+                <a:solidFill>
+                  <a:srgbClr val="111111"/>
+                </a:solidFill>
+                <a:latin typeface="Canva Sans"/>
+                <a:ea typeface="Canva Sans"/>
+                <a:cs typeface="Canva Sans"/>
+                <a:sym typeface="Canva Sans"/>
+              </a:rPr>
               <a:t>: a luta por um futuro humano na nova fronteira do poder. Tradução de George Schlesinger. Rio de Janeiro: Intrínseca, 2021. E-book.</a:t>
             </a:r>
-            <a:endParaRPr lang="pt-BR" sz="1550" dirty="0"/>
+            <a:endParaRPr lang="pt-BR" sz="1500" dirty="0"/>
           </a:p>
         </p:txBody>
       </p:sp>

</xml_diff>